<commit_message>
Slide 10 (MAF): widen code block, narrow side columns
- Reduce left tier stack from 3.5" to 3.0"
- Reduce MAF central block from 3.6" to 3.0"
- Yields ~5.3" wide code block (was 4.2")
- Flatten CreateAIAgent call, shorten instructions string
  so no line wraps

Co-authored-by: Copilot <223556219+Copilot@users.noreply.github.com>
</commit_message>
<xml_diff>
--- a/slides/Unifying-Local-Cloud-AI.pptx
+++ b/slides/Unifying-Local-Cloud-AI.pptx
@@ -2508,7 +2508,7 @@
         <p:spPr>
           <a:xfrm>
             <a:off x="548640" y="2377440"/>
-            <a:ext cx="3200400" cy="822960"/>
+            <a:ext cx="2743200" cy="822960"/>
           </a:xfrm>
           <a:prstGeom prst="roundRect">
             <a:avLst>
@@ -2560,7 +2560,7 @@
         <p:spPr>
           <a:xfrm>
             <a:off x="822960" y="2468880"/>
-            <a:ext cx="2834640" cy="320040"/>
+            <a:ext cx="2377440" cy="320040"/>
           </a:xfrm>
           <a:prstGeom prst="rect">
             <a:avLst/>
@@ -2599,7 +2599,7 @@
         <p:spPr>
           <a:xfrm>
             <a:off x="822960" y="2788920"/>
-            <a:ext cx="2834640" cy="320040"/>
+            <a:ext cx="2377440" cy="320040"/>
           </a:xfrm>
           <a:prstGeom prst="rect">
             <a:avLst/>
@@ -2638,7 +2638,7 @@
         <p:spPr>
           <a:xfrm>
             <a:off x="548640" y="3337560"/>
-            <a:ext cx="3200400" cy="822960"/>
+            <a:ext cx="2743200" cy="822960"/>
           </a:xfrm>
           <a:prstGeom prst="roundRect">
             <a:avLst>
@@ -2690,7 +2690,7 @@
         <p:spPr>
           <a:xfrm>
             <a:off x="822960" y="3429000"/>
-            <a:ext cx="2834640" cy="320040"/>
+            <a:ext cx="2377440" cy="320040"/>
           </a:xfrm>
           <a:prstGeom prst="rect">
             <a:avLst/>
@@ -2729,7 +2729,7 @@
         <p:spPr>
           <a:xfrm>
             <a:off x="822960" y="3749040"/>
-            <a:ext cx="2834640" cy="320040"/>
+            <a:ext cx="2377440" cy="320040"/>
           </a:xfrm>
           <a:prstGeom prst="rect">
             <a:avLst/>
@@ -2768,7 +2768,7 @@
         <p:spPr>
           <a:xfrm>
             <a:off x="548640" y="4297680"/>
-            <a:ext cx="3200400" cy="822960"/>
+            <a:ext cx="2743200" cy="822960"/>
           </a:xfrm>
           <a:prstGeom prst="roundRect">
             <a:avLst>
@@ -2820,7 +2820,7 @@
         <p:spPr>
           <a:xfrm>
             <a:off x="822960" y="4389120"/>
-            <a:ext cx="2834640" cy="320040"/>
+            <a:ext cx="2377440" cy="320040"/>
           </a:xfrm>
           <a:prstGeom prst="rect">
             <a:avLst/>
@@ -2859,7 +2859,7 @@
         <p:spPr>
           <a:xfrm>
             <a:off x="822960" y="4709160"/>
-            <a:ext cx="2834640" cy="320040"/>
+            <a:ext cx="2377440" cy="320040"/>
           </a:xfrm>
           <a:prstGeom prst="rect">
             <a:avLst/>
@@ -2897,7 +2897,7 @@
         </p:nvSpPr>
         <p:spPr>
           <a:xfrm rot="5400000">
-            <a:off x="3794760" y="2624328"/>
+            <a:off x="3337560" y="2624328"/>
             <a:ext cx="365760" cy="329184"/>
           </a:xfrm>
           <a:prstGeom prst="rightTriangle">
@@ -2922,7 +2922,7 @@
         </p:nvSpPr>
         <p:spPr>
           <a:xfrm rot="5400000">
-            <a:off x="3794760" y="3584448"/>
+            <a:off x="3337560" y="3584448"/>
             <a:ext cx="365760" cy="329184"/>
           </a:xfrm>
           <a:prstGeom prst="rightTriangle">
@@ -2947,7 +2947,7 @@
         </p:nvSpPr>
         <p:spPr>
           <a:xfrm rot="5400000">
-            <a:off x="3794760" y="4544568"/>
+            <a:off x="3337560" y="4544568"/>
             <a:ext cx="365760" cy="329184"/>
           </a:xfrm>
           <a:prstGeom prst="rightTriangle">
@@ -2972,12 +2972,12 @@
         </p:nvSpPr>
         <p:spPr>
           <a:xfrm>
-            <a:off x="4297680" y="2377440"/>
-            <a:ext cx="3291840" cy="2880360"/>
+            <a:off x="3840480" y="2377440"/>
+            <a:ext cx="2743200" cy="2880360"/>
           </a:xfrm>
           <a:prstGeom prst="roundRect">
             <a:avLst>
-              <a:gd name="adj" fmla="val 4762"/>
+              <a:gd name="adj" fmla="val 5000"/>
             </a:avLst>
           </a:prstGeom>
           <a:solidFill>
@@ -2999,8 +2999,8 @@
         </p:nvSpPr>
         <p:spPr>
           <a:xfrm>
-            <a:off x="4297680" y="2651760"/>
-            <a:ext cx="3291840" cy="548640"/>
+            <a:off x="3840480" y="2651760"/>
+            <a:ext cx="2743200" cy="548640"/>
           </a:xfrm>
           <a:prstGeom prst="rect">
             <a:avLst/>
@@ -3038,8 +3038,8 @@
         </p:nvSpPr>
         <p:spPr>
           <a:xfrm>
-            <a:off x="4297680" y="3383280"/>
-            <a:ext cx="3291840" cy="1463040"/>
+            <a:off x="3840480" y="3383280"/>
+            <a:ext cx="2743200" cy="1463040"/>
           </a:xfrm>
           <a:prstGeom prst="rect">
             <a:avLst/>
@@ -3120,8 +3120,8 @@
         </p:nvSpPr>
         <p:spPr>
           <a:xfrm>
-            <a:off x="4297680" y="4754880"/>
-            <a:ext cx="3291840" cy="365760"/>
+            <a:off x="3840480" y="4754880"/>
+            <a:ext cx="2743200" cy="365760"/>
           </a:xfrm>
           <a:prstGeom prst="rect">
             <a:avLst/>
@@ -3159,8 +3159,8 @@
         </p:nvSpPr>
         <p:spPr>
           <a:xfrm>
-            <a:off x="7863840" y="2377440"/>
-            <a:ext cx="3870655" cy="2880360"/>
+            <a:off x="6858000" y="2377440"/>
+            <a:ext cx="4876495" cy="2880360"/>
           </a:xfrm>
           <a:prstGeom prst="roundRect">
             <a:avLst>
@@ -3186,8 +3186,8 @@
         </p:nvSpPr>
         <p:spPr>
           <a:xfrm>
-            <a:off x="8046720" y="2514600"/>
-            <a:ext cx="3504895" cy="2606040"/>
+            <a:off x="7040880" y="2514600"/>
+            <a:ext cx="4510735" cy="2606040"/>
           </a:xfrm>
           <a:prstGeom prst="rect">
             <a:avLst/>
@@ -3211,7 +3211,7 @@
                 <a:ea typeface="Consolas" pitchFamily="34" charset="-122"/>
                 <a:cs typeface="Consolas" pitchFamily="34" charset="-120"/>
               </a:rPr>
-              <a:t>AIAgent agent = chatClient</a:t>
+              <a:t>AIAgent agent = chatClient.CreateAIAgent(</a:t>
             </a:r>
             <a:endParaRPr lang="en-US" sz="1200" dirty="0"/>
           </a:p>
@@ -3228,7 +3228,7 @@
                 <a:ea typeface="Consolas" pitchFamily="34" charset="-122"/>
                 <a:cs typeface="Consolas" pitchFamily="34" charset="-120"/>
               </a:rPr>
-              <a:t>    .CreateAIAgent(</a:t>
+              <a:t>    instructions: "You are helpful.",</a:t>
             </a:r>
             <a:endParaRPr lang="en-US" sz="1200" dirty="0"/>
           </a:p>
@@ -3245,24 +3245,7 @@
                 <a:ea typeface="Consolas" pitchFamily="34" charset="-122"/>
                 <a:cs typeface="Consolas" pitchFamily="34" charset="-120"/>
               </a:rPr>
-              <a:t>        instructions: "You are a helpful assistant.",</a:t>
-            </a:r>
-            <a:endParaRPr lang="en-US" sz="1200" dirty="0"/>
-          </a:p>
-          <a:p>
-            <a:pPr indent="0" marL="0">
-              <a:buNone/>
-            </a:pPr>
-            <a:r>
-              <a:rPr lang="en-US" sz="1200" dirty="0">
-                <a:solidFill>
-                  <a:srgbClr val="FAF8FF"/>
-                </a:solidFill>
-                <a:latin typeface="Consolas" pitchFamily="34" charset="0"/>
-                <a:ea typeface="Consolas" pitchFamily="34" charset="-122"/>
-                <a:cs typeface="Consolas" pitchFamily="34" charset="-120"/>
-              </a:rPr>
-              <a:t>        name: "assistant");</a:t>
+              <a:t>    name: "assistant");</a:t>
             </a:r>
             <a:endParaRPr lang="en-US" sz="1200" dirty="0"/>
           </a:p>

</xml_diff>

<commit_message>
Slide 12 (Demo 4): refocus on MAF workflows mixing Apple + Azure
Old: 'Mixing It All' showed three swappable chatClient flavors but didn't
actually mix anything — just three parallel ways to wire a single agent.

New: 'A Workflow of Agents' showcases MAF's real superpower:
- Pill-chain flow diagram up top — User → 📱 triage (Apple Intelligence)
  → ☁️ expert (Azure OpenAI) → User
- Code below uses AgentWorkflowBuilder.BuildSequential() to chain a
  local privacy-sensitive triage agent into a cloud frontier-reasoning
  agent — matching the real API used in demos/Demo.Orchestrations
- Drops Foundry Local from this slide (covered in Demo 3); focuses on
  the two extremes: ultra-local + ultra-cloud composed in one pipeline

Tagline: 'local privacy on the bookends, cloud reasoning in the middle.'

Co-authored-by: Copilot <223556219+Copilot@users.noreply.github.com>
</commit_message>
<xml_diff>
--- a/slides/Unifying-Local-Cloud-AI.pptx
+++ b/slides/Unifying-Local-Cloud-AI.pptx
@@ -6455,7 +6455,7 @@
         <p:spPr>
           <a:xfrm>
             <a:off x="0" y="0"/>
-            <a:ext cx="365760" cy="2286000"/>
+            <a:ext cx="365760" cy="3429000"/>
           </a:xfrm>
           <a:prstGeom prst="rect">
             <a:avLst/>
@@ -6479,33 +6479,8 @@
         </p:nvSpPr>
         <p:spPr>
           <a:xfrm>
-            <a:off x="0" y="2286000"/>
-            <a:ext cx="365760" cy="2286000"/>
-          </a:xfrm>
-          <a:prstGeom prst="rect">
-            <a:avLst/>
-          </a:prstGeom>
-          <a:solidFill>
-            <a:srgbClr val="FBBF24"/>
-          </a:solidFill>
-          <a:ln w="12700">
-            <a:solidFill>
-              <a:srgbClr val="FBBF24"/>
-            </a:solidFill>
-            <a:prstDash val="solid"/>
-          </a:ln>
-        </p:spPr>
-      </p:sp>
-      <p:sp>
-        <p:nvSpPr>
-          <p:cNvPr id="4" name="Shape 2"/>
-          <p:cNvSpPr/>
-          <p:nvPr/>
-        </p:nvSpPr>
-        <p:spPr>
-          <a:xfrm>
-            <a:off x="0" y="4572000"/>
-            <a:ext cx="365760" cy="2286000"/>
+            <a:off x="0" y="3429000"/>
+            <a:ext cx="365760" cy="3429000"/>
           </a:xfrm>
           <a:prstGeom prst="rect">
             <a:avLst/>
@@ -6523,69 +6498,69 @@
       </p:sp>
       <p:sp>
         <p:nvSpPr>
+          <p:cNvPr id="4" name="Text 2"/>
+          <p:cNvSpPr/>
+          <p:nvPr/>
+        </p:nvSpPr>
+        <p:spPr>
+          <a:xfrm>
+            <a:off x="822960" y="502920"/>
+            <a:ext cx="5486400" cy="411480"/>
+          </a:xfrm>
+          <a:prstGeom prst="rect">
+            <a:avLst/>
+          </a:prstGeom>
+          <a:noFill/>
+          <a:ln/>
+        </p:spPr>
+        <p:txBody>
+          <a:bodyPr wrap="square" rtlCol="0" anchor="ctr"/>
+          <a:lstStyle/>
+          <a:p>
+            <a:pPr indent="0" marL="0">
+              <a:buNone/>
+            </a:pPr>
+            <a:r>
+              <a:rPr lang="en-US" sz="1800" b="1" spc="800" kern="0" dirty="0">
+                <a:solidFill>
+                  <a:srgbClr val="CFCBED"/>
+                </a:solidFill>
+                <a:latin typeface="Calibri" pitchFamily="34" charset="0"/>
+                <a:ea typeface="Calibri" pitchFamily="34" charset="-122"/>
+                <a:cs typeface="Calibri" pitchFamily="34" charset="-120"/>
+              </a:rPr>
+              <a:t>DEMO  04</a:t>
+            </a:r>
+            <a:endParaRPr lang="en-US" sz="1800" dirty="0"/>
+          </a:p>
+        </p:txBody>
+      </p:sp>
+      <p:sp>
+        <p:nvSpPr>
           <p:cNvPr id="5" name="Text 3"/>
           <p:cNvSpPr/>
           <p:nvPr/>
         </p:nvSpPr>
         <p:spPr>
           <a:xfrm>
-            <a:off x="822960" y="640080"/>
-            <a:ext cx="5486400" cy="457200"/>
-          </a:xfrm>
-          <a:prstGeom prst="rect">
-            <a:avLst/>
-          </a:prstGeom>
-          <a:noFill/>
-          <a:ln/>
-        </p:spPr>
-        <p:txBody>
-          <a:bodyPr wrap="square" rtlCol="0" anchor="ctr"/>
-          <a:lstStyle/>
-          <a:p>
-            <a:pPr indent="0" marL="0">
-              <a:buNone/>
-            </a:pPr>
-            <a:r>
-              <a:rPr lang="en-US" sz="1800" b="1" spc="800" kern="0" dirty="0">
-                <a:solidFill>
-                  <a:srgbClr val="CFCBED"/>
-                </a:solidFill>
-                <a:latin typeface="Calibri" pitchFamily="34" charset="0"/>
-                <a:ea typeface="Calibri" pitchFamily="34" charset="-122"/>
-                <a:cs typeface="Calibri" pitchFamily="34" charset="-120"/>
-              </a:rPr>
-              <a:t>DEMO  04</a:t>
-            </a:r>
-            <a:endParaRPr lang="en-US" sz="1800" dirty="0"/>
-          </a:p>
-        </p:txBody>
-      </p:sp>
-      <p:sp>
-        <p:nvSpPr>
-          <p:cNvPr id="6" name="Text 4"/>
-          <p:cNvSpPr/>
-          <p:nvPr/>
-        </p:nvSpPr>
-        <p:spPr>
-          <a:xfrm>
-            <a:off x="822960" y="1143000"/>
-            <a:ext cx="10972800" cy="914400"/>
-          </a:xfrm>
-          <a:prstGeom prst="rect">
-            <a:avLst/>
-          </a:prstGeom>
-          <a:noFill/>
-          <a:ln/>
-        </p:spPr>
-        <p:txBody>
-          <a:bodyPr wrap="square" rtlCol="0" anchor="ctr"/>
-          <a:lstStyle/>
-          <a:p>
-            <a:pPr indent="0" marL="0">
-              <a:buNone/>
-            </a:pPr>
-            <a:r>
-              <a:rPr lang="en-US" sz="5200" b="1" dirty="0">
+            <a:off x="822960" y="960120"/>
+            <a:ext cx="10972800" cy="868680"/>
+          </a:xfrm>
+          <a:prstGeom prst="rect">
+            <a:avLst/>
+          </a:prstGeom>
+          <a:noFill/>
+          <a:ln/>
+        </p:spPr>
+        <p:txBody>
+          <a:bodyPr wrap="square" rtlCol="0" anchor="ctr"/>
+          <a:lstStyle/>
+          <a:p>
+            <a:pPr indent="0" marL="0">
+              <a:buNone/>
+            </a:pPr>
+            <a:r>
+              <a:rPr lang="en-US" sz="4800" b="1" dirty="0">
                 <a:solidFill>
                   <a:srgbClr val="FAF8FF"/>
                 </a:solidFill>
@@ -6593,21 +6568,21 @@
                 <a:ea typeface="Georgia" pitchFamily="34" charset="-122"/>
                 <a:cs typeface="Georgia" pitchFamily="34" charset="-120"/>
               </a:rPr>
-              <a:t>Mixing It All</a:t>
-            </a:r>
-            <a:endParaRPr lang="en-US" sz="5200" dirty="0"/>
-          </a:p>
-        </p:txBody>
-      </p:sp>
-      <p:sp>
-        <p:nvSpPr>
-          <p:cNvPr id="7" name="Text 5"/>
-          <p:cNvSpPr/>
-          <p:nvPr/>
-        </p:nvSpPr>
-        <p:spPr>
-          <a:xfrm>
-            <a:off x="822960" y="2148840"/>
+              <a:t>A Workflow of Agents</a:t>
+            </a:r>
+            <a:endParaRPr lang="en-US" sz="4800" dirty="0"/>
+          </a:p>
+        </p:txBody>
+      </p:sp>
+      <p:sp>
+        <p:nvSpPr>
+          <p:cNvPr id="6" name="Text 4"/>
+          <p:cNvSpPr/>
+          <p:nvPr/>
+        </p:nvSpPr>
+        <p:spPr>
+          <a:xfrm>
+            <a:off x="822960" y="1874520"/>
             <a:ext cx="10972800" cy="411480"/>
           </a:xfrm>
           <a:prstGeom prst="rect">
@@ -6624,7 +6599,7 @@
               <a:buNone/>
             </a:pPr>
             <a:r>
-              <a:rPr lang="en-US" sz="1700" i="1" dirty="0">
+              <a:rPr lang="en-US" sz="1600" i="1" dirty="0">
                 <a:solidFill>
                   <a:srgbClr val="CFCBED"/>
                 </a:solidFill>
@@ -6632,26 +6607,546 @@
                 <a:ea typeface="Calibri" pitchFamily="34" charset="-122"/>
                 <a:cs typeface="Calibri" pitchFamily="34" charset="-120"/>
               </a:rPr>
-              <a:t>Three different chatClient brains.  Same agent code path.</a:t>
-            </a:r>
-            <a:endParaRPr lang="en-US" sz="1700" dirty="0"/>
-          </a:p>
-        </p:txBody>
-      </p:sp>
-      <p:sp>
-        <p:nvSpPr>
-          <p:cNvPr id="8" name="Shape 6"/>
-          <p:cNvSpPr/>
-          <p:nvPr/>
-        </p:nvSpPr>
-        <p:spPr>
-          <a:xfrm>
-            <a:off x="822960" y="2697480"/>
-            <a:ext cx="10911535" cy="3794760"/>
+              <a:t>MAF workflows compose agents — local privacy on the bookends, cloud reasoning in the middle.</a:t>
+            </a:r>
+            <a:endParaRPr lang="en-US" sz="1600" dirty="0"/>
+          </a:p>
+        </p:txBody>
+      </p:sp>
+      <p:sp>
+        <p:nvSpPr>
+          <p:cNvPr id="7" name="Shape 5"/>
+          <p:cNvSpPr/>
+          <p:nvPr/>
+        </p:nvSpPr>
+        <p:spPr>
+          <a:xfrm>
+            <a:off x="822960" y="2468880"/>
+            <a:ext cx="2377440" cy="548640"/>
           </a:xfrm>
           <a:prstGeom prst="roundRect">
             <a:avLst>
-              <a:gd name="adj" fmla="val 2410"/>
+              <a:gd name="adj" fmla="val 50000"/>
+            </a:avLst>
+          </a:prstGeom>
+          <a:solidFill>
+            <a:srgbClr val="1E1B4B"/>
+          </a:solidFill>
+          <a:ln w="25400">
+            <a:solidFill>
+              <a:srgbClr val="CFCBED"/>
+            </a:solidFill>
+            <a:prstDash val="solid"/>
+          </a:ln>
+        </p:spPr>
+      </p:sp>
+      <p:sp>
+        <p:nvSpPr>
+          <p:cNvPr id="8" name="Text 6"/>
+          <p:cNvSpPr/>
+          <p:nvPr/>
+        </p:nvSpPr>
+        <p:spPr>
+          <a:xfrm>
+            <a:off x="914400" y="2468880"/>
+            <a:ext cx="2194560" cy="548640"/>
+          </a:xfrm>
+          <a:prstGeom prst="rect">
+            <a:avLst/>
+          </a:prstGeom>
+          <a:noFill/>
+          <a:ln/>
+        </p:spPr>
+        <p:txBody>
+          <a:bodyPr wrap="square" rtlCol="0" anchor="ctr"/>
+          <a:lstStyle/>
+          <a:p>
+            <a:pPr algn="ctr" indent="0" marL="0">
+              <a:buNone/>
+            </a:pPr>
+            <a:r>
+              <a:rPr lang="en-US" sz="1600" dirty="0">
+                <a:solidFill>
+                  <a:srgbClr val="000000"/>
+                </a:solidFill>
+                <a:latin typeface="Calibri" pitchFamily="34" charset="0"/>
+                <a:ea typeface="Calibri" pitchFamily="34" charset="-122"/>
+                <a:cs typeface="Calibri" pitchFamily="34" charset="-120"/>
+              </a:rPr>
+              <a:t>👤  </a:t>
+            </a:r>
+            <a:pPr algn="ctr" indent="0" marL="0">
+              <a:buNone/>
+            </a:pPr>
+            <a:r>
+              <a:rPr lang="en-US" sz="1400" b="1" dirty="0">
+                <a:solidFill>
+                  <a:srgbClr val="FAF8FF"/>
+                </a:solidFill>
+                <a:latin typeface="Calibri" pitchFamily="34" charset="0"/>
+                <a:ea typeface="Calibri" pitchFamily="34" charset="-122"/>
+                <a:cs typeface="Calibri" pitchFamily="34" charset="-120"/>
+              </a:rPr>
+              <a:t>User</a:t>
+            </a:r>
+            <a:pPr algn="ctr" indent="0" marL="0">
+              <a:buNone/>
+            </a:pPr>
+            <a:r>
+              <a:rPr lang="en-US" sz="1100" i="1" dirty="0">
+                <a:solidFill>
+                  <a:srgbClr val="CFCBED"/>
+                </a:solidFill>
+                <a:latin typeface="Calibri" pitchFamily="34" charset="0"/>
+                <a:ea typeface="Calibri" pitchFamily="34" charset="-122"/>
+                <a:cs typeface="Calibri" pitchFamily="34" charset="-120"/>
+              </a:rPr>
+              <a:t>   input</a:t>
+            </a:r>
+            <a:endParaRPr lang="en-US" sz="1600" dirty="0"/>
+          </a:p>
+        </p:txBody>
+      </p:sp>
+      <p:sp>
+        <p:nvSpPr>
+          <p:cNvPr id="9" name="Shape 7"/>
+          <p:cNvSpPr/>
+          <p:nvPr/>
+        </p:nvSpPr>
+        <p:spPr>
+          <a:xfrm>
+            <a:off x="3246120" y="2743200"/>
+            <a:ext cx="253898" cy="0"/>
+          </a:xfrm>
+          <a:prstGeom prst="line">
+            <a:avLst/>
+          </a:prstGeom>
+          <a:noFill/>
+          <a:ln w="25400">
+            <a:solidFill>
+              <a:srgbClr val="FB7185"/>
+            </a:solidFill>
+            <a:prstDash val="solid"/>
+          </a:ln>
+        </p:spPr>
+      </p:sp>
+      <p:sp>
+        <p:nvSpPr>
+          <p:cNvPr id="10" name="Shape 8"/>
+          <p:cNvSpPr/>
+          <p:nvPr/>
+        </p:nvSpPr>
+        <p:spPr>
+          <a:xfrm rot="5400000">
+            <a:off x="3362858" y="2670048"/>
+            <a:ext cx="164592" cy="146304"/>
+          </a:xfrm>
+          <a:prstGeom prst="rightTriangle">
+            <a:avLst/>
+          </a:prstGeom>
+          <a:solidFill>
+            <a:srgbClr val="FB7185"/>
+          </a:solidFill>
+          <a:ln w="12700">
+            <a:solidFill>
+              <a:srgbClr val="FB7185"/>
+            </a:solidFill>
+            <a:prstDash val="solid"/>
+          </a:ln>
+        </p:spPr>
+      </p:sp>
+      <p:sp>
+        <p:nvSpPr>
+          <p:cNvPr id="11" name="Shape 9"/>
+          <p:cNvSpPr/>
+          <p:nvPr/>
+        </p:nvSpPr>
+        <p:spPr>
+          <a:xfrm>
+            <a:off x="3545738" y="2468880"/>
+            <a:ext cx="2377440" cy="548640"/>
+          </a:xfrm>
+          <a:prstGeom prst="roundRect">
+            <a:avLst>
+              <a:gd name="adj" fmla="val 50000"/>
+            </a:avLst>
+          </a:prstGeom>
+          <a:solidFill>
+            <a:srgbClr val="1E1B4B"/>
+          </a:solidFill>
+          <a:ln w="25400">
+            <a:solidFill>
+              <a:srgbClr val="FB7185"/>
+            </a:solidFill>
+            <a:prstDash val="solid"/>
+          </a:ln>
+        </p:spPr>
+      </p:sp>
+      <p:sp>
+        <p:nvSpPr>
+          <p:cNvPr id="12" name="Text 10"/>
+          <p:cNvSpPr/>
+          <p:nvPr/>
+        </p:nvSpPr>
+        <p:spPr>
+          <a:xfrm>
+            <a:off x="3637178" y="2468880"/>
+            <a:ext cx="2194560" cy="548640"/>
+          </a:xfrm>
+          <a:prstGeom prst="rect">
+            <a:avLst/>
+          </a:prstGeom>
+          <a:noFill/>
+          <a:ln/>
+        </p:spPr>
+        <p:txBody>
+          <a:bodyPr wrap="square" rtlCol="0" anchor="ctr"/>
+          <a:lstStyle/>
+          <a:p>
+            <a:pPr algn="ctr" indent="0" marL="0">
+              <a:buNone/>
+            </a:pPr>
+            <a:r>
+              <a:rPr lang="en-US" sz="1600" dirty="0">
+                <a:solidFill>
+                  <a:srgbClr val="000000"/>
+                </a:solidFill>
+                <a:latin typeface="Calibri" pitchFamily="34" charset="0"/>
+                <a:ea typeface="Calibri" pitchFamily="34" charset="-122"/>
+                <a:cs typeface="Calibri" pitchFamily="34" charset="-120"/>
+              </a:rPr>
+              <a:t>📱  </a:t>
+            </a:r>
+            <a:pPr algn="ctr" indent="0" marL="0">
+              <a:buNone/>
+            </a:pPr>
+            <a:r>
+              <a:rPr lang="en-US" sz="1400" b="1" dirty="0">
+                <a:solidFill>
+                  <a:srgbClr val="FAF8FF"/>
+                </a:solidFill>
+                <a:latin typeface="Calibri" pitchFamily="34" charset="0"/>
+                <a:ea typeface="Calibri" pitchFamily="34" charset="-122"/>
+                <a:cs typeface="Calibri" pitchFamily="34" charset="-120"/>
+              </a:rPr>
+              <a:t>triage</a:t>
+            </a:r>
+            <a:pPr algn="ctr" indent="0" marL="0">
+              <a:buNone/>
+            </a:pPr>
+            <a:r>
+              <a:rPr lang="en-US" sz="1100" i="1" dirty="0">
+                <a:solidFill>
+                  <a:srgbClr val="CFCBED"/>
+                </a:solidFill>
+                <a:latin typeface="Calibri" pitchFamily="34" charset="0"/>
+                <a:ea typeface="Calibri" pitchFamily="34" charset="-122"/>
+                <a:cs typeface="Calibri" pitchFamily="34" charset="-120"/>
+              </a:rPr>
+              <a:t>   Apple Intelligence</a:t>
+            </a:r>
+            <a:endParaRPr lang="en-US" sz="1600" dirty="0"/>
+          </a:p>
+        </p:txBody>
+      </p:sp>
+      <p:sp>
+        <p:nvSpPr>
+          <p:cNvPr id="13" name="Shape 11"/>
+          <p:cNvSpPr/>
+          <p:nvPr/>
+        </p:nvSpPr>
+        <p:spPr>
+          <a:xfrm>
+            <a:off x="5968898" y="2743200"/>
+            <a:ext cx="253898" cy="0"/>
+          </a:xfrm>
+          <a:prstGeom prst="line">
+            <a:avLst/>
+          </a:prstGeom>
+          <a:noFill/>
+          <a:ln w="25400">
+            <a:solidFill>
+              <a:srgbClr val="FB7185"/>
+            </a:solidFill>
+            <a:prstDash val="solid"/>
+          </a:ln>
+        </p:spPr>
+      </p:sp>
+      <p:sp>
+        <p:nvSpPr>
+          <p:cNvPr id="14" name="Shape 12"/>
+          <p:cNvSpPr/>
+          <p:nvPr/>
+        </p:nvSpPr>
+        <p:spPr>
+          <a:xfrm rot="5400000">
+            <a:off x="6085637" y="2670048"/>
+            <a:ext cx="164592" cy="146304"/>
+          </a:xfrm>
+          <a:prstGeom prst="rightTriangle">
+            <a:avLst/>
+          </a:prstGeom>
+          <a:solidFill>
+            <a:srgbClr val="FB7185"/>
+          </a:solidFill>
+          <a:ln w="12700">
+            <a:solidFill>
+              <a:srgbClr val="FB7185"/>
+            </a:solidFill>
+            <a:prstDash val="solid"/>
+          </a:ln>
+        </p:spPr>
+      </p:sp>
+      <p:sp>
+        <p:nvSpPr>
+          <p:cNvPr id="15" name="Shape 13"/>
+          <p:cNvSpPr/>
+          <p:nvPr/>
+        </p:nvSpPr>
+        <p:spPr>
+          <a:xfrm>
+            <a:off x="6268517" y="2468880"/>
+            <a:ext cx="2377440" cy="548640"/>
+          </a:xfrm>
+          <a:prstGeom prst="roundRect">
+            <a:avLst>
+              <a:gd name="adj" fmla="val 50000"/>
+            </a:avLst>
+          </a:prstGeom>
+          <a:solidFill>
+            <a:srgbClr val="1E1B4B"/>
+          </a:solidFill>
+          <a:ln w="25400">
+            <a:solidFill>
+              <a:srgbClr val="6366F1"/>
+            </a:solidFill>
+            <a:prstDash val="solid"/>
+          </a:ln>
+        </p:spPr>
+      </p:sp>
+      <p:sp>
+        <p:nvSpPr>
+          <p:cNvPr id="16" name="Text 14"/>
+          <p:cNvSpPr/>
+          <p:nvPr/>
+        </p:nvSpPr>
+        <p:spPr>
+          <a:xfrm>
+            <a:off x="6359957" y="2468880"/>
+            <a:ext cx="2194560" cy="548640"/>
+          </a:xfrm>
+          <a:prstGeom prst="rect">
+            <a:avLst/>
+          </a:prstGeom>
+          <a:noFill/>
+          <a:ln/>
+        </p:spPr>
+        <p:txBody>
+          <a:bodyPr wrap="square" rtlCol="0" anchor="ctr"/>
+          <a:lstStyle/>
+          <a:p>
+            <a:pPr algn="ctr" indent="0" marL="0">
+              <a:buNone/>
+            </a:pPr>
+            <a:r>
+              <a:rPr lang="en-US" sz="1600" dirty="0">
+                <a:solidFill>
+                  <a:srgbClr val="000000"/>
+                </a:solidFill>
+                <a:latin typeface="Calibri" pitchFamily="34" charset="0"/>
+                <a:ea typeface="Calibri" pitchFamily="34" charset="-122"/>
+                <a:cs typeface="Calibri" pitchFamily="34" charset="-120"/>
+              </a:rPr>
+              <a:t>☁️  </a:t>
+            </a:r>
+            <a:pPr algn="ctr" indent="0" marL="0">
+              <a:buNone/>
+            </a:pPr>
+            <a:r>
+              <a:rPr lang="en-US" sz="1400" b="1" dirty="0">
+                <a:solidFill>
+                  <a:srgbClr val="FAF8FF"/>
+                </a:solidFill>
+                <a:latin typeface="Calibri" pitchFamily="34" charset="0"/>
+                <a:ea typeface="Calibri" pitchFamily="34" charset="-122"/>
+                <a:cs typeface="Calibri" pitchFamily="34" charset="-120"/>
+              </a:rPr>
+              <a:t>expert</a:t>
+            </a:r>
+            <a:pPr algn="ctr" indent="0" marL="0">
+              <a:buNone/>
+            </a:pPr>
+            <a:r>
+              <a:rPr lang="en-US" sz="1100" i="1" dirty="0">
+                <a:solidFill>
+                  <a:srgbClr val="CFCBED"/>
+                </a:solidFill>
+                <a:latin typeface="Calibri" pitchFamily="34" charset="0"/>
+                <a:ea typeface="Calibri" pitchFamily="34" charset="-122"/>
+                <a:cs typeface="Calibri" pitchFamily="34" charset="-120"/>
+              </a:rPr>
+              <a:t>   Azure OpenAI</a:t>
+            </a:r>
+            <a:endParaRPr lang="en-US" sz="1600" dirty="0"/>
+          </a:p>
+        </p:txBody>
+      </p:sp>
+      <p:sp>
+        <p:nvSpPr>
+          <p:cNvPr id="17" name="Shape 15"/>
+          <p:cNvSpPr/>
+          <p:nvPr/>
+        </p:nvSpPr>
+        <p:spPr>
+          <a:xfrm>
+            <a:off x="8691677" y="2743200"/>
+            <a:ext cx="253898" cy="0"/>
+          </a:xfrm>
+          <a:prstGeom prst="line">
+            <a:avLst/>
+          </a:prstGeom>
+          <a:noFill/>
+          <a:ln w="25400">
+            <a:solidFill>
+              <a:srgbClr val="FB7185"/>
+            </a:solidFill>
+            <a:prstDash val="solid"/>
+          </a:ln>
+        </p:spPr>
+      </p:sp>
+      <p:sp>
+        <p:nvSpPr>
+          <p:cNvPr id="18" name="Shape 16"/>
+          <p:cNvSpPr/>
+          <p:nvPr/>
+        </p:nvSpPr>
+        <p:spPr>
+          <a:xfrm rot="5400000">
+            <a:off x="8808415" y="2670048"/>
+            <a:ext cx="164592" cy="146304"/>
+          </a:xfrm>
+          <a:prstGeom prst="rightTriangle">
+            <a:avLst/>
+          </a:prstGeom>
+          <a:solidFill>
+            <a:srgbClr val="FB7185"/>
+          </a:solidFill>
+          <a:ln w="12700">
+            <a:solidFill>
+              <a:srgbClr val="FB7185"/>
+            </a:solidFill>
+            <a:prstDash val="solid"/>
+          </a:ln>
+        </p:spPr>
+      </p:sp>
+      <p:sp>
+        <p:nvSpPr>
+          <p:cNvPr id="19" name="Shape 17"/>
+          <p:cNvSpPr/>
+          <p:nvPr/>
+        </p:nvSpPr>
+        <p:spPr>
+          <a:xfrm>
+            <a:off x="8991295" y="2468880"/>
+            <a:ext cx="2377440" cy="548640"/>
+          </a:xfrm>
+          <a:prstGeom prst="roundRect">
+            <a:avLst>
+              <a:gd name="adj" fmla="val 50000"/>
+            </a:avLst>
+          </a:prstGeom>
+          <a:solidFill>
+            <a:srgbClr val="1E1B4B"/>
+          </a:solidFill>
+          <a:ln w="25400">
+            <a:solidFill>
+              <a:srgbClr val="CFCBED"/>
+            </a:solidFill>
+            <a:prstDash val="solid"/>
+          </a:ln>
+        </p:spPr>
+      </p:sp>
+      <p:sp>
+        <p:nvSpPr>
+          <p:cNvPr id="20" name="Text 18"/>
+          <p:cNvSpPr/>
+          <p:nvPr/>
+        </p:nvSpPr>
+        <p:spPr>
+          <a:xfrm>
+            <a:off x="9082735" y="2468880"/>
+            <a:ext cx="2194560" cy="548640"/>
+          </a:xfrm>
+          <a:prstGeom prst="rect">
+            <a:avLst/>
+          </a:prstGeom>
+          <a:noFill/>
+          <a:ln/>
+        </p:spPr>
+        <p:txBody>
+          <a:bodyPr wrap="square" rtlCol="0" anchor="ctr"/>
+          <a:lstStyle/>
+          <a:p>
+            <a:pPr algn="ctr" indent="0" marL="0">
+              <a:buNone/>
+            </a:pPr>
+            <a:r>
+              <a:rPr lang="en-US" sz="1600" dirty="0">
+                <a:solidFill>
+                  <a:srgbClr val="000000"/>
+                </a:solidFill>
+                <a:latin typeface="Calibri" pitchFamily="34" charset="0"/>
+                <a:ea typeface="Calibri" pitchFamily="34" charset="-122"/>
+                <a:cs typeface="Calibri" pitchFamily="34" charset="-120"/>
+              </a:rPr>
+              <a:t>👤  </a:t>
+            </a:r>
+            <a:pPr algn="ctr" indent="0" marL="0">
+              <a:buNone/>
+            </a:pPr>
+            <a:r>
+              <a:rPr lang="en-US" sz="1400" b="1" dirty="0">
+                <a:solidFill>
+                  <a:srgbClr val="FAF8FF"/>
+                </a:solidFill>
+                <a:latin typeface="Calibri" pitchFamily="34" charset="0"/>
+                <a:ea typeface="Calibri" pitchFamily="34" charset="-122"/>
+                <a:cs typeface="Calibri" pitchFamily="34" charset="-120"/>
+              </a:rPr>
+              <a:t>User</a:t>
+            </a:r>
+            <a:pPr algn="ctr" indent="0" marL="0">
+              <a:buNone/>
+            </a:pPr>
+            <a:r>
+              <a:rPr lang="en-US" sz="1100" i="1" dirty="0">
+                <a:solidFill>
+                  <a:srgbClr val="CFCBED"/>
+                </a:solidFill>
+                <a:latin typeface="Calibri" pitchFamily="34" charset="0"/>
+                <a:ea typeface="Calibri" pitchFamily="34" charset="-122"/>
+                <a:cs typeface="Calibri" pitchFamily="34" charset="-120"/>
+              </a:rPr>
+              <a:t>   answer</a:t>
+            </a:r>
+            <a:endParaRPr lang="en-US" sz="1600" dirty="0"/>
+          </a:p>
+        </p:txBody>
+      </p:sp>
+      <p:sp>
+        <p:nvSpPr>
+          <p:cNvPr id="21" name="Shape 19"/>
+          <p:cNvSpPr/>
+          <p:nvPr/>
+        </p:nvSpPr>
+        <p:spPr>
+          <a:xfrm>
+            <a:off x="822960" y="3291840"/>
+            <a:ext cx="10911535" cy="3200400"/>
+          </a:xfrm>
+          <a:prstGeom prst="roundRect">
+            <a:avLst>
+              <a:gd name="adj" fmla="val 2857"/>
             </a:avLst>
           </a:prstGeom>
           <a:solidFill>
@@ -6667,14 +7162,14 @@
       </p:sp>
       <p:sp>
         <p:nvSpPr>
-          <p:cNvPr id="9" name="Text 7"/>
-          <p:cNvSpPr/>
-          <p:nvPr/>
-        </p:nvSpPr>
-        <p:spPr>
-          <a:xfrm>
-            <a:off x="1051560" y="2862072"/>
-            <a:ext cx="10454335" cy="3474720"/>
+          <p:cNvPr id="22" name="Text 20"/>
+          <p:cNvSpPr/>
+          <p:nvPr/>
+        </p:nvSpPr>
+        <p:spPr>
+          <a:xfrm>
+            <a:off x="1051560" y="3456432"/>
+            <a:ext cx="10454335" cy="2880360"/>
           </a:xfrm>
           <a:prstGeom prst="rect">
             <a:avLst/>
@@ -6690,7 +7185,7 @@
               <a:buNone/>
             </a:pPr>
             <a:r>
-              <a:rPr lang="en-US" sz="1400" i="1" dirty="0">
+              <a:rPr lang="en-US" sz="1200" i="1" dirty="0">
                 <a:solidFill>
                   <a:srgbClr val="8B88B5"/>
                 </a:solidFill>
@@ -6698,19 +7193,33 @@
                 <a:ea typeface="Consolas" pitchFamily="34" charset="-122"/>
                 <a:cs typeface="Consolas" pitchFamily="34" charset="-120"/>
               </a:rPr>
-              <a:t>// 📱  OS Local — Apple Intelligence</a:t>
-            </a:r>
-            <a:pPr indent="0" marL="0">
-              <a:buNone/>
-            </a:pPr>
-            <a:endParaRPr lang="en-US" sz="1400" dirty="0"/>
-          </a:p>
-          <a:p>
-            <a:pPr indent="0" marL="0">
-              <a:buNone/>
-            </a:pPr>
-            <a:r>
-              <a:rPr lang="en-US" sz="1400" dirty="0">
+              <a:t>// 📱  Local — Apple Intelligence, on the device</a:t>
+            </a:r>
+            <a:pPr indent="0" marL="0">
+              <a:buNone/>
+            </a:pPr>
+            <a:endParaRPr lang="en-US" sz="1200" dirty="0"/>
+          </a:p>
+          <a:p>
+            <a:pPr indent="0" marL="0">
+              <a:buNone/>
+            </a:pPr>
+            <a:r>
+              <a:rPr lang="en-US" sz="1200" dirty="0">
+                <a:solidFill>
+                  <a:srgbClr val="A78BFA"/>
+                </a:solidFill>
+                <a:latin typeface="Consolas" pitchFamily="34" charset="0"/>
+                <a:ea typeface="Consolas" pitchFamily="34" charset="-122"/>
+                <a:cs typeface="Consolas" pitchFamily="34" charset="-120"/>
+              </a:rPr>
+              <a:t>AIAgent</a:t>
+            </a:r>
+            <a:pPr indent="0" marL="0">
+              <a:buNone/>
+            </a:pPr>
+            <a:r>
+              <a:rPr lang="en-US" sz="1200" dirty="0">
                 <a:solidFill>
                   <a:srgbClr val="FAF8FF"/>
                 </a:solidFill>
@@ -6718,13 +7227,13 @@
                 <a:ea typeface="Consolas" pitchFamily="34" charset="-122"/>
                 <a:cs typeface="Consolas" pitchFamily="34" charset="-120"/>
               </a:rPr>
-              <a:t>chatClient </a:t>
-            </a:r>
-            <a:pPr indent="0" marL="0">
-              <a:buNone/>
-            </a:pPr>
-            <a:r>
-              <a:rPr lang="en-US" sz="1400" dirty="0">
+              <a:t> triage </a:t>
+            </a:r>
+            <a:pPr indent="0" marL="0">
+              <a:buNone/>
+            </a:pPr>
+            <a:r>
+              <a:rPr lang="en-US" sz="1200" dirty="0">
                 <a:solidFill>
                   <a:srgbClr val="CFCBED"/>
                 </a:solidFill>
@@ -6738,7 +7247,7 @@
               <a:buNone/>
             </a:pPr>
             <a:r>
-              <a:rPr lang="en-US" sz="1400" dirty="0">
+              <a:rPr lang="en-US" sz="1200" dirty="0">
                 <a:solidFill>
                   <a:srgbClr val="FAF8FF"/>
                 </a:solidFill>
@@ -6752,7 +7261,7 @@
               <a:buNone/>
             </a:pPr>
             <a:r>
-              <a:rPr lang="en-US" sz="1400" dirty="0">
+              <a:rPr lang="en-US" sz="1200" dirty="0">
                 <a:solidFill>
                   <a:srgbClr val="FB7185"/>
                 </a:solidFill>
@@ -6766,7 +7275,7 @@
               <a:buNone/>
             </a:pPr>
             <a:r>
-              <a:rPr lang="en-US" sz="1400" dirty="0">
+              <a:rPr lang="en-US" sz="1200" dirty="0">
                 <a:solidFill>
                   <a:srgbClr val="FAF8FF"/>
                 </a:solidFill>
@@ -6780,7 +7289,7 @@
               <a:buNone/>
             </a:pPr>
             <a:r>
-              <a:rPr lang="en-US" sz="1400" dirty="0">
+              <a:rPr lang="en-US" sz="1200" dirty="0">
                 <a:solidFill>
                   <a:srgbClr val="FAF8FF"/>
                 </a:solidFill>
@@ -6794,7 +7303,7 @@
               <a:buNone/>
             </a:pPr>
             <a:r>
-              <a:rPr lang="en-US" sz="1400" dirty="0">
+              <a:rPr lang="en-US" sz="1200" dirty="0">
                 <a:solidFill>
                   <a:srgbClr val="B8B5D9"/>
                 </a:solidFill>
@@ -6808,7 +7317,7 @@
               <a:buNone/>
             </a:pPr>
             <a:r>
-              <a:rPr lang="en-US" sz="1400" dirty="0">
+              <a:rPr lang="en-US" sz="1200" dirty="0">
                 <a:solidFill>
                   <a:srgbClr val="B8B5D9"/>
                 </a:solidFill>
@@ -6821,8 +7330,28 @@
             <a:pPr indent="0" marL="0">
               <a:buNone/>
             </a:pPr>
-            <a:r>
-              <a:rPr lang="en-US" sz="1400" dirty="0">
+            <a:endParaRPr lang="en-US" sz="1200" dirty="0"/>
+          </a:p>
+          <a:p>
+            <a:pPr indent="0" marL="0">
+              <a:buNone/>
+            </a:pPr>
+            <a:r>
+              <a:rPr lang="en-US" sz="1200" dirty="0">
+                <a:solidFill>
+                  <a:srgbClr val="FAF8FF"/>
+                </a:solidFill>
+                <a:latin typeface="Consolas" pitchFamily="34" charset="0"/>
+                <a:ea typeface="Consolas" pitchFamily="34" charset="-122"/>
+                <a:cs typeface="Consolas" pitchFamily="34" charset="-120"/>
+              </a:rPr>
+              <a:t>    </a:t>
+            </a:r>
+            <a:pPr indent="0" marL="0">
+              <a:buNone/>
+            </a:pPr>
+            <a:r>
+              <a:rPr lang="en-US" sz="1200" dirty="0">
                 <a:solidFill>
                   <a:srgbClr val="B8B5D9"/>
                 </a:solidFill>
@@ -6830,25 +7359,179 @@
                 <a:ea typeface="Consolas" pitchFamily="34" charset="-122"/>
                 <a:cs typeface="Consolas" pitchFamily="34" charset="-120"/>
               </a:rPr>
+              <a:t>.</a:t>
+            </a:r>
+            <a:pPr indent="0" marL="0">
+              <a:buNone/>
+            </a:pPr>
+            <a:r>
+              <a:rPr lang="en-US" sz="1200" dirty="0">
+                <a:solidFill>
+                  <a:srgbClr val="86EFAC"/>
+                </a:solidFill>
+                <a:latin typeface="Consolas" pitchFamily="34" charset="0"/>
+                <a:ea typeface="Consolas" pitchFamily="34" charset="-122"/>
+                <a:cs typeface="Consolas" pitchFamily="34" charset="-120"/>
+              </a:rPr>
+              <a:t>CreateAIAgent</a:t>
+            </a:r>
+            <a:pPr indent="0" marL="0">
+              <a:buNone/>
+            </a:pPr>
+            <a:r>
+              <a:rPr lang="en-US" sz="1200" dirty="0">
+                <a:solidFill>
+                  <a:srgbClr val="B8B5D9"/>
+                </a:solidFill>
+                <a:latin typeface="Consolas" pitchFamily="34" charset="0"/>
+                <a:ea typeface="Consolas" pitchFamily="34" charset="-122"/>
+                <a:cs typeface="Consolas" pitchFamily="34" charset="-120"/>
+              </a:rPr>
+              <a:t>(</a:t>
+            </a:r>
+            <a:pPr indent="0" marL="0">
+              <a:buNone/>
+            </a:pPr>
+            <a:r>
+              <a:rPr lang="en-US" sz="1200" dirty="0">
+                <a:solidFill>
+                  <a:srgbClr val="FBBF24"/>
+                </a:solidFill>
+                <a:latin typeface="Consolas" pitchFamily="34" charset="0"/>
+                <a:ea typeface="Consolas" pitchFamily="34" charset="-122"/>
+                <a:cs typeface="Consolas" pitchFamily="34" charset="-120"/>
+              </a:rPr>
+              <a:t>"Strip personal info. Return only topic + intent."</a:t>
+            </a:r>
+            <a:pPr indent="0" marL="0">
+              <a:buNone/>
+            </a:pPr>
+            <a:r>
+              <a:rPr lang="en-US" sz="1200" dirty="0">
+                <a:solidFill>
+                  <a:srgbClr val="B8B5D9"/>
+                </a:solidFill>
+                <a:latin typeface="Consolas" pitchFamily="34" charset="0"/>
+                <a:ea typeface="Consolas" pitchFamily="34" charset="-122"/>
+                <a:cs typeface="Consolas" pitchFamily="34" charset="-120"/>
+              </a:rPr>
+              <a:t>,</a:t>
+            </a:r>
+            <a:pPr indent="0" marL="0">
+              <a:buNone/>
+            </a:pPr>
+            <a:r>
+              <a:rPr lang="en-US" sz="1200" dirty="0">
+                <a:solidFill>
+                  <a:srgbClr val="FAF8FF"/>
+                </a:solidFill>
+                <a:latin typeface="Consolas" pitchFamily="34" charset="0"/>
+                <a:ea typeface="Consolas" pitchFamily="34" charset="-122"/>
+                <a:cs typeface="Consolas" pitchFamily="34" charset="-120"/>
+              </a:rPr>
+              <a:t> </a:t>
+            </a:r>
+            <a:pPr indent="0" marL="0">
+              <a:buNone/>
+            </a:pPr>
+            <a:r>
+              <a:rPr lang="en-US" sz="1200" dirty="0">
+                <a:solidFill>
+                  <a:srgbClr val="FAF8FF"/>
+                </a:solidFill>
+                <a:latin typeface="Consolas" pitchFamily="34" charset="0"/>
+                <a:ea typeface="Consolas" pitchFamily="34" charset="-122"/>
+                <a:cs typeface="Consolas" pitchFamily="34" charset="-120"/>
+              </a:rPr>
+              <a:t>name</a:t>
+            </a:r>
+            <a:pPr indent="0" marL="0">
+              <a:buNone/>
+            </a:pPr>
+            <a:r>
+              <a:rPr lang="en-US" sz="1200" dirty="0">
+                <a:solidFill>
+                  <a:srgbClr val="B8B5D9"/>
+                </a:solidFill>
+                <a:latin typeface="Consolas" pitchFamily="34" charset="0"/>
+                <a:ea typeface="Consolas" pitchFamily="34" charset="-122"/>
+                <a:cs typeface="Consolas" pitchFamily="34" charset="-120"/>
+              </a:rPr>
+              <a:t>:</a:t>
+            </a:r>
+            <a:pPr indent="0" marL="0">
+              <a:buNone/>
+            </a:pPr>
+            <a:r>
+              <a:rPr lang="en-US" sz="1200" dirty="0">
+                <a:solidFill>
+                  <a:srgbClr val="FAF8FF"/>
+                </a:solidFill>
+                <a:latin typeface="Consolas" pitchFamily="34" charset="0"/>
+                <a:ea typeface="Consolas" pitchFamily="34" charset="-122"/>
+                <a:cs typeface="Consolas" pitchFamily="34" charset="-120"/>
+              </a:rPr>
+              <a:t> </a:t>
+            </a:r>
+            <a:pPr indent="0" marL="0">
+              <a:buNone/>
+            </a:pPr>
+            <a:r>
+              <a:rPr lang="en-US" sz="1200" dirty="0">
+                <a:solidFill>
+                  <a:srgbClr val="FBBF24"/>
+                </a:solidFill>
+                <a:latin typeface="Consolas" pitchFamily="34" charset="0"/>
+                <a:ea typeface="Consolas" pitchFamily="34" charset="-122"/>
+                <a:cs typeface="Consolas" pitchFamily="34" charset="-120"/>
+              </a:rPr>
+              <a:t>"triage"</a:t>
+            </a:r>
+            <a:pPr indent="0" marL="0">
+              <a:buNone/>
+            </a:pPr>
+            <a:r>
+              <a:rPr lang="en-US" sz="1200" dirty="0">
+                <a:solidFill>
+                  <a:srgbClr val="B8B5D9"/>
+                </a:solidFill>
+                <a:latin typeface="Consolas" pitchFamily="34" charset="0"/>
+                <a:ea typeface="Consolas" pitchFamily="34" charset="-122"/>
+                <a:cs typeface="Consolas" pitchFamily="34" charset="-120"/>
+              </a:rPr>
+              <a:t>)</a:t>
+            </a:r>
+            <a:pPr indent="0" marL="0">
+              <a:buNone/>
+            </a:pPr>
+            <a:r>
+              <a:rPr lang="en-US" sz="1200" dirty="0">
+                <a:solidFill>
+                  <a:srgbClr val="B8B5D9"/>
+                </a:solidFill>
+                <a:latin typeface="Consolas" pitchFamily="34" charset="0"/>
+                <a:ea typeface="Consolas" pitchFamily="34" charset="-122"/>
+                <a:cs typeface="Consolas" pitchFamily="34" charset="-120"/>
+              </a:rPr>
               <a:t>;</a:t>
             </a:r>
             <a:pPr indent="0" marL="0">
               <a:buNone/>
             </a:pPr>
-            <a:endParaRPr lang="en-US" sz="1400" dirty="0"/>
-          </a:p>
-          <a:p>
-            <a:pPr indent="0" marL="0">
-              <a:buNone/>
-            </a:pPr>
-            <a:endParaRPr lang="en-US" sz="1400" dirty="0"/>
-          </a:p>
-          <a:p>
-            <a:pPr indent="0" marL="0">
-              <a:buNone/>
-            </a:pPr>
-            <a:r>
-              <a:rPr lang="en-US" sz="1400" i="1" dirty="0">
+            <a:endParaRPr lang="en-US" sz="1200" dirty="0"/>
+          </a:p>
+          <a:p>
+            <a:pPr indent="0" marL="0">
+              <a:buNone/>
+            </a:pPr>
+            <a:endParaRPr lang="en-US" sz="1200" dirty="0"/>
+          </a:p>
+          <a:p>
+            <a:pPr indent="0" marL="0">
+              <a:buNone/>
+            </a:pPr>
+            <a:r>
+              <a:rPr lang="en-US" sz="1200" i="1" dirty="0">
                 <a:solidFill>
                   <a:srgbClr val="8B88B5"/>
                 </a:solidFill>
@@ -6856,19 +7539,75 @@
                 <a:ea typeface="Consolas" pitchFamily="34" charset="-122"/>
                 <a:cs typeface="Consolas" pitchFamily="34" charset="-120"/>
               </a:rPr>
-              <a:t>// 🧪  BYO Local — Foundry Local hosting a Phi-class LLM</a:t>
-            </a:r>
-            <a:pPr indent="0" marL="0">
-              <a:buNone/>
-            </a:pPr>
-            <a:endParaRPr lang="en-US" sz="1400" dirty="0"/>
-          </a:p>
-          <a:p>
-            <a:pPr indent="0" marL="0">
-              <a:buNone/>
-            </a:pPr>
-            <a:r>
-              <a:rPr lang="en-US" sz="1400" dirty="0">
+              <a:t>// ☁️  Cloud — Azure OpenAI, frontier reasoning</a:t>
+            </a:r>
+            <a:pPr indent="0" marL="0">
+              <a:buNone/>
+            </a:pPr>
+            <a:endParaRPr lang="en-US" sz="1200" dirty="0"/>
+          </a:p>
+          <a:p>
+            <a:pPr indent="0" marL="0">
+              <a:buNone/>
+            </a:pPr>
+            <a:r>
+              <a:rPr lang="en-US" sz="1200" dirty="0">
+                <a:solidFill>
+                  <a:srgbClr val="A78BFA"/>
+                </a:solidFill>
+                <a:latin typeface="Consolas" pitchFamily="34" charset="0"/>
+                <a:ea typeface="Consolas" pitchFamily="34" charset="-122"/>
+                <a:cs typeface="Consolas" pitchFamily="34" charset="-120"/>
+              </a:rPr>
+              <a:t>AIAgent</a:t>
+            </a:r>
+            <a:pPr indent="0" marL="0">
+              <a:buNone/>
+            </a:pPr>
+            <a:r>
+              <a:rPr lang="en-US" sz="1200" dirty="0">
+                <a:solidFill>
+                  <a:srgbClr val="FAF8FF"/>
+                </a:solidFill>
+                <a:latin typeface="Consolas" pitchFamily="34" charset="0"/>
+                <a:ea typeface="Consolas" pitchFamily="34" charset="-122"/>
+                <a:cs typeface="Consolas" pitchFamily="34" charset="-120"/>
+              </a:rPr>
+              <a:t> expert </a:t>
+            </a:r>
+            <a:pPr indent="0" marL="0">
+              <a:buNone/>
+            </a:pPr>
+            <a:r>
+              <a:rPr lang="en-US" sz="1200" dirty="0">
+                <a:solidFill>
+                  <a:srgbClr val="CFCBED"/>
+                </a:solidFill>
+                <a:latin typeface="Consolas" pitchFamily="34" charset="0"/>
+                <a:ea typeface="Consolas" pitchFamily="34" charset="-122"/>
+                <a:cs typeface="Consolas" pitchFamily="34" charset="-120"/>
+              </a:rPr>
+              <a:t>=</a:t>
+            </a:r>
+            <a:pPr indent="0" marL="0">
+              <a:buNone/>
+            </a:pPr>
+            <a:r>
+              <a:rPr lang="en-US" sz="1200" dirty="0">
+                <a:solidFill>
+                  <a:srgbClr val="FAF8FF"/>
+                </a:solidFill>
+                <a:latin typeface="Consolas" pitchFamily="34" charset="0"/>
+                <a:ea typeface="Consolas" pitchFamily="34" charset="-122"/>
+                <a:cs typeface="Consolas" pitchFamily="34" charset="-120"/>
+              </a:rPr>
+              <a:t> </a:t>
+            </a:r>
+            <a:pPr indent="0" marL="0">
+              <a:buNone/>
+            </a:pPr>
+            <a:r>
+              <a:rPr lang="en-US" sz="1200" dirty="0">
                 <a:solidFill>
                   <a:srgbClr val="FB7185"/>
                 </a:solidFill>
@@ -6876,13 +7615,561 @@
                 <a:ea typeface="Consolas" pitchFamily="34" charset="-122"/>
                 <a:cs typeface="Consolas" pitchFamily="34" charset="-120"/>
               </a:rPr>
+              <a:t>new</a:t>
+            </a:r>
+            <a:pPr indent="0" marL="0">
+              <a:buNone/>
+            </a:pPr>
+            <a:r>
+              <a:rPr lang="en-US" sz="1200" dirty="0">
+                <a:solidFill>
+                  <a:srgbClr val="FAF8FF"/>
+                </a:solidFill>
+                <a:latin typeface="Consolas" pitchFamily="34" charset="0"/>
+                <a:ea typeface="Consolas" pitchFamily="34" charset="-122"/>
+                <a:cs typeface="Consolas" pitchFamily="34" charset="-120"/>
+              </a:rPr>
+              <a:t> </a:t>
+            </a:r>
+            <a:pPr indent="0" marL="0">
+              <a:buNone/>
+            </a:pPr>
+            <a:r>
+              <a:rPr lang="en-US" sz="1200" dirty="0">
+                <a:solidFill>
+                  <a:srgbClr val="FAF8FF"/>
+                </a:solidFill>
+                <a:latin typeface="Consolas" pitchFamily="34" charset="0"/>
+                <a:ea typeface="Consolas" pitchFamily="34" charset="-122"/>
+                <a:cs typeface="Consolas" pitchFamily="34" charset="-120"/>
+              </a:rPr>
+              <a:t>AzureOpenAIClient</a:t>
+            </a:r>
+            <a:pPr indent="0" marL="0">
+              <a:buNone/>
+            </a:pPr>
+            <a:r>
+              <a:rPr lang="en-US" sz="1200" dirty="0">
+                <a:solidFill>
+                  <a:srgbClr val="B8B5D9"/>
+                </a:solidFill>
+                <a:latin typeface="Consolas" pitchFamily="34" charset="0"/>
+                <a:ea typeface="Consolas" pitchFamily="34" charset="-122"/>
+                <a:cs typeface="Consolas" pitchFamily="34" charset="-120"/>
+              </a:rPr>
+              <a:t>(</a:t>
+            </a:r>
+            <a:pPr indent="0" marL="0">
+              <a:buNone/>
+            </a:pPr>
+            <a:r>
+              <a:rPr lang="en-US" sz="1200" dirty="0">
+                <a:solidFill>
+                  <a:srgbClr val="FAF8FF"/>
+                </a:solidFill>
+                <a:latin typeface="Consolas" pitchFamily="34" charset="0"/>
+                <a:ea typeface="Consolas" pitchFamily="34" charset="-122"/>
+                <a:cs typeface="Consolas" pitchFamily="34" charset="-120"/>
+              </a:rPr>
+              <a:t>endpoint</a:t>
+            </a:r>
+            <a:pPr indent="0" marL="0">
+              <a:buNone/>
+            </a:pPr>
+            <a:r>
+              <a:rPr lang="en-US" sz="1200" dirty="0">
+                <a:solidFill>
+                  <a:srgbClr val="B8B5D9"/>
+                </a:solidFill>
+                <a:latin typeface="Consolas" pitchFamily="34" charset="0"/>
+                <a:ea typeface="Consolas" pitchFamily="34" charset="-122"/>
+                <a:cs typeface="Consolas" pitchFamily="34" charset="-120"/>
+              </a:rPr>
+              <a:t>,</a:t>
+            </a:r>
+            <a:pPr indent="0" marL="0">
+              <a:buNone/>
+            </a:pPr>
+            <a:r>
+              <a:rPr lang="en-US" sz="1200" dirty="0">
+                <a:solidFill>
+                  <a:srgbClr val="FAF8FF"/>
+                </a:solidFill>
+                <a:latin typeface="Consolas" pitchFamily="34" charset="0"/>
+                <a:ea typeface="Consolas" pitchFamily="34" charset="-122"/>
+                <a:cs typeface="Consolas" pitchFamily="34" charset="-120"/>
+              </a:rPr>
+              <a:t> </a:t>
+            </a:r>
+            <a:pPr indent="0" marL="0">
+              <a:buNone/>
+            </a:pPr>
+            <a:r>
+              <a:rPr lang="en-US" sz="1200" dirty="0">
+                <a:solidFill>
+                  <a:srgbClr val="FB7185"/>
+                </a:solidFill>
+                <a:latin typeface="Consolas" pitchFamily="34" charset="0"/>
+                <a:ea typeface="Consolas" pitchFamily="34" charset="-122"/>
+                <a:cs typeface="Consolas" pitchFamily="34" charset="-120"/>
+              </a:rPr>
+              <a:t>new</a:t>
+            </a:r>
+            <a:pPr indent="0" marL="0">
+              <a:buNone/>
+            </a:pPr>
+            <a:r>
+              <a:rPr lang="en-US" sz="1200" dirty="0">
+                <a:solidFill>
+                  <a:srgbClr val="FAF8FF"/>
+                </a:solidFill>
+                <a:latin typeface="Consolas" pitchFamily="34" charset="0"/>
+                <a:ea typeface="Consolas" pitchFamily="34" charset="-122"/>
+                <a:cs typeface="Consolas" pitchFamily="34" charset="-120"/>
+              </a:rPr>
+              <a:t> </a:t>
+            </a:r>
+            <a:pPr indent="0" marL="0">
+              <a:buNone/>
+            </a:pPr>
+            <a:r>
+              <a:rPr lang="en-US" sz="1200" dirty="0">
+                <a:solidFill>
+                  <a:srgbClr val="FAF8FF"/>
+                </a:solidFill>
+                <a:latin typeface="Consolas" pitchFamily="34" charset="0"/>
+                <a:ea typeface="Consolas" pitchFamily="34" charset="-122"/>
+                <a:cs typeface="Consolas" pitchFamily="34" charset="-120"/>
+              </a:rPr>
+              <a:t>DefaultAzureCredential</a:t>
+            </a:r>
+            <a:pPr indent="0" marL="0">
+              <a:buNone/>
+            </a:pPr>
+            <a:r>
+              <a:rPr lang="en-US" sz="1200" dirty="0">
+                <a:solidFill>
+                  <a:srgbClr val="B8B5D9"/>
+                </a:solidFill>
+                <a:latin typeface="Consolas" pitchFamily="34" charset="0"/>
+                <a:ea typeface="Consolas" pitchFamily="34" charset="-122"/>
+                <a:cs typeface="Consolas" pitchFamily="34" charset="-120"/>
+              </a:rPr>
+              <a:t>(</a:t>
+            </a:r>
+            <a:pPr indent="0" marL="0">
+              <a:buNone/>
+            </a:pPr>
+            <a:r>
+              <a:rPr lang="en-US" sz="1200" dirty="0">
+                <a:solidFill>
+                  <a:srgbClr val="B8B5D9"/>
+                </a:solidFill>
+                <a:latin typeface="Consolas" pitchFamily="34" charset="0"/>
+                <a:ea typeface="Consolas" pitchFamily="34" charset="-122"/>
+                <a:cs typeface="Consolas" pitchFamily="34" charset="-120"/>
+              </a:rPr>
+              <a:t>)</a:t>
+            </a:r>
+            <a:pPr indent="0" marL="0">
+              <a:buNone/>
+            </a:pPr>
+            <a:r>
+              <a:rPr lang="en-US" sz="1200" dirty="0">
+                <a:solidFill>
+                  <a:srgbClr val="B8B5D9"/>
+                </a:solidFill>
+                <a:latin typeface="Consolas" pitchFamily="34" charset="0"/>
+                <a:ea typeface="Consolas" pitchFamily="34" charset="-122"/>
+                <a:cs typeface="Consolas" pitchFamily="34" charset="-120"/>
+              </a:rPr>
+              <a:t>)</a:t>
+            </a:r>
+            <a:pPr indent="0" marL="0">
+              <a:buNone/>
+            </a:pPr>
+            <a:endParaRPr lang="en-US" sz="1200" dirty="0"/>
+          </a:p>
+          <a:p>
+            <a:pPr indent="0" marL="0">
+              <a:buNone/>
+            </a:pPr>
+            <a:r>
+              <a:rPr lang="en-US" sz="1200" dirty="0">
+                <a:solidFill>
+                  <a:srgbClr val="FAF8FF"/>
+                </a:solidFill>
+                <a:latin typeface="Consolas" pitchFamily="34" charset="0"/>
+                <a:ea typeface="Consolas" pitchFamily="34" charset="-122"/>
+                <a:cs typeface="Consolas" pitchFamily="34" charset="-120"/>
+              </a:rPr>
+              <a:t>    </a:t>
+            </a:r>
+            <a:pPr indent="0" marL="0">
+              <a:buNone/>
+            </a:pPr>
+            <a:r>
+              <a:rPr lang="en-US" sz="1200" dirty="0">
+                <a:solidFill>
+                  <a:srgbClr val="B8B5D9"/>
+                </a:solidFill>
+                <a:latin typeface="Consolas" pitchFamily="34" charset="0"/>
+                <a:ea typeface="Consolas" pitchFamily="34" charset="-122"/>
+                <a:cs typeface="Consolas" pitchFamily="34" charset="-120"/>
+              </a:rPr>
+              <a:t>.</a:t>
+            </a:r>
+            <a:pPr indent="0" marL="0">
+              <a:buNone/>
+            </a:pPr>
+            <a:r>
+              <a:rPr lang="en-US" sz="1200" dirty="0">
+                <a:solidFill>
+                  <a:srgbClr val="86EFAC"/>
+                </a:solidFill>
+                <a:latin typeface="Consolas" pitchFamily="34" charset="0"/>
+                <a:ea typeface="Consolas" pitchFamily="34" charset="-122"/>
+                <a:cs typeface="Consolas" pitchFamily="34" charset="-120"/>
+              </a:rPr>
+              <a:t>GetChatClient</a:t>
+            </a:r>
+            <a:pPr indent="0" marL="0">
+              <a:buNone/>
+            </a:pPr>
+            <a:r>
+              <a:rPr lang="en-US" sz="1200" dirty="0">
+                <a:solidFill>
+                  <a:srgbClr val="B8B5D9"/>
+                </a:solidFill>
+                <a:latin typeface="Consolas" pitchFamily="34" charset="0"/>
+                <a:ea typeface="Consolas" pitchFamily="34" charset="-122"/>
+                <a:cs typeface="Consolas" pitchFamily="34" charset="-120"/>
+              </a:rPr>
+              <a:t>(</a:t>
+            </a:r>
+            <a:pPr indent="0" marL="0">
+              <a:buNone/>
+            </a:pPr>
+            <a:r>
+              <a:rPr lang="en-US" sz="1200" dirty="0">
+                <a:solidFill>
+                  <a:srgbClr val="FBBF24"/>
+                </a:solidFill>
+                <a:latin typeface="Consolas" pitchFamily="34" charset="0"/>
+                <a:ea typeface="Consolas" pitchFamily="34" charset="-122"/>
+                <a:cs typeface="Consolas" pitchFamily="34" charset="-120"/>
+              </a:rPr>
+              <a:t>"gpt-4.1"</a:t>
+            </a:r>
+            <a:pPr indent="0" marL="0">
+              <a:buNone/>
+            </a:pPr>
+            <a:r>
+              <a:rPr lang="en-US" sz="1200" dirty="0">
+                <a:solidFill>
+                  <a:srgbClr val="B8B5D9"/>
+                </a:solidFill>
+                <a:latin typeface="Consolas" pitchFamily="34" charset="0"/>
+                <a:ea typeface="Consolas" pitchFamily="34" charset="-122"/>
+                <a:cs typeface="Consolas" pitchFamily="34" charset="-120"/>
+              </a:rPr>
+              <a:t>)</a:t>
+            </a:r>
+            <a:pPr indent="0" marL="0">
+              <a:buNone/>
+            </a:pPr>
+            <a:r>
+              <a:rPr lang="en-US" sz="1200" dirty="0">
+                <a:solidFill>
+                  <a:srgbClr val="B8B5D9"/>
+                </a:solidFill>
+                <a:latin typeface="Consolas" pitchFamily="34" charset="0"/>
+                <a:ea typeface="Consolas" pitchFamily="34" charset="-122"/>
+                <a:cs typeface="Consolas" pitchFamily="34" charset="-120"/>
+              </a:rPr>
+              <a:t>.</a:t>
+            </a:r>
+            <a:pPr indent="0" marL="0">
+              <a:buNone/>
+            </a:pPr>
+            <a:r>
+              <a:rPr lang="en-US" sz="1200" dirty="0">
+                <a:solidFill>
+                  <a:srgbClr val="86EFAC"/>
+                </a:solidFill>
+                <a:latin typeface="Consolas" pitchFamily="34" charset="0"/>
+                <a:ea typeface="Consolas" pitchFamily="34" charset="-122"/>
+                <a:cs typeface="Consolas" pitchFamily="34" charset="-120"/>
+              </a:rPr>
+              <a:t>AsIChatClient</a:t>
+            </a:r>
+            <a:pPr indent="0" marL="0">
+              <a:buNone/>
+            </a:pPr>
+            <a:r>
+              <a:rPr lang="en-US" sz="1200" dirty="0">
+                <a:solidFill>
+                  <a:srgbClr val="B8B5D9"/>
+                </a:solidFill>
+                <a:latin typeface="Consolas" pitchFamily="34" charset="0"/>
+                <a:ea typeface="Consolas" pitchFamily="34" charset="-122"/>
+                <a:cs typeface="Consolas" pitchFamily="34" charset="-120"/>
+              </a:rPr>
+              <a:t>(</a:t>
+            </a:r>
+            <a:pPr indent="0" marL="0">
+              <a:buNone/>
+            </a:pPr>
+            <a:r>
+              <a:rPr lang="en-US" sz="1200" dirty="0">
+                <a:solidFill>
+                  <a:srgbClr val="B8B5D9"/>
+                </a:solidFill>
+                <a:latin typeface="Consolas" pitchFamily="34" charset="0"/>
+                <a:ea typeface="Consolas" pitchFamily="34" charset="-122"/>
+                <a:cs typeface="Consolas" pitchFamily="34" charset="-120"/>
+              </a:rPr>
+              <a:t>)</a:t>
+            </a:r>
+            <a:pPr indent="0" marL="0">
+              <a:buNone/>
+            </a:pPr>
+            <a:endParaRPr lang="en-US" sz="1200" dirty="0"/>
+          </a:p>
+          <a:p>
+            <a:pPr indent="0" marL="0">
+              <a:buNone/>
+            </a:pPr>
+            <a:r>
+              <a:rPr lang="en-US" sz="1200" dirty="0">
+                <a:solidFill>
+                  <a:srgbClr val="FAF8FF"/>
+                </a:solidFill>
+                <a:latin typeface="Consolas" pitchFamily="34" charset="0"/>
+                <a:ea typeface="Consolas" pitchFamily="34" charset="-122"/>
+                <a:cs typeface="Consolas" pitchFamily="34" charset="-120"/>
+              </a:rPr>
+              <a:t>    </a:t>
+            </a:r>
+            <a:pPr indent="0" marL="0">
+              <a:buNone/>
+            </a:pPr>
+            <a:r>
+              <a:rPr lang="en-US" sz="1200" dirty="0">
+                <a:solidFill>
+                  <a:srgbClr val="B8B5D9"/>
+                </a:solidFill>
+                <a:latin typeface="Consolas" pitchFamily="34" charset="0"/>
+                <a:ea typeface="Consolas" pitchFamily="34" charset="-122"/>
+                <a:cs typeface="Consolas" pitchFamily="34" charset="-120"/>
+              </a:rPr>
+              <a:t>.</a:t>
+            </a:r>
+            <a:pPr indent="0" marL="0">
+              <a:buNone/>
+            </a:pPr>
+            <a:r>
+              <a:rPr lang="en-US" sz="1200" dirty="0">
+                <a:solidFill>
+                  <a:srgbClr val="86EFAC"/>
+                </a:solidFill>
+                <a:latin typeface="Consolas" pitchFamily="34" charset="0"/>
+                <a:ea typeface="Consolas" pitchFamily="34" charset="-122"/>
+                <a:cs typeface="Consolas" pitchFamily="34" charset="-120"/>
+              </a:rPr>
+              <a:t>CreateAIAgent</a:t>
+            </a:r>
+            <a:pPr indent="0" marL="0">
+              <a:buNone/>
+            </a:pPr>
+            <a:r>
+              <a:rPr lang="en-US" sz="1200" dirty="0">
+                <a:solidFill>
+                  <a:srgbClr val="B8B5D9"/>
+                </a:solidFill>
+                <a:latin typeface="Consolas" pitchFamily="34" charset="0"/>
+                <a:ea typeface="Consolas" pitchFamily="34" charset="-122"/>
+                <a:cs typeface="Consolas" pitchFamily="34" charset="-120"/>
+              </a:rPr>
+              <a:t>(</a:t>
+            </a:r>
+            <a:pPr indent="0" marL="0">
+              <a:buNone/>
+            </a:pPr>
+            <a:r>
+              <a:rPr lang="en-US" sz="1200" dirty="0">
+                <a:solidFill>
+                  <a:srgbClr val="FBBF24"/>
+                </a:solidFill>
+                <a:latin typeface="Consolas" pitchFamily="34" charset="0"/>
+                <a:ea typeface="Consolas" pitchFamily="34" charset="-122"/>
+                <a:cs typeface="Consolas" pitchFamily="34" charset="-120"/>
+              </a:rPr>
+              <a:t>"Answer with depth and current context."</a:t>
+            </a:r>
+            <a:pPr indent="0" marL="0">
+              <a:buNone/>
+            </a:pPr>
+            <a:r>
+              <a:rPr lang="en-US" sz="1200" dirty="0">
+                <a:solidFill>
+                  <a:srgbClr val="B8B5D9"/>
+                </a:solidFill>
+                <a:latin typeface="Consolas" pitchFamily="34" charset="0"/>
+                <a:ea typeface="Consolas" pitchFamily="34" charset="-122"/>
+                <a:cs typeface="Consolas" pitchFamily="34" charset="-120"/>
+              </a:rPr>
+              <a:t>,</a:t>
+            </a:r>
+            <a:pPr indent="0" marL="0">
+              <a:buNone/>
+            </a:pPr>
+            <a:r>
+              <a:rPr lang="en-US" sz="1200" dirty="0">
+                <a:solidFill>
+                  <a:srgbClr val="FAF8FF"/>
+                </a:solidFill>
+                <a:latin typeface="Consolas" pitchFamily="34" charset="0"/>
+                <a:ea typeface="Consolas" pitchFamily="34" charset="-122"/>
+                <a:cs typeface="Consolas" pitchFamily="34" charset="-120"/>
+              </a:rPr>
+              <a:t> </a:t>
+            </a:r>
+            <a:pPr indent="0" marL="0">
+              <a:buNone/>
+            </a:pPr>
+            <a:r>
+              <a:rPr lang="en-US" sz="1200" dirty="0">
+                <a:solidFill>
+                  <a:srgbClr val="FAF8FF"/>
+                </a:solidFill>
+                <a:latin typeface="Consolas" pitchFamily="34" charset="0"/>
+                <a:ea typeface="Consolas" pitchFamily="34" charset="-122"/>
+                <a:cs typeface="Consolas" pitchFamily="34" charset="-120"/>
+              </a:rPr>
+              <a:t>name</a:t>
+            </a:r>
+            <a:pPr indent="0" marL="0">
+              <a:buNone/>
+            </a:pPr>
+            <a:r>
+              <a:rPr lang="en-US" sz="1200" dirty="0">
+                <a:solidFill>
+                  <a:srgbClr val="B8B5D9"/>
+                </a:solidFill>
+                <a:latin typeface="Consolas" pitchFamily="34" charset="0"/>
+                <a:ea typeface="Consolas" pitchFamily="34" charset="-122"/>
+                <a:cs typeface="Consolas" pitchFamily="34" charset="-120"/>
+              </a:rPr>
+              <a:t>:</a:t>
+            </a:r>
+            <a:pPr indent="0" marL="0">
+              <a:buNone/>
+            </a:pPr>
+            <a:r>
+              <a:rPr lang="en-US" sz="1200" dirty="0">
+                <a:solidFill>
+                  <a:srgbClr val="FAF8FF"/>
+                </a:solidFill>
+                <a:latin typeface="Consolas" pitchFamily="34" charset="0"/>
+                <a:ea typeface="Consolas" pitchFamily="34" charset="-122"/>
+                <a:cs typeface="Consolas" pitchFamily="34" charset="-120"/>
+              </a:rPr>
+              <a:t> </a:t>
+            </a:r>
+            <a:pPr indent="0" marL="0">
+              <a:buNone/>
+            </a:pPr>
+            <a:r>
+              <a:rPr lang="en-US" sz="1200" dirty="0">
+                <a:solidFill>
+                  <a:srgbClr val="FBBF24"/>
+                </a:solidFill>
+                <a:latin typeface="Consolas" pitchFamily="34" charset="0"/>
+                <a:ea typeface="Consolas" pitchFamily="34" charset="-122"/>
+                <a:cs typeface="Consolas" pitchFamily="34" charset="-120"/>
+              </a:rPr>
+              <a:t>"expert"</a:t>
+            </a:r>
+            <a:pPr indent="0" marL="0">
+              <a:buNone/>
+            </a:pPr>
+            <a:r>
+              <a:rPr lang="en-US" sz="1200" dirty="0">
+                <a:solidFill>
+                  <a:srgbClr val="B8B5D9"/>
+                </a:solidFill>
+                <a:latin typeface="Consolas" pitchFamily="34" charset="0"/>
+                <a:ea typeface="Consolas" pitchFamily="34" charset="-122"/>
+                <a:cs typeface="Consolas" pitchFamily="34" charset="-120"/>
+              </a:rPr>
+              <a:t>)</a:t>
+            </a:r>
+            <a:pPr indent="0" marL="0">
+              <a:buNone/>
+            </a:pPr>
+            <a:r>
+              <a:rPr lang="en-US" sz="1200" dirty="0">
+                <a:solidFill>
+                  <a:srgbClr val="B8B5D9"/>
+                </a:solidFill>
+                <a:latin typeface="Consolas" pitchFamily="34" charset="0"/>
+                <a:ea typeface="Consolas" pitchFamily="34" charset="-122"/>
+                <a:cs typeface="Consolas" pitchFamily="34" charset="-120"/>
+              </a:rPr>
+              <a:t>;</a:t>
+            </a:r>
+            <a:pPr indent="0" marL="0">
+              <a:buNone/>
+            </a:pPr>
+            <a:endParaRPr lang="en-US" sz="1200" dirty="0"/>
+          </a:p>
+          <a:p>
+            <a:pPr indent="0" marL="0">
+              <a:buNone/>
+            </a:pPr>
+            <a:endParaRPr lang="en-US" sz="1200" dirty="0"/>
+          </a:p>
+          <a:p>
+            <a:pPr indent="0" marL="0">
+              <a:buNone/>
+            </a:pPr>
+            <a:r>
+              <a:rPr lang="en-US" sz="1200" i="1" dirty="0">
+                <a:solidFill>
+                  <a:srgbClr val="8B88B5"/>
+                </a:solidFill>
+                <a:latin typeface="Consolas" pitchFamily="34" charset="0"/>
+                <a:ea typeface="Consolas" pitchFamily="34" charset="-122"/>
+                <a:cs typeface="Consolas" pitchFamily="34" charset="-120"/>
+              </a:rPr>
+              <a:t>// 🔗  MAF workflow — pipe local → cloud, expose as an agent</a:t>
+            </a:r>
+            <a:pPr indent="0" marL="0">
+              <a:buNone/>
+            </a:pPr>
+            <a:endParaRPr lang="en-US" sz="1200" dirty="0"/>
+          </a:p>
+          <a:p>
+            <a:pPr indent="0" marL="0">
+              <a:buNone/>
+            </a:pPr>
+            <a:r>
+              <a:rPr lang="en-US" sz="1200" dirty="0">
+                <a:solidFill>
+                  <a:srgbClr val="FB7185"/>
+                </a:solidFill>
+                <a:latin typeface="Consolas" pitchFamily="34" charset="0"/>
+                <a:ea typeface="Consolas" pitchFamily="34" charset="-122"/>
+                <a:cs typeface="Consolas" pitchFamily="34" charset="-120"/>
+              </a:rPr>
               <a:t>var</a:t>
             </a:r>
             <a:pPr indent="0" marL="0">
               <a:buNone/>
             </a:pPr>
             <a:r>
-              <a:rPr lang="en-US" sz="1400" dirty="0">
+              <a:rPr lang="en-US" sz="1200" dirty="0">
                 <a:solidFill>
                   <a:srgbClr val="FAF8FF"/>
                 </a:solidFill>
@@ -6890,13 +8177,13 @@
                 <a:ea typeface="Consolas" pitchFamily="34" charset="-122"/>
                 <a:cs typeface="Consolas" pitchFamily="34" charset="-120"/>
               </a:rPr>
-              <a:t> mgr </a:t>
-            </a:r>
-            <a:pPr indent="0" marL="0">
-              <a:buNone/>
-            </a:pPr>
-            <a:r>
-              <a:rPr lang="en-US" sz="1400" dirty="0">
+              <a:t> workflow </a:t>
+            </a:r>
+            <a:pPr indent="0" marL="0">
+              <a:buNone/>
+            </a:pPr>
+            <a:r>
+              <a:rPr lang="en-US" sz="1200" dirty="0">
                 <a:solidFill>
                   <a:srgbClr val="CFCBED"/>
                 </a:solidFill>
@@ -6910,7 +8197,7 @@
               <a:buNone/>
             </a:pPr>
             <a:r>
-              <a:rPr lang="en-US" sz="1400" dirty="0">
+              <a:rPr lang="en-US" sz="1200" dirty="0">
                 <a:solidFill>
                   <a:srgbClr val="FAF8FF"/>
                 </a:solidFill>
@@ -6918,13 +8205,289 @@
                 <a:ea typeface="Consolas" pitchFamily="34" charset="-122"/>
                 <a:cs typeface="Consolas" pitchFamily="34" charset="-120"/>
               </a:rPr>
+              <a:t> AgentWorkflowBuilder</a:t>
+            </a:r>
+            <a:pPr indent="0" marL="0">
+              <a:buNone/>
+            </a:pPr>
+            <a:endParaRPr lang="en-US" sz="1200" dirty="0"/>
+          </a:p>
+          <a:p>
+            <a:pPr indent="0" marL="0">
+              <a:buNone/>
+            </a:pPr>
+            <a:r>
+              <a:rPr lang="en-US" sz="1200" dirty="0">
+                <a:solidFill>
+                  <a:srgbClr val="FAF8FF"/>
+                </a:solidFill>
+                <a:latin typeface="Consolas" pitchFamily="34" charset="0"/>
+                <a:ea typeface="Consolas" pitchFamily="34" charset="-122"/>
+                <a:cs typeface="Consolas" pitchFamily="34" charset="-120"/>
+              </a:rPr>
+              <a:t>    </a:t>
+            </a:r>
+            <a:pPr indent="0" marL="0">
+              <a:buNone/>
+            </a:pPr>
+            <a:r>
+              <a:rPr lang="en-US" sz="1200" dirty="0">
+                <a:solidFill>
+                  <a:srgbClr val="B8B5D9"/>
+                </a:solidFill>
+                <a:latin typeface="Consolas" pitchFamily="34" charset="0"/>
+                <a:ea typeface="Consolas" pitchFamily="34" charset="-122"/>
+                <a:cs typeface="Consolas" pitchFamily="34" charset="-120"/>
+              </a:rPr>
+              <a:t>.</a:t>
+            </a:r>
+            <a:pPr indent="0" marL="0">
+              <a:buNone/>
+            </a:pPr>
+            <a:r>
+              <a:rPr lang="en-US" sz="1200" dirty="0">
+                <a:solidFill>
+                  <a:srgbClr val="86EFAC"/>
+                </a:solidFill>
+                <a:latin typeface="Consolas" pitchFamily="34" charset="0"/>
+                <a:ea typeface="Consolas" pitchFamily="34" charset="-122"/>
+                <a:cs typeface="Consolas" pitchFamily="34" charset="-120"/>
+              </a:rPr>
+              <a:t>BuildSequential</a:t>
+            </a:r>
+            <a:pPr indent="0" marL="0">
+              <a:buNone/>
+            </a:pPr>
+            <a:r>
+              <a:rPr lang="en-US" sz="1200" dirty="0">
+                <a:solidFill>
+                  <a:srgbClr val="B8B5D9"/>
+                </a:solidFill>
+                <a:latin typeface="Consolas" pitchFamily="34" charset="0"/>
+                <a:ea typeface="Consolas" pitchFamily="34" charset="-122"/>
+                <a:cs typeface="Consolas" pitchFamily="34" charset="-120"/>
+              </a:rPr>
+              <a:t>(</a:t>
+            </a:r>
+            <a:pPr indent="0" marL="0">
+              <a:buNone/>
+            </a:pPr>
+            <a:r>
+              <a:rPr lang="en-US" sz="1200" dirty="0">
+                <a:solidFill>
+                  <a:srgbClr val="FBBF24"/>
+                </a:solidFill>
+                <a:latin typeface="Consolas" pitchFamily="34" charset="0"/>
+                <a:ea typeface="Consolas" pitchFamily="34" charset="-122"/>
+                <a:cs typeface="Consolas" pitchFamily="34" charset="-120"/>
+              </a:rPr>
+              <a:t>"local-then-cloud"</a:t>
+            </a:r>
+            <a:pPr indent="0" marL="0">
+              <a:buNone/>
+            </a:pPr>
+            <a:r>
+              <a:rPr lang="en-US" sz="1200" dirty="0">
+                <a:solidFill>
+                  <a:srgbClr val="B8B5D9"/>
+                </a:solidFill>
+                <a:latin typeface="Consolas" pitchFamily="34" charset="0"/>
+                <a:ea typeface="Consolas" pitchFamily="34" charset="-122"/>
+                <a:cs typeface="Consolas" pitchFamily="34" charset="-120"/>
+              </a:rPr>
+              <a:t>,</a:t>
+            </a:r>
+            <a:pPr indent="0" marL="0">
+              <a:buNone/>
+            </a:pPr>
+            <a:r>
+              <a:rPr lang="en-US" sz="1200" dirty="0">
+                <a:solidFill>
+                  <a:srgbClr val="FAF8FF"/>
+                </a:solidFill>
+                <a:latin typeface="Consolas" pitchFamily="34" charset="0"/>
+                <a:ea typeface="Consolas" pitchFamily="34" charset="-122"/>
+                <a:cs typeface="Consolas" pitchFamily="34" charset="-120"/>
+              </a:rPr>
+              <a:t> triage</a:t>
+            </a:r>
+            <a:pPr indent="0" marL="0">
+              <a:buNone/>
+            </a:pPr>
+            <a:r>
+              <a:rPr lang="en-US" sz="1200" dirty="0">
+                <a:solidFill>
+                  <a:srgbClr val="B8B5D9"/>
+                </a:solidFill>
+                <a:latin typeface="Consolas" pitchFamily="34" charset="0"/>
+                <a:ea typeface="Consolas" pitchFamily="34" charset="-122"/>
+                <a:cs typeface="Consolas" pitchFamily="34" charset="-120"/>
+              </a:rPr>
+              <a:t>,</a:t>
+            </a:r>
+            <a:pPr indent="0" marL="0">
+              <a:buNone/>
+            </a:pPr>
+            <a:r>
+              <a:rPr lang="en-US" sz="1200" dirty="0">
+                <a:solidFill>
+                  <a:srgbClr val="FAF8FF"/>
+                </a:solidFill>
+                <a:latin typeface="Consolas" pitchFamily="34" charset="0"/>
+                <a:ea typeface="Consolas" pitchFamily="34" charset="-122"/>
+                <a:cs typeface="Consolas" pitchFamily="34" charset="-120"/>
+              </a:rPr>
+              <a:t> expert</a:t>
+            </a:r>
+            <a:pPr indent="0" marL="0">
+              <a:buNone/>
+            </a:pPr>
+            <a:r>
+              <a:rPr lang="en-US" sz="1200" dirty="0">
+                <a:solidFill>
+                  <a:srgbClr val="B8B5D9"/>
+                </a:solidFill>
+                <a:latin typeface="Consolas" pitchFamily="34" charset="0"/>
+                <a:ea typeface="Consolas" pitchFamily="34" charset="-122"/>
+                <a:cs typeface="Consolas" pitchFamily="34" charset="-120"/>
+              </a:rPr>
+              <a:t>)</a:t>
+            </a:r>
+            <a:pPr indent="0" marL="0">
+              <a:buNone/>
+            </a:pPr>
+            <a:endParaRPr lang="en-US" sz="1200" dirty="0"/>
+          </a:p>
+          <a:p>
+            <a:pPr indent="0" marL="0">
+              <a:buNone/>
+            </a:pPr>
+            <a:r>
+              <a:rPr lang="en-US" sz="1200" dirty="0">
+                <a:solidFill>
+                  <a:srgbClr val="FAF8FF"/>
+                </a:solidFill>
+                <a:latin typeface="Consolas" pitchFamily="34" charset="0"/>
+                <a:ea typeface="Consolas" pitchFamily="34" charset="-122"/>
+                <a:cs typeface="Consolas" pitchFamily="34" charset="-120"/>
+              </a:rPr>
+              <a:t>    </a:t>
+            </a:r>
+            <a:pPr indent="0" marL="0">
+              <a:buNone/>
+            </a:pPr>
+            <a:r>
+              <a:rPr lang="en-US" sz="1200" dirty="0">
+                <a:solidFill>
+                  <a:srgbClr val="B8B5D9"/>
+                </a:solidFill>
+                <a:latin typeface="Consolas" pitchFamily="34" charset="0"/>
+                <a:ea typeface="Consolas" pitchFamily="34" charset="-122"/>
+                <a:cs typeface="Consolas" pitchFamily="34" charset="-120"/>
+              </a:rPr>
+              <a:t>.</a:t>
+            </a:r>
+            <a:pPr indent="0" marL="0">
+              <a:buNone/>
+            </a:pPr>
+            <a:r>
+              <a:rPr lang="en-US" sz="1200" dirty="0">
+                <a:solidFill>
+                  <a:srgbClr val="86EFAC"/>
+                </a:solidFill>
+                <a:latin typeface="Consolas" pitchFamily="34" charset="0"/>
+                <a:ea typeface="Consolas" pitchFamily="34" charset="-122"/>
+                <a:cs typeface="Consolas" pitchFamily="34" charset="-120"/>
+              </a:rPr>
+              <a:t>AsAgent</a:t>
+            </a:r>
+            <a:pPr indent="0" marL="0">
+              <a:buNone/>
+            </a:pPr>
+            <a:r>
+              <a:rPr lang="en-US" sz="1200" dirty="0">
+                <a:solidFill>
+                  <a:srgbClr val="B8B5D9"/>
+                </a:solidFill>
+                <a:latin typeface="Consolas" pitchFamily="34" charset="0"/>
+                <a:ea typeface="Consolas" pitchFamily="34" charset="-122"/>
+                <a:cs typeface="Consolas" pitchFamily="34" charset="-120"/>
+              </a:rPr>
+              <a:t>(</a:t>
+            </a:r>
+            <a:pPr indent="0" marL="0">
+              <a:buNone/>
+            </a:pPr>
+            <a:r>
+              <a:rPr lang="en-US" sz="1200" dirty="0">
+                <a:solidFill>
+                  <a:srgbClr val="B8B5D9"/>
+                </a:solidFill>
+                <a:latin typeface="Consolas" pitchFamily="34" charset="0"/>
+                <a:ea typeface="Consolas" pitchFamily="34" charset="-122"/>
+                <a:cs typeface="Consolas" pitchFamily="34" charset="-120"/>
+              </a:rPr>
+              <a:t>)</a:t>
+            </a:r>
+            <a:pPr indent="0" marL="0">
+              <a:buNone/>
+            </a:pPr>
+            <a:r>
+              <a:rPr lang="en-US" sz="1200" dirty="0">
+                <a:solidFill>
+                  <a:srgbClr val="B8B5D9"/>
+                </a:solidFill>
+                <a:latin typeface="Consolas" pitchFamily="34" charset="0"/>
+                <a:ea typeface="Consolas" pitchFamily="34" charset="-122"/>
+                <a:cs typeface="Consolas" pitchFamily="34" charset="-120"/>
+              </a:rPr>
+              <a:t>;</a:t>
+            </a:r>
+            <a:pPr indent="0" marL="0">
+              <a:buNone/>
+            </a:pPr>
+            <a:endParaRPr lang="en-US" sz="1200" dirty="0"/>
+          </a:p>
+          <a:p>
+            <a:pPr indent="0" marL="0">
+              <a:buNone/>
+            </a:pPr>
+            <a:endParaRPr lang="en-US" sz="1200" dirty="0"/>
+          </a:p>
+          <a:p>
+            <a:pPr indent="0" marL="0">
+              <a:buNone/>
+            </a:pPr>
+            <a:r>
+              <a:rPr lang="en-US" sz="1200" dirty="0">
+                <a:solidFill>
+                  <a:srgbClr val="FB7185"/>
+                </a:solidFill>
+                <a:latin typeface="Consolas" pitchFamily="34" charset="0"/>
+                <a:ea typeface="Consolas" pitchFamily="34" charset="-122"/>
+                <a:cs typeface="Consolas" pitchFamily="34" charset="-120"/>
+              </a:rPr>
+              <a:t>await</a:t>
+            </a:r>
+            <a:pPr indent="0" marL="0">
+              <a:buNone/>
+            </a:pPr>
+            <a:r>
+              <a:rPr lang="en-US" sz="1200" dirty="0">
+                <a:solidFill>
+                  <a:srgbClr val="FAF8FF"/>
+                </a:solidFill>
+                <a:latin typeface="Consolas" pitchFamily="34" charset="0"/>
+                <a:ea typeface="Consolas" pitchFamily="34" charset="-122"/>
+                <a:cs typeface="Consolas" pitchFamily="34" charset="-120"/>
+              </a:rPr>
               <a:t> </a:t>
             </a:r>
             <a:pPr indent="0" marL="0">
               <a:buNone/>
             </a:pPr>
             <a:r>
-              <a:rPr lang="en-US" sz="1400" dirty="0">
+              <a:rPr lang="en-US" sz="1200" dirty="0">
                 <a:solidFill>
                   <a:srgbClr val="FB7185"/>
                 </a:solidFill>
@@ -6932,13 +8495,13 @@
                 <a:ea typeface="Consolas" pitchFamily="34" charset="-122"/>
                 <a:cs typeface="Consolas" pitchFamily="34" charset="-120"/>
               </a:rPr>
-              <a:t>await</a:t>
-            </a:r>
-            <a:pPr indent="0" marL="0">
-              <a:buNone/>
-            </a:pPr>
-            <a:r>
-              <a:rPr lang="en-US" sz="1400" dirty="0">
+              <a:t>foreach</a:t>
+            </a:r>
+            <a:pPr indent="0" marL="0">
+              <a:buNone/>
+            </a:pPr>
+            <a:r>
+              <a:rPr lang="en-US" sz="1200" dirty="0">
                 <a:solidFill>
                   <a:srgbClr val="FAF8FF"/>
                 </a:solidFill>
@@ -6946,13 +8509,13 @@
                 <a:ea typeface="Consolas" pitchFamily="34" charset="-122"/>
                 <a:cs typeface="Consolas" pitchFamily="34" charset="-120"/>
               </a:rPr>
-              <a:t> FoundryLocalManager</a:t>
-            </a:r>
-            <a:pPr indent="0" marL="0">
-              <a:buNone/>
-            </a:pPr>
-            <a:r>
-              <a:rPr lang="en-US" sz="1400" dirty="0">
+              <a:t> </a:t>
+            </a:r>
+            <a:pPr indent="0" marL="0">
+              <a:buNone/>
+            </a:pPr>
+            <a:r>
+              <a:rPr lang="en-US" sz="1200" dirty="0">
                 <a:solidFill>
                   <a:srgbClr val="B8B5D9"/>
                 </a:solidFill>
@@ -6960,13 +8523,83 @@
                 <a:ea typeface="Consolas" pitchFamily="34" charset="-122"/>
                 <a:cs typeface="Consolas" pitchFamily="34" charset="-120"/>
               </a:rPr>
+              <a:t>(</a:t>
+            </a:r>
+            <a:pPr indent="0" marL="0">
+              <a:buNone/>
+            </a:pPr>
+            <a:r>
+              <a:rPr lang="en-US" sz="1200" dirty="0">
+                <a:solidFill>
+                  <a:srgbClr val="FB7185"/>
+                </a:solidFill>
+                <a:latin typeface="Consolas" pitchFamily="34" charset="0"/>
+                <a:ea typeface="Consolas" pitchFamily="34" charset="-122"/>
+                <a:cs typeface="Consolas" pitchFamily="34" charset="-120"/>
+              </a:rPr>
+              <a:t>var</a:t>
+            </a:r>
+            <a:pPr indent="0" marL="0">
+              <a:buNone/>
+            </a:pPr>
+            <a:r>
+              <a:rPr lang="en-US" sz="1200" dirty="0">
+                <a:solidFill>
+                  <a:srgbClr val="FAF8FF"/>
+                </a:solidFill>
+                <a:latin typeface="Consolas" pitchFamily="34" charset="0"/>
+                <a:ea typeface="Consolas" pitchFamily="34" charset="-122"/>
+                <a:cs typeface="Consolas" pitchFamily="34" charset="-120"/>
+              </a:rPr>
+              <a:t> update </a:t>
+            </a:r>
+            <a:pPr indent="0" marL="0">
+              <a:buNone/>
+            </a:pPr>
+            <a:r>
+              <a:rPr lang="en-US" sz="1200" dirty="0">
+                <a:solidFill>
+                  <a:srgbClr val="FB7185"/>
+                </a:solidFill>
+                <a:latin typeface="Consolas" pitchFamily="34" charset="0"/>
+                <a:ea typeface="Consolas" pitchFamily="34" charset="-122"/>
+                <a:cs typeface="Consolas" pitchFamily="34" charset="-120"/>
+              </a:rPr>
+              <a:t>in</a:t>
+            </a:r>
+            <a:pPr indent="0" marL="0">
+              <a:buNone/>
+            </a:pPr>
+            <a:r>
+              <a:rPr lang="en-US" sz="1200" dirty="0">
+                <a:solidFill>
+                  <a:srgbClr val="FAF8FF"/>
+                </a:solidFill>
+                <a:latin typeface="Consolas" pitchFamily="34" charset="0"/>
+                <a:ea typeface="Consolas" pitchFamily="34" charset="-122"/>
+                <a:cs typeface="Consolas" pitchFamily="34" charset="-120"/>
+              </a:rPr>
+              <a:t> workflow</a:t>
+            </a:r>
+            <a:pPr indent="0" marL="0">
+              <a:buNone/>
+            </a:pPr>
+            <a:r>
+              <a:rPr lang="en-US" sz="1200" dirty="0">
+                <a:solidFill>
+                  <a:srgbClr val="B8B5D9"/>
+                </a:solidFill>
+                <a:latin typeface="Consolas" pitchFamily="34" charset="0"/>
+                <a:ea typeface="Consolas" pitchFamily="34" charset="-122"/>
+                <a:cs typeface="Consolas" pitchFamily="34" charset="-120"/>
+              </a:rPr>
               <a:t>.</a:t>
             </a:r>
             <a:pPr indent="0" marL="0">
               <a:buNone/>
             </a:pPr>
             <a:r>
-              <a:rPr lang="en-US" sz="1400" dirty="0">
+              <a:rPr lang="en-US" sz="1200" dirty="0">
                 <a:solidFill>
                   <a:srgbClr val="86EFAC"/>
                 </a:solidFill>
@@ -6974,13 +8607,13 @@
                 <a:ea typeface="Consolas" pitchFamily="34" charset="-122"/>
                 <a:cs typeface="Consolas" pitchFamily="34" charset="-120"/>
               </a:rPr>
-              <a:t>StartModelAsync</a:t>
-            </a:r>
-            <a:pPr indent="0" marL="0">
-              <a:buNone/>
-            </a:pPr>
-            <a:r>
-              <a:rPr lang="en-US" sz="1400" dirty="0">
+              <a:t>RunStreamingAsync</a:t>
+            </a:r>
+            <a:pPr indent="0" marL="0">
+              <a:buNone/>
+            </a:pPr>
+            <a:r>
+              <a:rPr lang="en-US" sz="1200" dirty="0">
                 <a:solidFill>
                   <a:srgbClr val="B8B5D9"/>
                 </a:solidFill>
@@ -6994,21 +8627,21 @@
               <a:buNone/>
             </a:pPr>
             <a:r>
-              <a:rPr lang="en-US" sz="1400" dirty="0">
-                <a:solidFill>
-                  <a:srgbClr val="FBBF24"/>
-                </a:solidFill>
-                <a:latin typeface="Consolas" pitchFamily="34" charset="0"/>
-                <a:ea typeface="Consolas" pitchFamily="34" charset="-122"/>
-                <a:cs typeface="Consolas" pitchFamily="34" charset="-120"/>
-              </a:rPr>
-              <a:t>"phi-4-mini"</a:t>
-            </a:r>
-            <a:pPr indent="0" marL="0">
-              <a:buNone/>
-            </a:pPr>
-            <a:r>
-              <a:rPr lang="en-US" sz="1400" dirty="0">
+              <a:rPr lang="en-US" sz="1200" dirty="0">
+                <a:solidFill>
+                  <a:srgbClr val="FAF8FF"/>
+                </a:solidFill>
+                <a:latin typeface="Consolas" pitchFamily="34" charset="0"/>
+                <a:ea typeface="Consolas" pitchFamily="34" charset="-122"/>
+                <a:cs typeface="Consolas" pitchFamily="34" charset="-120"/>
+              </a:rPr>
+              <a:t>userInput</a:t>
+            </a:r>
+            <a:pPr indent="0" marL="0">
+              <a:buNone/>
+            </a:pPr>
+            <a:r>
+              <a:rPr lang="en-US" sz="1200" dirty="0">
                 <a:solidFill>
                   <a:srgbClr val="B8B5D9"/>
                 </a:solidFill>
@@ -7022,7 +8655,7 @@
               <a:buNone/>
             </a:pPr>
             <a:r>
-              <a:rPr lang="en-US" sz="1400" dirty="0">
+              <a:rPr lang="en-US" sz="1200" dirty="0">
                 <a:solidFill>
                   <a:srgbClr val="B8B5D9"/>
                 </a:solidFill>
@@ -7030,1195 +8663,141 @@
                 <a:ea typeface="Consolas" pitchFamily="34" charset="-122"/>
                 <a:cs typeface="Consolas" pitchFamily="34" charset="-120"/>
               </a:rPr>
+              <a:t>)</a:t>
+            </a:r>
+            <a:pPr indent="0" marL="0">
+              <a:buNone/>
+            </a:pPr>
+            <a:endParaRPr lang="en-US" sz="1200" dirty="0"/>
+          </a:p>
+          <a:p>
+            <a:pPr indent="0" marL="0">
+              <a:buNone/>
+            </a:pPr>
+            <a:r>
+              <a:rPr lang="en-US" sz="1200" dirty="0">
+                <a:solidFill>
+                  <a:srgbClr val="FAF8FF"/>
+                </a:solidFill>
+                <a:latin typeface="Consolas" pitchFamily="34" charset="0"/>
+                <a:ea typeface="Consolas" pitchFamily="34" charset="-122"/>
+                <a:cs typeface="Consolas" pitchFamily="34" charset="-120"/>
+              </a:rPr>
+              <a:t>    Console</a:t>
+            </a:r>
+            <a:pPr indent="0" marL="0">
+              <a:buNone/>
+            </a:pPr>
+            <a:r>
+              <a:rPr lang="en-US" sz="1200" dirty="0">
+                <a:solidFill>
+                  <a:srgbClr val="B8B5D9"/>
+                </a:solidFill>
+                <a:latin typeface="Consolas" pitchFamily="34" charset="0"/>
+                <a:ea typeface="Consolas" pitchFamily="34" charset="-122"/>
+                <a:cs typeface="Consolas" pitchFamily="34" charset="-120"/>
+              </a:rPr>
+              <a:t>.</a:t>
+            </a:r>
+            <a:pPr indent="0" marL="0">
+              <a:buNone/>
+            </a:pPr>
+            <a:r>
+              <a:rPr lang="en-US" sz="1200" dirty="0">
+                <a:solidFill>
+                  <a:srgbClr val="86EFAC"/>
+                </a:solidFill>
+                <a:latin typeface="Consolas" pitchFamily="34" charset="0"/>
+                <a:ea typeface="Consolas" pitchFamily="34" charset="-122"/>
+                <a:cs typeface="Consolas" pitchFamily="34" charset="-120"/>
+              </a:rPr>
+              <a:t>Write</a:t>
+            </a:r>
+            <a:pPr indent="0" marL="0">
+              <a:buNone/>
+            </a:pPr>
+            <a:r>
+              <a:rPr lang="en-US" sz="1200" dirty="0">
+                <a:solidFill>
+                  <a:srgbClr val="B8B5D9"/>
+                </a:solidFill>
+                <a:latin typeface="Consolas" pitchFamily="34" charset="0"/>
+                <a:ea typeface="Consolas" pitchFamily="34" charset="-122"/>
+                <a:cs typeface="Consolas" pitchFamily="34" charset="-120"/>
+              </a:rPr>
+              <a:t>(</a:t>
+            </a:r>
+            <a:pPr indent="0" marL="0">
+              <a:buNone/>
+            </a:pPr>
+            <a:r>
+              <a:rPr lang="en-US" sz="1200" dirty="0">
+                <a:solidFill>
+                  <a:srgbClr val="FAF8FF"/>
+                </a:solidFill>
+                <a:latin typeface="Consolas" pitchFamily="34" charset="0"/>
+                <a:ea typeface="Consolas" pitchFamily="34" charset="-122"/>
+                <a:cs typeface="Consolas" pitchFamily="34" charset="-120"/>
+              </a:rPr>
+              <a:t>update</a:t>
+            </a:r>
+            <a:pPr indent="0" marL="0">
+              <a:buNone/>
+            </a:pPr>
+            <a:r>
+              <a:rPr lang="en-US" sz="1200" dirty="0">
+                <a:solidFill>
+                  <a:srgbClr val="B8B5D9"/>
+                </a:solidFill>
+                <a:latin typeface="Consolas" pitchFamily="34" charset="0"/>
+                <a:ea typeface="Consolas" pitchFamily="34" charset="-122"/>
+                <a:cs typeface="Consolas" pitchFamily="34" charset="-120"/>
+              </a:rPr>
+              <a:t>.</a:t>
+            </a:r>
+            <a:pPr indent="0" marL="0">
+              <a:buNone/>
+            </a:pPr>
+            <a:r>
+              <a:rPr lang="en-US" sz="1200" dirty="0">
+                <a:solidFill>
+                  <a:srgbClr val="FAF8FF"/>
+                </a:solidFill>
+                <a:latin typeface="Consolas" pitchFamily="34" charset="0"/>
+                <a:ea typeface="Consolas" pitchFamily="34" charset="-122"/>
+                <a:cs typeface="Consolas" pitchFamily="34" charset="-120"/>
+              </a:rPr>
+              <a:t>Text</a:t>
+            </a:r>
+            <a:pPr indent="0" marL="0">
+              <a:buNone/>
+            </a:pPr>
+            <a:r>
+              <a:rPr lang="en-US" sz="1200" dirty="0">
+                <a:solidFill>
+                  <a:srgbClr val="B8B5D9"/>
+                </a:solidFill>
+                <a:latin typeface="Consolas" pitchFamily="34" charset="0"/>
+                <a:ea typeface="Consolas" pitchFamily="34" charset="-122"/>
+                <a:cs typeface="Consolas" pitchFamily="34" charset="-120"/>
+              </a:rPr>
+              <a:t>)</a:t>
+            </a:r>
+            <a:pPr indent="0" marL="0">
+              <a:buNone/>
+            </a:pPr>
+            <a:r>
+              <a:rPr lang="en-US" sz="1200" dirty="0">
+                <a:solidFill>
+                  <a:srgbClr val="B8B5D9"/>
+                </a:solidFill>
+                <a:latin typeface="Consolas" pitchFamily="34" charset="0"/>
+                <a:ea typeface="Consolas" pitchFamily="34" charset="-122"/>
+                <a:cs typeface="Consolas" pitchFamily="34" charset="-120"/>
+              </a:rPr>
               <a:t>;</a:t>
             </a:r>
-            <a:pPr indent="0" marL="0">
-              <a:buNone/>
-            </a:pPr>
-            <a:endParaRPr lang="en-US" sz="1400" dirty="0"/>
-          </a:p>
-          <a:p>
-            <a:pPr indent="0" marL="0">
-              <a:buNone/>
-            </a:pPr>
-            <a:r>
-              <a:rPr lang="en-US" sz="1400" dirty="0">
-                <a:solidFill>
-                  <a:srgbClr val="FAF8FF"/>
-                </a:solidFill>
-                <a:latin typeface="Consolas" pitchFamily="34" charset="0"/>
-                <a:ea typeface="Consolas" pitchFamily="34" charset="-122"/>
-                <a:cs typeface="Consolas" pitchFamily="34" charset="-120"/>
-              </a:rPr>
-              <a:t>chatClient </a:t>
-            </a:r>
-            <a:pPr indent="0" marL="0">
-              <a:buNone/>
-            </a:pPr>
-            <a:r>
-              <a:rPr lang="en-US" sz="1400" dirty="0">
-                <a:solidFill>
-                  <a:srgbClr val="CFCBED"/>
-                </a:solidFill>
-                <a:latin typeface="Consolas" pitchFamily="34" charset="0"/>
-                <a:ea typeface="Consolas" pitchFamily="34" charset="-122"/>
-                <a:cs typeface="Consolas" pitchFamily="34" charset="-120"/>
-              </a:rPr>
-              <a:t>=</a:t>
-            </a:r>
-            <a:pPr indent="0" marL="0">
-              <a:buNone/>
-            </a:pPr>
-            <a:r>
-              <a:rPr lang="en-US" sz="1400" dirty="0">
-                <a:solidFill>
-                  <a:srgbClr val="FAF8FF"/>
-                </a:solidFill>
-                <a:latin typeface="Consolas" pitchFamily="34" charset="0"/>
-                <a:ea typeface="Consolas" pitchFamily="34" charset="-122"/>
-                <a:cs typeface="Consolas" pitchFamily="34" charset="-120"/>
-              </a:rPr>
-              <a:t> </a:t>
-            </a:r>
-            <a:pPr indent="0" marL="0">
-              <a:buNone/>
-            </a:pPr>
-            <a:r>
-              <a:rPr lang="en-US" sz="1400" dirty="0">
-                <a:solidFill>
-                  <a:srgbClr val="FB7185"/>
-                </a:solidFill>
-                <a:latin typeface="Consolas" pitchFamily="34" charset="0"/>
-                <a:ea typeface="Consolas" pitchFamily="34" charset="-122"/>
-                <a:cs typeface="Consolas" pitchFamily="34" charset="-120"/>
-              </a:rPr>
-              <a:t>new</a:t>
-            </a:r>
-            <a:pPr indent="0" marL="0">
-              <a:buNone/>
-            </a:pPr>
-            <a:r>
-              <a:rPr lang="en-US" sz="1400" dirty="0">
-                <a:solidFill>
-                  <a:srgbClr val="FAF8FF"/>
-                </a:solidFill>
-                <a:latin typeface="Consolas" pitchFamily="34" charset="0"/>
-                <a:ea typeface="Consolas" pitchFamily="34" charset="-122"/>
-                <a:cs typeface="Consolas" pitchFamily="34" charset="-120"/>
-              </a:rPr>
-              <a:t> </a:t>
-            </a:r>
-            <a:pPr indent="0" marL="0">
-              <a:buNone/>
-            </a:pPr>
-            <a:r>
-              <a:rPr lang="en-US" sz="1400" dirty="0">
-                <a:solidFill>
-                  <a:srgbClr val="FAF8FF"/>
-                </a:solidFill>
-                <a:latin typeface="Consolas" pitchFamily="34" charset="0"/>
-                <a:ea typeface="Consolas" pitchFamily="34" charset="-122"/>
-                <a:cs typeface="Consolas" pitchFamily="34" charset="-120"/>
-              </a:rPr>
-              <a:t>OpenAIClient</a:t>
-            </a:r>
-            <a:pPr indent="0" marL="0">
-              <a:buNone/>
-            </a:pPr>
-            <a:r>
-              <a:rPr lang="en-US" sz="1400" dirty="0">
-                <a:solidFill>
-                  <a:srgbClr val="B8B5D9"/>
-                </a:solidFill>
-                <a:latin typeface="Consolas" pitchFamily="34" charset="0"/>
-                <a:ea typeface="Consolas" pitchFamily="34" charset="-122"/>
-                <a:cs typeface="Consolas" pitchFamily="34" charset="-120"/>
-              </a:rPr>
-              <a:t>(</a:t>
-            </a:r>
-            <a:pPr indent="0" marL="0">
-              <a:buNone/>
-            </a:pPr>
-            <a:endParaRPr lang="en-US" sz="1400" dirty="0"/>
-          </a:p>
-          <a:p>
-            <a:pPr indent="0" marL="0">
-              <a:buNone/>
-            </a:pPr>
-            <a:r>
-              <a:rPr lang="en-US" sz="1400" dirty="0">
-                <a:solidFill>
-                  <a:srgbClr val="FAF8FF"/>
-                </a:solidFill>
-                <a:latin typeface="Consolas" pitchFamily="34" charset="0"/>
-                <a:ea typeface="Consolas" pitchFamily="34" charset="-122"/>
-                <a:cs typeface="Consolas" pitchFamily="34" charset="-120"/>
-              </a:rPr>
-              <a:t>        </a:t>
-            </a:r>
-            <a:pPr indent="0" marL="0">
-              <a:buNone/>
-            </a:pPr>
-            <a:r>
-              <a:rPr lang="en-US" sz="1400" dirty="0">
-                <a:solidFill>
-                  <a:srgbClr val="FB7185"/>
-                </a:solidFill>
-                <a:latin typeface="Consolas" pitchFamily="34" charset="0"/>
-                <a:ea typeface="Consolas" pitchFamily="34" charset="-122"/>
-                <a:cs typeface="Consolas" pitchFamily="34" charset="-120"/>
-              </a:rPr>
-              <a:t>new</a:t>
-            </a:r>
-            <a:pPr indent="0" marL="0">
-              <a:buNone/>
-            </a:pPr>
-            <a:r>
-              <a:rPr lang="en-US" sz="1400" dirty="0">
-                <a:solidFill>
-                  <a:srgbClr val="FAF8FF"/>
-                </a:solidFill>
-                <a:latin typeface="Consolas" pitchFamily="34" charset="0"/>
-                <a:ea typeface="Consolas" pitchFamily="34" charset="-122"/>
-                <a:cs typeface="Consolas" pitchFamily="34" charset="-120"/>
-              </a:rPr>
-              <a:t> </a:t>
-            </a:r>
-            <a:pPr indent="0" marL="0">
-              <a:buNone/>
-            </a:pPr>
-            <a:r>
-              <a:rPr lang="en-US" sz="1400" dirty="0">
-                <a:solidFill>
-                  <a:srgbClr val="FAF8FF"/>
-                </a:solidFill>
-                <a:latin typeface="Consolas" pitchFamily="34" charset="0"/>
-                <a:ea typeface="Consolas" pitchFamily="34" charset="-122"/>
-                <a:cs typeface="Consolas" pitchFamily="34" charset="-120"/>
-              </a:rPr>
-              <a:t>ApiKeyCredential</a:t>
-            </a:r>
-            <a:pPr indent="0" marL="0">
-              <a:buNone/>
-            </a:pPr>
-            <a:r>
-              <a:rPr lang="en-US" sz="1400" dirty="0">
-                <a:solidFill>
-                  <a:srgbClr val="B8B5D9"/>
-                </a:solidFill>
-                <a:latin typeface="Consolas" pitchFamily="34" charset="0"/>
-                <a:ea typeface="Consolas" pitchFamily="34" charset="-122"/>
-                <a:cs typeface="Consolas" pitchFamily="34" charset="-120"/>
-              </a:rPr>
-              <a:t>(</a:t>
-            </a:r>
-            <a:pPr indent="0" marL="0">
-              <a:buNone/>
-            </a:pPr>
-            <a:r>
-              <a:rPr lang="en-US" sz="1400" dirty="0">
-                <a:solidFill>
-                  <a:srgbClr val="FBBF24"/>
-                </a:solidFill>
-                <a:latin typeface="Consolas" pitchFamily="34" charset="0"/>
-                <a:ea typeface="Consolas" pitchFamily="34" charset="-122"/>
-                <a:cs typeface="Consolas" pitchFamily="34" charset="-120"/>
-              </a:rPr>
-              <a:t>"nope"</a:t>
-            </a:r>
-            <a:pPr indent="0" marL="0">
-              <a:buNone/>
-            </a:pPr>
-            <a:r>
-              <a:rPr lang="en-US" sz="1400" dirty="0">
-                <a:solidFill>
-                  <a:srgbClr val="B8B5D9"/>
-                </a:solidFill>
-                <a:latin typeface="Consolas" pitchFamily="34" charset="0"/>
-                <a:ea typeface="Consolas" pitchFamily="34" charset="-122"/>
-                <a:cs typeface="Consolas" pitchFamily="34" charset="-120"/>
-              </a:rPr>
-              <a:t>)</a:t>
-            </a:r>
-            <a:pPr indent="0" marL="0">
-              <a:buNone/>
-            </a:pPr>
-            <a:r>
-              <a:rPr lang="en-US" sz="1400" dirty="0">
-                <a:solidFill>
-                  <a:srgbClr val="B8B5D9"/>
-                </a:solidFill>
-                <a:latin typeface="Consolas" pitchFamily="34" charset="0"/>
-                <a:ea typeface="Consolas" pitchFamily="34" charset="-122"/>
-                <a:cs typeface="Consolas" pitchFamily="34" charset="-120"/>
-              </a:rPr>
-              <a:t>,</a:t>
-            </a:r>
-            <a:pPr indent="0" marL="0">
-              <a:buNone/>
-            </a:pPr>
-            <a:endParaRPr lang="en-US" sz="1400" dirty="0"/>
-          </a:p>
-          <a:p>
-            <a:pPr indent="0" marL="0">
-              <a:buNone/>
-            </a:pPr>
-            <a:r>
-              <a:rPr lang="en-US" sz="1400" dirty="0">
-                <a:solidFill>
-                  <a:srgbClr val="FAF8FF"/>
-                </a:solidFill>
-                <a:latin typeface="Consolas" pitchFamily="34" charset="0"/>
-                <a:ea typeface="Consolas" pitchFamily="34" charset="-122"/>
-                <a:cs typeface="Consolas" pitchFamily="34" charset="-120"/>
-              </a:rPr>
-              <a:t>        </a:t>
-            </a:r>
-            <a:pPr indent="0" marL="0">
-              <a:buNone/>
-            </a:pPr>
-            <a:r>
-              <a:rPr lang="en-US" sz="1400" dirty="0">
-                <a:solidFill>
-                  <a:srgbClr val="FB7185"/>
-                </a:solidFill>
-                <a:latin typeface="Consolas" pitchFamily="34" charset="0"/>
-                <a:ea typeface="Consolas" pitchFamily="34" charset="-122"/>
-                <a:cs typeface="Consolas" pitchFamily="34" charset="-120"/>
-              </a:rPr>
-              <a:t>new</a:t>
-            </a:r>
-            <a:pPr indent="0" marL="0">
-              <a:buNone/>
-            </a:pPr>
-            <a:r>
-              <a:rPr lang="en-US" sz="1400" dirty="0">
-                <a:solidFill>
-                  <a:srgbClr val="FAF8FF"/>
-                </a:solidFill>
-                <a:latin typeface="Consolas" pitchFamily="34" charset="0"/>
-                <a:ea typeface="Consolas" pitchFamily="34" charset="-122"/>
-                <a:cs typeface="Consolas" pitchFamily="34" charset="-120"/>
-              </a:rPr>
-              <a:t> </a:t>
-            </a:r>
-            <a:pPr indent="0" marL="0">
-              <a:buNone/>
-            </a:pPr>
-            <a:r>
-              <a:rPr lang="en-US" sz="1400" dirty="0">
-                <a:solidFill>
-                  <a:srgbClr val="FAF8FF"/>
-                </a:solidFill>
-                <a:latin typeface="Consolas" pitchFamily="34" charset="0"/>
-                <a:ea typeface="Consolas" pitchFamily="34" charset="-122"/>
-                <a:cs typeface="Consolas" pitchFamily="34" charset="-120"/>
-              </a:rPr>
-              <a:t>OpenAIClientOptions</a:t>
-            </a:r>
-            <a:pPr indent="0" marL="0">
-              <a:buNone/>
-            </a:pPr>
-            <a:r>
-              <a:rPr lang="en-US" sz="1400" dirty="0">
-                <a:solidFill>
-                  <a:srgbClr val="FAF8FF"/>
-                </a:solidFill>
-                <a:latin typeface="Consolas" pitchFamily="34" charset="0"/>
-                <a:ea typeface="Consolas" pitchFamily="34" charset="-122"/>
-                <a:cs typeface="Consolas" pitchFamily="34" charset="-120"/>
-              </a:rPr>
-              <a:t> </a:t>
-            </a:r>
-            <a:pPr indent="0" marL="0">
-              <a:buNone/>
-            </a:pPr>
-            <a:r>
-              <a:rPr lang="en-US" sz="1400" dirty="0">
-                <a:solidFill>
-                  <a:srgbClr val="B8B5D9"/>
-                </a:solidFill>
-                <a:latin typeface="Consolas" pitchFamily="34" charset="0"/>
-                <a:ea typeface="Consolas" pitchFamily="34" charset="-122"/>
-                <a:cs typeface="Consolas" pitchFamily="34" charset="-120"/>
-              </a:rPr>
-              <a:t>{</a:t>
-            </a:r>
-            <a:pPr indent="0" marL="0">
-              <a:buNone/>
-            </a:pPr>
-            <a:r>
-              <a:rPr lang="en-US" sz="1400" dirty="0">
-                <a:solidFill>
-                  <a:srgbClr val="FAF8FF"/>
-                </a:solidFill>
-                <a:latin typeface="Consolas" pitchFamily="34" charset="0"/>
-                <a:ea typeface="Consolas" pitchFamily="34" charset="-122"/>
-                <a:cs typeface="Consolas" pitchFamily="34" charset="-120"/>
-              </a:rPr>
-              <a:t> Endpoint </a:t>
-            </a:r>
-            <a:pPr indent="0" marL="0">
-              <a:buNone/>
-            </a:pPr>
-            <a:r>
-              <a:rPr lang="en-US" sz="1400" dirty="0">
-                <a:solidFill>
-                  <a:srgbClr val="CFCBED"/>
-                </a:solidFill>
-                <a:latin typeface="Consolas" pitchFamily="34" charset="0"/>
-                <a:ea typeface="Consolas" pitchFamily="34" charset="-122"/>
-                <a:cs typeface="Consolas" pitchFamily="34" charset="-120"/>
-              </a:rPr>
-              <a:t>=</a:t>
-            </a:r>
-            <a:pPr indent="0" marL="0">
-              <a:buNone/>
-            </a:pPr>
-            <a:r>
-              <a:rPr lang="en-US" sz="1400" dirty="0">
-                <a:solidFill>
-                  <a:srgbClr val="FAF8FF"/>
-                </a:solidFill>
-                <a:latin typeface="Consolas" pitchFamily="34" charset="0"/>
-                <a:ea typeface="Consolas" pitchFamily="34" charset="-122"/>
-                <a:cs typeface="Consolas" pitchFamily="34" charset="-120"/>
-              </a:rPr>
-              <a:t> mgr</a:t>
-            </a:r>
-            <a:pPr indent="0" marL="0">
-              <a:buNone/>
-            </a:pPr>
-            <a:r>
-              <a:rPr lang="en-US" sz="1400" dirty="0">
-                <a:solidFill>
-                  <a:srgbClr val="B8B5D9"/>
-                </a:solidFill>
-                <a:latin typeface="Consolas" pitchFamily="34" charset="0"/>
-                <a:ea typeface="Consolas" pitchFamily="34" charset="-122"/>
-                <a:cs typeface="Consolas" pitchFamily="34" charset="-120"/>
-              </a:rPr>
-              <a:t>.</a:t>
-            </a:r>
-            <a:pPr indent="0" marL="0">
-              <a:buNone/>
-            </a:pPr>
-            <a:r>
-              <a:rPr lang="en-US" sz="1400" dirty="0">
-                <a:solidFill>
-                  <a:srgbClr val="FAF8FF"/>
-                </a:solidFill>
-                <a:latin typeface="Consolas" pitchFamily="34" charset="0"/>
-                <a:ea typeface="Consolas" pitchFamily="34" charset="-122"/>
-                <a:cs typeface="Consolas" pitchFamily="34" charset="-120"/>
-              </a:rPr>
-              <a:t>Endpoint </a:t>
-            </a:r>
-            <a:pPr indent="0" marL="0">
-              <a:buNone/>
-            </a:pPr>
-            <a:r>
-              <a:rPr lang="en-US" sz="1400" dirty="0">
-                <a:solidFill>
-                  <a:srgbClr val="B8B5D9"/>
-                </a:solidFill>
-                <a:latin typeface="Consolas" pitchFamily="34" charset="0"/>
-                <a:ea typeface="Consolas" pitchFamily="34" charset="-122"/>
-                <a:cs typeface="Consolas" pitchFamily="34" charset="-120"/>
-              </a:rPr>
-              <a:t>}</a:t>
-            </a:r>
-            <a:pPr indent="0" marL="0">
-              <a:buNone/>
-            </a:pPr>
-            <a:r>
-              <a:rPr lang="en-US" sz="1400" dirty="0">
-                <a:solidFill>
-                  <a:srgbClr val="B8B5D9"/>
-                </a:solidFill>
-                <a:latin typeface="Consolas" pitchFamily="34" charset="0"/>
-                <a:ea typeface="Consolas" pitchFamily="34" charset="-122"/>
-                <a:cs typeface="Consolas" pitchFamily="34" charset="-120"/>
-              </a:rPr>
-              <a:t>)</a:t>
-            </a:r>
-            <a:pPr indent="0" marL="0">
-              <a:buNone/>
-            </a:pPr>
-            <a:endParaRPr lang="en-US" sz="1400" dirty="0"/>
-          </a:p>
-          <a:p>
-            <a:pPr indent="0" marL="0">
-              <a:buNone/>
-            </a:pPr>
-            <a:r>
-              <a:rPr lang="en-US" sz="1400" dirty="0">
-                <a:solidFill>
-                  <a:srgbClr val="FAF8FF"/>
-                </a:solidFill>
-                <a:latin typeface="Consolas" pitchFamily="34" charset="0"/>
-                <a:ea typeface="Consolas" pitchFamily="34" charset="-122"/>
-                <a:cs typeface="Consolas" pitchFamily="34" charset="-120"/>
-              </a:rPr>
-              <a:t>    </a:t>
-            </a:r>
-            <a:pPr indent="0" marL="0">
-              <a:buNone/>
-            </a:pPr>
-            <a:r>
-              <a:rPr lang="en-US" sz="1400" dirty="0">
-                <a:solidFill>
-                  <a:srgbClr val="B8B5D9"/>
-                </a:solidFill>
-                <a:latin typeface="Consolas" pitchFamily="34" charset="0"/>
-                <a:ea typeface="Consolas" pitchFamily="34" charset="-122"/>
-                <a:cs typeface="Consolas" pitchFamily="34" charset="-120"/>
-              </a:rPr>
-              <a:t>.</a:t>
-            </a:r>
-            <a:pPr indent="0" marL="0">
-              <a:buNone/>
-            </a:pPr>
-            <a:r>
-              <a:rPr lang="en-US" sz="1400" dirty="0">
-                <a:solidFill>
-                  <a:srgbClr val="86EFAC"/>
-                </a:solidFill>
-                <a:latin typeface="Consolas" pitchFamily="34" charset="0"/>
-                <a:ea typeface="Consolas" pitchFamily="34" charset="-122"/>
-                <a:cs typeface="Consolas" pitchFamily="34" charset="-120"/>
-              </a:rPr>
-              <a:t>GetChatClient</a:t>
-            </a:r>
-            <a:pPr indent="0" marL="0">
-              <a:buNone/>
-            </a:pPr>
-            <a:r>
-              <a:rPr lang="en-US" sz="1400" dirty="0">
-                <a:solidFill>
-                  <a:srgbClr val="B8B5D9"/>
-                </a:solidFill>
-                <a:latin typeface="Consolas" pitchFamily="34" charset="0"/>
-                <a:ea typeface="Consolas" pitchFamily="34" charset="-122"/>
-                <a:cs typeface="Consolas" pitchFamily="34" charset="-120"/>
-              </a:rPr>
-              <a:t>(</a:t>
-            </a:r>
-            <a:pPr indent="0" marL="0">
-              <a:buNone/>
-            </a:pPr>
-            <a:r>
-              <a:rPr lang="en-US" sz="1400" dirty="0">
-                <a:solidFill>
-                  <a:srgbClr val="FAF8FF"/>
-                </a:solidFill>
-                <a:latin typeface="Consolas" pitchFamily="34" charset="0"/>
-                <a:ea typeface="Consolas" pitchFamily="34" charset="-122"/>
-                <a:cs typeface="Consolas" pitchFamily="34" charset="-120"/>
-              </a:rPr>
-              <a:t>mgr</a:t>
-            </a:r>
-            <a:pPr indent="0" marL="0">
-              <a:buNone/>
-            </a:pPr>
-            <a:r>
-              <a:rPr lang="en-US" sz="1400" dirty="0">
-                <a:solidFill>
-                  <a:srgbClr val="B8B5D9"/>
-                </a:solidFill>
-                <a:latin typeface="Consolas" pitchFamily="34" charset="0"/>
-                <a:ea typeface="Consolas" pitchFamily="34" charset="-122"/>
-                <a:cs typeface="Consolas" pitchFamily="34" charset="-120"/>
-              </a:rPr>
-              <a:t>.</a:t>
-            </a:r>
-            <a:pPr indent="0" marL="0">
-              <a:buNone/>
-            </a:pPr>
-            <a:r>
-              <a:rPr lang="en-US" sz="1400" dirty="0">
-                <a:solidFill>
-                  <a:srgbClr val="FAF8FF"/>
-                </a:solidFill>
-                <a:latin typeface="Consolas" pitchFamily="34" charset="0"/>
-                <a:ea typeface="Consolas" pitchFamily="34" charset="-122"/>
-                <a:cs typeface="Consolas" pitchFamily="34" charset="-120"/>
-              </a:rPr>
-              <a:t>ModelId</a:t>
-            </a:r>
-            <a:pPr indent="0" marL="0">
-              <a:buNone/>
-            </a:pPr>
-            <a:r>
-              <a:rPr lang="en-US" sz="1400" dirty="0">
-                <a:solidFill>
-                  <a:srgbClr val="B8B5D9"/>
-                </a:solidFill>
-                <a:latin typeface="Consolas" pitchFamily="34" charset="0"/>
-                <a:ea typeface="Consolas" pitchFamily="34" charset="-122"/>
-                <a:cs typeface="Consolas" pitchFamily="34" charset="-120"/>
-              </a:rPr>
-              <a:t>)</a:t>
-            </a:r>
-            <a:pPr indent="0" marL="0">
-              <a:buNone/>
-            </a:pPr>
-            <a:r>
-              <a:rPr lang="en-US" sz="1400" dirty="0">
-                <a:solidFill>
-                  <a:srgbClr val="B8B5D9"/>
-                </a:solidFill>
-                <a:latin typeface="Consolas" pitchFamily="34" charset="0"/>
-                <a:ea typeface="Consolas" pitchFamily="34" charset="-122"/>
-                <a:cs typeface="Consolas" pitchFamily="34" charset="-120"/>
-              </a:rPr>
-              <a:t>.</a:t>
-            </a:r>
-            <a:pPr indent="0" marL="0">
-              <a:buNone/>
-            </a:pPr>
-            <a:r>
-              <a:rPr lang="en-US" sz="1400" dirty="0">
-                <a:solidFill>
-                  <a:srgbClr val="86EFAC"/>
-                </a:solidFill>
-                <a:latin typeface="Consolas" pitchFamily="34" charset="0"/>
-                <a:ea typeface="Consolas" pitchFamily="34" charset="-122"/>
-                <a:cs typeface="Consolas" pitchFamily="34" charset="-120"/>
-              </a:rPr>
-              <a:t>AsIChatClient</a:t>
-            </a:r>
-            <a:pPr indent="0" marL="0">
-              <a:buNone/>
-            </a:pPr>
-            <a:r>
-              <a:rPr lang="en-US" sz="1400" dirty="0">
-                <a:solidFill>
-                  <a:srgbClr val="B8B5D9"/>
-                </a:solidFill>
-                <a:latin typeface="Consolas" pitchFamily="34" charset="0"/>
-                <a:ea typeface="Consolas" pitchFamily="34" charset="-122"/>
-                <a:cs typeface="Consolas" pitchFamily="34" charset="-120"/>
-              </a:rPr>
-              <a:t>(</a:t>
-            </a:r>
-            <a:pPr indent="0" marL="0">
-              <a:buNone/>
-            </a:pPr>
-            <a:r>
-              <a:rPr lang="en-US" sz="1400" dirty="0">
-                <a:solidFill>
-                  <a:srgbClr val="B8B5D9"/>
-                </a:solidFill>
-                <a:latin typeface="Consolas" pitchFamily="34" charset="0"/>
-                <a:ea typeface="Consolas" pitchFamily="34" charset="-122"/>
-                <a:cs typeface="Consolas" pitchFamily="34" charset="-120"/>
-              </a:rPr>
-              <a:t>)</a:t>
-            </a:r>
-            <a:pPr indent="0" marL="0">
-              <a:buNone/>
-            </a:pPr>
-            <a:r>
-              <a:rPr lang="en-US" sz="1400" dirty="0">
-                <a:solidFill>
-                  <a:srgbClr val="B8B5D9"/>
-                </a:solidFill>
-                <a:latin typeface="Consolas" pitchFamily="34" charset="0"/>
-                <a:ea typeface="Consolas" pitchFamily="34" charset="-122"/>
-                <a:cs typeface="Consolas" pitchFamily="34" charset="-120"/>
-              </a:rPr>
-              <a:t>;</a:t>
-            </a:r>
-            <a:pPr indent="0" marL="0">
-              <a:buNone/>
-            </a:pPr>
-            <a:endParaRPr lang="en-US" sz="1400" dirty="0"/>
-          </a:p>
-          <a:p>
-            <a:pPr indent="0" marL="0">
-              <a:buNone/>
-            </a:pPr>
-            <a:endParaRPr lang="en-US" sz="1400" dirty="0"/>
-          </a:p>
-          <a:p>
-            <a:pPr indent="0" marL="0">
-              <a:buNone/>
-            </a:pPr>
-            <a:r>
-              <a:rPr lang="en-US" sz="1400" i="1" dirty="0">
-                <a:solidFill>
-                  <a:srgbClr val="8B88B5"/>
-                </a:solidFill>
-                <a:latin typeface="Consolas" pitchFamily="34" charset="0"/>
-                <a:ea typeface="Consolas" pitchFamily="34" charset="-122"/>
-                <a:cs typeface="Consolas" pitchFamily="34" charset="-120"/>
-              </a:rPr>
-              <a:t>// ☁️   Cloud — Azure OpenAI</a:t>
-            </a:r>
-            <a:pPr indent="0" marL="0">
-              <a:buNone/>
-            </a:pPr>
-            <a:endParaRPr lang="en-US" sz="1400" dirty="0"/>
-          </a:p>
-          <a:p>
-            <a:pPr indent="0" marL="0">
-              <a:buNone/>
-            </a:pPr>
-            <a:r>
-              <a:rPr lang="en-US" sz="1400" dirty="0">
-                <a:solidFill>
-                  <a:srgbClr val="FAF8FF"/>
-                </a:solidFill>
-                <a:latin typeface="Consolas" pitchFamily="34" charset="0"/>
-                <a:ea typeface="Consolas" pitchFamily="34" charset="-122"/>
-                <a:cs typeface="Consolas" pitchFamily="34" charset="-120"/>
-              </a:rPr>
-              <a:t>chatClient </a:t>
-            </a:r>
-            <a:pPr indent="0" marL="0">
-              <a:buNone/>
-            </a:pPr>
-            <a:r>
-              <a:rPr lang="en-US" sz="1400" dirty="0">
-                <a:solidFill>
-                  <a:srgbClr val="CFCBED"/>
-                </a:solidFill>
-                <a:latin typeface="Consolas" pitchFamily="34" charset="0"/>
-                <a:ea typeface="Consolas" pitchFamily="34" charset="-122"/>
-                <a:cs typeface="Consolas" pitchFamily="34" charset="-120"/>
-              </a:rPr>
-              <a:t>=</a:t>
-            </a:r>
-            <a:pPr indent="0" marL="0">
-              <a:buNone/>
-            </a:pPr>
-            <a:r>
-              <a:rPr lang="en-US" sz="1400" dirty="0">
-                <a:solidFill>
-                  <a:srgbClr val="FAF8FF"/>
-                </a:solidFill>
-                <a:latin typeface="Consolas" pitchFamily="34" charset="0"/>
-                <a:ea typeface="Consolas" pitchFamily="34" charset="-122"/>
-                <a:cs typeface="Consolas" pitchFamily="34" charset="-120"/>
-              </a:rPr>
-              <a:t> </a:t>
-            </a:r>
-            <a:pPr indent="0" marL="0">
-              <a:buNone/>
-            </a:pPr>
-            <a:r>
-              <a:rPr lang="en-US" sz="1400" dirty="0">
-                <a:solidFill>
-                  <a:srgbClr val="FB7185"/>
-                </a:solidFill>
-                <a:latin typeface="Consolas" pitchFamily="34" charset="0"/>
-                <a:ea typeface="Consolas" pitchFamily="34" charset="-122"/>
-                <a:cs typeface="Consolas" pitchFamily="34" charset="-120"/>
-              </a:rPr>
-              <a:t>new</a:t>
-            </a:r>
-            <a:pPr indent="0" marL="0">
-              <a:buNone/>
-            </a:pPr>
-            <a:r>
-              <a:rPr lang="en-US" sz="1400" dirty="0">
-                <a:solidFill>
-                  <a:srgbClr val="FAF8FF"/>
-                </a:solidFill>
-                <a:latin typeface="Consolas" pitchFamily="34" charset="0"/>
-                <a:ea typeface="Consolas" pitchFamily="34" charset="-122"/>
-                <a:cs typeface="Consolas" pitchFamily="34" charset="-120"/>
-              </a:rPr>
-              <a:t> </a:t>
-            </a:r>
-            <a:pPr indent="0" marL="0">
-              <a:buNone/>
-            </a:pPr>
-            <a:r>
-              <a:rPr lang="en-US" sz="1400" dirty="0">
-                <a:solidFill>
-                  <a:srgbClr val="FAF8FF"/>
-                </a:solidFill>
-                <a:latin typeface="Consolas" pitchFamily="34" charset="0"/>
-                <a:ea typeface="Consolas" pitchFamily="34" charset="-122"/>
-                <a:cs typeface="Consolas" pitchFamily="34" charset="-120"/>
-              </a:rPr>
-              <a:t>AzureOpenAIClient</a:t>
-            </a:r>
-            <a:pPr indent="0" marL="0">
-              <a:buNone/>
-            </a:pPr>
-            <a:r>
-              <a:rPr lang="en-US" sz="1400" dirty="0">
-                <a:solidFill>
-                  <a:srgbClr val="B8B5D9"/>
-                </a:solidFill>
-                <a:latin typeface="Consolas" pitchFamily="34" charset="0"/>
-                <a:ea typeface="Consolas" pitchFamily="34" charset="-122"/>
-                <a:cs typeface="Consolas" pitchFamily="34" charset="-120"/>
-              </a:rPr>
-              <a:t>(</a:t>
-            </a:r>
-            <a:pPr indent="0" marL="0">
-              <a:buNone/>
-            </a:pPr>
-            <a:r>
-              <a:rPr lang="en-US" sz="1400" dirty="0">
-                <a:solidFill>
-                  <a:srgbClr val="FAF8FF"/>
-                </a:solidFill>
-                <a:latin typeface="Consolas" pitchFamily="34" charset="0"/>
-                <a:ea typeface="Consolas" pitchFamily="34" charset="-122"/>
-                <a:cs typeface="Consolas" pitchFamily="34" charset="-120"/>
-              </a:rPr>
-              <a:t>endpoint</a:t>
-            </a:r>
-            <a:pPr indent="0" marL="0">
-              <a:buNone/>
-            </a:pPr>
-            <a:r>
-              <a:rPr lang="en-US" sz="1400" dirty="0">
-                <a:solidFill>
-                  <a:srgbClr val="B8B5D9"/>
-                </a:solidFill>
-                <a:latin typeface="Consolas" pitchFamily="34" charset="0"/>
-                <a:ea typeface="Consolas" pitchFamily="34" charset="-122"/>
-                <a:cs typeface="Consolas" pitchFamily="34" charset="-120"/>
-              </a:rPr>
-              <a:t>,</a:t>
-            </a:r>
-            <a:pPr indent="0" marL="0">
-              <a:buNone/>
-            </a:pPr>
-            <a:r>
-              <a:rPr lang="en-US" sz="1400" dirty="0">
-                <a:solidFill>
-                  <a:srgbClr val="FAF8FF"/>
-                </a:solidFill>
-                <a:latin typeface="Consolas" pitchFamily="34" charset="0"/>
-                <a:ea typeface="Consolas" pitchFamily="34" charset="-122"/>
-                <a:cs typeface="Consolas" pitchFamily="34" charset="-120"/>
-              </a:rPr>
-              <a:t> </a:t>
-            </a:r>
-            <a:pPr indent="0" marL="0">
-              <a:buNone/>
-            </a:pPr>
-            <a:r>
-              <a:rPr lang="en-US" sz="1400" dirty="0">
-                <a:solidFill>
-                  <a:srgbClr val="FB7185"/>
-                </a:solidFill>
-                <a:latin typeface="Consolas" pitchFamily="34" charset="0"/>
-                <a:ea typeface="Consolas" pitchFamily="34" charset="-122"/>
-                <a:cs typeface="Consolas" pitchFamily="34" charset="-120"/>
-              </a:rPr>
-              <a:t>new</a:t>
-            </a:r>
-            <a:pPr indent="0" marL="0">
-              <a:buNone/>
-            </a:pPr>
-            <a:r>
-              <a:rPr lang="en-US" sz="1400" dirty="0">
-                <a:solidFill>
-                  <a:srgbClr val="FAF8FF"/>
-                </a:solidFill>
-                <a:latin typeface="Consolas" pitchFamily="34" charset="0"/>
-                <a:ea typeface="Consolas" pitchFamily="34" charset="-122"/>
-                <a:cs typeface="Consolas" pitchFamily="34" charset="-120"/>
-              </a:rPr>
-              <a:t> </a:t>
-            </a:r>
-            <a:pPr indent="0" marL="0">
-              <a:buNone/>
-            </a:pPr>
-            <a:r>
-              <a:rPr lang="en-US" sz="1400" dirty="0">
-                <a:solidFill>
-                  <a:srgbClr val="FAF8FF"/>
-                </a:solidFill>
-                <a:latin typeface="Consolas" pitchFamily="34" charset="0"/>
-                <a:ea typeface="Consolas" pitchFamily="34" charset="-122"/>
-                <a:cs typeface="Consolas" pitchFamily="34" charset="-120"/>
-              </a:rPr>
-              <a:t>DefaultAzureCredential</a:t>
-            </a:r>
-            <a:pPr indent="0" marL="0">
-              <a:buNone/>
-            </a:pPr>
-            <a:r>
-              <a:rPr lang="en-US" sz="1400" dirty="0">
-                <a:solidFill>
-                  <a:srgbClr val="B8B5D9"/>
-                </a:solidFill>
-                <a:latin typeface="Consolas" pitchFamily="34" charset="0"/>
-                <a:ea typeface="Consolas" pitchFamily="34" charset="-122"/>
-                <a:cs typeface="Consolas" pitchFamily="34" charset="-120"/>
-              </a:rPr>
-              <a:t>(</a:t>
-            </a:r>
-            <a:pPr indent="0" marL="0">
-              <a:buNone/>
-            </a:pPr>
-            <a:r>
-              <a:rPr lang="en-US" sz="1400" dirty="0">
-                <a:solidFill>
-                  <a:srgbClr val="B8B5D9"/>
-                </a:solidFill>
-                <a:latin typeface="Consolas" pitchFamily="34" charset="0"/>
-                <a:ea typeface="Consolas" pitchFamily="34" charset="-122"/>
-                <a:cs typeface="Consolas" pitchFamily="34" charset="-120"/>
-              </a:rPr>
-              <a:t>)</a:t>
-            </a:r>
-            <a:pPr indent="0" marL="0">
-              <a:buNone/>
-            </a:pPr>
-            <a:r>
-              <a:rPr lang="en-US" sz="1400" dirty="0">
-                <a:solidFill>
-                  <a:srgbClr val="B8B5D9"/>
-                </a:solidFill>
-                <a:latin typeface="Consolas" pitchFamily="34" charset="0"/>
-                <a:ea typeface="Consolas" pitchFamily="34" charset="-122"/>
-                <a:cs typeface="Consolas" pitchFamily="34" charset="-120"/>
-              </a:rPr>
-              <a:t>)</a:t>
-            </a:r>
-            <a:pPr indent="0" marL="0">
-              <a:buNone/>
-            </a:pPr>
-            <a:endParaRPr lang="en-US" sz="1400" dirty="0"/>
-          </a:p>
-          <a:p>
-            <a:pPr indent="0" marL="0">
-              <a:buNone/>
-            </a:pPr>
-            <a:r>
-              <a:rPr lang="en-US" sz="1400" dirty="0">
-                <a:solidFill>
-                  <a:srgbClr val="FAF8FF"/>
-                </a:solidFill>
-                <a:latin typeface="Consolas" pitchFamily="34" charset="0"/>
-                <a:ea typeface="Consolas" pitchFamily="34" charset="-122"/>
-                <a:cs typeface="Consolas" pitchFamily="34" charset="-120"/>
-              </a:rPr>
-              <a:t>    </a:t>
-            </a:r>
-            <a:pPr indent="0" marL="0">
-              <a:buNone/>
-            </a:pPr>
-            <a:r>
-              <a:rPr lang="en-US" sz="1400" dirty="0">
-                <a:solidFill>
-                  <a:srgbClr val="B8B5D9"/>
-                </a:solidFill>
-                <a:latin typeface="Consolas" pitchFamily="34" charset="0"/>
-                <a:ea typeface="Consolas" pitchFamily="34" charset="-122"/>
-                <a:cs typeface="Consolas" pitchFamily="34" charset="-120"/>
-              </a:rPr>
-              <a:t>.</a:t>
-            </a:r>
-            <a:pPr indent="0" marL="0">
-              <a:buNone/>
-            </a:pPr>
-            <a:r>
-              <a:rPr lang="en-US" sz="1400" dirty="0">
-                <a:solidFill>
-                  <a:srgbClr val="86EFAC"/>
-                </a:solidFill>
-                <a:latin typeface="Consolas" pitchFamily="34" charset="0"/>
-                <a:ea typeface="Consolas" pitchFamily="34" charset="-122"/>
-                <a:cs typeface="Consolas" pitchFamily="34" charset="-120"/>
-              </a:rPr>
-              <a:t>GetChatClient</a:t>
-            </a:r>
-            <a:pPr indent="0" marL="0">
-              <a:buNone/>
-            </a:pPr>
-            <a:r>
-              <a:rPr lang="en-US" sz="1400" dirty="0">
-                <a:solidFill>
-                  <a:srgbClr val="B8B5D9"/>
-                </a:solidFill>
-                <a:latin typeface="Consolas" pitchFamily="34" charset="0"/>
-                <a:ea typeface="Consolas" pitchFamily="34" charset="-122"/>
-                <a:cs typeface="Consolas" pitchFamily="34" charset="-120"/>
-              </a:rPr>
-              <a:t>(</a:t>
-            </a:r>
-            <a:pPr indent="0" marL="0">
-              <a:buNone/>
-            </a:pPr>
-            <a:r>
-              <a:rPr lang="en-US" sz="1400" dirty="0">
-                <a:solidFill>
-                  <a:srgbClr val="FBBF24"/>
-                </a:solidFill>
-                <a:latin typeface="Consolas" pitchFamily="34" charset="0"/>
-                <a:ea typeface="Consolas" pitchFamily="34" charset="-122"/>
-                <a:cs typeface="Consolas" pitchFamily="34" charset="-120"/>
-              </a:rPr>
-              <a:t>"gpt-4.1"</a:t>
-            </a:r>
-            <a:pPr indent="0" marL="0">
-              <a:buNone/>
-            </a:pPr>
-            <a:r>
-              <a:rPr lang="en-US" sz="1400" dirty="0">
-                <a:solidFill>
-                  <a:srgbClr val="B8B5D9"/>
-                </a:solidFill>
-                <a:latin typeface="Consolas" pitchFamily="34" charset="0"/>
-                <a:ea typeface="Consolas" pitchFamily="34" charset="-122"/>
-                <a:cs typeface="Consolas" pitchFamily="34" charset="-120"/>
-              </a:rPr>
-              <a:t>)</a:t>
-            </a:r>
-            <a:pPr indent="0" marL="0">
-              <a:buNone/>
-            </a:pPr>
-            <a:r>
-              <a:rPr lang="en-US" sz="1400" dirty="0">
-                <a:solidFill>
-                  <a:srgbClr val="B8B5D9"/>
-                </a:solidFill>
-                <a:latin typeface="Consolas" pitchFamily="34" charset="0"/>
-                <a:ea typeface="Consolas" pitchFamily="34" charset="-122"/>
-                <a:cs typeface="Consolas" pitchFamily="34" charset="-120"/>
-              </a:rPr>
-              <a:t>.</a:t>
-            </a:r>
-            <a:pPr indent="0" marL="0">
-              <a:buNone/>
-            </a:pPr>
-            <a:r>
-              <a:rPr lang="en-US" sz="1400" dirty="0">
-                <a:solidFill>
-                  <a:srgbClr val="86EFAC"/>
-                </a:solidFill>
-                <a:latin typeface="Consolas" pitchFamily="34" charset="0"/>
-                <a:ea typeface="Consolas" pitchFamily="34" charset="-122"/>
-                <a:cs typeface="Consolas" pitchFamily="34" charset="-120"/>
-              </a:rPr>
-              <a:t>AsIChatClient</a:t>
-            </a:r>
-            <a:pPr indent="0" marL="0">
-              <a:buNone/>
-            </a:pPr>
-            <a:r>
-              <a:rPr lang="en-US" sz="1400" dirty="0">
-                <a:solidFill>
-                  <a:srgbClr val="B8B5D9"/>
-                </a:solidFill>
-                <a:latin typeface="Consolas" pitchFamily="34" charset="0"/>
-                <a:ea typeface="Consolas" pitchFamily="34" charset="-122"/>
-                <a:cs typeface="Consolas" pitchFamily="34" charset="-120"/>
-              </a:rPr>
-              <a:t>(</a:t>
-            </a:r>
-            <a:pPr indent="0" marL="0">
-              <a:buNone/>
-            </a:pPr>
-            <a:r>
-              <a:rPr lang="en-US" sz="1400" dirty="0">
-                <a:solidFill>
-                  <a:srgbClr val="B8B5D9"/>
-                </a:solidFill>
-                <a:latin typeface="Consolas" pitchFamily="34" charset="0"/>
-                <a:ea typeface="Consolas" pitchFamily="34" charset="-122"/>
-                <a:cs typeface="Consolas" pitchFamily="34" charset="-120"/>
-              </a:rPr>
-              <a:t>)</a:t>
-            </a:r>
-            <a:pPr indent="0" marL="0">
-              <a:buNone/>
-            </a:pPr>
-            <a:r>
-              <a:rPr lang="en-US" sz="1400" dirty="0">
-                <a:solidFill>
-                  <a:srgbClr val="B8B5D9"/>
-                </a:solidFill>
-                <a:latin typeface="Consolas" pitchFamily="34" charset="0"/>
-                <a:ea typeface="Consolas" pitchFamily="34" charset="-122"/>
-                <a:cs typeface="Consolas" pitchFamily="34" charset="-120"/>
-              </a:rPr>
-              <a:t>;</a:t>
-            </a:r>
-            <a:pPr indent="0" marL="0">
-              <a:buNone/>
-            </a:pPr>
-            <a:endParaRPr lang="en-US" sz="1400" dirty="0"/>
-          </a:p>
-          <a:p>
-            <a:pPr indent="0" marL="0">
-              <a:buNone/>
-            </a:pPr>
-            <a:endParaRPr lang="en-US" sz="1400" dirty="0"/>
-          </a:p>
-          <a:p>
-            <a:pPr indent="0" marL="0">
-              <a:buNone/>
-            </a:pPr>
-            <a:r>
-              <a:rPr lang="en-US" sz="1400" i="1" dirty="0">
-                <a:solidFill>
-                  <a:srgbClr val="8B88B5"/>
-                </a:solidFill>
-                <a:latin typeface="Consolas" pitchFamily="34" charset="0"/>
-                <a:ea typeface="Consolas" pitchFamily="34" charset="-122"/>
-                <a:cs typeface="Consolas" pitchFamily="34" charset="-120"/>
-              </a:rPr>
-              <a:t>// ✨  Same agent. Every tier.</a:t>
-            </a:r>
-            <a:pPr indent="0" marL="0">
-              <a:buNone/>
-            </a:pPr>
-            <a:endParaRPr lang="en-US" sz="1400" dirty="0"/>
-          </a:p>
-          <a:p>
-            <a:pPr indent="0" marL="0">
-              <a:buNone/>
-            </a:pPr>
-            <a:r>
-              <a:rPr lang="en-US" sz="1400" dirty="0">
-                <a:solidFill>
-                  <a:srgbClr val="FB7185"/>
-                </a:solidFill>
-                <a:latin typeface="Consolas" pitchFamily="34" charset="0"/>
-                <a:ea typeface="Consolas" pitchFamily="34" charset="-122"/>
-                <a:cs typeface="Consolas" pitchFamily="34" charset="-120"/>
-              </a:rPr>
-              <a:t>var</a:t>
-            </a:r>
-            <a:pPr indent="0" marL="0">
-              <a:buNone/>
-            </a:pPr>
-            <a:r>
-              <a:rPr lang="en-US" sz="1400" dirty="0">
-                <a:solidFill>
-                  <a:srgbClr val="FAF8FF"/>
-                </a:solidFill>
-                <a:latin typeface="Consolas" pitchFamily="34" charset="0"/>
-                <a:ea typeface="Consolas" pitchFamily="34" charset="-122"/>
-                <a:cs typeface="Consolas" pitchFamily="34" charset="-120"/>
-              </a:rPr>
-              <a:t> agent </a:t>
-            </a:r>
-            <a:pPr indent="0" marL="0">
-              <a:buNone/>
-            </a:pPr>
-            <a:r>
-              <a:rPr lang="en-US" sz="1400" dirty="0">
-                <a:solidFill>
-                  <a:srgbClr val="CFCBED"/>
-                </a:solidFill>
-                <a:latin typeface="Consolas" pitchFamily="34" charset="0"/>
-                <a:ea typeface="Consolas" pitchFamily="34" charset="-122"/>
-                <a:cs typeface="Consolas" pitchFamily="34" charset="-120"/>
-              </a:rPr>
-              <a:t>=</a:t>
-            </a:r>
-            <a:pPr indent="0" marL="0">
-              <a:buNone/>
-            </a:pPr>
-            <a:r>
-              <a:rPr lang="en-US" sz="1400" dirty="0">
-                <a:solidFill>
-                  <a:srgbClr val="FAF8FF"/>
-                </a:solidFill>
-                <a:latin typeface="Consolas" pitchFamily="34" charset="0"/>
-                <a:ea typeface="Consolas" pitchFamily="34" charset="-122"/>
-                <a:cs typeface="Consolas" pitchFamily="34" charset="-120"/>
-              </a:rPr>
-              <a:t> chatClient</a:t>
-            </a:r>
-            <a:pPr indent="0" marL="0">
-              <a:buNone/>
-            </a:pPr>
-            <a:r>
-              <a:rPr lang="en-US" sz="1400" dirty="0">
-                <a:solidFill>
-                  <a:srgbClr val="B8B5D9"/>
-                </a:solidFill>
-                <a:latin typeface="Consolas" pitchFamily="34" charset="0"/>
-                <a:ea typeface="Consolas" pitchFamily="34" charset="-122"/>
-                <a:cs typeface="Consolas" pitchFamily="34" charset="-120"/>
-              </a:rPr>
-              <a:t>.</a:t>
-            </a:r>
-            <a:pPr indent="0" marL="0">
-              <a:buNone/>
-            </a:pPr>
-            <a:r>
-              <a:rPr lang="en-US" sz="1400" dirty="0">
-                <a:solidFill>
-                  <a:srgbClr val="86EFAC"/>
-                </a:solidFill>
-                <a:latin typeface="Consolas" pitchFamily="34" charset="0"/>
-                <a:ea typeface="Consolas" pitchFamily="34" charset="-122"/>
-                <a:cs typeface="Consolas" pitchFamily="34" charset="-120"/>
-              </a:rPr>
-              <a:t>CreateAIAgent</a:t>
-            </a:r>
-            <a:pPr indent="0" marL="0">
-              <a:buNone/>
-            </a:pPr>
-            <a:r>
-              <a:rPr lang="en-US" sz="1400" dirty="0">
-                <a:solidFill>
-                  <a:srgbClr val="B8B5D9"/>
-                </a:solidFill>
-                <a:latin typeface="Consolas" pitchFamily="34" charset="0"/>
-                <a:ea typeface="Consolas" pitchFamily="34" charset="-122"/>
-                <a:cs typeface="Consolas" pitchFamily="34" charset="-120"/>
-              </a:rPr>
-              <a:t>(</a:t>
-            </a:r>
-            <a:pPr indent="0" marL="0">
-              <a:buNone/>
-            </a:pPr>
-            <a:r>
-              <a:rPr lang="en-US" sz="1400" dirty="0">
-                <a:solidFill>
-                  <a:srgbClr val="FBBF24"/>
-                </a:solidFill>
-                <a:latin typeface="Consolas" pitchFamily="34" charset="0"/>
-                <a:ea typeface="Consolas" pitchFamily="34" charset="-122"/>
-                <a:cs typeface="Consolas" pitchFamily="34" charset="-120"/>
-              </a:rPr>
-              <a:t>"You are helpful."</a:t>
-            </a:r>
-            <a:pPr indent="0" marL="0">
-              <a:buNone/>
-            </a:pPr>
-            <a:r>
-              <a:rPr lang="en-US" sz="1400" dirty="0">
-                <a:solidFill>
-                  <a:srgbClr val="B8B5D9"/>
-                </a:solidFill>
-                <a:latin typeface="Consolas" pitchFamily="34" charset="0"/>
-                <a:ea typeface="Consolas" pitchFamily="34" charset="-122"/>
-                <a:cs typeface="Consolas" pitchFamily="34" charset="-120"/>
-              </a:rPr>
-              <a:t>)</a:t>
-            </a:r>
-            <a:pPr indent="0" marL="0">
-              <a:buNone/>
-            </a:pPr>
-            <a:r>
-              <a:rPr lang="en-US" sz="1400" dirty="0">
-                <a:solidFill>
-                  <a:srgbClr val="B8B5D9"/>
-                </a:solidFill>
-                <a:latin typeface="Consolas" pitchFamily="34" charset="0"/>
-                <a:ea typeface="Consolas" pitchFamily="34" charset="-122"/>
-                <a:cs typeface="Consolas" pitchFamily="34" charset="-120"/>
-              </a:rPr>
-              <a:t>;</a:t>
-            </a:r>
-            <a:endParaRPr lang="en-US" sz="1400" dirty="0"/>
+            <a:endParaRPr lang="en-US" sz="1200" dirty="0"/>
           </a:p>
         </p:txBody>
       </p:sp>

</xml_diff>

<commit_message>
Slide 12: flow diagram becomes vertical chain on the right
- Right column: 4 stacked pills with downward arrows
  (User → 📱 triage → ☁️ expert → User), color-coded by tier,
  each with glyph + name + provider sub-label
- Left: taller code block fills the vertical space, slightly narrower
  so multi-arg CreateAIAgent calls wrap onto multiple lines naturally

Co-authored-by: Copilot <223556219+Copilot@users.noreply.github.com>
</commit_message>
<xml_diff>
--- a/slides/Unifying-Local-Cloud-AI.pptx
+++ b/slides/Unifying-Local-Cloud-AI.pptx
@@ -6621,12 +6621,12 @@
         </p:nvSpPr>
         <p:spPr>
           <a:xfrm>
-            <a:off x="822960" y="2468880"/>
-            <a:ext cx="2377440" cy="548640"/>
+            <a:off x="9082735" y="2377440"/>
+            <a:ext cx="2651760" cy="685800"/>
           </a:xfrm>
           <a:prstGeom prst="roundRect">
             <a:avLst>
-              <a:gd name="adj" fmla="val 50000"/>
+              <a:gd name="adj" fmla="val 24000"/>
             </a:avLst>
           </a:prstGeom>
           <a:solidFill>
@@ -6648,8 +6648,8 @@
         </p:nvSpPr>
         <p:spPr>
           <a:xfrm>
-            <a:off x="914400" y="2468880"/>
-            <a:ext cx="2194560" cy="548640"/>
+            <a:off x="9219895" y="2377440"/>
+            <a:ext cx="548640" cy="685800"/>
           </a:xfrm>
           <a:prstGeom prst="rect">
             <a:avLst/>
@@ -6665,7 +6665,7 @@
               <a:buNone/>
             </a:pPr>
             <a:r>
-              <a:rPr lang="en-US" sz="1600" dirty="0">
+              <a:rPr lang="en-US" sz="2200" dirty="0">
                 <a:solidFill>
                   <a:srgbClr val="000000"/>
                 </a:solidFill>
@@ -6673,13 +6673,38 @@
                 <a:ea typeface="Calibri" pitchFamily="34" charset="-122"/>
                 <a:cs typeface="Calibri" pitchFamily="34" charset="-120"/>
               </a:rPr>
-              <a:t>👤  </a:t>
-            </a:r>
-            <a:pPr algn="ctr" indent="0" marL="0">
-              <a:buNone/>
-            </a:pPr>
-            <a:r>
-              <a:rPr lang="en-US" sz="1400" b="1" dirty="0">
+              <a:t>👤</a:t>
+            </a:r>
+            <a:endParaRPr lang="en-US" sz="2200" dirty="0"/>
+          </a:p>
+        </p:txBody>
+      </p:sp>
+      <p:sp>
+        <p:nvSpPr>
+          <p:cNvPr id="9" name="Text 7"/>
+          <p:cNvSpPr/>
+          <p:nvPr/>
+        </p:nvSpPr>
+        <p:spPr>
+          <a:xfrm>
+            <a:off x="9859975" y="2468880"/>
+            <a:ext cx="1783080" cy="320040"/>
+          </a:xfrm>
+          <a:prstGeom prst="rect">
+            <a:avLst/>
+          </a:prstGeom>
+          <a:noFill/>
+          <a:ln/>
+        </p:spPr>
+        <p:txBody>
+          <a:bodyPr wrap="square" rtlCol="0" anchor="ctr"/>
+          <a:lstStyle/>
+          <a:p>
+            <a:pPr indent="0" marL="0">
+              <a:buNone/>
+            </a:pPr>
+            <a:r>
+              <a:rPr lang="en-US" sz="1600" b="1" dirty="0">
                 <a:solidFill>
                   <a:srgbClr val="FAF8FF"/>
                 </a:solidFill>
@@ -6687,9 +6712,34 @@
                 <a:ea typeface="Calibri" pitchFamily="34" charset="-122"/>
                 <a:cs typeface="Calibri" pitchFamily="34" charset="-120"/>
               </a:rPr>
-              <a:t>User</a:t>
-            </a:r>
-            <a:pPr algn="ctr" indent="0" marL="0">
+              <a:t>User input</a:t>
+            </a:r>
+            <a:endParaRPr lang="en-US" sz="1600" dirty="0"/>
+          </a:p>
+        </p:txBody>
+      </p:sp>
+      <p:sp>
+        <p:nvSpPr>
+          <p:cNvPr id="10" name="Text 8"/>
+          <p:cNvSpPr/>
+          <p:nvPr/>
+        </p:nvSpPr>
+        <p:spPr>
+          <a:xfrm>
+            <a:off x="9859975" y="2743200"/>
+            <a:ext cx="1783080" cy="274320"/>
+          </a:xfrm>
+          <a:prstGeom prst="rect">
+            <a:avLst/>
+          </a:prstGeom>
+          <a:noFill/>
+          <a:ln/>
+        </p:spPr>
+        <p:txBody>
+          <a:bodyPr wrap="square" rtlCol="0" anchor="ctr"/>
+          <a:lstStyle/>
+          <a:p>
+            <a:pPr indent="0" marL="0">
               <a:buNone/>
             </a:pPr>
             <a:r>
@@ -6701,22 +6751,22 @@
                 <a:ea typeface="Calibri" pitchFamily="34" charset="-122"/>
                 <a:cs typeface="Calibri" pitchFamily="34" charset="-120"/>
               </a:rPr>
-              <a:t>   input</a:t>
-            </a:r>
-            <a:endParaRPr lang="en-US" sz="1600" dirty="0"/>
-          </a:p>
-        </p:txBody>
-      </p:sp>
-      <p:sp>
-        <p:nvSpPr>
-          <p:cNvPr id="9" name="Shape 7"/>
-          <p:cNvSpPr/>
-          <p:nvPr/>
-        </p:nvSpPr>
-        <p:spPr>
-          <a:xfrm>
-            <a:off x="3246120" y="2743200"/>
-            <a:ext cx="253898" cy="0"/>
+              <a:t>raw, may have PII</a:t>
+            </a:r>
+            <a:endParaRPr lang="en-US" sz="1100" dirty="0"/>
+          </a:p>
+        </p:txBody>
+      </p:sp>
+      <p:sp>
+        <p:nvSpPr>
+          <p:cNvPr id="11" name="Shape 9"/>
+          <p:cNvSpPr/>
+          <p:nvPr/>
+        </p:nvSpPr>
+        <p:spPr>
+          <a:xfrm>
+            <a:off x="10408615" y="3108960"/>
+            <a:ext cx="0" cy="228600"/>
           </a:xfrm>
           <a:prstGeom prst="line">
             <a:avLst/>
@@ -6732,16 +6782,16 @@
       </p:sp>
       <p:sp>
         <p:nvSpPr>
-          <p:cNvPr id="10" name="Shape 8"/>
-          <p:cNvSpPr/>
-          <p:nvPr/>
-        </p:nvSpPr>
-        <p:spPr>
-          <a:xfrm rot="5400000">
-            <a:off x="3362858" y="2670048"/>
-            <a:ext cx="164592" cy="146304"/>
-          </a:xfrm>
-          <a:prstGeom prst="rightTriangle">
+          <p:cNvPr id="12" name="Shape 10"/>
+          <p:cNvSpPr/>
+          <p:nvPr/>
+        </p:nvSpPr>
+        <p:spPr>
+          <a:xfrm flipV="1">
+            <a:off x="10317175" y="3337560"/>
+            <a:ext cx="182880" cy="164592"/>
+          </a:xfrm>
+          <a:prstGeom prst="triangle">
             <a:avLst/>
           </a:prstGeom>
           <a:solidFill>
@@ -6757,18 +6807,18 @@
       </p:sp>
       <p:sp>
         <p:nvSpPr>
-          <p:cNvPr id="11" name="Shape 9"/>
-          <p:cNvSpPr/>
-          <p:nvPr/>
-        </p:nvSpPr>
-        <p:spPr>
-          <a:xfrm>
-            <a:off x="3545738" y="2468880"/>
-            <a:ext cx="2377440" cy="548640"/>
+          <p:cNvPr id="13" name="Shape 11"/>
+          <p:cNvSpPr/>
+          <p:nvPr/>
+        </p:nvSpPr>
+        <p:spPr>
+          <a:xfrm>
+            <a:off x="9082735" y="3474720"/>
+            <a:ext cx="2651760" cy="685800"/>
           </a:xfrm>
           <a:prstGeom prst="roundRect">
             <a:avLst>
-              <a:gd name="adj" fmla="val 50000"/>
+              <a:gd name="adj" fmla="val 24000"/>
             </a:avLst>
           </a:prstGeom>
           <a:solidFill>
@@ -6784,14 +6834,14 @@
       </p:sp>
       <p:sp>
         <p:nvSpPr>
-          <p:cNvPr id="12" name="Text 10"/>
-          <p:cNvSpPr/>
-          <p:nvPr/>
-        </p:nvSpPr>
-        <p:spPr>
-          <a:xfrm>
-            <a:off x="3637178" y="2468880"/>
-            <a:ext cx="2194560" cy="548640"/>
+          <p:cNvPr id="14" name="Text 12"/>
+          <p:cNvSpPr/>
+          <p:nvPr/>
+        </p:nvSpPr>
+        <p:spPr>
+          <a:xfrm>
+            <a:off x="9219895" y="3474720"/>
+            <a:ext cx="548640" cy="685800"/>
           </a:xfrm>
           <a:prstGeom prst="rect">
             <a:avLst/>
@@ -6807,7 +6857,7 @@
               <a:buNone/>
             </a:pPr>
             <a:r>
-              <a:rPr lang="en-US" sz="1600" dirty="0">
+              <a:rPr lang="en-US" sz="2200" dirty="0">
                 <a:solidFill>
                   <a:srgbClr val="000000"/>
                 </a:solidFill>
@@ -6815,13 +6865,38 @@
                 <a:ea typeface="Calibri" pitchFamily="34" charset="-122"/>
                 <a:cs typeface="Calibri" pitchFamily="34" charset="-120"/>
               </a:rPr>
-              <a:t>📱  </a:t>
-            </a:r>
-            <a:pPr algn="ctr" indent="0" marL="0">
-              <a:buNone/>
-            </a:pPr>
-            <a:r>
-              <a:rPr lang="en-US" sz="1400" b="1" dirty="0">
+              <a:t>📱</a:t>
+            </a:r>
+            <a:endParaRPr lang="en-US" sz="2200" dirty="0"/>
+          </a:p>
+        </p:txBody>
+      </p:sp>
+      <p:sp>
+        <p:nvSpPr>
+          <p:cNvPr id="15" name="Text 13"/>
+          <p:cNvSpPr/>
+          <p:nvPr/>
+        </p:nvSpPr>
+        <p:spPr>
+          <a:xfrm>
+            <a:off x="9859975" y="3566160"/>
+            <a:ext cx="1783080" cy="320040"/>
+          </a:xfrm>
+          <a:prstGeom prst="rect">
+            <a:avLst/>
+          </a:prstGeom>
+          <a:noFill/>
+          <a:ln/>
+        </p:spPr>
+        <p:txBody>
+          <a:bodyPr wrap="square" rtlCol="0" anchor="ctr"/>
+          <a:lstStyle/>
+          <a:p>
+            <a:pPr indent="0" marL="0">
+              <a:buNone/>
+            </a:pPr>
+            <a:r>
+              <a:rPr lang="en-US" sz="1600" b="1" dirty="0">
                 <a:solidFill>
                   <a:srgbClr val="FAF8FF"/>
                 </a:solidFill>
@@ -6831,7 +6906,32 @@
               </a:rPr>
               <a:t>triage</a:t>
             </a:r>
-            <a:pPr algn="ctr" indent="0" marL="0">
+            <a:endParaRPr lang="en-US" sz="1600" dirty="0"/>
+          </a:p>
+        </p:txBody>
+      </p:sp>
+      <p:sp>
+        <p:nvSpPr>
+          <p:cNvPr id="16" name="Text 14"/>
+          <p:cNvSpPr/>
+          <p:nvPr/>
+        </p:nvSpPr>
+        <p:spPr>
+          <a:xfrm>
+            <a:off x="9859975" y="3840480"/>
+            <a:ext cx="1783080" cy="274320"/>
+          </a:xfrm>
+          <a:prstGeom prst="rect">
+            <a:avLst/>
+          </a:prstGeom>
+          <a:noFill/>
+          <a:ln/>
+        </p:spPr>
+        <p:txBody>
+          <a:bodyPr wrap="square" rtlCol="0" anchor="ctr"/>
+          <a:lstStyle/>
+          <a:p>
+            <a:pPr indent="0" marL="0">
               <a:buNone/>
             </a:pPr>
             <a:r>
@@ -6843,22 +6943,22 @@
                 <a:ea typeface="Calibri" pitchFamily="34" charset="-122"/>
                 <a:cs typeface="Calibri" pitchFamily="34" charset="-120"/>
               </a:rPr>
-              <a:t>   Apple Intelligence</a:t>
-            </a:r>
-            <a:endParaRPr lang="en-US" sz="1600" dirty="0"/>
-          </a:p>
-        </p:txBody>
-      </p:sp>
-      <p:sp>
-        <p:nvSpPr>
-          <p:cNvPr id="13" name="Shape 11"/>
-          <p:cNvSpPr/>
-          <p:nvPr/>
-        </p:nvSpPr>
-        <p:spPr>
-          <a:xfrm>
-            <a:off x="5968898" y="2743200"/>
-            <a:ext cx="253898" cy="0"/>
+              <a:t>Apple Intelligence</a:t>
+            </a:r>
+            <a:endParaRPr lang="en-US" sz="1100" dirty="0"/>
+          </a:p>
+        </p:txBody>
+      </p:sp>
+      <p:sp>
+        <p:nvSpPr>
+          <p:cNvPr id="17" name="Shape 15"/>
+          <p:cNvSpPr/>
+          <p:nvPr/>
+        </p:nvSpPr>
+        <p:spPr>
+          <a:xfrm>
+            <a:off x="10408615" y="4206240"/>
+            <a:ext cx="0" cy="228600"/>
           </a:xfrm>
           <a:prstGeom prst="line">
             <a:avLst/>
@@ -6874,16 +6974,16 @@
       </p:sp>
       <p:sp>
         <p:nvSpPr>
-          <p:cNvPr id="14" name="Shape 12"/>
-          <p:cNvSpPr/>
-          <p:nvPr/>
-        </p:nvSpPr>
-        <p:spPr>
-          <a:xfrm rot="5400000">
-            <a:off x="6085637" y="2670048"/>
-            <a:ext cx="164592" cy="146304"/>
-          </a:xfrm>
-          <a:prstGeom prst="rightTriangle">
+          <p:cNvPr id="18" name="Shape 16"/>
+          <p:cNvSpPr/>
+          <p:nvPr/>
+        </p:nvSpPr>
+        <p:spPr>
+          <a:xfrm flipV="1">
+            <a:off x="10317175" y="4434840"/>
+            <a:ext cx="182880" cy="164592"/>
+          </a:xfrm>
+          <a:prstGeom prst="triangle">
             <a:avLst/>
           </a:prstGeom>
           <a:solidFill>
@@ -6899,18 +6999,18 @@
       </p:sp>
       <p:sp>
         <p:nvSpPr>
-          <p:cNvPr id="15" name="Shape 13"/>
-          <p:cNvSpPr/>
-          <p:nvPr/>
-        </p:nvSpPr>
-        <p:spPr>
-          <a:xfrm>
-            <a:off x="6268517" y="2468880"/>
-            <a:ext cx="2377440" cy="548640"/>
+          <p:cNvPr id="19" name="Shape 17"/>
+          <p:cNvSpPr/>
+          <p:nvPr/>
+        </p:nvSpPr>
+        <p:spPr>
+          <a:xfrm>
+            <a:off x="9082735" y="4572000"/>
+            <a:ext cx="2651760" cy="685800"/>
           </a:xfrm>
           <a:prstGeom prst="roundRect">
             <a:avLst>
-              <a:gd name="adj" fmla="val 50000"/>
+              <a:gd name="adj" fmla="val 24000"/>
             </a:avLst>
           </a:prstGeom>
           <a:solidFill>
@@ -6926,14 +7026,14 @@
       </p:sp>
       <p:sp>
         <p:nvSpPr>
-          <p:cNvPr id="16" name="Text 14"/>
-          <p:cNvSpPr/>
-          <p:nvPr/>
-        </p:nvSpPr>
-        <p:spPr>
-          <a:xfrm>
-            <a:off x="6359957" y="2468880"/>
-            <a:ext cx="2194560" cy="548640"/>
+          <p:cNvPr id="20" name="Text 18"/>
+          <p:cNvSpPr/>
+          <p:nvPr/>
+        </p:nvSpPr>
+        <p:spPr>
+          <a:xfrm>
+            <a:off x="9219895" y="4572000"/>
+            <a:ext cx="548640" cy="685800"/>
           </a:xfrm>
           <a:prstGeom prst="rect">
             <a:avLst/>
@@ -6949,7 +7049,7 @@
               <a:buNone/>
             </a:pPr>
             <a:r>
-              <a:rPr lang="en-US" sz="1600" dirty="0">
+              <a:rPr lang="en-US" sz="2200" dirty="0">
                 <a:solidFill>
                   <a:srgbClr val="000000"/>
                 </a:solidFill>
@@ -6957,13 +7057,38 @@
                 <a:ea typeface="Calibri" pitchFamily="34" charset="-122"/>
                 <a:cs typeface="Calibri" pitchFamily="34" charset="-120"/>
               </a:rPr>
-              <a:t>☁️  </a:t>
-            </a:r>
-            <a:pPr algn="ctr" indent="0" marL="0">
-              <a:buNone/>
-            </a:pPr>
-            <a:r>
-              <a:rPr lang="en-US" sz="1400" b="1" dirty="0">
+              <a:t>☁️</a:t>
+            </a:r>
+            <a:endParaRPr lang="en-US" sz="2200" dirty="0"/>
+          </a:p>
+        </p:txBody>
+      </p:sp>
+      <p:sp>
+        <p:nvSpPr>
+          <p:cNvPr id="21" name="Text 19"/>
+          <p:cNvSpPr/>
+          <p:nvPr/>
+        </p:nvSpPr>
+        <p:spPr>
+          <a:xfrm>
+            <a:off x="9859975" y="4663440"/>
+            <a:ext cx="1783080" cy="320040"/>
+          </a:xfrm>
+          <a:prstGeom prst="rect">
+            <a:avLst/>
+          </a:prstGeom>
+          <a:noFill/>
+          <a:ln/>
+        </p:spPr>
+        <p:txBody>
+          <a:bodyPr wrap="square" rtlCol="0" anchor="ctr"/>
+          <a:lstStyle/>
+          <a:p>
+            <a:pPr indent="0" marL="0">
+              <a:buNone/>
+            </a:pPr>
+            <a:r>
+              <a:rPr lang="en-US" sz="1600" b="1" dirty="0">
                 <a:solidFill>
                   <a:srgbClr val="FAF8FF"/>
                 </a:solidFill>
@@ -6973,7 +7098,32 @@
               </a:rPr>
               <a:t>expert</a:t>
             </a:r>
-            <a:pPr algn="ctr" indent="0" marL="0">
+            <a:endParaRPr lang="en-US" sz="1600" dirty="0"/>
+          </a:p>
+        </p:txBody>
+      </p:sp>
+      <p:sp>
+        <p:nvSpPr>
+          <p:cNvPr id="22" name="Text 20"/>
+          <p:cNvSpPr/>
+          <p:nvPr/>
+        </p:nvSpPr>
+        <p:spPr>
+          <a:xfrm>
+            <a:off x="9859975" y="4937760"/>
+            <a:ext cx="1783080" cy="274320"/>
+          </a:xfrm>
+          <a:prstGeom prst="rect">
+            <a:avLst/>
+          </a:prstGeom>
+          <a:noFill/>
+          <a:ln/>
+        </p:spPr>
+        <p:txBody>
+          <a:bodyPr wrap="square" rtlCol="0" anchor="ctr"/>
+          <a:lstStyle/>
+          <a:p>
+            <a:pPr indent="0" marL="0">
               <a:buNone/>
             </a:pPr>
             <a:r>
@@ -6985,22 +7135,22 @@
                 <a:ea typeface="Calibri" pitchFamily="34" charset="-122"/>
                 <a:cs typeface="Calibri" pitchFamily="34" charset="-120"/>
               </a:rPr>
-              <a:t>   Azure OpenAI</a:t>
-            </a:r>
-            <a:endParaRPr lang="en-US" sz="1600" dirty="0"/>
-          </a:p>
-        </p:txBody>
-      </p:sp>
-      <p:sp>
-        <p:nvSpPr>
-          <p:cNvPr id="17" name="Shape 15"/>
-          <p:cNvSpPr/>
-          <p:nvPr/>
-        </p:nvSpPr>
-        <p:spPr>
-          <a:xfrm>
-            <a:off x="8691677" y="2743200"/>
-            <a:ext cx="253898" cy="0"/>
+              <a:t>Azure OpenAI</a:t>
+            </a:r>
+            <a:endParaRPr lang="en-US" sz="1100" dirty="0"/>
+          </a:p>
+        </p:txBody>
+      </p:sp>
+      <p:sp>
+        <p:nvSpPr>
+          <p:cNvPr id="23" name="Shape 21"/>
+          <p:cNvSpPr/>
+          <p:nvPr/>
+        </p:nvSpPr>
+        <p:spPr>
+          <a:xfrm>
+            <a:off x="10408615" y="5303520"/>
+            <a:ext cx="0" cy="228600"/>
           </a:xfrm>
           <a:prstGeom prst="line">
             <a:avLst/>
@@ -7016,16 +7166,16 @@
       </p:sp>
       <p:sp>
         <p:nvSpPr>
-          <p:cNvPr id="18" name="Shape 16"/>
-          <p:cNvSpPr/>
-          <p:nvPr/>
-        </p:nvSpPr>
-        <p:spPr>
-          <a:xfrm rot="5400000">
-            <a:off x="8808415" y="2670048"/>
-            <a:ext cx="164592" cy="146304"/>
-          </a:xfrm>
-          <a:prstGeom prst="rightTriangle">
+          <p:cNvPr id="24" name="Shape 22"/>
+          <p:cNvSpPr/>
+          <p:nvPr/>
+        </p:nvSpPr>
+        <p:spPr>
+          <a:xfrm flipV="1">
+            <a:off x="10317175" y="5532120"/>
+            <a:ext cx="182880" cy="164592"/>
+          </a:xfrm>
+          <a:prstGeom prst="triangle">
             <a:avLst/>
           </a:prstGeom>
           <a:solidFill>
@@ -7041,18 +7191,18 @@
       </p:sp>
       <p:sp>
         <p:nvSpPr>
-          <p:cNvPr id="19" name="Shape 17"/>
-          <p:cNvSpPr/>
-          <p:nvPr/>
-        </p:nvSpPr>
-        <p:spPr>
-          <a:xfrm>
-            <a:off x="8991295" y="2468880"/>
-            <a:ext cx="2377440" cy="548640"/>
+          <p:cNvPr id="25" name="Shape 23"/>
+          <p:cNvSpPr/>
+          <p:nvPr/>
+        </p:nvSpPr>
+        <p:spPr>
+          <a:xfrm>
+            <a:off x="9082735" y="5669280"/>
+            <a:ext cx="2651760" cy="685800"/>
           </a:xfrm>
           <a:prstGeom prst="roundRect">
             <a:avLst>
-              <a:gd name="adj" fmla="val 50000"/>
+              <a:gd name="adj" fmla="val 24000"/>
             </a:avLst>
           </a:prstGeom>
           <a:solidFill>
@@ -7068,14 +7218,14 @@
       </p:sp>
       <p:sp>
         <p:nvSpPr>
-          <p:cNvPr id="20" name="Text 18"/>
-          <p:cNvSpPr/>
-          <p:nvPr/>
-        </p:nvSpPr>
-        <p:spPr>
-          <a:xfrm>
-            <a:off x="9082735" y="2468880"/>
-            <a:ext cx="2194560" cy="548640"/>
+          <p:cNvPr id="26" name="Text 24"/>
+          <p:cNvSpPr/>
+          <p:nvPr/>
+        </p:nvSpPr>
+        <p:spPr>
+          <a:xfrm>
+            <a:off x="9219895" y="5669280"/>
+            <a:ext cx="548640" cy="685800"/>
           </a:xfrm>
           <a:prstGeom prst="rect">
             <a:avLst/>
@@ -7091,7 +7241,7 @@
               <a:buNone/>
             </a:pPr>
             <a:r>
-              <a:rPr lang="en-US" sz="1600" dirty="0">
+              <a:rPr lang="en-US" sz="2200" dirty="0">
                 <a:solidFill>
                   <a:srgbClr val="000000"/>
                 </a:solidFill>
@@ -7099,13 +7249,38 @@
                 <a:ea typeface="Calibri" pitchFamily="34" charset="-122"/>
                 <a:cs typeface="Calibri" pitchFamily="34" charset="-120"/>
               </a:rPr>
-              <a:t>👤  </a:t>
-            </a:r>
-            <a:pPr algn="ctr" indent="0" marL="0">
-              <a:buNone/>
-            </a:pPr>
-            <a:r>
-              <a:rPr lang="en-US" sz="1400" b="1" dirty="0">
+              <a:t>👤</a:t>
+            </a:r>
+            <a:endParaRPr lang="en-US" sz="2200" dirty="0"/>
+          </a:p>
+        </p:txBody>
+      </p:sp>
+      <p:sp>
+        <p:nvSpPr>
+          <p:cNvPr id="27" name="Text 25"/>
+          <p:cNvSpPr/>
+          <p:nvPr/>
+        </p:nvSpPr>
+        <p:spPr>
+          <a:xfrm>
+            <a:off x="9859975" y="5760720"/>
+            <a:ext cx="1783080" cy="320040"/>
+          </a:xfrm>
+          <a:prstGeom prst="rect">
+            <a:avLst/>
+          </a:prstGeom>
+          <a:noFill/>
+          <a:ln/>
+        </p:spPr>
+        <p:txBody>
+          <a:bodyPr wrap="square" rtlCol="0" anchor="ctr"/>
+          <a:lstStyle/>
+          <a:p>
+            <a:pPr indent="0" marL="0">
+              <a:buNone/>
+            </a:pPr>
+            <a:r>
+              <a:rPr lang="en-US" sz="1600" b="1" dirty="0">
                 <a:solidFill>
                   <a:srgbClr val="FAF8FF"/>
                 </a:solidFill>
@@ -7113,9 +7288,34 @@
                 <a:ea typeface="Calibri" pitchFamily="34" charset="-122"/>
                 <a:cs typeface="Calibri" pitchFamily="34" charset="-120"/>
               </a:rPr>
-              <a:t>User</a:t>
-            </a:r>
-            <a:pPr algn="ctr" indent="0" marL="0">
+              <a:t>User answer</a:t>
+            </a:r>
+            <a:endParaRPr lang="en-US" sz="1600" dirty="0"/>
+          </a:p>
+        </p:txBody>
+      </p:sp>
+      <p:sp>
+        <p:nvSpPr>
+          <p:cNvPr id="28" name="Text 26"/>
+          <p:cNvSpPr/>
+          <p:nvPr/>
+        </p:nvSpPr>
+        <p:spPr>
+          <a:xfrm>
+            <a:off x="9859975" y="6035040"/>
+            <a:ext cx="1783080" cy="274320"/>
+          </a:xfrm>
+          <a:prstGeom prst="rect">
+            <a:avLst/>
+          </a:prstGeom>
+          <a:noFill/>
+          <a:ln/>
+        </p:spPr>
+        <p:txBody>
+          <a:bodyPr wrap="square" rtlCol="0" anchor="ctr"/>
+          <a:lstStyle/>
+          <a:p>
+            <a:pPr indent="0" marL="0">
               <a:buNone/>
             </a:pPr>
             <a:r>
@@ -7127,26 +7327,26 @@
                 <a:ea typeface="Calibri" pitchFamily="34" charset="-122"/>
                 <a:cs typeface="Calibri" pitchFamily="34" charset="-120"/>
               </a:rPr>
-              <a:t>   answer</a:t>
-            </a:r>
-            <a:endParaRPr lang="en-US" sz="1600" dirty="0"/>
-          </a:p>
-        </p:txBody>
-      </p:sp>
-      <p:sp>
-        <p:nvSpPr>
-          <p:cNvPr id="21" name="Shape 19"/>
-          <p:cNvSpPr/>
-          <p:nvPr/>
-        </p:nvSpPr>
-        <p:spPr>
-          <a:xfrm>
-            <a:off x="822960" y="3291840"/>
-            <a:ext cx="10911535" cy="3200400"/>
+              <a:t>sanitised reply</a:t>
+            </a:r>
+            <a:endParaRPr lang="en-US" sz="1100" dirty="0"/>
+          </a:p>
+        </p:txBody>
+      </p:sp>
+      <p:sp>
+        <p:nvSpPr>
+          <p:cNvPr id="29" name="Shape 27"/>
+          <p:cNvSpPr/>
+          <p:nvPr/>
+        </p:nvSpPr>
+        <p:spPr>
+          <a:xfrm>
+            <a:off x="822960" y="2377440"/>
+            <a:ext cx="7985455" cy="4114800"/>
           </a:xfrm>
           <a:prstGeom prst="roundRect">
             <a:avLst>
-              <a:gd name="adj" fmla="val 2857"/>
+              <a:gd name="adj" fmla="val 2222"/>
             </a:avLst>
           </a:prstGeom>
           <a:solidFill>
@@ -7162,14 +7362,14 @@
       </p:sp>
       <p:sp>
         <p:nvSpPr>
-          <p:cNvPr id="22" name="Text 20"/>
-          <p:cNvSpPr/>
-          <p:nvPr/>
-        </p:nvSpPr>
-        <p:spPr>
-          <a:xfrm>
-            <a:off x="1051560" y="3456432"/>
-            <a:ext cx="10454335" cy="2880360"/>
+          <p:cNvPr id="30" name="Text 28"/>
+          <p:cNvSpPr/>
+          <p:nvPr/>
+        </p:nvSpPr>
+        <p:spPr>
+          <a:xfrm>
+            <a:off x="1051560" y="2542032"/>
+            <a:ext cx="7528255" cy="3794760"/>
           </a:xfrm>
           <a:prstGeom prst="rect">
             <a:avLst/>
@@ -7392,9 +7592,29 @@
             <a:pPr indent="0" marL="0">
               <a:buNone/>
             </a:pPr>
+            <a:endParaRPr lang="en-US" sz="1200" dirty="0"/>
+          </a:p>
+          <a:p>
+            <a:pPr indent="0" marL="0">
+              <a:buNone/>
+            </a:pPr>
             <a:r>
               <a:rPr lang="en-US" sz="1200" dirty="0">
                 <a:solidFill>
+                  <a:srgbClr val="FAF8FF"/>
+                </a:solidFill>
+                <a:latin typeface="Consolas" pitchFamily="34" charset="0"/>
+                <a:ea typeface="Consolas" pitchFamily="34" charset="-122"/>
+                <a:cs typeface="Consolas" pitchFamily="34" charset="-120"/>
+              </a:rPr>
+              <a:t>        </a:t>
+            </a:r>
+            <a:pPr indent="0" marL="0">
+              <a:buNone/>
+            </a:pPr>
+            <a:r>
+              <a:rPr lang="en-US" sz="1200" dirty="0">
+                <a:solidFill>
                   <a:srgbClr val="FBBF24"/>
                 </a:solidFill>
                 <a:latin typeface="Consolas" pitchFamily="34" charset="0"/>
@@ -7420,6 +7640,12 @@
             <a:pPr indent="0" marL="0">
               <a:buNone/>
             </a:pPr>
+            <a:endParaRPr lang="en-US" sz="1200" dirty="0"/>
+          </a:p>
+          <a:p>
+            <a:pPr indent="0" marL="0">
+              <a:buNone/>
+            </a:pPr>
             <a:r>
               <a:rPr lang="en-US" sz="1200" dirty="0">
                 <a:solidFill>
@@ -7429,6 +7655,48 @@
                 <a:ea typeface="Consolas" pitchFamily="34" charset="-122"/>
                 <a:cs typeface="Consolas" pitchFamily="34" charset="-120"/>
               </a:rPr>
+              <a:t>        </a:t>
+            </a:r>
+            <a:pPr indent="0" marL="0">
+              <a:buNone/>
+            </a:pPr>
+            <a:r>
+              <a:rPr lang="en-US" sz="1200" dirty="0">
+                <a:solidFill>
+                  <a:srgbClr val="FAF8FF"/>
+                </a:solidFill>
+                <a:latin typeface="Consolas" pitchFamily="34" charset="0"/>
+                <a:ea typeface="Consolas" pitchFamily="34" charset="-122"/>
+                <a:cs typeface="Consolas" pitchFamily="34" charset="-120"/>
+              </a:rPr>
+              <a:t>name</a:t>
+            </a:r>
+            <a:pPr indent="0" marL="0">
+              <a:buNone/>
+            </a:pPr>
+            <a:r>
+              <a:rPr lang="en-US" sz="1200" dirty="0">
+                <a:solidFill>
+                  <a:srgbClr val="B8B5D9"/>
+                </a:solidFill>
+                <a:latin typeface="Consolas" pitchFamily="34" charset="0"/>
+                <a:ea typeface="Consolas" pitchFamily="34" charset="-122"/>
+                <a:cs typeface="Consolas" pitchFamily="34" charset="-120"/>
+              </a:rPr>
+              <a:t>:</a:t>
+            </a:r>
+            <a:pPr indent="0" marL="0">
+              <a:buNone/>
+            </a:pPr>
+            <a:r>
+              <a:rPr lang="en-US" sz="1200" dirty="0">
+                <a:solidFill>
+                  <a:srgbClr val="FAF8FF"/>
+                </a:solidFill>
+                <a:latin typeface="Consolas" pitchFamily="34" charset="0"/>
+                <a:ea typeface="Consolas" pitchFamily="34" charset="-122"/>
+                <a:cs typeface="Consolas" pitchFamily="34" charset="-120"/>
+              </a:rPr>
               <a:t> </a:t>
             </a:r>
             <a:pPr indent="0" marL="0">
@@ -7437,13 +7705,101 @@
             <a:r>
               <a:rPr lang="en-US" sz="1200" dirty="0">
                 <a:solidFill>
+                  <a:srgbClr val="FBBF24"/>
+                </a:solidFill>
+                <a:latin typeface="Consolas" pitchFamily="34" charset="0"/>
+                <a:ea typeface="Consolas" pitchFamily="34" charset="-122"/>
+                <a:cs typeface="Consolas" pitchFamily="34" charset="-120"/>
+              </a:rPr>
+              <a:t>"triage"</a:t>
+            </a:r>
+            <a:pPr indent="0" marL="0">
+              <a:buNone/>
+            </a:pPr>
+            <a:r>
+              <a:rPr lang="en-US" sz="1200" dirty="0">
+                <a:solidFill>
+                  <a:srgbClr val="B8B5D9"/>
+                </a:solidFill>
+                <a:latin typeface="Consolas" pitchFamily="34" charset="0"/>
+                <a:ea typeface="Consolas" pitchFamily="34" charset="-122"/>
+                <a:cs typeface="Consolas" pitchFamily="34" charset="-120"/>
+              </a:rPr>
+              <a:t>)</a:t>
+            </a:r>
+            <a:pPr indent="0" marL="0">
+              <a:buNone/>
+            </a:pPr>
+            <a:r>
+              <a:rPr lang="en-US" sz="1200" dirty="0">
+                <a:solidFill>
+                  <a:srgbClr val="B8B5D9"/>
+                </a:solidFill>
+                <a:latin typeface="Consolas" pitchFamily="34" charset="0"/>
+                <a:ea typeface="Consolas" pitchFamily="34" charset="-122"/>
+                <a:cs typeface="Consolas" pitchFamily="34" charset="-120"/>
+              </a:rPr>
+              <a:t>;</a:t>
+            </a:r>
+            <a:pPr indent="0" marL="0">
+              <a:buNone/>
+            </a:pPr>
+            <a:endParaRPr lang="en-US" sz="1200" dirty="0"/>
+          </a:p>
+          <a:p>
+            <a:pPr indent="0" marL="0">
+              <a:buNone/>
+            </a:pPr>
+            <a:endParaRPr lang="en-US" sz="1200" dirty="0"/>
+          </a:p>
+          <a:p>
+            <a:pPr indent="0" marL="0">
+              <a:buNone/>
+            </a:pPr>
+            <a:r>
+              <a:rPr lang="en-US" sz="1200" i="1" dirty="0">
+                <a:solidFill>
+                  <a:srgbClr val="8B88B5"/>
+                </a:solidFill>
+                <a:latin typeface="Consolas" pitchFamily="34" charset="0"/>
+                <a:ea typeface="Consolas" pitchFamily="34" charset="-122"/>
+                <a:cs typeface="Consolas" pitchFamily="34" charset="-120"/>
+              </a:rPr>
+              <a:t>// ☁️  Cloud — Azure OpenAI, frontier reasoning</a:t>
+            </a:r>
+            <a:pPr indent="0" marL="0">
+              <a:buNone/>
+            </a:pPr>
+            <a:endParaRPr lang="en-US" sz="1200" dirty="0"/>
+          </a:p>
+          <a:p>
+            <a:pPr indent="0" marL="0">
+              <a:buNone/>
+            </a:pPr>
+            <a:r>
+              <a:rPr lang="en-US" sz="1200" dirty="0">
+                <a:solidFill>
+                  <a:srgbClr val="A78BFA"/>
+                </a:solidFill>
+                <a:latin typeface="Consolas" pitchFamily="34" charset="0"/>
+                <a:ea typeface="Consolas" pitchFamily="34" charset="-122"/>
+                <a:cs typeface="Consolas" pitchFamily="34" charset="-120"/>
+              </a:rPr>
+              <a:t>AIAgent</a:t>
+            </a:r>
+            <a:pPr indent="0" marL="0">
+              <a:buNone/>
+            </a:pPr>
+            <a:r>
+              <a:rPr lang="en-US" sz="1200" dirty="0">
+                <a:solidFill>
                   <a:srgbClr val="FAF8FF"/>
                 </a:solidFill>
                 <a:latin typeface="Consolas" pitchFamily="34" charset="0"/>
                 <a:ea typeface="Consolas" pitchFamily="34" charset="-122"/>
                 <a:cs typeface="Consolas" pitchFamily="34" charset="-120"/>
               </a:rPr>
-              <a:t>name</a:t>
+              <a:t> expert </a:t>
             </a:r>
             <a:pPr indent="0" marL="0">
               <a:buNone/>
@@ -7451,14 +7807,90 @@
             <a:r>
               <a:rPr lang="en-US" sz="1200" dirty="0">
                 <a:solidFill>
+                  <a:srgbClr val="CFCBED"/>
+                </a:solidFill>
+                <a:latin typeface="Consolas" pitchFamily="34" charset="0"/>
+                <a:ea typeface="Consolas" pitchFamily="34" charset="-122"/>
+                <a:cs typeface="Consolas" pitchFamily="34" charset="-120"/>
+              </a:rPr>
+              <a:t>=</a:t>
+            </a:r>
+            <a:pPr indent="0" marL="0">
+              <a:buNone/>
+            </a:pPr>
+            <a:r>
+              <a:rPr lang="en-US" sz="1200" dirty="0">
+                <a:solidFill>
+                  <a:srgbClr val="FAF8FF"/>
+                </a:solidFill>
+                <a:latin typeface="Consolas" pitchFamily="34" charset="0"/>
+                <a:ea typeface="Consolas" pitchFamily="34" charset="-122"/>
+                <a:cs typeface="Consolas" pitchFamily="34" charset="-120"/>
+              </a:rPr>
+              <a:t> </a:t>
+            </a:r>
+            <a:pPr indent="0" marL="0">
+              <a:buNone/>
+            </a:pPr>
+            <a:r>
+              <a:rPr lang="en-US" sz="1200" dirty="0">
+                <a:solidFill>
+                  <a:srgbClr val="FB7185"/>
+                </a:solidFill>
+                <a:latin typeface="Consolas" pitchFamily="34" charset="0"/>
+                <a:ea typeface="Consolas" pitchFamily="34" charset="-122"/>
+                <a:cs typeface="Consolas" pitchFamily="34" charset="-120"/>
+              </a:rPr>
+              <a:t>new</a:t>
+            </a:r>
+            <a:pPr indent="0" marL="0">
+              <a:buNone/>
+            </a:pPr>
+            <a:r>
+              <a:rPr lang="en-US" sz="1200" dirty="0">
+                <a:solidFill>
+                  <a:srgbClr val="FAF8FF"/>
+                </a:solidFill>
+                <a:latin typeface="Consolas" pitchFamily="34" charset="0"/>
+                <a:ea typeface="Consolas" pitchFamily="34" charset="-122"/>
+                <a:cs typeface="Consolas" pitchFamily="34" charset="-120"/>
+              </a:rPr>
+              <a:t> </a:t>
+            </a:r>
+            <a:pPr indent="0" marL="0">
+              <a:buNone/>
+            </a:pPr>
+            <a:r>
+              <a:rPr lang="en-US" sz="1200" dirty="0">
+                <a:solidFill>
+                  <a:srgbClr val="FAF8FF"/>
+                </a:solidFill>
+                <a:latin typeface="Consolas" pitchFamily="34" charset="0"/>
+                <a:ea typeface="Consolas" pitchFamily="34" charset="-122"/>
+                <a:cs typeface="Consolas" pitchFamily="34" charset="-120"/>
+              </a:rPr>
+              <a:t>AzureOpenAIClient</a:t>
+            </a:r>
+            <a:pPr indent="0" marL="0">
+              <a:buNone/>
+            </a:pPr>
+            <a:r>
+              <a:rPr lang="en-US" sz="1200" dirty="0">
+                <a:solidFill>
                   <a:srgbClr val="B8B5D9"/>
                 </a:solidFill>
                 <a:latin typeface="Consolas" pitchFamily="34" charset="0"/>
                 <a:ea typeface="Consolas" pitchFamily="34" charset="-122"/>
                 <a:cs typeface="Consolas" pitchFamily="34" charset="-120"/>
               </a:rPr>
-              <a:t>:</a:t>
-            </a:r>
+              <a:t>(</a:t>
+            </a:r>
+            <a:pPr indent="0" marL="0">
+              <a:buNone/>
+            </a:pPr>
+            <a:endParaRPr lang="en-US" sz="1200" dirty="0"/>
+          </a:p>
+          <a:p>
             <a:pPr indent="0" marL="0">
               <a:buNone/>
             </a:pPr>
@@ -7471,6 +7903,34 @@
                 <a:ea typeface="Consolas" pitchFamily="34" charset="-122"/>
                 <a:cs typeface="Consolas" pitchFamily="34" charset="-120"/>
               </a:rPr>
+              <a:t>        endpoint</a:t>
+            </a:r>
+            <a:pPr indent="0" marL="0">
+              <a:buNone/>
+            </a:pPr>
+            <a:r>
+              <a:rPr lang="en-US" sz="1200" dirty="0">
+                <a:solidFill>
+                  <a:srgbClr val="B8B5D9"/>
+                </a:solidFill>
+                <a:latin typeface="Consolas" pitchFamily="34" charset="0"/>
+                <a:ea typeface="Consolas" pitchFamily="34" charset="-122"/>
+                <a:cs typeface="Consolas" pitchFamily="34" charset="-120"/>
+              </a:rPr>
+              <a:t>,</a:t>
+            </a:r>
+            <a:pPr indent="0" marL="0">
+              <a:buNone/>
+            </a:pPr>
+            <a:r>
+              <a:rPr lang="en-US" sz="1200" dirty="0">
+                <a:solidFill>
+                  <a:srgbClr val="FAF8FF"/>
+                </a:solidFill>
+                <a:latin typeface="Consolas" pitchFamily="34" charset="0"/>
+                <a:ea typeface="Consolas" pitchFamily="34" charset="-122"/>
+                <a:cs typeface="Consolas" pitchFamily="34" charset="-120"/>
+              </a:rPr>
               <a:t> </a:t>
             </a:r>
             <a:pPr indent="0" marL="0">
@@ -7479,13 +7939,159 @@
             <a:r>
               <a:rPr lang="en-US" sz="1200" dirty="0">
                 <a:solidFill>
+                  <a:srgbClr val="FB7185"/>
+                </a:solidFill>
+                <a:latin typeface="Consolas" pitchFamily="34" charset="0"/>
+                <a:ea typeface="Consolas" pitchFamily="34" charset="-122"/>
+                <a:cs typeface="Consolas" pitchFamily="34" charset="-120"/>
+              </a:rPr>
+              <a:t>new</a:t>
+            </a:r>
+            <a:pPr indent="0" marL="0">
+              <a:buNone/>
+            </a:pPr>
+            <a:r>
+              <a:rPr lang="en-US" sz="1200" dirty="0">
+                <a:solidFill>
+                  <a:srgbClr val="FAF8FF"/>
+                </a:solidFill>
+                <a:latin typeface="Consolas" pitchFamily="34" charset="0"/>
+                <a:ea typeface="Consolas" pitchFamily="34" charset="-122"/>
+                <a:cs typeface="Consolas" pitchFamily="34" charset="-120"/>
+              </a:rPr>
+              <a:t> </a:t>
+            </a:r>
+            <a:pPr indent="0" marL="0">
+              <a:buNone/>
+            </a:pPr>
+            <a:r>
+              <a:rPr lang="en-US" sz="1200" dirty="0">
+                <a:solidFill>
+                  <a:srgbClr val="FAF8FF"/>
+                </a:solidFill>
+                <a:latin typeface="Consolas" pitchFamily="34" charset="0"/>
+                <a:ea typeface="Consolas" pitchFamily="34" charset="-122"/>
+                <a:cs typeface="Consolas" pitchFamily="34" charset="-120"/>
+              </a:rPr>
+              <a:t>DefaultAzureCredential</a:t>
+            </a:r>
+            <a:pPr indent="0" marL="0">
+              <a:buNone/>
+            </a:pPr>
+            <a:r>
+              <a:rPr lang="en-US" sz="1200" dirty="0">
+                <a:solidFill>
+                  <a:srgbClr val="B8B5D9"/>
+                </a:solidFill>
+                <a:latin typeface="Consolas" pitchFamily="34" charset="0"/>
+                <a:ea typeface="Consolas" pitchFamily="34" charset="-122"/>
+                <a:cs typeface="Consolas" pitchFamily="34" charset="-120"/>
+              </a:rPr>
+              <a:t>(</a:t>
+            </a:r>
+            <a:pPr indent="0" marL="0">
+              <a:buNone/>
+            </a:pPr>
+            <a:r>
+              <a:rPr lang="en-US" sz="1200" dirty="0">
+                <a:solidFill>
+                  <a:srgbClr val="B8B5D9"/>
+                </a:solidFill>
+                <a:latin typeface="Consolas" pitchFamily="34" charset="0"/>
+                <a:ea typeface="Consolas" pitchFamily="34" charset="-122"/>
+                <a:cs typeface="Consolas" pitchFamily="34" charset="-120"/>
+              </a:rPr>
+              <a:t>)</a:t>
+            </a:r>
+            <a:pPr indent="0" marL="0">
+              <a:buNone/>
+            </a:pPr>
+            <a:r>
+              <a:rPr lang="en-US" sz="1200" dirty="0">
+                <a:solidFill>
+                  <a:srgbClr val="B8B5D9"/>
+                </a:solidFill>
+                <a:latin typeface="Consolas" pitchFamily="34" charset="0"/>
+                <a:ea typeface="Consolas" pitchFamily="34" charset="-122"/>
+                <a:cs typeface="Consolas" pitchFamily="34" charset="-120"/>
+              </a:rPr>
+              <a:t>)</a:t>
+            </a:r>
+            <a:pPr indent="0" marL="0">
+              <a:buNone/>
+            </a:pPr>
+            <a:endParaRPr lang="en-US" sz="1200" dirty="0"/>
+          </a:p>
+          <a:p>
+            <a:pPr indent="0" marL="0">
+              <a:buNone/>
+            </a:pPr>
+            <a:r>
+              <a:rPr lang="en-US" sz="1200" dirty="0">
+                <a:solidFill>
+                  <a:srgbClr val="FAF8FF"/>
+                </a:solidFill>
+                <a:latin typeface="Consolas" pitchFamily="34" charset="0"/>
+                <a:ea typeface="Consolas" pitchFamily="34" charset="-122"/>
+                <a:cs typeface="Consolas" pitchFamily="34" charset="-120"/>
+              </a:rPr>
+              <a:t>    </a:t>
+            </a:r>
+            <a:pPr indent="0" marL="0">
+              <a:buNone/>
+            </a:pPr>
+            <a:r>
+              <a:rPr lang="en-US" sz="1200" dirty="0">
+                <a:solidFill>
+                  <a:srgbClr val="B8B5D9"/>
+                </a:solidFill>
+                <a:latin typeface="Consolas" pitchFamily="34" charset="0"/>
+                <a:ea typeface="Consolas" pitchFamily="34" charset="-122"/>
+                <a:cs typeface="Consolas" pitchFamily="34" charset="-120"/>
+              </a:rPr>
+              <a:t>.</a:t>
+            </a:r>
+            <a:pPr indent="0" marL="0">
+              <a:buNone/>
+            </a:pPr>
+            <a:r>
+              <a:rPr lang="en-US" sz="1200" dirty="0">
+                <a:solidFill>
+                  <a:srgbClr val="86EFAC"/>
+                </a:solidFill>
+                <a:latin typeface="Consolas" pitchFamily="34" charset="0"/>
+                <a:ea typeface="Consolas" pitchFamily="34" charset="-122"/>
+                <a:cs typeface="Consolas" pitchFamily="34" charset="-120"/>
+              </a:rPr>
+              <a:t>GetChatClient</a:t>
+            </a:r>
+            <a:pPr indent="0" marL="0">
+              <a:buNone/>
+            </a:pPr>
+            <a:r>
+              <a:rPr lang="en-US" sz="1200" dirty="0">
+                <a:solidFill>
+                  <a:srgbClr val="B8B5D9"/>
+                </a:solidFill>
+                <a:latin typeface="Consolas" pitchFamily="34" charset="0"/>
+                <a:ea typeface="Consolas" pitchFamily="34" charset="-122"/>
+                <a:cs typeface="Consolas" pitchFamily="34" charset="-120"/>
+              </a:rPr>
+              <a:t>(</a:t>
+            </a:r>
+            <a:pPr indent="0" marL="0">
+              <a:buNone/>
+            </a:pPr>
+            <a:r>
+              <a:rPr lang="en-US" sz="1200" dirty="0">
+                <a:solidFill>
                   <a:srgbClr val="FBBF24"/>
                 </a:solidFill>
                 <a:latin typeface="Consolas" pitchFamily="34" charset="0"/>
                 <a:ea typeface="Consolas" pitchFamily="34" charset="-122"/>
                 <a:cs typeface="Consolas" pitchFamily="34" charset="-120"/>
               </a:rPr>
-              <a:t>"triage"</a:t>
+              <a:t>"gpt-4.1"</a:t>
             </a:r>
             <a:pPr indent="0" marL="0">
               <a:buNone/>
@@ -7513,7 +8119,49 @@
                 <a:ea typeface="Consolas" pitchFamily="34" charset="-122"/>
                 <a:cs typeface="Consolas" pitchFamily="34" charset="-120"/>
               </a:rPr>
-              <a:t>;</a:t>
+              <a:t>.</a:t>
+            </a:r>
+            <a:pPr indent="0" marL="0">
+              <a:buNone/>
+            </a:pPr>
+            <a:r>
+              <a:rPr lang="en-US" sz="1200" dirty="0">
+                <a:solidFill>
+                  <a:srgbClr val="86EFAC"/>
+                </a:solidFill>
+                <a:latin typeface="Consolas" pitchFamily="34" charset="0"/>
+                <a:ea typeface="Consolas" pitchFamily="34" charset="-122"/>
+                <a:cs typeface="Consolas" pitchFamily="34" charset="-120"/>
+              </a:rPr>
+              <a:t>AsIChatClient</a:t>
+            </a:r>
+            <a:pPr indent="0" marL="0">
+              <a:buNone/>
+            </a:pPr>
+            <a:r>
+              <a:rPr lang="en-US" sz="1200" dirty="0">
+                <a:solidFill>
+                  <a:srgbClr val="B8B5D9"/>
+                </a:solidFill>
+                <a:latin typeface="Consolas" pitchFamily="34" charset="0"/>
+                <a:ea typeface="Consolas" pitchFamily="34" charset="-122"/>
+                <a:cs typeface="Consolas" pitchFamily="34" charset="-120"/>
+              </a:rPr>
+              <a:t>(</a:t>
+            </a:r>
+            <a:pPr indent="0" marL="0">
+              <a:buNone/>
+            </a:pPr>
+            <a:r>
+              <a:rPr lang="en-US" sz="1200" dirty="0">
+                <a:solidFill>
+                  <a:srgbClr val="B8B5D9"/>
+                </a:solidFill>
+                <a:latin typeface="Consolas" pitchFamily="34" charset="0"/>
+                <a:ea typeface="Consolas" pitchFamily="34" charset="-122"/>
+                <a:cs typeface="Consolas" pitchFamily="34" charset="-120"/>
+              </a:rPr>
+              <a:t>)</a:t>
             </a:r>
             <a:pPr indent="0" marL="0">
               <a:buNone/>
@@ -7524,6 +8172,62 @@
             <a:pPr indent="0" marL="0">
               <a:buNone/>
             </a:pPr>
+            <a:r>
+              <a:rPr lang="en-US" sz="1200" dirty="0">
+                <a:solidFill>
+                  <a:srgbClr val="FAF8FF"/>
+                </a:solidFill>
+                <a:latin typeface="Consolas" pitchFamily="34" charset="0"/>
+                <a:ea typeface="Consolas" pitchFamily="34" charset="-122"/>
+                <a:cs typeface="Consolas" pitchFamily="34" charset="-120"/>
+              </a:rPr>
+              <a:t>    </a:t>
+            </a:r>
+            <a:pPr indent="0" marL="0">
+              <a:buNone/>
+            </a:pPr>
+            <a:r>
+              <a:rPr lang="en-US" sz="1200" dirty="0">
+                <a:solidFill>
+                  <a:srgbClr val="B8B5D9"/>
+                </a:solidFill>
+                <a:latin typeface="Consolas" pitchFamily="34" charset="0"/>
+                <a:ea typeface="Consolas" pitchFamily="34" charset="-122"/>
+                <a:cs typeface="Consolas" pitchFamily="34" charset="-120"/>
+              </a:rPr>
+              <a:t>.</a:t>
+            </a:r>
+            <a:pPr indent="0" marL="0">
+              <a:buNone/>
+            </a:pPr>
+            <a:r>
+              <a:rPr lang="en-US" sz="1200" dirty="0">
+                <a:solidFill>
+                  <a:srgbClr val="86EFAC"/>
+                </a:solidFill>
+                <a:latin typeface="Consolas" pitchFamily="34" charset="0"/>
+                <a:ea typeface="Consolas" pitchFamily="34" charset="-122"/>
+                <a:cs typeface="Consolas" pitchFamily="34" charset="-120"/>
+              </a:rPr>
+              <a:t>CreateAIAgent</a:t>
+            </a:r>
+            <a:pPr indent="0" marL="0">
+              <a:buNone/>
+            </a:pPr>
+            <a:r>
+              <a:rPr lang="en-US" sz="1200" dirty="0">
+                <a:solidFill>
+                  <a:srgbClr val="B8B5D9"/>
+                </a:solidFill>
+                <a:latin typeface="Consolas" pitchFamily="34" charset="0"/>
+                <a:ea typeface="Consolas" pitchFamily="34" charset="-122"/>
+                <a:cs typeface="Consolas" pitchFamily="34" charset="-120"/>
+              </a:rPr>
+              <a:t>(</a:t>
+            </a:r>
+            <a:pPr indent="0" marL="0">
+              <a:buNone/>
+            </a:pPr>
             <a:endParaRPr lang="en-US" sz="1200" dirty="0"/>
           </a:p>
           <a:p>
@@ -7531,15 +8235,43 @@
               <a:buNone/>
             </a:pPr>
             <a:r>
-              <a:rPr lang="en-US" sz="1200" i="1" dirty="0">
-                <a:solidFill>
-                  <a:srgbClr val="8B88B5"/>
-                </a:solidFill>
-                <a:latin typeface="Consolas" pitchFamily="34" charset="0"/>
-                <a:ea typeface="Consolas" pitchFamily="34" charset="-122"/>
-                <a:cs typeface="Consolas" pitchFamily="34" charset="-120"/>
-              </a:rPr>
-              <a:t>// ☁️  Cloud — Azure OpenAI, frontier reasoning</a:t>
+              <a:rPr lang="en-US" sz="1200" dirty="0">
+                <a:solidFill>
+                  <a:srgbClr val="FAF8FF"/>
+                </a:solidFill>
+                <a:latin typeface="Consolas" pitchFamily="34" charset="0"/>
+                <a:ea typeface="Consolas" pitchFamily="34" charset="-122"/>
+                <a:cs typeface="Consolas" pitchFamily="34" charset="-120"/>
+              </a:rPr>
+              <a:t>        </a:t>
+            </a:r>
+            <a:pPr indent="0" marL="0">
+              <a:buNone/>
+            </a:pPr>
+            <a:r>
+              <a:rPr lang="en-US" sz="1200" dirty="0">
+                <a:solidFill>
+                  <a:srgbClr val="FBBF24"/>
+                </a:solidFill>
+                <a:latin typeface="Consolas" pitchFamily="34" charset="0"/>
+                <a:ea typeface="Consolas" pitchFamily="34" charset="-122"/>
+                <a:cs typeface="Consolas" pitchFamily="34" charset="-120"/>
+              </a:rPr>
+              <a:t>"Answer with depth and current context."</a:t>
+            </a:r>
+            <a:pPr indent="0" marL="0">
+              <a:buNone/>
+            </a:pPr>
+            <a:r>
+              <a:rPr lang="en-US" sz="1200" dirty="0">
+                <a:solidFill>
+                  <a:srgbClr val="B8B5D9"/>
+                </a:solidFill>
+                <a:latin typeface="Consolas" pitchFamily="34" charset="0"/>
+                <a:ea typeface="Consolas" pitchFamily="34" charset="-122"/>
+                <a:cs typeface="Consolas" pitchFamily="34" charset="-120"/>
+              </a:rPr>
+              <a:t>,</a:t>
             </a:r>
             <a:pPr indent="0" marL="0">
               <a:buNone/>
@@ -7553,487 +8285,13 @@
             <a:r>
               <a:rPr lang="en-US" sz="1200" dirty="0">
                 <a:solidFill>
-                  <a:srgbClr val="A78BFA"/>
-                </a:solidFill>
-                <a:latin typeface="Consolas" pitchFamily="34" charset="0"/>
-                <a:ea typeface="Consolas" pitchFamily="34" charset="-122"/>
-                <a:cs typeface="Consolas" pitchFamily="34" charset="-120"/>
-              </a:rPr>
-              <a:t>AIAgent</a:t>
-            </a:r>
-            <a:pPr indent="0" marL="0">
-              <a:buNone/>
-            </a:pPr>
-            <a:r>
-              <a:rPr lang="en-US" sz="1200" dirty="0">
-                <a:solidFill>
                   <a:srgbClr val="FAF8FF"/>
                 </a:solidFill>
                 <a:latin typeface="Consolas" pitchFamily="34" charset="0"/>
                 <a:ea typeface="Consolas" pitchFamily="34" charset="-122"/>
                 <a:cs typeface="Consolas" pitchFamily="34" charset="-120"/>
               </a:rPr>
-              <a:t> expert </a:t>
-            </a:r>
-            <a:pPr indent="0" marL="0">
-              <a:buNone/>
-            </a:pPr>
-            <a:r>
-              <a:rPr lang="en-US" sz="1200" dirty="0">
-                <a:solidFill>
-                  <a:srgbClr val="CFCBED"/>
-                </a:solidFill>
-                <a:latin typeface="Consolas" pitchFamily="34" charset="0"/>
-                <a:ea typeface="Consolas" pitchFamily="34" charset="-122"/>
-                <a:cs typeface="Consolas" pitchFamily="34" charset="-120"/>
-              </a:rPr>
-              <a:t>=</a:t>
-            </a:r>
-            <a:pPr indent="0" marL="0">
-              <a:buNone/>
-            </a:pPr>
-            <a:r>
-              <a:rPr lang="en-US" sz="1200" dirty="0">
-                <a:solidFill>
-                  <a:srgbClr val="FAF8FF"/>
-                </a:solidFill>
-                <a:latin typeface="Consolas" pitchFamily="34" charset="0"/>
-                <a:ea typeface="Consolas" pitchFamily="34" charset="-122"/>
-                <a:cs typeface="Consolas" pitchFamily="34" charset="-120"/>
-              </a:rPr>
-              <a:t> </a:t>
-            </a:r>
-            <a:pPr indent="0" marL="0">
-              <a:buNone/>
-            </a:pPr>
-            <a:r>
-              <a:rPr lang="en-US" sz="1200" dirty="0">
-                <a:solidFill>
-                  <a:srgbClr val="FB7185"/>
-                </a:solidFill>
-                <a:latin typeface="Consolas" pitchFamily="34" charset="0"/>
-                <a:ea typeface="Consolas" pitchFamily="34" charset="-122"/>
-                <a:cs typeface="Consolas" pitchFamily="34" charset="-120"/>
-              </a:rPr>
-              <a:t>new</a:t>
-            </a:r>
-            <a:pPr indent="0" marL="0">
-              <a:buNone/>
-            </a:pPr>
-            <a:r>
-              <a:rPr lang="en-US" sz="1200" dirty="0">
-                <a:solidFill>
-                  <a:srgbClr val="FAF8FF"/>
-                </a:solidFill>
-                <a:latin typeface="Consolas" pitchFamily="34" charset="0"/>
-                <a:ea typeface="Consolas" pitchFamily="34" charset="-122"/>
-                <a:cs typeface="Consolas" pitchFamily="34" charset="-120"/>
-              </a:rPr>
-              <a:t> </a:t>
-            </a:r>
-            <a:pPr indent="0" marL="0">
-              <a:buNone/>
-            </a:pPr>
-            <a:r>
-              <a:rPr lang="en-US" sz="1200" dirty="0">
-                <a:solidFill>
-                  <a:srgbClr val="FAF8FF"/>
-                </a:solidFill>
-                <a:latin typeface="Consolas" pitchFamily="34" charset="0"/>
-                <a:ea typeface="Consolas" pitchFamily="34" charset="-122"/>
-                <a:cs typeface="Consolas" pitchFamily="34" charset="-120"/>
-              </a:rPr>
-              <a:t>AzureOpenAIClient</a:t>
-            </a:r>
-            <a:pPr indent="0" marL="0">
-              <a:buNone/>
-            </a:pPr>
-            <a:r>
-              <a:rPr lang="en-US" sz="1200" dirty="0">
-                <a:solidFill>
-                  <a:srgbClr val="B8B5D9"/>
-                </a:solidFill>
-                <a:latin typeface="Consolas" pitchFamily="34" charset="0"/>
-                <a:ea typeface="Consolas" pitchFamily="34" charset="-122"/>
-                <a:cs typeface="Consolas" pitchFamily="34" charset="-120"/>
-              </a:rPr>
-              <a:t>(</a:t>
-            </a:r>
-            <a:pPr indent="0" marL="0">
-              <a:buNone/>
-            </a:pPr>
-            <a:r>
-              <a:rPr lang="en-US" sz="1200" dirty="0">
-                <a:solidFill>
-                  <a:srgbClr val="FAF8FF"/>
-                </a:solidFill>
-                <a:latin typeface="Consolas" pitchFamily="34" charset="0"/>
-                <a:ea typeface="Consolas" pitchFamily="34" charset="-122"/>
-                <a:cs typeface="Consolas" pitchFamily="34" charset="-120"/>
-              </a:rPr>
-              <a:t>endpoint</a:t>
-            </a:r>
-            <a:pPr indent="0" marL="0">
-              <a:buNone/>
-            </a:pPr>
-            <a:r>
-              <a:rPr lang="en-US" sz="1200" dirty="0">
-                <a:solidFill>
-                  <a:srgbClr val="B8B5D9"/>
-                </a:solidFill>
-                <a:latin typeface="Consolas" pitchFamily="34" charset="0"/>
-                <a:ea typeface="Consolas" pitchFamily="34" charset="-122"/>
-                <a:cs typeface="Consolas" pitchFamily="34" charset="-120"/>
-              </a:rPr>
-              <a:t>,</a:t>
-            </a:r>
-            <a:pPr indent="0" marL="0">
-              <a:buNone/>
-            </a:pPr>
-            <a:r>
-              <a:rPr lang="en-US" sz="1200" dirty="0">
-                <a:solidFill>
-                  <a:srgbClr val="FAF8FF"/>
-                </a:solidFill>
-                <a:latin typeface="Consolas" pitchFamily="34" charset="0"/>
-                <a:ea typeface="Consolas" pitchFamily="34" charset="-122"/>
-                <a:cs typeface="Consolas" pitchFamily="34" charset="-120"/>
-              </a:rPr>
-              <a:t> </a:t>
-            </a:r>
-            <a:pPr indent="0" marL="0">
-              <a:buNone/>
-            </a:pPr>
-            <a:r>
-              <a:rPr lang="en-US" sz="1200" dirty="0">
-                <a:solidFill>
-                  <a:srgbClr val="FB7185"/>
-                </a:solidFill>
-                <a:latin typeface="Consolas" pitchFamily="34" charset="0"/>
-                <a:ea typeface="Consolas" pitchFamily="34" charset="-122"/>
-                <a:cs typeface="Consolas" pitchFamily="34" charset="-120"/>
-              </a:rPr>
-              <a:t>new</a:t>
-            </a:r>
-            <a:pPr indent="0" marL="0">
-              <a:buNone/>
-            </a:pPr>
-            <a:r>
-              <a:rPr lang="en-US" sz="1200" dirty="0">
-                <a:solidFill>
-                  <a:srgbClr val="FAF8FF"/>
-                </a:solidFill>
-                <a:latin typeface="Consolas" pitchFamily="34" charset="0"/>
-                <a:ea typeface="Consolas" pitchFamily="34" charset="-122"/>
-                <a:cs typeface="Consolas" pitchFamily="34" charset="-120"/>
-              </a:rPr>
-              <a:t> </a:t>
-            </a:r>
-            <a:pPr indent="0" marL="0">
-              <a:buNone/>
-            </a:pPr>
-            <a:r>
-              <a:rPr lang="en-US" sz="1200" dirty="0">
-                <a:solidFill>
-                  <a:srgbClr val="FAF8FF"/>
-                </a:solidFill>
-                <a:latin typeface="Consolas" pitchFamily="34" charset="0"/>
-                <a:ea typeface="Consolas" pitchFamily="34" charset="-122"/>
-                <a:cs typeface="Consolas" pitchFamily="34" charset="-120"/>
-              </a:rPr>
-              <a:t>DefaultAzureCredential</a:t>
-            </a:r>
-            <a:pPr indent="0" marL="0">
-              <a:buNone/>
-            </a:pPr>
-            <a:r>
-              <a:rPr lang="en-US" sz="1200" dirty="0">
-                <a:solidFill>
-                  <a:srgbClr val="B8B5D9"/>
-                </a:solidFill>
-                <a:latin typeface="Consolas" pitchFamily="34" charset="0"/>
-                <a:ea typeface="Consolas" pitchFamily="34" charset="-122"/>
-                <a:cs typeface="Consolas" pitchFamily="34" charset="-120"/>
-              </a:rPr>
-              <a:t>(</a:t>
-            </a:r>
-            <a:pPr indent="0" marL="0">
-              <a:buNone/>
-            </a:pPr>
-            <a:r>
-              <a:rPr lang="en-US" sz="1200" dirty="0">
-                <a:solidFill>
-                  <a:srgbClr val="B8B5D9"/>
-                </a:solidFill>
-                <a:latin typeface="Consolas" pitchFamily="34" charset="0"/>
-                <a:ea typeface="Consolas" pitchFamily="34" charset="-122"/>
-                <a:cs typeface="Consolas" pitchFamily="34" charset="-120"/>
-              </a:rPr>
-              <a:t>)</a:t>
-            </a:r>
-            <a:pPr indent="0" marL="0">
-              <a:buNone/>
-            </a:pPr>
-            <a:r>
-              <a:rPr lang="en-US" sz="1200" dirty="0">
-                <a:solidFill>
-                  <a:srgbClr val="B8B5D9"/>
-                </a:solidFill>
-                <a:latin typeface="Consolas" pitchFamily="34" charset="0"/>
-                <a:ea typeface="Consolas" pitchFamily="34" charset="-122"/>
-                <a:cs typeface="Consolas" pitchFamily="34" charset="-120"/>
-              </a:rPr>
-              <a:t>)</a:t>
-            </a:r>
-            <a:pPr indent="0" marL="0">
-              <a:buNone/>
-            </a:pPr>
-            <a:endParaRPr lang="en-US" sz="1200" dirty="0"/>
-          </a:p>
-          <a:p>
-            <a:pPr indent="0" marL="0">
-              <a:buNone/>
-            </a:pPr>
-            <a:r>
-              <a:rPr lang="en-US" sz="1200" dirty="0">
-                <a:solidFill>
-                  <a:srgbClr val="FAF8FF"/>
-                </a:solidFill>
-                <a:latin typeface="Consolas" pitchFamily="34" charset="0"/>
-                <a:ea typeface="Consolas" pitchFamily="34" charset="-122"/>
-                <a:cs typeface="Consolas" pitchFamily="34" charset="-120"/>
-              </a:rPr>
-              <a:t>    </a:t>
-            </a:r>
-            <a:pPr indent="0" marL="0">
-              <a:buNone/>
-            </a:pPr>
-            <a:r>
-              <a:rPr lang="en-US" sz="1200" dirty="0">
-                <a:solidFill>
-                  <a:srgbClr val="B8B5D9"/>
-                </a:solidFill>
-                <a:latin typeface="Consolas" pitchFamily="34" charset="0"/>
-                <a:ea typeface="Consolas" pitchFamily="34" charset="-122"/>
-                <a:cs typeface="Consolas" pitchFamily="34" charset="-120"/>
-              </a:rPr>
-              <a:t>.</a:t>
-            </a:r>
-            <a:pPr indent="0" marL="0">
-              <a:buNone/>
-            </a:pPr>
-            <a:r>
-              <a:rPr lang="en-US" sz="1200" dirty="0">
-                <a:solidFill>
-                  <a:srgbClr val="86EFAC"/>
-                </a:solidFill>
-                <a:latin typeface="Consolas" pitchFamily="34" charset="0"/>
-                <a:ea typeface="Consolas" pitchFamily="34" charset="-122"/>
-                <a:cs typeface="Consolas" pitchFamily="34" charset="-120"/>
-              </a:rPr>
-              <a:t>GetChatClient</a:t>
-            </a:r>
-            <a:pPr indent="0" marL="0">
-              <a:buNone/>
-            </a:pPr>
-            <a:r>
-              <a:rPr lang="en-US" sz="1200" dirty="0">
-                <a:solidFill>
-                  <a:srgbClr val="B8B5D9"/>
-                </a:solidFill>
-                <a:latin typeface="Consolas" pitchFamily="34" charset="0"/>
-                <a:ea typeface="Consolas" pitchFamily="34" charset="-122"/>
-                <a:cs typeface="Consolas" pitchFamily="34" charset="-120"/>
-              </a:rPr>
-              <a:t>(</a:t>
-            </a:r>
-            <a:pPr indent="0" marL="0">
-              <a:buNone/>
-            </a:pPr>
-            <a:r>
-              <a:rPr lang="en-US" sz="1200" dirty="0">
-                <a:solidFill>
-                  <a:srgbClr val="FBBF24"/>
-                </a:solidFill>
-                <a:latin typeface="Consolas" pitchFamily="34" charset="0"/>
-                <a:ea typeface="Consolas" pitchFamily="34" charset="-122"/>
-                <a:cs typeface="Consolas" pitchFamily="34" charset="-120"/>
-              </a:rPr>
-              <a:t>"gpt-4.1"</a:t>
-            </a:r>
-            <a:pPr indent="0" marL="0">
-              <a:buNone/>
-            </a:pPr>
-            <a:r>
-              <a:rPr lang="en-US" sz="1200" dirty="0">
-                <a:solidFill>
-                  <a:srgbClr val="B8B5D9"/>
-                </a:solidFill>
-                <a:latin typeface="Consolas" pitchFamily="34" charset="0"/>
-                <a:ea typeface="Consolas" pitchFamily="34" charset="-122"/>
-                <a:cs typeface="Consolas" pitchFamily="34" charset="-120"/>
-              </a:rPr>
-              <a:t>)</a:t>
-            </a:r>
-            <a:pPr indent="0" marL="0">
-              <a:buNone/>
-            </a:pPr>
-            <a:r>
-              <a:rPr lang="en-US" sz="1200" dirty="0">
-                <a:solidFill>
-                  <a:srgbClr val="B8B5D9"/>
-                </a:solidFill>
-                <a:latin typeface="Consolas" pitchFamily="34" charset="0"/>
-                <a:ea typeface="Consolas" pitchFamily="34" charset="-122"/>
-                <a:cs typeface="Consolas" pitchFamily="34" charset="-120"/>
-              </a:rPr>
-              <a:t>.</a:t>
-            </a:r>
-            <a:pPr indent="0" marL="0">
-              <a:buNone/>
-            </a:pPr>
-            <a:r>
-              <a:rPr lang="en-US" sz="1200" dirty="0">
-                <a:solidFill>
-                  <a:srgbClr val="86EFAC"/>
-                </a:solidFill>
-                <a:latin typeface="Consolas" pitchFamily="34" charset="0"/>
-                <a:ea typeface="Consolas" pitchFamily="34" charset="-122"/>
-                <a:cs typeface="Consolas" pitchFamily="34" charset="-120"/>
-              </a:rPr>
-              <a:t>AsIChatClient</a:t>
-            </a:r>
-            <a:pPr indent="0" marL="0">
-              <a:buNone/>
-            </a:pPr>
-            <a:r>
-              <a:rPr lang="en-US" sz="1200" dirty="0">
-                <a:solidFill>
-                  <a:srgbClr val="B8B5D9"/>
-                </a:solidFill>
-                <a:latin typeface="Consolas" pitchFamily="34" charset="0"/>
-                <a:ea typeface="Consolas" pitchFamily="34" charset="-122"/>
-                <a:cs typeface="Consolas" pitchFamily="34" charset="-120"/>
-              </a:rPr>
-              <a:t>(</a:t>
-            </a:r>
-            <a:pPr indent="0" marL="0">
-              <a:buNone/>
-            </a:pPr>
-            <a:r>
-              <a:rPr lang="en-US" sz="1200" dirty="0">
-                <a:solidFill>
-                  <a:srgbClr val="B8B5D9"/>
-                </a:solidFill>
-                <a:latin typeface="Consolas" pitchFamily="34" charset="0"/>
-                <a:ea typeface="Consolas" pitchFamily="34" charset="-122"/>
-                <a:cs typeface="Consolas" pitchFamily="34" charset="-120"/>
-              </a:rPr>
-              <a:t>)</a:t>
-            </a:r>
-            <a:pPr indent="0" marL="0">
-              <a:buNone/>
-            </a:pPr>
-            <a:endParaRPr lang="en-US" sz="1200" dirty="0"/>
-          </a:p>
-          <a:p>
-            <a:pPr indent="0" marL="0">
-              <a:buNone/>
-            </a:pPr>
-            <a:r>
-              <a:rPr lang="en-US" sz="1200" dirty="0">
-                <a:solidFill>
-                  <a:srgbClr val="FAF8FF"/>
-                </a:solidFill>
-                <a:latin typeface="Consolas" pitchFamily="34" charset="0"/>
-                <a:ea typeface="Consolas" pitchFamily="34" charset="-122"/>
-                <a:cs typeface="Consolas" pitchFamily="34" charset="-120"/>
-              </a:rPr>
-              <a:t>    </a:t>
-            </a:r>
-            <a:pPr indent="0" marL="0">
-              <a:buNone/>
-            </a:pPr>
-            <a:r>
-              <a:rPr lang="en-US" sz="1200" dirty="0">
-                <a:solidFill>
-                  <a:srgbClr val="B8B5D9"/>
-                </a:solidFill>
-                <a:latin typeface="Consolas" pitchFamily="34" charset="0"/>
-                <a:ea typeface="Consolas" pitchFamily="34" charset="-122"/>
-                <a:cs typeface="Consolas" pitchFamily="34" charset="-120"/>
-              </a:rPr>
-              <a:t>.</a:t>
-            </a:r>
-            <a:pPr indent="0" marL="0">
-              <a:buNone/>
-            </a:pPr>
-            <a:r>
-              <a:rPr lang="en-US" sz="1200" dirty="0">
-                <a:solidFill>
-                  <a:srgbClr val="86EFAC"/>
-                </a:solidFill>
-                <a:latin typeface="Consolas" pitchFamily="34" charset="0"/>
-                <a:ea typeface="Consolas" pitchFamily="34" charset="-122"/>
-                <a:cs typeface="Consolas" pitchFamily="34" charset="-120"/>
-              </a:rPr>
-              <a:t>CreateAIAgent</a:t>
-            </a:r>
-            <a:pPr indent="0" marL="0">
-              <a:buNone/>
-            </a:pPr>
-            <a:r>
-              <a:rPr lang="en-US" sz="1200" dirty="0">
-                <a:solidFill>
-                  <a:srgbClr val="B8B5D9"/>
-                </a:solidFill>
-                <a:latin typeface="Consolas" pitchFamily="34" charset="0"/>
-                <a:ea typeface="Consolas" pitchFamily="34" charset="-122"/>
-                <a:cs typeface="Consolas" pitchFamily="34" charset="-120"/>
-              </a:rPr>
-              <a:t>(</a:t>
-            </a:r>
-            <a:pPr indent="0" marL="0">
-              <a:buNone/>
-            </a:pPr>
-            <a:r>
-              <a:rPr lang="en-US" sz="1200" dirty="0">
-                <a:solidFill>
-                  <a:srgbClr val="FBBF24"/>
-                </a:solidFill>
-                <a:latin typeface="Consolas" pitchFamily="34" charset="0"/>
-                <a:ea typeface="Consolas" pitchFamily="34" charset="-122"/>
-                <a:cs typeface="Consolas" pitchFamily="34" charset="-120"/>
-              </a:rPr>
-              <a:t>"Answer with depth and current context."</a:t>
-            </a:r>
-            <a:pPr indent="0" marL="0">
-              <a:buNone/>
-            </a:pPr>
-            <a:r>
-              <a:rPr lang="en-US" sz="1200" dirty="0">
-                <a:solidFill>
-                  <a:srgbClr val="B8B5D9"/>
-                </a:solidFill>
-                <a:latin typeface="Consolas" pitchFamily="34" charset="0"/>
-                <a:ea typeface="Consolas" pitchFamily="34" charset="-122"/>
-                <a:cs typeface="Consolas" pitchFamily="34" charset="-120"/>
-              </a:rPr>
-              <a:t>,</a:t>
-            </a:r>
-            <a:pPr indent="0" marL="0">
-              <a:buNone/>
-            </a:pPr>
-            <a:r>
-              <a:rPr lang="en-US" sz="1200" dirty="0">
-                <a:solidFill>
-                  <a:srgbClr val="FAF8FF"/>
-                </a:solidFill>
-                <a:latin typeface="Consolas" pitchFamily="34" charset="0"/>
-                <a:ea typeface="Consolas" pitchFamily="34" charset="-122"/>
-                <a:cs typeface="Consolas" pitchFamily="34" charset="-120"/>
-              </a:rPr>
-              <a:t> </a:t>
+              <a:t>        </a:t>
             </a:r>
             <a:pPr indent="0" marL="0">
               <a:buNone/>

</xml_diff>

<commit_message>
Slide 12: replace emojis with Lucide SVG icons
- Add lucide-static dependency + lucideDataUri() and addIcon() helpers
- Pill chain on the right now uses UserRound / Smartphone / Cloud
  icons embedded as inline SVG with currentColor swapped for the
  pill border color — consistent rendering across PowerPoint / Keynote
  / LibreOffice / web with no emoji-tofu risk
- Code-comment emojis (📱 ☁️ 🔗) replaced with plain text since
  they were rendering tiny and inconsistently

Co-authored-by: Copilot <223556219+Copilot@users.noreply.github.com>
</commit_message>
<xml_diff>
--- a/slides/Unifying-Local-Cloud-AI.pptx
+++ b/slides/Unifying-Local-Cloud-AI.pptx
@@ -6640,48 +6640,39 @@
           </a:ln>
         </p:spPr>
       </p:sp>
-      <p:sp>
-        <p:nvSpPr>
-          <p:cNvPr id="8" name="Text 6"/>
-          <p:cNvSpPr/>
-          <p:nvPr/>
-        </p:nvSpPr>
-        <p:spPr>
-          <a:xfrm>
-            <a:off x="9219895" y="2377440"/>
-            <a:ext cx="548640" cy="685800"/>
-          </a:xfrm>
-          <a:prstGeom prst="rect">
-            <a:avLst/>
-          </a:prstGeom>
-          <a:noFill/>
-          <a:ln/>
-        </p:spPr>
-        <p:txBody>
-          <a:bodyPr wrap="square" rtlCol="0" anchor="ctr"/>
-          <a:lstStyle/>
-          <a:p>
-            <a:pPr algn="ctr" indent="0" marL="0">
-              <a:buNone/>
-            </a:pPr>
-            <a:r>
-              <a:rPr lang="en-US" sz="2200" dirty="0">
-                <a:solidFill>
-                  <a:srgbClr val="000000"/>
-                </a:solidFill>
-                <a:latin typeface="Calibri" pitchFamily="34" charset="0"/>
-                <a:ea typeface="Calibri" pitchFamily="34" charset="-122"/>
-                <a:cs typeface="Calibri" pitchFamily="34" charset="-120"/>
-              </a:rPr>
-              <a:t>👤</a:t>
-            </a:r>
-            <a:endParaRPr lang="en-US" sz="2200" dirty="0"/>
-          </a:p>
-        </p:txBody>
-      </p:sp>
-      <p:sp>
-        <p:nvSpPr>
-          <p:cNvPr id="9" name="Text 7"/>
+      <p:pic>
+        <p:nvPicPr>
+          <p:cNvPr id="8" name="Image 0" descr="preencoded.png">    </p:cNvPr>
+          <p:cNvPicPr>
+            <a:picLocks noChangeAspect="1"/>
+          </p:cNvPicPr>
+          <p:nvPr/>
+        </p:nvPicPr>
+        <p:blipFill>
+          <a:blip r:embed="rId1">
+            <a:extLst>
+              <a:ext uri="{96DAC541-7B7A-43D3-8B79-37D633B846F1}">
+                <asvg:svgBlip xmlns:asvg="http://schemas.microsoft.com/office/drawing/2016/SVG/main" r:embed="rId2"/>
+              </a:ext>
+            </a:extLst>
+          </a:blip>
+          <a:stretch>
+            <a:fillRect/>
+          </a:stretch>
+        </p:blipFill>
+        <p:spPr>
+          <a:xfrm>
+            <a:off x="9265615" y="2528316"/>
+            <a:ext cx="384048" cy="384048"/>
+          </a:xfrm>
+          <a:prstGeom prst="rect">
+            <a:avLst/>
+          </a:prstGeom>
+        </p:spPr>
+      </p:pic>
+      <p:sp>
+        <p:nvSpPr>
+          <p:cNvPr id="9" name="Text 6"/>
           <p:cNvSpPr/>
           <p:nvPr/>
         </p:nvSpPr>
@@ -6720,7 +6711,7 @@
       </p:sp>
       <p:sp>
         <p:nvSpPr>
-          <p:cNvPr id="10" name="Text 8"/>
+          <p:cNvPr id="10" name="Text 7"/>
           <p:cNvSpPr/>
           <p:nvPr/>
         </p:nvSpPr>
@@ -6759,7 +6750,7 @@
       </p:sp>
       <p:sp>
         <p:nvSpPr>
-          <p:cNvPr id="11" name="Shape 9"/>
+          <p:cNvPr id="11" name="Shape 8"/>
           <p:cNvSpPr/>
           <p:nvPr/>
         </p:nvSpPr>
@@ -6782,7 +6773,7 @@
       </p:sp>
       <p:sp>
         <p:nvSpPr>
-          <p:cNvPr id="12" name="Shape 10"/>
+          <p:cNvPr id="12" name="Shape 9"/>
           <p:cNvSpPr/>
           <p:nvPr/>
         </p:nvSpPr>
@@ -6807,7 +6798,7 @@
       </p:sp>
       <p:sp>
         <p:nvSpPr>
-          <p:cNvPr id="13" name="Shape 11"/>
+          <p:cNvPr id="13" name="Shape 10"/>
           <p:cNvSpPr/>
           <p:nvPr/>
         </p:nvSpPr>
@@ -6832,48 +6823,39 @@
           </a:ln>
         </p:spPr>
       </p:sp>
-      <p:sp>
-        <p:nvSpPr>
-          <p:cNvPr id="14" name="Text 12"/>
-          <p:cNvSpPr/>
-          <p:nvPr/>
-        </p:nvSpPr>
-        <p:spPr>
-          <a:xfrm>
-            <a:off x="9219895" y="3474720"/>
-            <a:ext cx="548640" cy="685800"/>
-          </a:xfrm>
-          <a:prstGeom prst="rect">
-            <a:avLst/>
-          </a:prstGeom>
-          <a:noFill/>
-          <a:ln/>
-        </p:spPr>
-        <p:txBody>
-          <a:bodyPr wrap="square" rtlCol="0" anchor="ctr"/>
-          <a:lstStyle/>
-          <a:p>
-            <a:pPr algn="ctr" indent="0" marL="0">
-              <a:buNone/>
-            </a:pPr>
-            <a:r>
-              <a:rPr lang="en-US" sz="2200" dirty="0">
-                <a:solidFill>
-                  <a:srgbClr val="000000"/>
-                </a:solidFill>
-                <a:latin typeface="Calibri" pitchFamily="34" charset="0"/>
-                <a:ea typeface="Calibri" pitchFamily="34" charset="-122"/>
-                <a:cs typeface="Calibri" pitchFamily="34" charset="-120"/>
-              </a:rPr>
-              <a:t>📱</a:t>
-            </a:r>
-            <a:endParaRPr lang="en-US" sz="2200" dirty="0"/>
-          </a:p>
-        </p:txBody>
-      </p:sp>
-      <p:sp>
-        <p:nvSpPr>
-          <p:cNvPr id="15" name="Text 13"/>
+      <p:pic>
+        <p:nvPicPr>
+          <p:cNvPr id="14" name="Image 1" descr="preencoded.png">    </p:cNvPr>
+          <p:cNvPicPr>
+            <a:picLocks noChangeAspect="1"/>
+          </p:cNvPicPr>
+          <p:nvPr/>
+        </p:nvPicPr>
+        <p:blipFill>
+          <a:blip r:embed="rId3">
+            <a:extLst>
+              <a:ext uri="{96DAC541-7B7A-43D3-8B79-37D633B846F1}">
+                <asvg:svgBlip xmlns:asvg="http://schemas.microsoft.com/office/drawing/2016/SVG/main" r:embed="rId4"/>
+              </a:ext>
+            </a:extLst>
+          </a:blip>
+          <a:stretch>
+            <a:fillRect/>
+          </a:stretch>
+        </p:blipFill>
+        <p:spPr>
+          <a:xfrm>
+            <a:off x="9265615" y="3625596"/>
+            <a:ext cx="384048" cy="384048"/>
+          </a:xfrm>
+          <a:prstGeom prst="rect">
+            <a:avLst/>
+          </a:prstGeom>
+        </p:spPr>
+      </p:pic>
+      <p:sp>
+        <p:nvSpPr>
+          <p:cNvPr id="15" name="Text 11"/>
           <p:cNvSpPr/>
           <p:nvPr/>
         </p:nvSpPr>
@@ -6912,7 +6894,7 @@
       </p:sp>
       <p:sp>
         <p:nvSpPr>
-          <p:cNvPr id="16" name="Text 14"/>
+          <p:cNvPr id="16" name="Text 12"/>
           <p:cNvSpPr/>
           <p:nvPr/>
         </p:nvSpPr>
@@ -6951,7 +6933,7 @@
       </p:sp>
       <p:sp>
         <p:nvSpPr>
-          <p:cNvPr id="17" name="Shape 15"/>
+          <p:cNvPr id="17" name="Shape 13"/>
           <p:cNvSpPr/>
           <p:nvPr/>
         </p:nvSpPr>
@@ -6974,7 +6956,7 @@
       </p:sp>
       <p:sp>
         <p:nvSpPr>
-          <p:cNvPr id="18" name="Shape 16"/>
+          <p:cNvPr id="18" name="Shape 14"/>
           <p:cNvSpPr/>
           <p:nvPr/>
         </p:nvSpPr>
@@ -6999,7 +6981,7 @@
       </p:sp>
       <p:sp>
         <p:nvSpPr>
-          <p:cNvPr id="19" name="Shape 17"/>
+          <p:cNvPr id="19" name="Shape 15"/>
           <p:cNvSpPr/>
           <p:nvPr/>
         </p:nvSpPr>
@@ -7024,48 +7006,39 @@
           </a:ln>
         </p:spPr>
       </p:sp>
-      <p:sp>
-        <p:nvSpPr>
-          <p:cNvPr id="20" name="Text 18"/>
-          <p:cNvSpPr/>
-          <p:nvPr/>
-        </p:nvSpPr>
-        <p:spPr>
-          <a:xfrm>
-            <a:off x="9219895" y="4572000"/>
-            <a:ext cx="548640" cy="685800"/>
-          </a:xfrm>
-          <a:prstGeom prst="rect">
-            <a:avLst/>
-          </a:prstGeom>
-          <a:noFill/>
-          <a:ln/>
-        </p:spPr>
-        <p:txBody>
-          <a:bodyPr wrap="square" rtlCol="0" anchor="ctr"/>
-          <a:lstStyle/>
-          <a:p>
-            <a:pPr algn="ctr" indent="0" marL="0">
-              <a:buNone/>
-            </a:pPr>
-            <a:r>
-              <a:rPr lang="en-US" sz="2200" dirty="0">
-                <a:solidFill>
-                  <a:srgbClr val="000000"/>
-                </a:solidFill>
-                <a:latin typeface="Calibri" pitchFamily="34" charset="0"/>
-                <a:ea typeface="Calibri" pitchFamily="34" charset="-122"/>
-                <a:cs typeface="Calibri" pitchFamily="34" charset="-120"/>
-              </a:rPr>
-              <a:t>☁️</a:t>
-            </a:r>
-            <a:endParaRPr lang="en-US" sz="2200" dirty="0"/>
-          </a:p>
-        </p:txBody>
-      </p:sp>
-      <p:sp>
-        <p:nvSpPr>
-          <p:cNvPr id="21" name="Text 19"/>
+      <p:pic>
+        <p:nvPicPr>
+          <p:cNvPr id="20" name="Image 2" descr="preencoded.png">    </p:cNvPr>
+          <p:cNvPicPr>
+            <a:picLocks noChangeAspect="1"/>
+          </p:cNvPicPr>
+          <p:nvPr/>
+        </p:nvPicPr>
+        <p:blipFill>
+          <a:blip r:embed="rId5">
+            <a:extLst>
+              <a:ext uri="{96DAC541-7B7A-43D3-8B79-37D633B846F1}">
+                <asvg:svgBlip xmlns:asvg="http://schemas.microsoft.com/office/drawing/2016/SVG/main" r:embed="rId6"/>
+              </a:ext>
+            </a:extLst>
+          </a:blip>
+          <a:stretch>
+            <a:fillRect/>
+          </a:stretch>
+        </p:blipFill>
+        <p:spPr>
+          <a:xfrm>
+            <a:off x="9265615" y="4722876"/>
+            <a:ext cx="384048" cy="384048"/>
+          </a:xfrm>
+          <a:prstGeom prst="rect">
+            <a:avLst/>
+          </a:prstGeom>
+        </p:spPr>
+      </p:pic>
+      <p:sp>
+        <p:nvSpPr>
+          <p:cNvPr id="21" name="Text 16"/>
           <p:cNvSpPr/>
           <p:nvPr/>
         </p:nvSpPr>
@@ -7104,7 +7077,7 @@
       </p:sp>
       <p:sp>
         <p:nvSpPr>
-          <p:cNvPr id="22" name="Text 20"/>
+          <p:cNvPr id="22" name="Text 17"/>
           <p:cNvSpPr/>
           <p:nvPr/>
         </p:nvSpPr>
@@ -7143,7 +7116,7 @@
       </p:sp>
       <p:sp>
         <p:nvSpPr>
-          <p:cNvPr id="23" name="Shape 21"/>
+          <p:cNvPr id="23" name="Shape 18"/>
           <p:cNvSpPr/>
           <p:nvPr/>
         </p:nvSpPr>
@@ -7166,7 +7139,7 @@
       </p:sp>
       <p:sp>
         <p:nvSpPr>
-          <p:cNvPr id="24" name="Shape 22"/>
+          <p:cNvPr id="24" name="Shape 19"/>
           <p:cNvSpPr/>
           <p:nvPr/>
         </p:nvSpPr>
@@ -7191,7 +7164,7 @@
       </p:sp>
       <p:sp>
         <p:nvSpPr>
-          <p:cNvPr id="25" name="Shape 23"/>
+          <p:cNvPr id="25" name="Shape 20"/>
           <p:cNvSpPr/>
           <p:nvPr/>
         </p:nvSpPr>
@@ -7216,48 +7189,39 @@
           </a:ln>
         </p:spPr>
       </p:sp>
-      <p:sp>
-        <p:nvSpPr>
-          <p:cNvPr id="26" name="Text 24"/>
-          <p:cNvSpPr/>
-          <p:nvPr/>
-        </p:nvSpPr>
-        <p:spPr>
-          <a:xfrm>
-            <a:off x="9219895" y="5669280"/>
-            <a:ext cx="548640" cy="685800"/>
-          </a:xfrm>
-          <a:prstGeom prst="rect">
-            <a:avLst/>
-          </a:prstGeom>
-          <a:noFill/>
-          <a:ln/>
-        </p:spPr>
-        <p:txBody>
-          <a:bodyPr wrap="square" rtlCol="0" anchor="ctr"/>
-          <a:lstStyle/>
-          <a:p>
-            <a:pPr algn="ctr" indent="0" marL="0">
-              <a:buNone/>
-            </a:pPr>
-            <a:r>
-              <a:rPr lang="en-US" sz="2200" dirty="0">
-                <a:solidFill>
-                  <a:srgbClr val="000000"/>
-                </a:solidFill>
-                <a:latin typeface="Calibri" pitchFamily="34" charset="0"/>
-                <a:ea typeface="Calibri" pitchFamily="34" charset="-122"/>
-                <a:cs typeface="Calibri" pitchFamily="34" charset="-120"/>
-              </a:rPr>
-              <a:t>👤</a:t>
-            </a:r>
-            <a:endParaRPr lang="en-US" sz="2200" dirty="0"/>
-          </a:p>
-        </p:txBody>
-      </p:sp>
-      <p:sp>
-        <p:nvSpPr>
-          <p:cNvPr id="27" name="Text 25"/>
+      <p:pic>
+        <p:nvPicPr>
+          <p:cNvPr id="26" name="Image 3" descr="preencoded.png">    </p:cNvPr>
+          <p:cNvPicPr>
+            <a:picLocks noChangeAspect="1"/>
+          </p:cNvPicPr>
+          <p:nvPr/>
+        </p:nvPicPr>
+        <p:blipFill>
+          <a:blip r:embed="rId7">
+            <a:extLst>
+              <a:ext uri="{96DAC541-7B7A-43D3-8B79-37D633B846F1}">
+                <asvg:svgBlip xmlns:asvg="http://schemas.microsoft.com/office/drawing/2016/SVG/main" r:embed="rId8"/>
+              </a:ext>
+            </a:extLst>
+          </a:blip>
+          <a:stretch>
+            <a:fillRect/>
+          </a:stretch>
+        </p:blipFill>
+        <p:spPr>
+          <a:xfrm>
+            <a:off x="9265615" y="5820156"/>
+            <a:ext cx="384048" cy="384048"/>
+          </a:xfrm>
+          <a:prstGeom prst="rect">
+            <a:avLst/>
+          </a:prstGeom>
+        </p:spPr>
+      </p:pic>
+      <p:sp>
+        <p:nvSpPr>
+          <p:cNvPr id="27" name="Text 21"/>
           <p:cNvSpPr/>
           <p:nvPr/>
         </p:nvSpPr>
@@ -7296,7 +7260,7 @@
       </p:sp>
       <p:sp>
         <p:nvSpPr>
-          <p:cNvPr id="28" name="Text 26"/>
+          <p:cNvPr id="28" name="Text 22"/>
           <p:cNvSpPr/>
           <p:nvPr/>
         </p:nvSpPr>
@@ -7335,7 +7299,7 @@
       </p:sp>
       <p:sp>
         <p:nvSpPr>
-          <p:cNvPr id="29" name="Shape 27"/>
+          <p:cNvPr id="29" name="Shape 23"/>
           <p:cNvSpPr/>
           <p:nvPr/>
         </p:nvSpPr>
@@ -7362,7 +7326,7 @@
       </p:sp>
       <p:sp>
         <p:nvSpPr>
-          <p:cNvPr id="30" name="Text 28"/>
+          <p:cNvPr id="30" name="Text 24"/>
           <p:cNvSpPr/>
           <p:nvPr/>
         </p:nvSpPr>
@@ -7393,7 +7357,7 @@
                 <a:ea typeface="Consolas" pitchFamily="34" charset="-122"/>
                 <a:cs typeface="Consolas" pitchFamily="34" charset="-120"/>
               </a:rPr>
-              <a:t>// 📱  Local — Apple Intelligence, on the device</a:t>
+              <a:t>// Local — Apple Intelligence, on the device</a:t>
             </a:r>
             <a:pPr indent="0" marL="0">
               <a:buNone/>
@@ -7765,7 +7729,7 @@
                 <a:ea typeface="Consolas" pitchFamily="34" charset="-122"/>
                 <a:cs typeface="Consolas" pitchFamily="34" charset="-120"/>
               </a:rPr>
-              <a:t>// ☁️  Cloud — Azure OpenAI, frontier reasoning</a:t>
+              <a:t>// Cloud — Azure OpenAI, frontier reasoning</a:t>
             </a:r>
             <a:pPr indent="0" marL="0">
               <a:buNone/>
@@ -8401,7 +8365,7 @@
                 <a:ea typeface="Consolas" pitchFamily="34" charset="-122"/>
                 <a:cs typeface="Consolas" pitchFamily="34" charset="-120"/>
               </a:rPr>
-              <a:t>// 🔗  MAF workflow — pipe local → cloud, expose as an agent</a:t>
+              <a:t>// MAF workflow — pipe local → cloud, expose as an agent</a:t>
             </a:r>
             <a:pPr indent="0" marL="0">
               <a:buNone/>

</xml_diff>

<commit_message>
Sweep emojis from entire deck — Lucide icons everywhere
Every emoji used as a visual indicator (motif, watch-for lists, taglines,
title-slide graphics) is now a Lucide SVG icon. Render consistently in
PowerPoint / Keynote / LibreOffice / web with no emoji-tofu or
platform-specific color quirks.

Per-slide changes:
- Title slide (1) + Thank You (16): Smartphone / ArrowLeftRight / Cloud
  trio replaces 📱 ↔ ☁️
- addMotif() helper (top-right of every light content slide): same trio
  at small size
- Slide 4 Cloud: hollow Cloud icon as decorative graphic (was ☁️ 220pt)
- Slide 5 Demo 1 watch-for: Zap / Globe / Brain / Coins
- Slide 7 Demo 2 watch-for: Zap / WifiOff / Ruler / AlertTriangle;
  emojis also stripped from in-code comments
- Slide 9 Demo 3 watch-for: Brain / Shield / Plug / HardDrive
- Slide 14 Rules hand-off tagline: Workflow icon
- Slide 12 Demo 4 already converted in prior commit

Co-authored-by: Copilot <223556219+Copilot@users.noreply.github.com>
</commit_message>
<xml_diff>
--- a/slides/Unifying-Local-Cloud-AI.pptx
+++ b/slides/Unifying-Local-Cloud-AI.pptx
@@ -2235,126 +2235,99 @@
           </a:ln>
         </p:spPr>
       </p:sp>
-      <p:sp>
-        <p:nvSpPr>
-          <p:cNvPr id="3" name="Text 1"/>
-          <p:cNvSpPr/>
-          <p:nvPr/>
-        </p:nvSpPr>
-        <p:spPr>
-          <a:xfrm>
-            <a:off x="9265615" y="548640"/>
-            <a:ext cx="1097280" cy="1097280"/>
-          </a:xfrm>
-          <a:prstGeom prst="rect">
-            <a:avLst/>
-          </a:prstGeom>
-          <a:noFill/>
-          <a:ln/>
-        </p:spPr>
-        <p:txBody>
-          <a:bodyPr wrap="square" rtlCol="0" anchor="ctr"/>
-          <a:lstStyle/>
-          <a:p>
-            <a:pPr algn="ctr" indent="0" marL="0">
-              <a:buNone/>
-            </a:pPr>
-            <a:r>
-              <a:rPr lang="en-US" sz="6000" dirty="0">
-                <a:solidFill>
-                  <a:srgbClr val="FB7185"/>
-                </a:solidFill>
-                <a:latin typeface="Calibri" pitchFamily="34" charset="0"/>
-                <a:ea typeface="Calibri" pitchFamily="34" charset="-122"/>
-                <a:cs typeface="Calibri" pitchFamily="34" charset="-120"/>
-              </a:rPr>
-              <a:t>📱</a:t>
-            </a:r>
-            <a:endParaRPr lang="en-US" sz="6000" dirty="0"/>
-          </a:p>
-        </p:txBody>
-      </p:sp>
-      <p:sp>
-        <p:nvSpPr>
-          <p:cNvPr id="4" name="Text 2"/>
-          <p:cNvSpPr/>
-          <p:nvPr/>
-        </p:nvSpPr>
-        <p:spPr>
-          <a:xfrm>
-            <a:off x="10180015" y="731520"/>
-            <a:ext cx="914400" cy="914400"/>
-          </a:xfrm>
-          <a:prstGeom prst="rect">
-            <a:avLst/>
-          </a:prstGeom>
-          <a:noFill/>
-          <a:ln/>
-        </p:spPr>
-        <p:txBody>
-          <a:bodyPr wrap="square" rtlCol="0" anchor="ctr"/>
-          <a:lstStyle/>
-          <a:p>
-            <a:pPr algn="ctr" indent="0" marL="0">
-              <a:buNone/>
-            </a:pPr>
-            <a:r>
-              <a:rPr lang="en-US" sz="5000" b="1" dirty="0">
-                <a:solidFill>
-                  <a:srgbClr val="CFCBED"/>
-                </a:solidFill>
-                <a:latin typeface="Calibri" pitchFamily="34" charset="0"/>
-                <a:ea typeface="Calibri" pitchFamily="34" charset="-122"/>
-                <a:cs typeface="Calibri" pitchFamily="34" charset="-120"/>
-              </a:rPr>
-              <a:t>↔</a:t>
-            </a:r>
-            <a:endParaRPr lang="en-US" sz="5000" dirty="0"/>
-          </a:p>
-        </p:txBody>
-      </p:sp>
-      <p:sp>
-        <p:nvSpPr>
-          <p:cNvPr id="5" name="Text 3"/>
-          <p:cNvSpPr/>
-          <p:nvPr/>
-        </p:nvSpPr>
-        <p:spPr>
-          <a:xfrm>
-            <a:off x="10911535" y="502920"/>
-            <a:ext cx="1097280" cy="1143000"/>
-          </a:xfrm>
-          <a:prstGeom prst="rect">
-            <a:avLst/>
-          </a:prstGeom>
-          <a:noFill/>
-          <a:ln/>
-        </p:spPr>
-        <p:txBody>
-          <a:bodyPr wrap="square" rtlCol="0" anchor="ctr"/>
-          <a:lstStyle/>
-          <a:p>
-            <a:pPr algn="ctr" indent="0" marL="0">
-              <a:buNone/>
-            </a:pPr>
-            <a:r>
-              <a:rPr lang="en-US" sz="6400" dirty="0">
-                <a:solidFill>
-                  <a:srgbClr val="6366F1"/>
-                </a:solidFill>
-                <a:latin typeface="Calibri" pitchFamily="34" charset="0"/>
-                <a:ea typeface="Calibri" pitchFamily="34" charset="-122"/>
-                <a:cs typeface="Calibri" pitchFamily="34" charset="-120"/>
-              </a:rPr>
-              <a:t>☁</a:t>
-            </a:r>
-            <a:endParaRPr lang="en-US" sz="6400" dirty="0"/>
-          </a:p>
-        </p:txBody>
-      </p:sp>
-      <p:sp>
-        <p:nvSpPr>
-          <p:cNvPr id="6" name="Text 4"/>
+      <p:pic>
+        <p:nvPicPr>
+          <p:cNvPr id="3" name="Image 0" descr="preencoded.png">    </p:cNvPr>
+          <p:cNvPicPr>
+            <a:picLocks noChangeAspect="1"/>
+          </p:cNvPicPr>
+          <p:nvPr/>
+        </p:nvPicPr>
+        <p:blipFill>
+          <a:blip r:embed="rId1">
+            <a:extLst>
+              <a:ext uri="{96DAC541-7B7A-43D3-8B79-37D633B846F1}">
+                <asvg:svgBlip xmlns:asvg="http://schemas.microsoft.com/office/drawing/2016/SVG/main" r:embed="rId2"/>
+              </a:ext>
+            </a:extLst>
+          </a:blip>
+          <a:stretch>
+            <a:fillRect/>
+          </a:stretch>
+        </p:blipFill>
+        <p:spPr>
+          <a:xfrm>
+            <a:off x="9265615" y="640080"/>
+            <a:ext cx="1005840" cy="1005840"/>
+          </a:xfrm>
+          <a:prstGeom prst="rect">
+            <a:avLst/>
+          </a:prstGeom>
+        </p:spPr>
+      </p:pic>
+      <p:pic>
+        <p:nvPicPr>
+          <p:cNvPr id="4" name="Image 1" descr="preencoded.png">    </p:cNvPr>
+          <p:cNvPicPr>
+            <a:picLocks noChangeAspect="1"/>
+          </p:cNvPicPr>
+          <p:nvPr/>
+        </p:nvPicPr>
+        <p:blipFill>
+          <a:blip r:embed="rId3">
+            <a:extLst>
+              <a:ext uri="{96DAC541-7B7A-43D3-8B79-37D633B846F1}">
+                <asvg:svgBlip xmlns:asvg="http://schemas.microsoft.com/office/drawing/2016/SVG/main" r:embed="rId4"/>
+              </a:ext>
+            </a:extLst>
+          </a:blip>
+          <a:stretch>
+            <a:fillRect/>
+          </a:stretch>
+        </p:blipFill>
+        <p:spPr>
+          <a:xfrm>
+            <a:off x="10317175" y="713232"/>
+            <a:ext cx="868680" cy="868680"/>
+          </a:xfrm>
+          <a:prstGeom prst="rect">
+            <a:avLst/>
+          </a:prstGeom>
+        </p:spPr>
+      </p:pic>
+      <p:pic>
+        <p:nvPicPr>
+          <p:cNvPr id="5" name="Image 2" descr="preencoded.png">    </p:cNvPr>
+          <p:cNvPicPr>
+            <a:picLocks noChangeAspect="1"/>
+          </p:cNvPicPr>
+          <p:nvPr/>
+        </p:nvPicPr>
+        <p:blipFill>
+          <a:blip r:embed="rId5">
+            <a:extLst>
+              <a:ext uri="{96DAC541-7B7A-43D3-8B79-37D633B846F1}">
+                <asvg:svgBlip xmlns:asvg="http://schemas.microsoft.com/office/drawing/2016/SVG/main" r:embed="rId6"/>
+              </a:ext>
+            </a:extLst>
+          </a:blip>
+          <a:stretch>
+            <a:fillRect/>
+          </a:stretch>
+        </p:blipFill>
+        <p:spPr>
+          <a:xfrm>
+            <a:off x="10865815" y="640080"/>
+            <a:ext cx="1051560" cy="1051560"/>
+          </a:xfrm>
+          <a:prstGeom prst="rect">
+            <a:avLst/>
+          </a:prstGeom>
+        </p:spPr>
+      </p:pic>
+      <p:sp>
+        <p:nvSpPr>
+          <p:cNvPr id="6" name="Text 1"/>
           <p:cNvSpPr/>
           <p:nvPr/>
         </p:nvSpPr>
@@ -2393,7 +2366,7 @@
       </p:sp>
       <p:sp>
         <p:nvSpPr>
-          <p:cNvPr id="7" name="Text 5"/>
+          <p:cNvPr id="7" name="Text 2"/>
           <p:cNvSpPr/>
           <p:nvPr/>
         </p:nvSpPr>
@@ -2432,7 +2405,7 @@
       </p:sp>
       <p:sp>
         <p:nvSpPr>
-          <p:cNvPr id="8" name="Text 6"/>
+          <p:cNvPr id="8" name="Text 3"/>
           <p:cNvSpPr/>
           <p:nvPr/>
         </p:nvSpPr>
@@ -2513,7 +2486,7 @@
       </p:sp>
       <p:sp>
         <p:nvSpPr>
-          <p:cNvPr id="9" name="Text 7"/>
+          <p:cNvPr id="9" name="Text 4"/>
           <p:cNvSpPr/>
           <p:nvPr/>
         </p:nvSpPr>
@@ -2552,7 +2525,7 @@
       </p:sp>
       <p:sp>
         <p:nvSpPr>
-          <p:cNvPr id="10" name="Text 8"/>
+          <p:cNvPr id="10" name="Text 5"/>
           <p:cNvSpPr/>
           <p:nvPr/>
         </p:nvSpPr>
@@ -3911,111 +3884,99 @@
           </a:p>
         </p:txBody>
       </p:sp>
-      <p:sp>
-        <p:nvSpPr>
-          <p:cNvPr id="39" name="Shape 37"/>
-          <p:cNvSpPr/>
-          <p:nvPr/>
-        </p:nvSpPr>
+      <p:pic>
+        <p:nvPicPr>
+          <p:cNvPr id="39" name="Image 0" descr="preencoded.png">    </p:cNvPr>
+          <p:cNvPicPr>
+            <a:picLocks noChangeAspect="1"/>
+          </p:cNvPicPr>
+          <p:nvPr/>
+        </p:nvPicPr>
+        <p:blipFill>
+          <a:blip r:embed="rId1">
+            <a:extLst>
+              <a:ext uri="{96DAC541-7B7A-43D3-8B79-37D633B846F1}">
+                <asvg:svgBlip xmlns:asvg="http://schemas.microsoft.com/office/drawing/2016/SVG/main" r:embed="rId2"/>
+              </a:ext>
+            </a:extLst>
+          </a:blip>
+          <a:stretch>
+            <a:fillRect/>
+          </a:stretch>
+        </p:blipFill>
         <p:spPr>
           <a:xfrm>
             <a:off x="10180015" y="502920"/>
-            <a:ext cx="292608" cy="292608"/>
-          </a:xfrm>
-          <a:prstGeom prst="roundRect">
-            <a:avLst>
-              <a:gd name="adj" fmla="val 15625"/>
-            </a:avLst>
-          </a:prstGeom>
-          <a:ln w="19050">
-            <a:solidFill>
-              <a:srgbClr val="6366F1"/>
-            </a:solidFill>
-            <a:prstDash val="solid"/>
-          </a:ln>
-        </p:spPr>
-      </p:sp>
-      <p:sp>
-        <p:nvSpPr>
-          <p:cNvPr id="40" name="Text 38"/>
-          <p:cNvSpPr/>
-          <p:nvPr/>
-        </p:nvSpPr>
-        <p:spPr>
-          <a:xfrm>
-            <a:off x="10472623" y="457200"/>
-            <a:ext cx="411480" cy="384048"/>
-          </a:xfrm>
-          <a:prstGeom prst="rect">
-            <a:avLst/>
-          </a:prstGeom>
-          <a:noFill/>
-          <a:ln/>
-        </p:spPr>
-        <p:txBody>
-          <a:bodyPr wrap="square" rtlCol="0" anchor="ctr"/>
-          <a:lstStyle/>
-          <a:p>
-            <a:pPr algn="ctr" indent="0" marL="0">
-              <a:buNone/>
-            </a:pPr>
-            <a:r>
-              <a:rPr lang="en-US" sz="1800" b="1" dirty="0">
-                <a:solidFill>
-                  <a:srgbClr val="6366F1"/>
-                </a:solidFill>
-                <a:latin typeface="Calibri" pitchFamily="34" charset="0"/>
-                <a:ea typeface="Calibri" pitchFamily="34" charset="-122"/>
-                <a:cs typeface="Calibri" pitchFamily="34" charset="-120"/>
-              </a:rPr>
-              <a:t>↔</a:t>
-            </a:r>
-            <a:endParaRPr lang="en-US" sz="1800" dirty="0"/>
-          </a:p>
-        </p:txBody>
-      </p:sp>
-      <p:sp>
-        <p:nvSpPr>
-          <p:cNvPr id="41" name="Text 39"/>
-          <p:cNvSpPr/>
-          <p:nvPr/>
-        </p:nvSpPr>
-        <p:spPr>
-          <a:xfrm>
-            <a:off x="10893247" y="429768"/>
-            <a:ext cx="411480" cy="457200"/>
-          </a:xfrm>
-          <a:prstGeom prst="rect">
-            <a:avLst/>
-          </a:prstGeom>
-          <a:noFill/>
-          <a:ln/>
-        </p:spPr>
-        <p:txBody>
-          <a:bodyPr wrap="square" rtlCol="0" anchor="ctr"/>
-          <a:lstStyle/>
-          <a:p>
-            <a:pPr algn="ctr" indent="0" marL="0">
-              <a:buNone/>
-            </a:pPr>
-            <a:r>
-              <a:rPr lang="en-US" sz="2200" dirty="0">
-                <a:solidFill>
-                  <a:srgbClr val="6366F1"/>
-                </a:solidFill>
-                <a:latin typeface="Calibri" pitchFamily="34" charset="0"/>
-                <a:ea typeface="Calibri" pitchFamily="34" charset="-122"/>
-                <a:cs typeface="Calibri" pitchFamily="34" charset="-120"/>
-              </a:rPr>
-              <a:t>☁</a:t>
-            </a:r>
-            <a:endParaRPr lang="en-US" sz="2200" dirty="0"/>
-          </a:p>
-        </p:txBody>
-      </p:sp>
-      <p:sp>
-        <p:nvSpPr>
-          <p:cNvPr id="42" name="Text 40"/>
+            <a:ext cx="329184" cy="329184"/>
+          </a:xfrm>
+          <a:prstGeom prst="rect">
+            <a:avLst/>
+          </a:prstGeom>
+        </p:spPr>
+      </p:pic>
+      <p:pic>
+        <p:nvPicPr>
+          <p:cNvPr id="40" name="Image 1" descr="preencoded.png">    </p:cNvPr>
+          <p:cNvPicPr>
+            <a:picLocks noChangeAspect="1"/>
+          </p:cNvPicPr>
+          <p:nvPr/>
+        </p:nvPicPr>
+        <p:blipFill>
+          <a:blip r:embed="rId3">
+            <a:extLst>
+              <a:ext uri="{96DAC541-7B7A-43D3-8B79-37D633B846F1}">
+                <asvg:svgBlip xmlns:asvg="http://schemas.microsoft.com/office/drawing/2016/SVG/main" r:embed="rId4"/>
+              </a:ext>
+            </a:extLst>
+          </a:blip>
+          <a:stretch>
+            <a:fillRect/>
+          </a:stretch>
+        </p:blipFill>
+        <p:spPr>
+          <a:xfrm>
+            <a:off x="10564063" y="502920"/>
+            <a:ext cx="329184" cy="329184"/>
+          </a:xfrm>
+          <a:prstGeom prst="rect">
+            <a:avLst/>
+          </a:prstGeom>
+        </p:spPr>
+      </p:pic>
+      <p:pic>
+        <p:nvPicPr>
+          <p:cNvPr id="41" name="Image 2" descr="preencoded.png">    </p:cNvPr>
+          <p:cNvPicPr>
+            <a:picLocks noChangeAspect="1"/>
+          </p:cNvPicPr>
+          <p:nvPr/>
+        </p:nvPicPr>
+        <p:blipFill>
+          <a:blip r:embed="rId5">
+            <a:extLst>
+              <a:ext uri="{96DAC541-7B7A-43D3-8B79-37D633B846F1}">
+                <asvg:svgBlip xmlns:asvg="http://schemas.microsoft.com/office/drawing/2016/SVG/main" r:embed="rId6"/>
+              </a:ext>
+            </a:extLst>
+          </a:blip>
+          <a:stretch>
+            <a:fillRect/>
+          </a:stretch>
+        </p:blipFill>
+        <p:spPr>
+          <a:xfrm>
+            <a:off x="10948111" y="502920"/>
+            <a:ext cx="329184" cy="329184"/>
+          </a:xfrm>
+          <a:prstGeom prst="rect">
+            <a:avLst/>
+          </a:prstGeom>
+        </p:spPr>
+      </p:pic>
+      <p:sp>
+        <p:nvSpPr>
+          <p:cNvPr id="42" name="Text 37"/>
           <p:cNvSpPr/>
           <p:nvPr/>
         </p:nvSpPr>
@@ -4096,7 +4057,7 @@
       </p:sp>
       <p:sp>
         <p:nvSpPr>
-          <p:cNvPr id="43" name="Text 41"/>
+          <p:cNvPr id="43" name="Text 38"/>
           <p:cNvSpPr/>
           <p:nvPr/>
         </p:nvSpPr>
@@ -6192,111 +6153,99 @@
           </a:p>
         </p:txBody>
       </p:sp>
-      <p:sp>
-        <p:nvSpPr>
-          <p:cNvPr id="27" name="Shape 25"/>
-          <p:cNvSpPr/>
-          <p:nvPr/>
-        </p:nvSpPr>
+      <p:pic>
+        <p:nvPicPr>
+          <p:cNvPr id="27" name="Image 0" descr="preencoded.png">    </p:cNvPr>
+          <p:cNvPicPr>
+            <a:picLocks noChangeAspect="1"/>
+          </p:cNvPicPr>
+          <p:nvPr/>
+        </p:nvPicPr>
+        <p:blipFill>
+          <a:blip r:embed="rId1">
+            <a:extLst>
+              <a:ext uri="{96DAC541-7B7A-43D3-8B79-37D633B846F1}">
+                <asvg:svgBlip xmlns:asvg="http://schemas.microsoft.com/office/drawing/2016/SVG/main" r:embed="rId2"/>
+              </a:ext>
+            </a:extLst>
+          </a:blip>
+          <a:stretch>
+            <a:fillRect/>
+          </a:stretch>
+        </p:blipFill>
         <p:spPr>
           <a:xfrm>
             <a:off x="10180015" y="502920"/>
-            <a:ext cx="292608" cy="292608"/>
-          </a:xfrm>
-          <a:prstGeom prst="roundRect">
-            <a:avLst>
-              <a:gd name="adj" fmla="val 15625"/>
-            </a:avLst>
-          </a:prstGeom>
-          <a:ln w="19050">
-            <a:solidFill>
-              <a:srgbClr val="6366F1"/>
-            </a:solidFill>
-            <a:prstDash val="solid"/>
-          </a:ln>
-        </p:spPr>
-      </p:sp>
-      <p:sp>
-        <p:nvSpPr>
-          <p:cNvPr id="28" name="Text 26"/>
-          <p:cNvSpPr/>
-          <p:nvPr/>
-        </p:nvSpPr>
-        <p:spPr>
-          <a:xfrm>
-            <a:off x="10472623" y="457200"/>
-            <a:ext cx="411480" cy="384048"/>
-          </a:xfrm>
-          <a:prstGeom prst="rect">
-            <a:avLst/>
-          </a:prstGeom>
-          <a:noFill/>
-          <a:ln/>
-        </p:spPr>
-        <p:txBody>
-          <a:bodyPr wrap="square" rtlCol="0" anchor="ctr"/>
-          <a:lstStyle/>
-          <a:p>
-            <a:pPr algn="ctr" indent="0" marL="0">
-              <a:buNone/>
-            </a:pPr>
-            <a:r>
-              <a:rPr lang="en-US" sz="1800" b="1" dirty="0">
-                <a:solidFill>
-                  <a:srgbClr val="6366F1"/>
-                </a:solidFill>
-                <a:latin typeface="Calibri" pitchFamily="34" charset="0"/>
-                <a:ea typeface="Calibri" pitchFamily="34" charset="-122"/>
-                <a:cs typeface="Calibri" pitchFamily="34" charset="-120"/>
-              </a:rPr>
-              <a:t>↔</a:t>
-            </a:r>
-            <a:endParaRPr lang="en-US" sz="1800" dirty="0"/>
-          </a:p>
-        </p:txBody>
-      </p:sp>
-      <p:sp>
-        <p:nvSpPr>
-          <p:cNvPr id="29" name="Text 27"/>
-          <p:cNvSpPr/>
-          <p:nvPr/>
-        </p:nvSpPr>
-        <p:spPr>
-          <a:xfrm>
-            <a:off x="10893247" y="429768"/>
-            <a:ext cx="411480" cy="457200"/>
-          </a:xfrm>
-          <a:prstGeom prst="rect">
-            <a:avLst/>
-          </a:prstGeom>
-          <a:noFill/>
-          <a:ln/>
-        </p:spPr>
-        <p:txBody>
-          <a:bodyPr wrap="square" rtlCol="0" anchor="ctr"/>
-          <a:lstStyle/>
-          <a:p>
-            <a:pPr algn="ctr" indent="0" marL="0">
-              <a:buNone/>
-            </a:pPr>
-            <a:r>
-              <a:rPr lang="en-US" sz="2200" dirty="0">
-                <a:solidFill>
-                  <a:srgbClr val="6366F1"/>
-                </a:solidFill>
-                <a:latin typeface="Calibri" pitchFamily="34" charset="0"/>
-                <a:ea typeface="Calibri" pitchFamily="34" charset="-122"/>
-                <a:cs typeface="Calibri" pitchFamily="34" charset="-120"/>
-              </a:rPr>
-              <a:t>☁</a:t>
-            </a:r>
-            <a:endParaRPr lang="en-US" sz="2200" dirty="0"/>
-          </a:p>
-        </p:txBody>
-      </p:sp>
-      <p:sp>
-        <p:nvSpPr>
-          <p:cNvPr id="30" name="Text 28"/>
+            <a:ext cx="329184" cy="329184"/>
+          </a:xfrm>
+          <a:prstGeom prst="rect">
+            <a:avLst/>
+          </a:prstGeom>
+        </p:spPr>
+      </p:pic>
+      <p:pic>
+        <p:nvPicPr>
+          <p:cNvPr id="28" name="Image 1" descr="preencoded.png">    </p:cNvPr>
+          <p:cNvPicPr>
+            <a:picLocks noChangeAspect="1"/>
+          </p:cNvPicPr>
+          <p:nvPr/>
+        </p:nvPicPr>
+        <p:blipFill>
+          <a:blip r:embed="rId3">
+            <a:extLst>
+              <a:ext uri="{96DAC541-7B7A-43D3-8B79-37D633B846F1}">
+                <asvg:svgBlip xmlns:asvg="http://schemas.microsoft.com/office/drawing/2016/SVG/main" r:embed="rId4"/>
+              </a:ext>
+            </a:extLst>
+          </a:blip>
+          <a:stretch>
+            <a:fillRect/>
+          </a:stretch>
+        </p:blipFill>
+        <p:spPr>
+          <a:xfrm>
+            <a:off x="10564063" y="502920"/>
+            <a:ext cx="329184" cy="329184"/>
+          </a:xfrm>
+          <a:prstGeom prst="rect">
+            <a:avLst/>
+          </a:prstGeom>
+        </p:spPr>
+      </p:pic>
+      <p:pic>
+        <p:nvPicPr>
+          <p:cNvPr id="29" name="Image 2" descr="preencoded.png">    </p:cNvPr>
+          <p:cNvPicPr>
+            <a:picLocks noChangeAspect="1"/>
+          </p:cNvPicPr>
+          <p:nvPr/>
+        </p:nvPicPr>
+        <p:blipFill>
+          <a:blip r:embed="rId5">
+            <a:extLst>
+              <a:ext uri="{96DAC541-7B7A-43D3-8B79-37D633B846F1}">
+                <asvg:svgBlip xmlns:asvg="http://schemas.microsoft.com/office/drawing/2016/SVG/main" r:embed="rId6"/>
+              </a:ext>
+            </a:extLst>
+          </a:blip>
+          <a:stretch>
+            <a:fillRect/>
+          </a:stretch>
+        </p:blipFill>
+        <p:spPr>
+          <a:xfrm>
+            <a:off x="10948111" y="502920"/>
+            <a:ext cx="329184" cy="329184"/>
+          </a:xfrm>
+          <a:prstGeom prst="rect">
+            <a:avLst/>
+          </a:prstGeom>
+        </p:spPr>
+      </p:pic>
+      <p:sp>
+        <p:nvSpPr>
+          <p:cNvPr id="30" name="Text 25"/>
           <p:cNvSpPr/>
           <p:nvPr/>
         </p:nvSpPr>
@@ -6377,7 +6326,7 @@
       </p:sp>
       <p:sp>
         <p:nvSpPr>
-          <p:cNvPr id="31" name="Text 29"/>
+          <p:cNvPr id="31" name="Text 26"/>
           <p:cNvSpPr/>
           <p:nvPr/>
         </p:nvSpPr>
@@ -9887,111 +9836,99 @@
           </a:p>
         </p:txBody>
       </p:sp>
-      <p:sp>
-        <p:nvSpPr>
-          <p:cNvPr id="26" name="Shape 24"/>
-          <p:cNvSpPr/>
-          <p:nvPr/>
-        </p:nvSpPr>
+      <p:pic>
+        <p:nvPicPr>
+          <p:cNvPr id="26" name="Image 0" descr="preencoded.png">    </p:cNvPr>
+          <p:cNvPicPr>
+            <a:picLocks noChangeAspect="1"/>
+          </p:cNvPicPr>
+          <p:nvPr/>
+        </p:nvPicPr>
+        <p:blipFill>
+          <a:blip r:embed="rId1">
+            <a:extLst>
+              <a:ext uri="{96DAC541-7B7A-43D3-8B79-37D633B846F1}">
+                <asvg:svgBlip xmlns:asvg="http://schemas.microsoft.com/office/drawing/2016/SVG/main" r:embed="rId2"/>
+              </a:ext>
+            </a:extLst>
+          </a:blip>
+          <a:stretch>
+            <a:fillRect/>
+          </a:stretch>
+        </p:blipFill>
         <p:spPr>
           <a:xfrm>
             <a:off x="10180015" y="502920"/>
-            <a:ext cx="292608" cy="292608"/>
-          </a:xfrm>
-          <a:prstGeom prst="roundRect">
-            <a:avLst>
-              <a:gd name="adj" fmla="val 15625"/>
-            </a:avLst>
-          </a:prstGeom>
-          <a:ln w="19050">
-            <a:solidFill>
-              <a:srgbClr val="6366F1"/>
-            </a:solidFill>
-            <a:prstDash val="solid"/>
-          </a:ln>
-        </p:spPr>
-      </p:sp>
-      <p:sp>
-        <p:nvSpPr>
-          <p:cNvPr id="27" name="Text 25"/>
-          <p:cNvSpPr/>
-          <p:nvPr/>
-        </p:nvSpPr>
-        <p:spPr>
-          <a:xfrm>
-            <a:off x="10472623" y="457200"/>
-            <a:ext cx="411480" cy="384048"/>
-          </a:xfrm>
-          <a:prstGeom prst="rect">
-            <a:avLst/>
-          </a:prstGeom>
-          <a:noFill/>
-          <a:ln/>
-        </p:spPr>
-        <p:txBody>
-          <a:bodyPr wrap="square" rtlCol="0" anchor="ctr"/>
-          <a:lstStyle/>
-          <a:p>
-            <a:pPr algn="ctr" indent="0" marL="0">
-              <a:buNone/>
-            </a:pPr>
-            <a:r>
-              <a:rPr lang="en-US" sz="1800" b="1" dirty="0">
-                <a:solidFill>
-                  <a:srgbClr val="6366F1"/>
-                </a:solidFill>
-                <a:latin typeface="Calibri" pitchFamily="34" charset="0"/>
-                <a:ea typeface="Calibri" pitchFamily="34" charset="-122"/>
-                <a:cs typeface="Calibri" pitchFamily="34" charset="-120"/>
-              </a:rPr>
-              <a:t>↔</a:t>
-            </a:r>
-            <a:endParaRPr lang="en-US" sz="1800" dirty="0"/>
-          </a:p>
-        </p:txBody>
-      </p:sp>
-      <p:sp>
-        <p:nvSpPr>
-          <p:cNvPr id="28" name="Text 26"/>
-          <p:cNvSpPr/>
-          <p:nvPr/>
-        </p:nvSpPr>
-        <p:spPr>
-          <a:xfrm>
-            <a:off x="10893247" y="429768"/>
-            <a:ext cx="411480" cy="457200"/>
-          </a:xfrm>
-          <a:prstGeom prst="rect">
-            <a:avLst/>
-          </a:prstGeom>
-          <a:noFill/>
-          <a:ln/>
-        </p:spPr>
-        <p:txBody>
-          <a:bodyPr wrap="square" rtlCol="0" anchor="ctr"/>
-          <a:lstStyle/>
-          <a:p>
-            <a:pPr algn="ctr" indent="0" marL="0">
-              <a:buNone/>
-            </a:pPr>
-            <a:r>
-              <a:rPr lang="en-US" sz="2200" dirty="0">
-                <a:solidFill>
-                  <a:srgbClr val="6366F1"/>
-                </a:solidFill>
-                <a:latin typeface="Calibri" pitchFamily="34" charset="0"/>
-                <a:ea typeface="Calibri" pitchFamily="34" charset="-122"/>
-                <a:cs typeface="Calibri" pitchFamily="34" charset="-120"/>
-              </a:rPr>
-              <a:t>☁</a:t>
-            </a:r>
-            <a:endParaRPr lang="en-US" sz="2200" dirty="0"/>
-          </a:p>
-        </p:txBody>
-      </p:sp>
-      <p:sp>
-        <p:nvSpPr>
-          <p:cNvPr id="29" name="Text 27"/>
+            <a:ext cx="329184" cy="329184"/>
+          </a:xfrm>
+          <a:prstGeom prst="rect">
+            <a:avLst/>
+          </a:prstGeom>
+        </p:spPr>
+      </p:pic>
+      <p:pic>
+        <p:nvPicPr>
+          <p:cNvPr id="27" name="Image 1" descr="preencoded.png">    </p:cNvPr>
+          <p:cNvPicPr>
+            <a:picLocks noChangeAspect="1"/>
+          </p:cNvPicPr>
+          <p:nvPr/>
+        </p:nvPicPr>
+        <p:blipFill>
+          <a:blip r:embed="rId3">
+            <a:extLst>
+              <a:ext uri="{96DAC541-7B7A-43D3-8B79-37D633B846F1}">
+                <asvg:svgBlip xmlns:asvg="http://schemas.microsoft.com/office/drawing/2016/SVG/main" r:embed="rId4"/>
+              </a:ext>
+            </a:extLst>
+          </a:blip>
+          <a:stretch>
+            <a:fillRect/>
+          </a:stretch>
+        </p:blipFill>
+        <p:spPr>
+          <a:xfrm>
+            <a:off x="10564063" y="502920"/>
+            <a:ext cx="329184" cy="329184"/>
+          </a:xfrm>
+          <a:prstGeom prst="rect">
+            <a:avLst/>
+          </a:prstGeom>
+        </p:spPr>
+      </p:pic>
+      <p:pic>
+        <p:nvPicPr>
+          <p:cNvPr id="28" name="Image 2" descr="preencoded.png">    </p:cNvPr>
+          <p:cNvPicPr>
+            <a:picLocks noChangeAspect="1"/>
+          </p:cNvPicPr>
+          <p:nvPr/>
+        </p:nvPicPr>
+        <p:blipFill>
+          <a:blip r:embed="rId5">
+            <a:extLst>
+              <a:ext uri="{96DAC541-7B7A-43D3-8B79-37D633B846F1}">
+                <asvg:svgBlip xmlns:asvg="http://schemas.microsoft.com/office/drawing/2016/SVG/main" r:embed="rId6"/>
+              </a:ext>
+            </a:extLst>
+          </a:blip>
+          <a:stretch>
+            <a:fillRect/>
+          </a:stretch>
+        </p:blipFill>
+        <p:spPr>
+          <a:xfrm>
+            <a:off x="10948111" y="502920"/>
+            <a:ext cx="329184" cy="329184"/>
+          </a:xfrm>
+          <a:prstGeom prst="rect">
+            <a:avLst/>
+          </a:prstGeom>
+        </p:spPr>
+      </p:pic>
+      <p:sp>
+        <p:nvSpPr>
+          <p:cNvPr id="29" name="Text 24"/>
           <p:cNvSpPr/>
           <p:nvPr/>
         </p:nvSpPr>
@@ -10072,7 +10009,7 @@
       </p:sp>
       <p:sp>
         <p:nvSpPr>
-          <p:cNvPr id="30" name="Text 28"/>
+          <p:cNvPr id="30" name="Text 25"/>
           <p:cNvSpPr/>
           <p:nvPr/>
         </p:nvSpPr>
@@ -11254,28 +11191,58 @@
           </a:p>
         </p:txBody>
       </p:sp>
-      <p:sp>
-        <p:nvSpPr>
-          <p:cNvPr id="29" name="Text 27"/>
-          <p:cNvSpPr/>
-          <p:nvPr/>
-        </p:nvSpPr>
-        <p:spPr>
-          <a:xfrm>
-            <a:off x="548640" y="5852160"/>
-            <a:ext cx="10972800" cy="411480"/>
-          </a:xfrm>
-          <a:prstGeom prst="rect">
-            <a:avLst/>
-          </a:prstGeom>
-          <a:noFill/>
-          <a:ln/>
-        </p:spPr>
-        <p:txBody>
-          <a:bodyPr wrap="square" rtlCol="0" anchor="ctr"/>
-          <a:lstStyle/>
-          <a:p>
-            <a:pPr algn="ctr" indent="0" marL="0">
+      <p:pic>
+        <p:nvPicPr>
+          <p:cNvPr id="29" name="Image 0" descr="preencoded.png">    </p:cNvPr>
+          <p:cNvPicPr>
+            <a:picLocks noChangeAspect="1"/>
+          </p:cNvPicPr>
+          <p:nvPr/>
+        </p:nvPicPr>
+        <p:blipFill>
+          <a:blip r:embed="rId1">
+            <a:extLst>
+              <a:ext uri="{96DAC541-7B7A-43D3-8B79-37D633B846F1}">
+                <asvg:svgBlip xmlns:asvg="http://schemas.microsoft.com/office/drawing/2016/SVG/main" r:embed="rId2"/>
+              </a:ext>
+            </a:extLst>
+          </a:blip>
+          <a:stretch>
+            <a:fillRect/>
+          </a:stretch>
+        </p:blipFill>
+        <p:spPr>
+          <a:xfrm>
+            <a:off x="1828800" y="5870448"/>
+            <a:ext cx="310896" cy="310896"/>
+          </a:xfrm>
+          <a:prstGeom prst="rect">
+            <a:avLst/>
+          </a:prstGeom>
+        </p:spPr>
+      </p:pic>
+      <p:sp>
+        <p:nvSpPr>
+          <p:cNvPr id="30" name="Text 27"/>
+          <p:cNvSpPr/>
+          <p:nvPr/>
+        </p:nvSpPr>
+        <p:spPr>
+          <a:xfrm>
+            <a:off x="2240280" y="5852160"/>
+            <a:ext cx="9326880" cy="411480"/>
+          </a:xfrm>
+          <a:prstGeom prst="rect">
+            <a:avLst/>
+          </a:prstGeom>
+          <a:noFill/>
+          <a:ln/>
+        </p:spPr>
+        <p:txBody>
+          <a:bodyPr wrap="square" rtlCol="0" anchor="ctr"/>
+          <a:lstStyle/>
+          <a:p>
+            <a:pPr indent="0" marL="0">
               <a:buNone/>
             </a:pPr>
             <a:r>
@@ -11287,117 +11254,105 @@
                 <a:ea typeface="Georgia" pitchFamily="34" charset="-122"/>
                 <a:cs typeface="Georgia" pitchFamily="34" charset="-120"/>
               </a:rPr>
-              <a:t>📐  Hand-off pattern:  local triage  →  cloud reasoning  →  local rendering</a:t>
+              <a:t>Hand-off pattern:  local triage  →  cloud reasoning  →  local rendering</a:t>
             </a:r>
             <a:endParaRPr lang="en-US" sz="1600" dirty="0"/>
           </a:p>
         </p:txBody>
       </p:sp>
-      <p:sp>
-        <p:nvSpPr>
-          <p:cNvPr id="30" name="Shape 28"/>
-          <p:cNvSpPr/>
-          <p:nvPr/>
-        </p:nvSpPr>
+      <p:pic>
+        <p:nvPicPr>
+          <p:cNvPr id="31" name="Image 1" descr="preencoded.png">    </p:cNvPr>
+          <p:cNvPicPr>
+            <a:picLocks noChangeAspect="1"/>
+          </p:cNvPicPr>
+          <p:nvPr/>
+        </p:nvPicPr>
+        <p:blipFill>
+          <a:blip r:embed="rId3">
+            <a:extLst>
+              <a:ext uri="{96DAC541-7B7A-43D3-8B79-37D633B846F1}">
+                <asvg:svgBlip xmlns:asvg="http://schemas.microsoft.com/office/drawing/2016/SVG/main" r:embed="rId4"/>
+              </a:ext>
+            </a:extLst>
+          </a:blip>
+          <a:stretch>
+            <a:fillRect/>
+          </a:stretch>
+        </p:blipFill>
         <p:spPr>
           <a:xfrm>
             <a:off x="10180015" y="502920"/>
-            <a:ext cx="292608" cy="292608"/>
-          </a:xfrm>
-          <a:prstGeom prst="roundRect">
-            <a:avLst>
-              <a:gd name="adj" fmla="val 15625"/>
-            </a:avLst>
-          </a:prstGeom>
-          <a:ln w="19050">
-            <a:solidFill>
-              <a:srgbClr val="6366F1"/>
-            </a:solidFill>
-            <a:prstDash val="solid"/>
-          </a:ln>
-        </p:spPr>
-      </p:sp>
-      <p:sp>
-        <p:nvSpPr>
-          <p:cNvPr id="31" name="Text 29"/>
-          <p:cNvSpPr/>
-          <p:nvPr/>
-        </p:nvSpPr>
-        <p:spPr>
-          <a:xfrm>
-            <a:off x="10472623" y="457200"/>
-            <a:ext cx="411480" cy="384048"/>
-          </a:xfrm>
-          <a:prstGeom prst="rect">
-            <a:avLst/>
-          </a:prstGeom>
-          <a:noFill/>
-          <a:ln/>
-        </p:spPr>
-        <p:txBody>
-          <a:bodyPr wrap="square" rtlCol="0" anchor="ctr"/>
-          <a:lstStyle/>
-          <a:p>
-            <a:pPr algn="ctr" indent="0" marL="0">
-              <a:buNone/>
-            </a:pPr>
-            <a:r>
-              <a:rPr lang="en-US" sz="1800" b="1" dirty="0">
-                <a:solidFill>
-                  <a:srgbClr val="6366F1"/>
-                </a:solidFill>
-                <a:latin typeface="Calibri" pitchFamily="34" charset="0"/>
-                <a:ea typeface="Calibri" pitchFamily="34" charset="-122"/>
-                <a:cs typeface="Calibri" pitchFamily="34" charset="-120"/>
-              </a:rPr>
-              <a:t>↔</a:t>
-            </a:r>
-            <a:endParaRPr lang="en-US" sz="1800" dirty="0"/>
-          </a:p>
-        </p:txBody>
-      </p:sp>
-      <p:sp>
-        <p:nvSpPr>
-          <p:cNvPr id="32" name="Text 30"/>
-          <p:cNvSpPr/>
-          <p:nvPr/>
-        </p:nvSpPr>
-        <p:spPr>
-          <a:xfrm>
-            <a:off x="10893247" y="429768"/>
-            <a:ext cx="411480" cy="457200"/>
-          </a:xfrm>
-          <a:prstGeom prst="rect">
-            <a:avLst/>
-          </a:prstGeom>
-          <a:noFill/>
-          <a:ln/>
-        </p:spPr>
-        <p:txBody>
-          <a:bodyPr wrap="square" rtlCol="0" anchor="ctr"/>
-          <a:lstStyle/>
-          <a:p>
-            <a:pPr algn="ctr" indent="0" marL="0">
-              <a:buNone/>
-            </a:pPr>
-            <a:r>
-              <a:rPr lang="en-US" sz="2200" dirty="0">
-                <a:solidFill>
-                  <a:srgbClr val="6366F1"/>
-                </a:solidFill>
-                <a:latin typeface="Calibri" pitchFamily="34" charset="0"/>
-                <a:ea typeface="Calibri" pitchFamily="34" charset="-122"/>
-                <a:cs typeface="Calibri" pitchFamily="34" charset="-120"/>
-              </a:rPr>
-              <a:t>☁</a:t>
-            </a:r>
-            <a:endParaRPr lang="en-US" sz="2200" dirty="0"/>
-          </a:p>
-        </p:txBody>
-      </p:sp>
-      <p:sp>
-        <p:nvSpPr>
-          <p:cNvPr id="33" name="Text 31"/>
+            <a:ext cx="329184" cy="329184"/>
+          </a:xfrm>
+          <a:prstGeom prst="rect">
+            <a:avLst/>
+          </a:prstGeom>
+        </p:spPr>
+      </p:pic>
+      <p:pic>
+        <p:nvPicPr>
+          <p:cNvPr id="32" name="Image 2" descr="preencoded.png">    </p:cNvPr>
+          <p:cNvPicPr>
+            <a:picLocks noChangeAspect="1"/>
+          </p:cNvPicPr>
+          <p:nvPr/>
+        </p:nvPicPr>
+        <p:blipFill>
+          <a:blip r:embed="rId5">
+            <a:extLst>
+              <a:ext uri="{96DAC541-7B7A-43D3-8B79-37D633B846F1}">
+                <asvg:svgBlip xmlns:asvg="http://schemas.microsoft.com/office/drawing/2016/SVG/main" r:embed="rId6"/>
+              </a:ext>
+            </a:extLst>
+          </a:blip>
+          <a:stretch>
+            <a:fillRect/>
+          </a:stretch>
+        </p:blipFill>
+        <p:spPr>
+          <a:xfrm>
+            <a:off x="10564063" y="502920"/>
+            <a:ext cx="329184" cy="329184"/>
+          </a:xfrm>
+          <a:prstGeom prst="rect">
+            <a:avLst/>
+          </a:prstGeom>
+        </p:spPr>
+      </p:pic>
+      <p:pic>
+        <p:nvPicPr>
+          <p:cNvPr id="33" name="Image 3" descr="preencoded.png">    </p:cNvPr>
+          <p:cNvPicPr>
+            <a:picLocks noChangeAspect="1"/>
+          </p:cNvPicPr>
+          <p:nvPr/>
+        </p:nvPicPr>
+        <p:blipFill>
+          <a:blip r:embed="rId7">
+            <a:extLst>
+              <a:ext uri="{96DAC541-7B7A-43D3-8B79-37D633B846F1}">
+                <asvg:svgBlip xmlns:asvg="http://schemas.microsoft.com/office/drawing/2016/SVG/main" r:embed="rId8"/>
+              </a:ext>
+            </a:extLst>
+          </a:blip>
+          <a:stretch>
+            <a:fillRect/>
+          </a:stretch>
+        </p:blipFill>
+        <p:spPr>
+          <a:xfrm>
+            <a:off x="10948111" y="502920"/>
+            <a:ext cx="329184" cy="329184"/>
+          </a:xfrm>
+          <a:prstGeom prst="rect">
+            <a:avLst/>
+          </a:prstGeom>
+        </p:spPr>
+      </p:pic>
+      <p:sp>
+        <p:nvSpPr>
+          <p:cNvPr id="34" name="Text 28"/>
           <p:cNvSpPr/>
           <p:nvPr/>
         </p:nvSpPr>
@@ -11478,7 +11433,7 @@
       </p:sp>
       <p:sp>
         <p:nvSpPr>
-          <p:cNvPr id="34" name="Text 32"/>
+          <p:cNvPr id="35" name="Text 29"/>
           <p:cNvSpPr/>
           <p:nvPr/>
         </p:nvSpPr>
@@ -12912,111 +12867,99 @@
           </a:p>
         </p:txBody>
       </p:sp>
-      <p:sp>
-        <p:nvSpPr>
-          <p:cNvPr id="41" name="Shape 39"/>
-          <p:cNvSpPr/>
-          <p:nvPr/>
-        </p:nvSpPr>
+      <p:pic>
+        <p:nvPicPr>
+          <p:cNvPr id="41" name="Image 0" descr="preencoded.png">    </p:cNvPr>
+          <p:cNvPicPr>
+            <a:picLocks noChangeAspect="1"/>
+          </p:cNvPicPr>
+          <p:nvPr/>
+        </p:nvPicPr>
+        <p:blipFill>
+          <a:blip r:embed="rId1">
+            <a:extLst>
+              <a:ext uri="{96DAC541-7B7A-43D3-8B79-37D633B846F1}">
+                <asvg:svgBlip xmlns:asvg="http://schemas.microsoft.com/office/drawing/2016/SVG/main" r:embed="rId2"/>
+              </a:ext>
+            </a:extLst>
+          </a:blip>
+          <a:stretch>
+            <a:fillRect/>
+          </a:stretch>
+        </p:blipFill>
         <p:spPr>
           <a:xfrm>
             <a:off x="10180015" y="502920"/>
-            <a:ext cx="292608" cy="292608"/>
-          </a:xfrm>
-          <a:prstGeom prst="roundRect">
-            <a:avLst>
-              <a:gd name="adj" fmla="val 15625"/>
-            </a:avLst>
-          </a:prstGeom>
-          <a:ln w="19050">
-            <a:solidFill>
-              <a:srgbClr val="6366F1"/>
-            </a:solidFill>
-            <a:prstDash val="solid"/>
-          </a:ln>
-        </p:spPr>
-      </p:sp>
-      <p:sp>
-        <p:nvSpPr>
-          <p:cNvPr id="42" name="Text 40"/>
-          <p:cNvSpPr/>
-          <p:nvPr/>
-        </p:nvSpPr>
-        <p:spPr>
-          <a:xfrm>
-            <a:off x="10472623" y="457200"/>
-            <a:ext cx="411480" cy="384048"/>
-          </a:xfrm>
-          <a:prstGeom prst="rect">
-            <a:avLst/>
-          </a:prstGeom>
-          <a:noFill/>
-          <a:ln/>
-        </p:spPr>
-        <p:txBody>
-          <a:bodyPr wrap="square" rtlCol="0" anchor="ctr"/>
-          <a:lstStyle/>
-          <a:p>
-            <a:pPr algn="ctr" indent="0" marL="0">
-              <a:buNone/>
-            </a:pPr>
-            <a:r>
-              <a:rPr lang="en-US" sz="1800" b="1" dirty="0">
-                <a:solidFill>
-                  <a:srgbClr val="6366F1"/>
-                </a:solidFill>
-                <a:latin typeface="Calibri" pitchFamily="34" charset="0"/>
-                <a:ea typeface="Calibri" pitchFamily="34" charset="-122"/>
-                <a:cs typeface="Calibri" pitchFamily="34" charset="-120"/>
-              </a:rPr>
-              <a:t>↔</a:t>
-            </a:r>
-            <a:endParaRPr lang="en-US" sz="1800" dirty="0"/>
-          </a:p>
-        </p:txBody>
-      </p:sp>
-      <p:sp>
-        <p:nvSpPr>
-          <p:cNvPr id="43" name="Text 41"/>
-          <p:cNvSpPr/>
-          <p:nvPr/>
-        </p:nvSpPr>
-        <p:spPr>
-          <a:xfrm>
-            <a:off x="10893247" y="429768"/>
-            <a:ext cx="411480" cy="457200"/>
-          </a:xfrm>
-          <a:prstGeom prst="rect">
-            <a:avLst/>
-          </a:prstGeom>
-          <a:noFill/>
-          <a:ln/>
-        </p:spPr>
-        <p:txBody>
-          <a:bodyPr wrap="square" rtlCol="0" anchor="ctr"/>
-          <a:lstStyle/>
-          <a:p>
-            <a:pPr algn="ctr" indent="0" marL="0">
-              <a:buNone/>
-            </a:pPr>
-            <a:r>
-              <a:rPr lang="en-US" sz="2200" dirty="0">
-                <a:solidFill>
-                  <a:srgbClr val="6366F1"/>
-                </a:solidFill>
-                <a:latin typeface="Calibri" pitchFamily="34" charset="0"/>
-                <a:ea typeface="Calibri" pitchFamily="34" charset="-122"/>
-                <a:cs typeface="Calibri" pitchFamily="34" charset="-120"/>
-              </a:rPr>
-              <a:t>☁</a:t>
-            </a:r>
-            <a:endParaRPr lang="en-US" sz="2200" dirty="0"/>
-          </a:p>
-        </p:txBody>
-      </p:sp>
-      <p:sp>
-        <p:nvSpPr>
-          <p:cNvPr id="44" name="Text 42"/>
+            <a:ext cx="329184" cy="329184"/>
+          </a:xfrm>
+          <a:prstGeom prst="rect">
+            <a:avLst/>
+          </a:prstGeom>
+        </p:spPr>
+      </p:pic>
+      <p:pic>
+        <p:nvPicPr>
+          <p:cNvPr id="42" name="Image 1" descr="preencoded.png">    </p:cNvPr>
+          <p:cNvPicPr>
+            <a:picLocks noChangeAspect="1"/>
+          </p:cNvPicPr>
+          <p:nvPr/>
+        </p:nvPicPr>
+        <p:blipFill>
+          <a:blip r:embed="rId3">
+            <a:extLst>
+              <a:ext uri="{96DAC541-7B7A-43D3-8B79-37D633B846F1}">
+                <asvg:svgBlip xmlns:asvg="http://schemas.microsoft.com/office/drawing/2016/SVG/main" r:embed="rId4"/>
+              </a:ext>
+            </a:extLst>
+          </a:blip>
+          <a:stretch>
+            <a:fillRect/>
+          </a:stretch>
+        </p:blipFill>
+        <p:spPr>
+          <a:xfrm>
+            <a:off x="10564063" y="502920"/>
+            <a:ext cx="329184" cy="329184"/>
+          </a:xfrm>
+          <a:prstGeom prst="rect">
+            <a:avLst/>
+          </a:prstGeom>
+        </p:spPr>
+      </p:pic>
+      <p:pic>
+        <p:nvPicPr>
+          <p:cNvPr id="43" name="Image 2" descr="preencoded.png">    </p:cNvPr>
+          <p:cNvPicPr>
+            <a:picLocks noChangeAspect="1"/>
+          </p:cNvPicPr>
+          <p:nvPr/>
+        </p:nvPicPr>
+        <p:blipFill>
+          <a:blip r:embed="rId5">
+            <a:extLst>
+              <a:ext uri="{96DAC541-7B7A-43D3-8B79-37D633B846F1}">
+                <asvg:svgBlip xmlns:asvg="http://schemas.microsoft.com/office/drawing/2016/SVG/main" r:embed="rId6"/>
+              </a:ext>
+            </a:extLst>
+          </a:blip>
+          <a:stretch>
+            <a:fillRect/>
+          </a:stretch>
+        </p:blipFill>
+        <p:spPr>
+          <a:xfrm>
+            <a:off x="10948111" y="502920"/>
+            <a:ext cx="329184" cy="329184"/>
+          </a:xfrm>
+          <a:prstGeom prst="rect">
+            <a:avLst/>
+          </a:prstGeom>
+        </p:spPr>
+      </p:pic>
+      <p:sp>
+        <p:nvSpPr>
+          <p:cNvPr id="44" name="Text 39"/>
           <p:cNvSpPr/>
           <p:nvPr/>
         </p:nvSpPr>
@@ -13097,7 +13040,7 @@
       </p:sp>
       <p:sp>
         <p:nvSpPr>
-          <p:cNvPr id="45" name="Text 43"/>
+          <p:cNvPr id="45" name="Text 40"/>
           <p:cNvSpPr/>
           <p:nvPr/>
         </p:nvSpPr>
@@ -13191,126 +13134,99 @@
           </a:ln>
         </p:spPr>
       </p:sp>
-      <p:sp>
-        <p:nvSpPr>
-          <p:cNvPr id="3" name="Text 1"/>
-          <p:cNvSpPr/>
-          <p:nvPr/>
-        </p:nvSpPr>
-        <p:spPr>
-          <a:xfrm>
-            <a:off x="822960" y="502920"/>
-            <a:ext cx="1097280" cy="1143000"/>
-          </a:xfrm>
-          <a:prstGeom prst="rect">
-            <a:avLst/>
-          </a:prstGeom>
-          <a:noFill/>
-          <a:ln/>
-        </p:spPr>
-        <p:txBody>
-          <a:bodyPr wrap="square" rtlCol="0" anchor="ctr"/>
-          <a:lstStyle/>
-          <a:p>
-            <a:pPr algn="ctr" indent="0" marL="0">
-              <a:buNone/>
-            </a:pPr>
-            <a:r>
-              <a:rPr lang="en-US" sz="6400" dirty="0">
-                <a:solidFill>
-                  <a:srgbClr val="6366F1"/>
-                </a:solidFill>
-                <a:latin typeface="Calibri" pitchFamily="34" charset="0"/>
-                <a:ea typeface="Calibri" pitchFamily="34" charset="-122"/>
-                <a:cs typeface="Calibri" pitchFamily="34" charset="-120"/>
-              </a:rPr>
-              <a:t>☁</a:t>
-            </a:r>
-            <a:endParaRPr lang="en-US" sz="6400" dirty="0"/>
-          </a:p>
-        </p:txBody>
-      </p:sp>
-      <p:sp>
-        <p:nvSpPr>
-          <p:cNvPr id="4" name="Text 2"/>
-          <p:cNvSpPr/>
-          <p:nvPr/>
-        </p:nvSpPr>
-        <p:spPr>
-          <a:xfrm>
-            <a:off x="1554480" y="731520"/>
-            <a:ext cx="914400" cy="914400"/>
-          </a:xfrm>
-          <a:prstGeom prst="rect">
-            <a:avLst/>
-          </a:prstGeom>
-          <a:noFill/>
-          <a:ln/>
-        </p:spPr>
-        <p:txBody>
-          <a:bodyPr wrap="square" rtlCol="0" anchor="ctr"/>
-          <a:lstStyle/>
-          <a:p>
-            <a:pPr algn="ctr" indent="0" marL="0">
-              <a:buNone/>
-            </a:pPr>
-            <a:r>
-              <a:rPr lang="en-US" sz="5000" b="1" dirty="0">
-                <a:solidFill>
-                  <a:srgbClr val="CFCBED"/>
-                </a:solidFill>
-                <a:latin typeface="Calibri" pitchFamily="34" charset="0"/>
-                <a:ea typeface="Calibri" pitchFamily="34" charset="-122"/>
-                <a:cs typeface="Calibri" pitchFamily="34" charset="-120"/>
-              </a:rPr>
-              <a:t>↔</a:t>
-            </a:r>
-            <a:endParaRPr lang="en-US" sz="5000" dirty="0"/>
-          </a:p>
-        </p:txBody>
-      </p:sp>
-      <p:sp>
-        <p:nvSpPr>
-          <p:cNvPr id="5" name="Text 3"/>
-          <p:cNvSpPr/>
-          <p:nvPr/>
-        </p:nvSpPr>
-        <p:spPr>
-          <a:xfrm>
-            <a:off x="2286000" y="548640"/>
-            <a:ext cx="1097280" cy="1097280"/>
-          </a:xfrm>
-          <a:prstGeom prst="rect">
-            <a:avLst/>
-          </a:prstGeom>
-          <a:noFill/>
-          <a:ln/>
-        </p:spPr>
-        <p:txBody>
-          <a:bodyPr wrap="square" rtlCol="0" anchor="ctr"/>
-          <a:lstStyle/>
-          <a:p>
-            <a:pPr algn="ctr" indent="0" marL="0">
-              <a:buNone/>
-            </a:pPr>
-            <a:r>
-              <a:rPr lang="en-US" sz="6000" dirty="0">
-                <a:solidFill>
-                  <a:srgbClr val="FB7185"/>
-                </a:solidFill>
-                <a:latin typeface="Calibri" pitchFamily="34" charset="0"/>
-                <a:ea typeface="Calibri" pitchFamily="34" charset="-122"/>
-                <a:cs typeface="Calibri" pitchFamily="34" charset="-120"/>
-              </a:rPr>
-              <a:t>📱</a:t>
-            </a:r>
-            <a:endParaRPr lang="en-US" sz="6000" dirty="0"/>
-          </a:p>
-        </p:txBody>
-      </p:sp>
-      <p:sp>
-        <p:nvSpPr>
-          <p:cNvPr id="6" name="Text 4"/>
+      <p:pic>
+        <p:nvPicPr>
+          <p:cNvPr id="3" name="Image 0" descr="preencoded.png">    </p:cNvPr>
+          <p:cNvPicPr>
+            <a:picLocks noChangeAspect="1"/>
+          </p:cNvPicPr>
+          <p:nvPr/>
+        </p:nvPicPr>
+        <p:blipFill>
+          <a:blip r:embed="rId1">
+            <a:extLst>
+              <a:ext uri="{96DAC541-7B7A-43D3-8B79-37D633B846F1}">
+                <asvg:svgBlip xmlns:asvg="http://schemas.microsoft.com/office/drawing/2016/SVG/main" r:embed="rId2"/>
+              </a:ext>
+            </a:extLst>
+          </a:blip>
+          <a:stretch>
+            <a:fillRect/>
+          </a:stretch>
+        </p:blipFill>
+        <p:spPr>
+          <a:xfrm>
+            <a:off x="822960" y="594360"/>
+            <a:ext cx="1051560" cy="1051560"/>
+          </a:xfrm>
+          <a:prstGeom prst="rect">
+            <a:avLst/>
+          </a:prstGeom>
+        </p:spPr>
+      </p:pic>
+      <p:pic>
+        <p:nvPicPr>
+          <p:cNvPr id="4" name="Image 1" descr="preencoded.png">    </p:cNvPr>
+          <p:cNvPicPr>
+            <a:picLocks noChangeAspect="1"/>
+          </p:cNvPicPr>
+          <p:nvPr/>
+        </p:nvPicPr>
+        <p:blipFill>
+          <a:blip r:embed="rId3">
+            <a:extLst>
+              <a:ext uri="{96DAC541-7B7A-43D3-8B79-37D633B846F1}">
+                <asvg:svgBlip xmlns:asvg="http://schemas.microsoft.com/office/drawing/2016/SVG/main" r:embed="rId4"/>
+              </a:ext>
+            </a:extLst>
+          </a:blip>
+          <a:stretch>
+            <a:fillRect/>
+          </a:stretch>
+        </p:blipFill>
+        <p:spPr>
+          <a:xfrm>
+            <a:off x="1965960" y="713232"/>
+            <a:ext cx="868680" cy="868680"/>
+          </a:xfrm>
+          <a:prstGeom prst="rect">
+            <a:avLst/>
+          </a:prstGeom>
+        </p:spPr>
+      </p:pic>
+      <p:pic>
+        <p:nvPicPr>
+          <p:cNvPr id="5" name="Image 2" descr="preencoded.png">    </p:cNvPr>
+          <p:cNvPicPr>
+            <a:picLocks noChangeAspect="1"/>
+          </p:cNvPicPr>
+          <p:nvPr/>
+        </p:nvPicPr>
+        <p:blipFill>
+          <a:blip r:embed="rId5">
+            <a:extLst>
+              <a:ext uri="{96DAC541-7B7A-43D3-8B79-37D633B846F1}">
+                <asvg:svgBlip xmlns:asvg="http://schemas.microsoft.com/office/drawing/2016/SVG/main" r:embed="rId6"/>
+              </a:ext>
+            </a:extLst>
+          </a:blip>
+          <a:stretch>
+            <a:fillRect/>
+          </a:stretch>
+        </p:blipFill>
+        <p:spPr>
+          <a:xfrm>
+            <a:off x="2926080" y="640080"/>
+            <a:ext cx="1005840" cy="1005840"/>
+          </a:xfrm>
+          <a:prstGeom prst="rect">
+            <a:avLst/>
+          </a:prstGeom>
+        </p:spPr>
+      </p:pic>
+      <p:sp>
+        <p:nvSpPr>
+          <p:cNvPr id="6" name="Text 1"/>
           <p:cNvSpPr/>
           <p:nvPr/>
         </p:nvSpPr>
@@ -13349,7 +13265,7 @@
       </p:sp>
       <p:sp>
         <p:nvSpPr>
-          <p:cNvPr id="7" name="Text 5"/>
+          <p:cNvPr id="7" name="Text 2"/>
           <p:cNvSpPr/>
           <p:nvPr/>
         </p:nvSpPr>
@@ -13388,7 +13304,7 @@
       </p:sp>
       <p:sp>
         <p:nvSpPr>
-          <p:cNvPr id="8" name="Text 6"/>
+          <p:cNvPr id="8" name="Text 3"/>
           <p:cNvSpPr/>
           <p:nvPr/>
         </p:nvSpPr>
@@ -13455,7 +13371,7 @@
       </p:sp>
       <p:sp>
         <p:nvSpPr>
-          <p:cNvPr id="9" name="Text 7"/>
+          <p:cNvPr id="9" name="Text 4"/>
           <p:cNvSpPr/>
           <p:nvPr/>
         </p:nvSpPr>
@@ -14095,111 +14011,99 @@
           </a:p>
         </p:txBody>
       </p:sp>
-      <p:sp>
-        <p:nvSpPr>
-          <p:cNvPr id="17" name="Shape 15"/>
-          <p:cNvSpPr/>
-          <p:nvPr/>
-        </p:nvSpPr>
+      <p:pic>
+        <p:nvPicPr>
+          <p:cNvPr id="17" name="Image 0" descr="preencoded.png">    </p:cNvPr>
+          <p:cNvPicPr>
+            <a:picLocks noChangeAspect="1"/>
+          </p:cNvPicPr>
+          <p:nvPr/>
+        </p:nvPicPr>
+        <p:blipFill>
+          <a:blip r:embed="rId1">
+            <a:extLst>
+              <a:ext uri="{96DAC541-7B7A-43D3-8B79-37D633B846F1}">
+                <asvg:svgBlip xmlns:asvg="http://schemas.microsoft.com/office/drawing/2016/SVG/main" r:embed="rId2"/>
+              </a:ext>
+            </a:extLst>
+          </a:blip>
+          <a:stretch>
+            <a:fillRect/>
+          </a:stretch>
+        </p:blipFill>
         <p:spPr>
           <a:xfrm>
             <a:off x="10180015" y="502920"/>
-            <a:ext cx="292608" cy="292608"/>
-          </a:xfrm>
-          <a:prstGeom prst="roundRect">
-            <a:avLst>
-              <a:gd name="adj" fmla="val 15625"/>
-            </a:avLst>
-          </a:prstGeom>
-          <a:ln w="19050">
-            <a:solidFill>
-              <a:srgbClr val="6366F1"/>
-            </a:solidFill>
-            <a:prstDash val="solid"/>
-          </a:ln>
-        </p:spPr>
-      </p:sp>
-      <p:sp>
-        <p:nvSpPr>
-          <p:cNvPr id="18" name="Text 16"/>
-          <p:cNvSpPr/>
-          <p:nvPr/>
-        </p:nvSpPr>
-        <p:spPr>
-          <a:xfrm>
-            <a:off x="10472623" y="457200"/>
-            <a:ext cx="411480" cy="384048"/>
-          </a:xfrm>
-          <a:prstGeom prst="rect">
-            <a:avLst/>
-          </a:prstGeom>
-          <a:noFill/>
-          <a:ln/>
-        </p:spPr>
-        <p:txBody>
-          <a:bodyPr wrap="square" rtlCol="0" anchor="ctr"/>
-          <a:lstStyle/>
-          <a:p>
-            <a:pPr algn="ctr" indent="0" marL="0">
-              <a:buNone/>
-            </a:pPr>
-            <a:r>
-              <a:rPr lang="en-US" sz="1800" b="1" dirty="0">
-                <a:solidFill>
-                  <a:srgbClr val="6366F1"/>
-                </a:solidFill>
-                <a:latin typeface="Calibri" pitchFamily="34" charset="0"/>
-                <a:ea typeface="Calibri" pitchFamily="34" charset="-122"/>
-                <a:cs typeface="Calibri" pitchFamily="34" charset="-120"/>
-              </a:rPr>
-              <a:t>↔</a:t>
-            </a:r>
-            <a:endParaRPr lang="en-US" sz="1800" dirty="0"/>
-          </a:p>
-        </p:txBody>
-      </p:sp>
-      <p:sp>
-        <p:nvSpPr>
-          <p:cNvPr id="19" name="Text 17"/>
-          <p:cNvSpPr/>
-          <p:nvPr/>
-        </p:nvSpPr>
-        <p:spPr>
-          <a:xfrm>
-            <a:off x="10893247" y="429768"/>
-            <a:ext cx="411480" cy="457200"/>
-          </a:xfrm>
-          <a:prstGeom prst="rect">
-            <a:avLst/>
-          </a:prstGeom>
-          <a:noFill/>
-          <a:ln/>
-        </p:spPr>
-        <p:txBody>
-          <a:bodyPr wrap="square" rtlCol="0" anchor="ctr"/>
-          <a:lstStyle/>
-          <a:p>
-            <a:pPr algn="ctr" indent="0" marL="0">
-              <a:buNone/>
-            </a:pPr>
-            <a:r>
-              <a:rPr lang="en-US" sz="2200" dirty="0">
-                <a:solidFill>
-                  <a:srgbClr val="6366F1"/>
-                </a:solidFill>
-                <a:latin typeface="Calibri" pitchFamily="34" charset="0"/>
-                <a:ea typeface="Calibri" pitchFamily="34" charset="-122"/>
-                <a:cs typeface="Calibri" pitchFamily="34" charset="-120"/>
-              </a:rPr>
-              <a:t>☁</a:t>
-            </a:r>
-            <a:endParaRPr lang="en-US" sz="2200" dirty="0"/>
-          </a:p>
-        </p:txBody>
-      </p:sp>
-      <p:sp>
-        <p:nvSpPr>
-          <p:cNvPr id="20" name="Text 18"/>
+            <a:ext cx="329184" cy="329184"/>
+          </a:xfrm>
+          <a:prstGeom prst="rect">
+            <a:avLst/>
+          </a:prstGeom>
+        </p:spPr>
+      </p:pic>
+      <p:pic>
+        <p:nvPicPr>
+          <p:cNvPr id="18" name="Image 1" descr="preencoded.png">    </p:cNvPr>
+          <p:cNvPicPr>
+            <a:picLocks noChangeAspect="1"/>
+          </p:cNvPicPr>
+          <p:nvPr/>
+        </p:nvPicPr>
+        <p:blipFill>
+          <a:blip r:embed="rId3">
+            <a:extLst>
+              <a:ext uri="{96DAC541-7B7A-43D3-8B79-37D633B846F1}">
+                <asvg:svgBlip xmlns:asvg="http://schemas.microsoft.com/office/drawing/2016/SVG/main" r:embed="rId4"/>
+              </a:ext>
+            </a:extLst>
+          </a:blip>
+          <a:stretch>
+            <a:fillRect/>
+          </a:stretch>
+        </p:blipFill>
+        <p:spPr>
+          <a:xfrm>
+            <a:off x="10564063" y="502920"/>
+            <a:ext cx="329184" cy="329184"/>
+          </a:xfrm>
+          <a:prstGeom prst="rect">
+            <a:avLst/>
+          </a:prstGeom>
+        </p:spPr>
+      </p:pic>
+      <p:pic>
+        <p:nvPicPr>
+          <p:cNvPr id="19" name="Image 2" descr="preencoded.png">    </p:cNvPr>
+          <p:cNvPicPr>
+            <a:picLocks noChangeAspect="1"/>
+          </p:cNvPicPr>
+          <p:nvPr/>
+        </p:nvPicPr>
+        <p:blipFill>
+          <a:blip r:embed="rId5">
+            <a:extLst>
+              <a:ext uri="{96DAC541-7B7A-43D3-8B79-37D633B846F1}">
+                <asvg:svgBlip xmlns:asvg="http://schemas.microsoft.com/office/drawing/2016/SVG/main" r:embed="rId6"/>
+              </a:ext>
+            </a:extLst>
+          </a:blip>
+          <a:stretch>
+            <a:fillRect/>
+          </a:stretch>
+        </p:blipFill>
+        <p:spPr>
+          <a:xfrm>
+            <a:off x="10948111" y="502920"/>
+            <a:ext cx="329184" cy="329184"/>
+          </a:xfrm>
+          <a:prstGeom prst="rect">
+            <a:avLst/>
+          </a:prstGeom>
+        </p:spPr>
+      </p:pic>
+      <p:sp>
+        <p:nvSpPr>
+          <p:cNvPr id="20" name="Text 15"/>
           <p:cNvSpPr/>
           <p:nvPr/>
         </p:nvSpPr>
@@ -14280,7 +14184,7 @@
       </p:sp>
       <p:sp>
         <p:nvSpPr>
-          <p:cNvPr id="21" name="Text 19"/>
+          <p:cNvPr id="21" name="Text 16"/>
           <p:cNvSpPr/>
           <p:nvPr/>
         </p:nvSpPr>
@@ -15027,111 +14931,99 @@
           </a:p>
         </p:txBody>
       </p:sp>
-      <p:sp>
-        <p:nvSpPr>
-          <p:cNvPr id="22" name="Shape 20"/>
-          <p:cNvSpPr/>
-          <p:nvPr/>
-        </p:nvSpPr>
+      <p:pic>
+        <p:nvPicPr>
+          <p:cNvPr id="22" name="Image 0" descr="preencoded.png">    </p:cNvPr>
+          <p:cNvPicPr>
+            <a:picLocks noChangeAspect="1"/>
+          </p:cNvPicPr>
+          <p:nvPr/>
+        </p:nvPicPr>
+        <p:blipFill>
+          <a:blip r:embed="rId1">
+            <a:extLst>
+              <a:ext uri="{96DAC541-7B7A-43D3-8B79-37D633B846F1}">
+                <asvg:svgBlip xmlns:asvg="http://schemas.microsoft.com/office/drawing/2016/SVG/main" r:embed="rId2"/>
+              </a:ext>
+            </a:extLst>
+          </a:blip>
+          <a:stretch>
+            <a:fillRect/>
+          </a:stretch>
+        </p:blipFill>
         <p:spPr>
           <a:xfrm>
             <a:off x="10180015" y="502920"/>
-            <a:ext cx="292608" cy="292608"/>
-          </a:xfrm>
-          <a:prstGeom prst="roundRect">
-            <a:avLst>
-              <a:gd name="adj" fmla="val 15625"/>
-            </a:avLst>
-          </a:prstGeom>
-          <a:ln w="19050">
-            <a:solidFill>
-              <a:srgbClr val="6366F1"/>
-            </a:solidFill>
-            <a:prstDash val="solid"/>
-          </a:ln>
-        </p:spPr>
-      </p:sp>
-      <p:sp>
-        <p:nvSpPr>
-          <p:cNvPr id="23" name="Text 21"/>
-          <p:cNvSpPr/>
-          <p:nvPr/>
-        </p:nvSpPr>
-        <p:spPr>
-          <a:xfrm>
-            <a:off x="10472623" y="457200"/>
-            <a:ext cx="411480" cy="384048"/>
-          </a:xfrm>
-          <a:prstGeom prst="rect">
-            <a:avLst/>
-          </a:prstGeom>
-          <a:noFill/>
-          <a:ln/>
-        </p:spPr>
-        <p:txBody>
-          <a:bodyPr wrap="square" rtlCol="0" anchor="ctr"/>
-          <a:lstStyle/>
-          <a:p>
-            <a:pPr algn="ctr" indent="0" marL="0">
-              <a:buNone/>
-            </a:pPr>
-            <a:r>
-              <a:rPr lang="en-US" sz="1800" b="1" dirty="0">
-                <a:solidFill>
-                  <a:srgbClr val="6366F1"/>
-                </a:solidFill>
-                <a:latin typeface="Calibri" pitchFamily="34" charset="0"/>
-                <a:ea typeface="Calibri" pitchFamily="34" charset="-122"/>
-                <a:cs typeface="Calibri" pitchFamily="34" charset="-120"/>
-              </a:rPr>
-              <a:t>↔</a:t>
-            </a:r>
-            <a:endParaRPr lang="en-US" sz="1800" dirty="0"/>
-          </a:p>
-        </p:txBody>
-      </p:sp>
-      <p:sp>
-        <p:nvSpPr>
-          <p:cNvPr id="24" name="Text 22"/>
-          <p:cNvSpPr/>
-          <p:nvPr/>
-        </p:nvSpPr>
-        <p:spPr>
-          <a:xfrm>
-            <a:off x="10893247" y="429768"/>
-            <a:ext cx="411480" cy="457200"/>
-          </a:xfrm>
-          <a:prstGeom prst="rect">
-            <a:avLst/>
-          </a:prstGeom>
-          <a:noFill/>
-          <a:ln/>
-        </p:spPr>
-        <p:txBody>
-          <a:bodyPr wrap="square" rtlCol="0" anchor="ctr"/>
-          <a:lstStyle/>
-          <a:p>
-            <a:pPr algn="ctr" indent="0" marL="0">
-              <a:buNone/>
-            </a:pPr>
-            <a:r>
-              <a:rPr lang="en-US" sz="2200" dirty="0">
-                <a:solidFill>
-                  <a:srgbClr val="6366F1"/>
-                </a:solidFill>
-                <a:latin typeface="Calibri" pitchFamily="34" charset="0"/>
-                <a:ea typeface="Calibri" pitchFamily="34" charset="-122"/>
-                <a:cs typeface="Calibri" pitchFamily="34" charset="-120"/>
-              </a:rPr>
-              <a:t>☁</a:t>
-            </a:r>
-            <a:endParaRPr lang="en-US" sz="2200" dirty="0"/>
-          </a:p>
-        </p:txBody>
-      </p:sp>
-      <p:sp>
-        <p:nvSpPr>
-          <p:cNvPr id="25" name="Text 23"/>
+            <a:ext cx="329184" cy="329184"/>
+          </a:xfrm>
+          <a:prstGeom prst="rect">
+            <a:avLst/>
+          </a:prstGeom>
+        </p:spPr>
+      </p:pic>
+      <p:pic>
+        <p:nvPicPr>
+          <p:cNvPr id="23" name="Image 1" descr="preencoded.png">    </p:cNvPr>
+          <p:cNvPicPr>
+            <a:picLocks noChangeAspect="1"/>
+          </p:cNvPicPr>
+          <p:nvPr/>
+        </p:nvPicPr>
+        <p:blipFill>
+          <a:blip r:embed="rId3">
+            <a:extLst>
+              <a:ext uri="{96DAC541-7B7A-43D3-8B79-37D633B846F1}">
+                <asvg:svgBlip xmlns:asvg="http://schemas.microsoft.com/office/drawing/2016/SVG/main" r:embed="rId4"/>
+              </a:ext>
+            </a:extLst>
+          </a:blip>
+          <a:stretch>
+            <a:fillRect/>
+          </a:stretch>
+        </p:blipFill>
+        <p:spPr>
+          <a:xfrm>
+            <a:off x="10564063" y="502920"/>
+            <a:ext cx="329184" cy="329184"/>
+          </a:xfrm>
+          <a:prstGeom prst="rect">
+            <a:avLst/>
+          </a:prstGeom>
+        </p:spPr>
+      </p:pic>
+      <p:pic>
+        <p:nvPicPr>
+          <p:cNvPr id="24" name="Image 2" descr="preencoded.png">    </p:cNvPr>
+          <p:cNvPicPr>
+            <a:picLocks noChangeAspect="1"/>
+          </p:cNvPicPr>
+          <p:nvPr/>
+        </p:nvPicPr>
+        <p:blipFill>
+          <a:blip r:embed="rId5">
+            <a:extLst>
+              <a:ext uri="{96DAC541-7B7A-43D3-8B79-37D633B846F1}">
+                <asvg:svgBlip xmlns:asvg="http://schemas.microsoft.com/office/drawing/2016/SVG/main" r:embed="rId6"/>
+              </a:ext>
+            </a:extLst>
+          </a:blip>
+          <a:stretch>
+            <a:fillRect/>
+          </a:stretch>
+        </p:blipFill>
+        <p:spPr>
+          <a:xfrm>
+            <a:off x="10948111" y="502920"/>
+            <a:ext cx="329184" cy="329184"/>
+          </a:xfrm>
+          <a:prstGeom prst="rect">
+            <a:avLst/>
+          </a:prstGeom>
+        </p:spPr>
+      </p:pic>
+      <p:sp>
+        <p:nvSpPr>
+          <p:cNvPr id="25" name="Text 20"/>
           <p:cNvSpPr/>
           <p:nvPr/>
         </p:nvSpPr>
@@ -15212,7 +15104,7 @@
       </p:sp>
       <p:sp>
         <p:nvSpPr>
-          <p:cNvPr id="26" name="Text 24"/>
+          <p:cNvPr id="26" name="Text 21"/>
           <p:cNvSpPr/>
           <p:nvPr/>
         </p:nvSpPr>
@@ -15359,48 +15251,39 @@
           </a:p>
         </p:txBody>
       </p:sp>
-      <p:sp>
-        <p:nvSpPr>
-          <p:cNvPr id="4" name="Text 2"/>
-          <p:cNvSpPr/>
-          <p:nvPr/>
-        </p:nvSpPr>
-        <p:spPr>
-          <a:xfrm>
-            <a:off x="548640" y="2194560"/>
-            <a:ext cx="4114800" cy="3657600"/>
-          </a:xfrm>
-          <a:prstGeom prst="rect">
-            <a:avLst/>
-          </a:prstGeom>
-          <a:noFill/>
-          <a:ln/>
-        </p:spPr>
-        <p:txBody>
-          <a:bodyPr wrap="square" rtlCol="0" anchor="ctr"/>
-          <a:lstStyle/>
-          <a:p>
-            <a:pPr algn="ctr" indent="0" marL="0">
-              <a:buNone/>
-            </a:pPr>
-            <a:r>
-              <a:rPr lang="en-US" sz="22000" dirty="0">
-                <a:solidFill>
-                  <a:srgbClr val="6366F1"/>
-                </a:solidFill>
-                <a:latin typeface="Calibri" pitchFamily="34" charset="0"/>
-                <a:ea typeface="Calibri" pitchFamily="34" charset="-122"/>
-                <a:cs typeface="Calibri" pitchFamily="34" charset="-120"/>
-              </a:rPr>
-              <a:t>☁</a:t>
-            </a:r>
-            <a:endParaRPr lang="en-US" sz="22000" dirty="0"/>
-          </a:p>
-        </p:txBody>
-      </p:sp>
-      <p:sp>
-        <p:nvSpPr>
-          <p:cNvPr id="5" name="Text 3"/>
+      <p:pic>
+        <p:nvPicPr>
+          <p:cNvPr id="4" name="Image 0" descr="preencoded.png">    </p:cNvPr>
+          <p:cNvPicPr>
+            <a:picLocks noChangeAspect="1"/>
+          </p:cNvPicPr>
+          <p:nvPr/>
+        </p:nvPicPr>
+        <p:blipFill>
+          <a:blip r:embed="rId1">
+            <a:extLst>
+              <a:ext uri="{96DAC541-7B7A-43D3-8B79-37D633B846F1}">
+                <asvg:svgBlip xmlns:asvg="http://schemas.microsoft.com/office/drawing/2016/SVG/main" r:embed="rId2"/>
+              </a:ext>
+            </a:extLst>
+          </a:blip>
+          <a:stretch>
+            <a:fillRect/>
+          </a:stretch>
+        </p:blipFill>
+        <p:spPr>
+          <a:xfrm>
+            <a:off x="548640" y="2377440"/>
+            <a:ext cx="3291840" cy="3291840"/>
+          </a:xfrm>
+          <a:prstGeom prst="rect">
+            <a:avLst/>
+          </a:prstGeom>
+        </p:spPr>
+      </p:pic>
+      <p:sp>
+        <p:nvSpPr>
+          <p:cNvPr id="5" name="Text 2"/>
           <p:cNvSpPr/>
           <p:nvPr/>
         </p:nvSpPr>
@@ -15439,7 +15322,7 @@
       </p:sp>
       <p:sp>
         <p:nvSpPr>
-          <p:cNvPr id="6" name="Shape 4"/>
+          <p:cNvPr id="6" name="Shape 3"/>
           <p:cNvSpPr/>
           <p:nvPr/>
         </p:nvSpPr>
@@ -15466,7 +15349,7 @@
       </p:sp>
       <p:sp>
         <p:nvSpPr>
-          <p:cNvPr id="7" name="Text 5"/>
+          <p:cNvPr id="7" name="Text 4"/>
           <p:cNvSpPr/>
           <p:nvPr/>
         </p:nvSpPr>
@@ -15505,7 +15388,7 @@
       </p:sp>
       <p:sp>
         <p:nvSpPr>
-          <p:cNvPr id="8" name="Text 6"/>
+          <p:cNvPr id="8" name="Text 5"/>
           <p:cNvSpPr/>
           <p:nvPr/>
         </p:nvSpPr>
@@ -15544,7 +15427,7 @@
       </p:sp>
       <p:sp>
         <p:nvSpPr>
-          <p:cNvPr id="9" name="Shape 7"/>
+          <p:cNvPr id="9" name="Shape 6"/>
           <p:cNvSpPr/>
           <p:nvPr/>
         </p:nvSpPr>
@@ -15571,7 +15454,7 @@
       </p:sp>
       <p:sp>
         <p:nvSpPr>
-          <p:cNvPr id="10" name="Text 8"/>
+          <p:cNvPr id="10" name="Text 7"/>
           <p:cNvSpPr/>
           <p:nvPr/>
         </p:nvSpPr>
@@ -15610,7 +15493,7 @@
       </p:sp>
       <p:sp>
         <p:nvSpPr>
-          <p:cNvPr id="11" name="Text 9"/>
+          <p:cNvPr id="11" name="Text 8"/>
           <p:cNvSpPr/>
           <p:nvPr/>
         </p:nvSpPr>
@@ -15649,7 +15532,7 @@
       </p:sp>
       <p:sp>
         <p:nvSpPr>
-          <p:cNvPr id="12" name="Shape 10"/>
+          <p:cNvPr id="12" name="Shape 9"/>
           <p:cNvSpPr/>
           <p:nvPr/>
         </p:nvSpPr>
@@ -15676,7 +15559,7 @@
       </p:sp>
       <p:sp>
         <p:nvSpPr>
-          <p:cNvPr id="13" name="Text 11"/>
+          <p:cNvPr id="13" name="Text 10"/>
           <p:cNvSpPr/>
           <p:nvPr/>
         </p:nvSpPr>
@@ -15715,7 +15598,7 @@
       </p:sp>
       <p:sp>
         <p:nvSpPr>
-          <p:cNvPr id="14" name="Text 12"/>
+          <p:cNvPr id="14" name="Text 11"/>
           <p:cNvSpPr/>
           <p:nvPr/>
         </p:nvSpPr>
@@ -15754,7 +15637,7 @@
       </p:sp>
       <p:sp>
         <p:nvSpPr>
-          <p:cNvPr id="15" name="Shape 13"/>
+          <p:cNvPr id="15" name="Shape 12"/>
           <p:cNvSpPr/>
           <p:nvPr/>
         </p:nvSpPr>
@@ -15781,7 +15664,7 @@
       </p:sp>
       <p:sp>
         <p:nvSpPr>
-          <p:cNvPr id="16" name="Text 14"/>
+          <p:cNvPr id="16" name="Text 13"/>
           <p:cNvSpPr/>
           <p:nvPr/>
         </p:nvSpPr>
@@ -15820,7 +15703,7 @@
       </p:sp>
       <p:sp>
         <p:nvSpPr>
-          <p:cNvPr id="17" name="Text 15"/>
+          <p:cNvPr id="17" name="Text 14"/>
           <p:cNvSpPr/>
           <p:nvPr/>
         </p:nvSpPr>
@@ -15922,7 +15805,7 @@
       </p:sp>
       <p:sp>
         <p:nvSpPr>
-          <p:cNvPr id="18" name="Shape 16"/>
+          <p:cNvPr id="18" name="Shape 15"/>
           <p:cNvSpPr/>
           <p:nvPr/>
         </p:nvSpPr>
@@ -15949,7 +15832,7 @@
       </p:sp>
       <p:sp>
         <p:nvSpPr>
-          <p:cNvPr id="19" name="Text 17"/>
+          <p:cNvPr id="19" name="Text 16"/>
           <p:cNvSpPr/>
           <p:nvPr/>
         </p:nvSpPr>
@@ -15988,7 +15871,7 @@
       </p:sp>
       <p:sp>
         <p:nvSpPr>
-          <p:cNvPr id="20" name="Text 18"/>
+          <p:cNvPr id="20" name="Text 17"/>
           <p:cNvSpPr/>
           <p:nvPr/>
         </p:nvSpPr>
@@ -16088,111 +15971,99 @@
           </a:p>
         </p:txBody>
       </p:sp>
-      <p:sp>
-        <p:nvSpPr>
-          <p:cNvPr id="21" name="Shape 19"/>
-          <p:cNvSpPr/>
-          <p:nvPr/>
-        </p:nvSpPr>
+      <p:pic>
+        <p:nvPicPr>
+          <p:cNvPr id="21" name="Image 1" descr="preencoded.png">    </p:cNvPr>
+          <p:cNvPicPr>
+            <a:picLocks noChangeAspect="1"/>
+          </p:cNvPicPr>
+          <p:nvPr/>
+        </p:nvPicPr>
+        <p:blipFill>
+          <a:blip r:embed="rId3">
+            <a:extLst>
+              <a:ext uri="{96DAC541-7B7A-43D3-8B79-37D633B846F1}">
+                <asvg:svgBlip xmlns:asvg="http://schemas.microsoft.com/office/drawing/2016/SVG/main" r:embed="rId4"/>
+              </a:ext>
+            </a:extLst>
+          </a:blip>
+          <a:stretch>
+            <a:fillRect/>
+          </a:stretch>
+        </p:blipFill>
         <p:spPr>
           <a:xfrm>
             <a:off x="10180015" y="502920"/>
-            <a:ext cx="292608" cy="292608"/>
-          </a:xfrm>
-          <a:prstGeom prst="roundRect">
-            <a:avLst>
-              <a:gd name="adj" fmla="val 15625"/>
-            </a:avLst>
-          </a:prstGeom>
-          <a:ln w="19050">
-            <a:solidFill>
-              <a:srgbClr val="6366F1"/>
-            </a:solidFill>
-            <a:prstDash val="solid"/>
-          </a:ln>
-        </p:spPr>
-      </p:sp>
-      <p:sp>
-        <p:nvSpPr>
-          <p:cNvPr id="22" name="Text 20"/>
-          <p:cNvSpPr/>
-          <p:nvPr/>
-        </p:nvSpPr>
-        <p:spPr>
-          <a:xfrm>
-            <a:off x="10472623" y="457200"/>
-            <a:ext cx="411480" cy="384048"/>
-          </a:xfrm>
-          <a:prstGeom prst="rect">
-            <a:avLst/>
-          </a:prstGeom>
-          <a:noFill/>
-          <a:ln/>
-        </p:spPr>
-        <p:txBody>
-          <a:bodyPr wrap="square" rtlCol="0" anchor="ctr"/>
-          <a:lstStyle/>
-          <a:p>
-            <a:pPr algn="ctr" indent="0" marL="0">
-              <a:buNone/>
-            </a:pPr>
-            <a:r>
-              <a:rPr lang="en-US" sz="1800" b="1" dirty="0">
-                <a:solidFill>
-                  <a:srgbClr val="6366F1"/>
-                </a:solidFill>
-                <a:latin typeface="Calibri" pitchFamily="34" charset="0"/>
-                <a:ea typeface="Calibri" pitchFamily="34" charset="-122"/>
-                <a:cs typeface="Calibri" pitchFamily="34" charset="-120"/>
-              </a:rPr>
-              <a:t>↔</a:t>
-            </a:r>
-            <a:endParaRPr lang="en-US" sz="1800" dirty="0"/>
-          </a:p>
-        </p:txBody>
-      </p:sp>
-      <p:sp>
-        <p:nvSpPr>
-          <p:cNvPr id="23" name="Text 21"/>
-          <p:cNvSpPr/>
-          <p:nvPr/>
-        </p:nvSpPr>
-        <p:spPr>
-          <a:xfrm>
-            <a:off x="10893247" y="429768"/>
-            <a:ext cx="411480" cy="457200"/>
-          </a:xfrm>
-          <a:prstGeom prst="rect">
-            <a:avLst/>
-          </a:prstGeom>
-          <a:noFill/>
-          <a:ln/>
-        </p:spPr>
-        <p:txBody>
-          <a:bodyPr wrap="square" rtlCol="0" anchor="ctr"/>
-          <a:lstStyle/>
-          <a:p>
-            <a:pPr algn="ctr" indent="0" marL="0">
-              <a:buNone/>
-            </a:pPr>
-            <a:r>
-              <a:rPr lang="en-US" sz="2200" dirty="0">
-                <a:solidFill>
-                  <a:srgbClr val="6366F1"/>
-                </a:solidFill>
-                <a:latin typeface="Calibri" pitchFamily="34" charset="0"/>
-                <a:ea typeface="Calibri" pitchFamily="34" charset="-122"/>
-                <a:cs typeface="Calibri" pitchFamily="34" charset="-120"/>
-              </a:rPr>
-              <a:t>☁</a:t>
-            </a:r>
-            <a:endParaRPr lang="en-US" sz="2200" dirty="0"/>
-          </a:p>
-        </p:txBody>
-      </p:sp>
-      <p:sp>
-        <p:nvSpPr>
-          <p:cNvPr id="24" name="Text 22"/>
+            <a:ext cx="329184" cy="329184"/>
+          </a:xfrm>
+          <a:prstGeom prst="rect">
+            <a:avLst/>
+          </a:prstGeom>
+        </p:spPr>
+      </p:pic>
+      <p:pic>
+        <p:nvPicPr>
+          <p:cNvPr id="22" name="Image 2" descr="preencoded.png">    </p:cNvPr>
+          <p:cNvPicPr>
+            <a:picLocks noChangeAspect="1"/>
+          </p:cNvPicPr>
+          <p:nvPr/>
+        </p:nvPicPr>
+        <p:blipFill>
+          <a:blip r:embed="rId5">
+            <a:extLst>
+              <a:ext uri="{96DAC541-7B7A-43D3-8B79-37D633B846F1}">
+                <asvg:svgBlip xmlns:asvg="http://schemas.microsoft.com/office/drawing/2016/SVG/main" r:embed="rId6"/>
+              </a:ext>
+            </a:extLst>
+          </a:blip>
+          <a:stretch>
+            <a:fillRect/>
+          </a:stretch>
+        </p:blipFill>
+        <p:spPr>
+          <a:xfrm>
+            <a:off x="10564063" y="502920"/>
+            <a:ext cx="329184" cy="329184"/>
+          </a:xfrm>
+          <a:prstGeom prst="rect">
+            <a:avLst/>
+          </a:prstGeom>
+        </p:spPr>
+      </p:pic>
+      <p:pic>
+        <p:nvPicPr>
+          <p:cNvPr id="23" name="Image 3" descr="preencoded.png">    </p:cNvPr>
+          <p:cNvPicPr>
+            <a:picLocks noChangeAspect="1"/>
+          </p:cNvPicPr>
+          <p:nvPr/>
+        </p:nvPicPr>
+        <p:blipFill>
+          <a:blip r:embed="rId7">
+            <a:extLst>
+              <a:ext uri="{96DAC541-7B7A-43D3-8B79-37D633B846F1}">
+                <asvg:svgBlip xmlns:asvg="http://schemas.microsoft.com/office/drawing/2016/SVG/main" r:embed="rId8"/>
+              </a:ext>
+            </a:extLst>
+          </a:blip>
+          <a:stretch>
+            <a:fillRect/>
+          </a:stretch>
+        </p:blipFill>
+        <p:spPr>
+          <a:xfrm>
+            <a:off x="10948111" y="502920"/>
+            <a:ext cx="329184" cy="329184"/>
+          </a:xfrm>
+          <a:prstGeom prst="rect">
+            <a:avLst/>
+          </a:prstGeom>
+        </p:spPr>
+      </p:pic>
+      <p:sp>
+        <p:nvSpPr>
+          <p:cNvPr id="24" name="Text 18"/>
           <p:cNvSpPr/>
           <p:nvPr/>
         </p:nvSpPr>
@@ -16273,7 +16144,7 @@
       </p:sp>
       <p:sp>
         <p:nvSpPr>
-          <p:cNvPr id="25" name="Text 23"/>
+          <p:cNvPr id="25" name="Text 19"/>
           <p:cNvSpPr/>
           <p:nvPr/>
         </p:nvSpPr>
@@ -17511,16 +17382,46 @@
           </a:p>
         </p:txBody>
       </p:sp>
-      <p:sp>
-        <p:nvSpPr>
-          <p:cNvPr id="9" name="Text 7"/>
-          <p:cNvSpPr/>
-          <p:nvPr/>
-        </p:nvSpPr>
-        <p:spPr>
-          <a:xfrm>
-            <a:off x="8046720" y="3611880"/>
-            <a:ext cx="3657600" cy="274320"/>
+      <p:pic>
+        <p:nvPicPr>
+          <p:cNvPr id="9" name="Image 0" descr="preencoded.png">    </p:cNvPr>
+          <p:cNvPicPr>
+            <a:picLocks noChangeAspect="1"/>
+          </p:cNvPicPr>
+          <p:nvPr/>
+        </p:nvPicPr>
+        <p:blipFill>
+          <a:blip r:embed="rId1">
+            <a:extLst>
+              <a:ext uri="{96DAC541-7B7A-43D3-8B79-37D633B846F1}">
+                <asvg:svgBlip xmlns:asvg="http://schemas.microsoft.com/office/drawing/2016/SVG/main" r:embed="rId2"/>
+              </a:ext>
+            </a:extLst>
+          </a:blip>
+          <a:stretch>
+            <a:fillRect/>
+          </a:stretch>
+        </p:blipFill>
+        <p:spPr>
+          <a:xfrm>
+            <a:off x="8046720" y="3648456"/>
+            <a:ext cx="256032" cy="256032"/>
+          </a:xfrm>
+          <a:prstGeom prst="rect">
+            <a:avLst/>
+          </a:prstGeom>
+        </p:spPr>
+      </p:pic>
+      <p:sp>
+        <p:nvSpPr>
+          <p:cNvPr id="10" name="Text 7"/>
+          <p:cNvSpPr/>
+          <p:nvPr/>
+        </p:nvSpPr>
+        <p:spPr>
+          <a:xfrm>
+            <a:off x="8394192" y="3611880"/>
+            <a:ext cx="3291840" cy="274320"/>
           </a:xfrm>
           <a:prstGeom prst="rect">
             <a:avLst/>
@@ -17544,7 +17445,7 @@
                 <a:ea typeface="Calibri" pitchFamily="34" charset="-122"/>
                 <a:cs typeface="Calibri" pitchFamily="34" charset="-120"/>
               </a:rPr>
-              <a:t>⚡ Latency</a:t>
+              <a:t>Latency</a:t>
             </a:r>
             <a:endParaRPr lang="en-US" sz="1400" dirty="0"/>
           </a:p>
@@ -17552,14 +17453,14 @@
       </p:sp>
       <p:sp>
         <p:nvSpPr>
-          <p:cNvPr id="10" name="Text 8"/>
-          <p:cNvSpPr/>
-          <p:nvPr/>
-        </p:nvSpPr>
-        <p:spPr>
-          <a:xfrm>
-            <a:off x="8046720" y="3886200"/>
-            <a:ext cx="3657600" cy="274320"/>
+          <p:cNvPr id="11" name="Text 8"/>
+          <p:cNvSpPr/>
+          <p:nvPr/>
+        </p:nvSpPr>
+        <p:spPr>
+          <a:xfrm>
+            <a:off x="8394192" y="3886200"/>
+            <a:ext cx="3291840" cy="274320"/>
           </a:xfrm>
           <a:prstGeom prst="rect">
             <a:avLst/>
@@ -17589,16 +17490,46 @@
           </a:p>
         </p:txBody>
       </p:sp>
-      <p:sp>
-        <p:nvSpPr>
-          <p:cNvPr id="11" name="Text 9"/>
-          <p:cNvSpPr/>
-          <p:nvPr/>
-        </p:nvSpPr>
-        <p:spPr>
-          <a:xfrm>
-            <a:off x="8046720" y="4251960"/>
-            <a:ext cx="3657600" cy="274320"/>
+      <p:pic>
+        <p:nvPicPr>
+          <p:cNvPr id="12" name="Image 1" descr="preencoded.png">    </p:cNvPr>
+          <p:cNvPicPr>
+            <a:picLocks noChangeAspect="1"/>
+          </p:cNvPicPr>
+          <p:nvPr/>
+        </p:nvPicPr>
+        <p:blipFill>
+          <a:blip r:embed="rId3">
+            <a:extLst>
+              <a:ext uri="{96DAC541-7B7A-43D3-8B79-37D633B846F1}">
+                <asvg:svgBlip xmlns:asvg="http://schemas.microsoft.com/office/drawing/2016/SVG/main" r:embed="rId4"/>
+              </a:ext>
+            </a:extLst>
+          </a:blip>
+          <a:stretch>
+            <a:fillRect/>
+          </a:stretch>
+        </p:blipFill>
+        <p:spPr>
+          <a:xfrm>
+            <a:off x="8046720" y="4288536"/>
+            <a:ext cx="256032" cy="256032"/>
+          </a:xfrm>
+          <a:prstGeom prst="rect">
+            <a:avLst/>
+          </a:prstGeom>
+        </p:spPr>
+      </p:pic>
+      <p:sp>
+        <p:nvSpPr>
+          <p:cNvPr id="13" name="Text 9"/>
+          <p:cNvSpPr/>
+          <p:nvPr/>
+        </p:nvSpPr>
+        <p:spPr>
+          <a:xfrm>
+            <a:off x="8394192" y="4251960"/>
+            <a:ext cx="3291840" cy="274320"/>
           </a:xfrm>
           <a:prstGeom prst="rect">
             <a:avLst/>
@@ -17622,7 +17553,7 @@
                 <a:ea typeface="Calibri" pitchFamily="34" charset="-122"/>
                 <a:cs typeface="Calibri" pitchFamily="34" charset="-120"/>
               </a:rPr>
-              <a:t>🌐 Connectivity</a:t>
+              <a:t>Connectivity</a:t>
             </a:r>
             <a:endParaRPr lang="en-US" sz="1400" dirty="0"/>
           </a:p>
@@ -17630,14 +17561,14 @@
       </p:sp>
       <p:sp>
         <p:nvSpPr>
-          <p:cNvPr id="12" name="Text 10"/>
-          <p:cNvSpPr/>
-          <p:nvPr/>
-        </p:nvSpPr>
-        <p:spPr>
-          <a:xfrm>
-            <a:off x="8046720" y="4526280"/>
-            <a:ext cx="3657600" cy="274320"/>
+          <p:cNvPr id="14" name="Text 10"/>
+          <p:cNvSpPr/>
+          <p:nvPr/>
+        </p:nvSpPr>
+        <p:spPr>
+          <a:xfrm>
+            <a:off x="8394192" y="4526280"/>
+            <a:ext cx="3291840" cy="274320"/>
           </a:xfrm>
           <a:prstGeom prst="rect">
             <a:avLst/>
@@ -17667,16 +17598,46 @@
           </a:p>
         </p:txBody>
       </p:sp>
-      <p:sp>
-        <p:nvSpPr>
-          <p:cNvPr id="13" name="Text 11"/>
-          <p:cNvSpPr/>
-          <p:nvPr/>
-        </p:nvSpPr>
-        <p:spPr>
-          <a:xfrm>
-            <a:off x="8046720" y="4892040"/>
-            <a:ext cx="3657600" cy="274320"/>
+      <p:pic>
+        <p:nvPicPr>
+          <p:cNvPr id="15" name="Image 2" descr="preencoded.png">    </p:cNvPr>
+          <p:cNvPicPr>
+            <a:picLocks noChangeAspect="1"/>
+          </p:cNvPicPr>
+          <p:nvPr/>
+        </p:nvPicPr>
+        <p:blipFill>
+          <a:blip r:embed="rId5">
+            <a:extLst>
+              <a:ext uri="{96DAC541-7B7A-43D3-8B79-37D633B846F1}">
+                <asvg:svgBlip xmlns:asvg="http://schemas.microsoft.com/office/drawing/2016/SVG/main" r:embed="rId6"/>
+              </a:ext>
+            </a:extLst>
+          </a:blip>
+          <a:stretch>
+            <a:fillRect/>
+          </a:stretch>
+        </p:blipFill>
+        <p:spPr>
+          <a:xfrm>
+            <a:off x="8046720" y="4928616"/>
+            <a:ext cx="256032" cy="256032"/>
+          </a:xfrm>
+          <a:prstGeom prst="rect">
+            <a:avLst/>
+          </a:prstGeom>
+        </p:spPr>
+      </p:pic>
+      <p:sp>
+        <p:nvSpPr>
+          <p:cNvPr id="16" name="Text 11"/>
+          <p:cNvSpPr/>
+          <p:nvPr/>
+        </p:nvSpPr>
+        <p:spPr>
+          <a:xfrm>
+            <a:off x="8394192" y="4892040"/>
+            <a:ext cx="3291840" cy="274320"/>
           </a:xfrm>
           <a:prstGeom prst="rect">
             <a:avLst/>
@@ -17700,7 +17661,7 @@
                 <a:ea typeface="Calibri" pitchFamily="34" charset="-122"/>
                 <a:cs typeface="Calibri" pitchFamily="34" charset="-120"/>
               </a:rPr>
-              <a:t>🧠 Quality</a:t>
+              <a:t>Quality</a:t>
             </a:r>
             <a:endParaRPr lang="en-US" sz="1400" dirty="0"/>
           </a:p>
@@ -17708,14 +17669,14 @@
       </p:sp>
       <p:sp>
         <p:nvSpPr>
-          <p:cNvPr id="14" name="Text 12"/>
-          <p:cNvSpPr/>
-          <p:nvPr/>
-        </p:nvSpPr>
-        <p:spPr>
-          <a:xfrm>
-            <a:off x="8046720" y="5166360"/>
-            <a:ext cx="3657600" cy="274320"/>
+          <p:cNvPr id="17" name="Text 12"/>
+          <p:cNvSpPr/>
+          <p:nvPr/>
+        </p:nvSpPr>
+        <p:spPr>
+          <a:xfrm>
+            <a:off x="8394192" y="5166360"/>
+            <a:ext cx="3291840" cy="274320"/>
           </a:xfrm>
           <a:prstGeom prst="rect">
             <a:avLst/>
@@ -17745,16 +17706,46 @@
           </a:p>
         </p:txBody>
       </p:sp>
-      <p:sp>
-        <p:nvSpPr>
-          <p:cNvPr id="15" name="Text 13"/>
-          <p:cNvSpPr/>
-          <p:nvPr/>
-        </p:nvSpPr>
-        <p:spPr>
-          <a:xfrm>
-            <a:off x="8046720" y="5532120"/>
-            <a:ext cx="3657600" cy="274320"/>
+      <p:pic>
+        <p:nvPicPr>
+          <p:cNvPr id="18" name="Image 3" descr="preencoded.png">    </p:cNvPr>
+          <p:cNvPicPr>
+            <a:picLocks noChangeAspect="1"/>
+          </p:cNvPicPr>
+          <p:nvPr/>
+        </p:nvPicPr>
+        <p:blipFill>
+          <a:blip r:embed="rId7">
+            <a:extLst>
+              <a:ext uri="{96DAC541-7B7A-43D3-8B79-37D633B846F1}">
+                <asvg:svgBlip xmlns:asvg="http://schemas.microsoft.com/office/drawing/2016/SVG/main" r:embed="rId8"/>
+              </a:ext>
+            </a:extLst>
+          </a:blip>
+          <a:stretch>
+            <a:fillRect/>
+          </a:stretch>
+        </p:blipFill>
+        <p:spPr>
+          <a:xfrm>
+            <a:off x="8046720" y="5568696"/>
+            <a:ext cx="256032" cy="256032"/>
+          </a:xfrm>
+          <a:prstGeom prst="rect">
+            <a:avLst/>
+          </a:prstGeom>
+        </p:spPr>
+      </p:pic>
+      <p:sp>
+        <p:nvSpPr>
+          <p:cNvPr id="19" name="Text 13"/>
+          <p:cNvSpPr/>
+          <p:nvPr/>
+        </p:nvSpPr>
+        <p:spPr>
+          <a:xfrm>
+            <a:off x="8394192" y="5532120"/>
+            <a:ext cx="3291840" cy="274320"/>
           </a:xfrm>
           <a:prstGeom prst="rect">
             <a:avLst/>
@@ -17778,7 +17769,7 @@
                 <a:ea typeface="Calibri" pitchFamily="34" charset="-122"/>
                 <a:cs typeface="Calibri" pitchFamily="34" charset="-120"/>
               </a:rPr>
-              <a:t>💸 Cost</a:t>
+              <a:t>Cost</a:t>
             </a:r>
             <a:endParaRPr lang="en-US" sz="1400" dirty="0"/>
           </a:p>
@@ -17786,14 +17777,14 @@
       </p:sp>
       <p:sp>
         <p:nvSpPr>
-          <p:cNvPr id="16" name="Text 14"/>
-          <p:cNvSpPr/>
-          <p:nvPr/>
-        </p:nvSpPr>
-        <p:spPr>
-          <a:xfrm>
-            <a:off x="8046720" y="5806440"/>
-            <a:ext cx="3657600" cy="274320"/>
+          <p:cNvPr id="20" name="Text 14"/>
+          <p:cNvSpPr/>
+          <p:nvPr/>
+        </p:nvSpPr>
+        <p:spPr>
+          <a:xfrm>
+            <a:off x="8394192" y="5806440"/>
+            <a:ext cx="3291840" cy="274320"/>
           </a:xfrm>
           <a:prstGeom prst="rect">
             <a:avLst/>
@@ -17823,108 +17814,96 @@
           </a:p>
         </p:txBody>
       </p:sp>
-      <p:sp>
-        <p:nvSpPr>
-          <p:cNvPr id="17" name="Shape 15"/>
-          <p:cNvSpPr/>
-          <p:nvPr/>
-        </p:nvSpPr>
+      <p:pic>
+        <p:nvPicPr>
+          <p:cNvPr id="21" name="Image 4" descr="preencoded.png">    </p:cNvPr>
+          <p:cNvPicPr>
+            <a:picLocks noChangeAspect="1"/>
+          </p:cNvPicPr>
+          <p:nvPr/>
+        </p:nvPicPr>
+        <p:blipFill>
+          <a:blip r:embed="rId9">
+            <a:extLst>
+              <a:ext uri="{96DAC541-7B7A-43D3-8B79-37D633B846F1}">
+                <asvg:svgBlip xmlns:asvg="http://schemas.microsoft.com/office/drawing/2016/SVG/main" r:embed="rId10"/>
+              </a:ext>
+            </a:extLst>
+          </a:blip>
+          <a:stretch>
+            <a:fillRect/>
+          </a:stretch>
+        </p:blipFill>
         <p:spPr>
           <a:xfrm>
             <a:off x="10180015" y="502920"/>
-            <a:ext cx="292608" cy="292608"/>
-          </a:xfrm>
-          <a:prstGeom prst="roundRect">
-            <a:avLst>
-              <a:gd name="adj" fmla="val 15625"/>
-            </a:avLst>
-          </a:prstGeom>
-          <a:ln w="19050">
-            <a:solidFill>
-              <a:srgbClr val="6366F1"/>
-            </a:solidFill>
-            <a:prstDash val="solid"/>
-          </a:ln>
-        </p:spPr>
-      </p:sp>
-      <p:sp>
-        <p:nvSpPr>
-          <p:cNvPr id="18" name="Text 16"/>
-          <p:cNvSpPr/>
-          <p:nvPr/>
-        </p:nvSpPr>
-        <p:spPr>
-          <a:xfrm>
-            <a:off x="10472623" y="457200"/>
-            <a:ext cx="411480" cy="384048"/>
-          </a:xfrm>
-          <a:prstGeom prst="rect">
-            <a:avLst/>
-          </a:prstGeom>
-          <a:noFill/>
-          <a:ln/>
-        </p:spPr>
-        <p:txBody>
-          <a:bodyPr wrap="square" rtlCol="0" anchor="ctr"/>
-          <a:lstStyle/>
-          <a:p>
-            <a:pPr algn="ctr" indent="0" marL="0">
-              <a:buNone/>
-            </a:pPr>
-            <a:r>
-              <a:rPr lang="en-US" sz="1800" b="1" dirty="0">
-                <a:solidFill>
-                  <a:srgbClr val="6366F1"/>
-                </a:solidFill>
-                <a:latin typeface="Calibri" pitchFamily="34" charset="0"/>
-                <a:ea typeface="Calibri" pitchFamily="34" charset="-122"/>
-                <a:cs typeface="Calibri" pitchFamily="34" charset="-120"/>
-              </a:rPr>
-              <a:t>↔</a:t>
-            </a:r>
-            <a:endParaRPr lang="en-US" sz="1800" dirty="0"/>
-          </a:p>
-        </p:txBody>
-      </p:sp>
-      <p:sp>
-        <p:nvSpPr>
-          <p:cNvPr id="19" name="Text 17"/>
-          <p:cNvSpPr/>
-          <p:nvPr/>
-        </p:nvSpPr>
-        <p:spPr>
-          <a:xfrm>
-            <a:off x="10893247" y="429768"/>
-            <a:ext cx="411480" cy="457200"/>
-          </a:xfrm>
-          <a:prstGeom prst="rect">
-            <a:avLst/>
-          </a:prstGeom>
-          <a:noFill/>
-          <a:ln/>
-        </p:spPr>
-        <p:txBody>
-          <a:bodyPr wrap="square" rtlCol="0" anchor="ctr"/>
-          <a:lstStyle/>
-          <a:p>
-            <a:pPr algn="ctr" indent="0" marL="0">
-              <a:buNone/>
-            </a:pPr>
-            <a:r>
-              <a:rPr lang="en-US" sz="2200" dirty="0">
-                <a:solidFill>
-                  <a:srgbClr val="6366F1"/>
-                </a:solidFill>
-                <a:latin typeface="Calibri" pitchFamily="34" charset="0"/>
-                <a:ea typeface="Calibri" pitchFamily="34" charset="-122"/>
-                <a:cs typeface="Calibri" pitchFamily="34" charset="-120"/>
-              </a:rPr>
-              <a:t>☁</a:t>
-            </a:r>
-            <a:endParaRPr lang="en-US" sz="2200" dirty="0"/>
-          </a:p>
-        </p:txBody>
-      </p:sp>
+            <a:ext cx="329184" cy="329184"/>
+          </a:xfrm>
+          <a:prstGeom prst="rect">
+            <a:avLst/>
+          </a:prstGeom>
+        </p:spPr>
+      </p:pic>
+      <p:pic>
+        <p:nvPicPr>
+          <p:cNvPr id="22" name="Image 5" descr="preencoded.png">    </p:cNvPr>
+          <p:cNvPicPr>
+            <a:picLocks noChangeAspect="1"/>
+          </p:cNvPicPr>
+          <p:nvPr/>
+        </p:nvPicPr>
+        <p:blipFill>
+          <a:blip r:embed="rId11">
+            <a:extLst>
+              <a:ext uri="{96DAC541-7B7A-43D3-8B79-37D633B846F1}">
+                <asvg:svgBlip xmlns:asvg="http://schemas.microsoft.com/office/drawing/2016/SVG/main" r:embed="rId12"/>
+              </a:ext>
+            </a:extLst>
+          </a:blip>
+          <a:stretch>
+            <a:fillRect/>
+          </a:stretch>
+        </p:blipFill>
+        <p:spPr>
+          <a:xfrm>
+            <a:off x="10564063" y="502920"/>
+            <a:ext cx="329184" cy="329184"/>
+          </a:xfrm>
+          <a:prstGeom prst="rect">
+            <a:avLst/>
+          </a:prstGeom>
+        </p:spPr>
+      </p:pic>
+      <p:pic>
+        <p:nvPicPr>
+          <p:cNvPr id="23" name="Image 6" descr="preencoded.png">    </p:cNvPr>
+          <p:cNvPicPr>
+            <a:picLocks noChangeAspect="1"/>
+          </p:cNvPicPr>
+          <p:nvPr/>
+        </p:nvPicPr>
+        <p:blipFill>
+          <a:blip r:embed="rId13">
+            <a:extLst>
+              <a:ext uri="{96DAC541-7B7A-43D3-8B79-37D633B846F1}">
+                <asvg:svgBlip xmlns:asvg="http://schemas.microsoft.com/office/drawing/2016/SVG/main" r:embed="rId14"/>
+              </a:ext>
+            </a:extLst>
+          </a:blip>
+          <a:stretch>
+            <a:fillRect/>
+          </a:stretch>
+        </p:blipFill>
+        <p:spPr>
+          <a:xfrm>
+            <a:off x="10948111" y="502920"/>
+            <a:ext cx="329184" cy="329184"/>
+          </a:xfrm>
+          <a:prstGeom prst="rect">
+            <a:avLst/>
+          </a:prstGeom>
+        </p:spPr>
+      </p:pic>
     </p:spTree>
   </p:cSld>
   <p:clrMapOvr>
@@ -19107,111 +19086,99 @@
           </a:p>
         </p:txBody>
       </p:sp>
-      <p:sp>
-        <p:nvSpPr>
-          <p:cNvPr id="31" name="Shape 29"/>
-          <p:cNvSpPr/>
-          <p:nvPr/>
-        </p:nvSpPr>
+      <p:pic>
+        <p:nvPicPr>
+          <p:cNvPr id="31" name="Image 0" descr="preencoded.png">    </p:cNvPr>
+          <p:cNvPicPr>
+            <a:picLocks noChangeAspect="1"/>
+          </p:cNvPicPr>
+          <p:nvPr/>
+        </p:nvPicPr>
+        <p:blipFill>
+          <a:blip r:embed="rId1">
+            <a:extLst>
+              <a:ext uri="{96DAC541-7B7A-43D3-8B79-37D633B846F1}">
+                <asvg:svgBlip xmlns:asvg="http://schemas.microsoft.com/office/drawing/2016/SVG/main" r:embed="rId2"/>
+              </a:ext>
+            </a:extLst>
+          </a:blip>
+          <a:stretch>
+            <a:fillRect/>
+          </a:stretch>
+        </p:blipFill>
         <p:spPr>
           <a:xfrm>
             <a:off x="10180015" y="502920"/>
-            <a:ext cx="292608" cy="292608"/>
-          </a:xfrm>
-          <a:prstGeom prst="roundRect">
-            <a:avLst>
-              <a:gd name="adj" fmla="val 15625"/>
-            </a:avLst>
-          </a:prstGeom>
-          <a:ln w="19050">
-            <a:solidFill>
-              <a:srgbClr val="6366F1"/>
-            </a:solidFill>
-            <a:prstDash val="solid"/>
-          </a:ln>
-        </p:spPr>
-      </p:sp>
-      <p:sp>
-        <p:nvSpPr>
-          <p:cNvPr id="32" name="Text 30"/>
-          <p:cNvSpPr/>
-          <p:nvPr/>
-        </p:nvSpPr>
-        <p:spPr>
-          <a:xfrm>
-            <a:off x="10472623" y="457200"/>
-            <a:ext cx="411480" cy="384048"/>
-          </a:xfrm>
-          <a:prstGeom prst="rect">
-            <a:avLst/>
-          </a:prstGeom>
-          <a:noFill/>
-          <a:ln/>
-        </p:spPr>
-        <p:txBody>
-          <a:bodyPr wrap="square" rtlCol="0" anchor="ctr"/>
-          <a:lstStyle/>
-          <a:p>
-            <a:pPr algn="ctr" indent="0" marL="0">
-              <a:buNone/>
-            </a:pPr>
-            <a:r>
-              <a:rPr lang="en-US" sz="1800" b="1" dirty="0">
-                <a:solidFill>
-                  <a:srgbClr val="6366F1"/>
-                </a:solidFill>
-                <a:latin typeface="Calibri" pitchFamily="34" charset="0"/>
-                <a:ea typeface="Calibri" pitchFamily="34" charset="-122"/>
-                <a:cs typeface="Calibri" pitchFamily="34" charset="-120"/>
-              </a:rPr>
-              <a:t>↔</a:t>
-            </a:r>
-            <a:endParaRPr lang="en-US" sz="1800" dirty="0"/>
-          </a:p>
-        </p:txBody>
-      </p:sp>
-      <p:sp>
-        <p:nvSpPr>
-          <p:cNvPr id="33" name="Text 31"/>
-          <p:cNvSpPr/>
-          <p:nvPr/>
-        </p:nvSpPr>
-        <p:spPr>
-          <a:xfrm>
-            <a:off x="10893247" y="429768"/>
-            <a:ext cx="411480" cy="457200"/>
-          </a:xfrm>
-          <a:prstGeom prst="rect">
-            <a:avLst/>
-          </a:prstGeom>
-          <a:noFill/>
-          <a:ln/>
-        </p:spPr>
-        <p:txBody>
-          <a:bodyPr wrap="square" rtlCol="0" anchor="ctr"/>
-          <a:lstStyle/>
-          <a:p>
-            <a:pPr algn="ctr" indent="0" marL="0">
-              <a:buNone/>
-            </a:pPr>
-            <a:r>
-              <a:rPr lang="en-US" sz="2200" dirty="0">
-                <a:solidFill>
-                  <a:srgbClr val="6366F1"/>
-                </a:solidFill>
-                <a:latin typeface="Calibri" pitchFamily="34" charset="0"/>
-                <a:ea typeface="Calibri" pitchFamily="34" charset="-122"/>
-                <a:cs typeface="Calibri" pitchFamily="34" charset="-120"/>
-              </a:rPr>
-              <a:t>☁</a:t>
-            </a:r>
-            <a:endParaRPr lang="en-US" sz="2200" dirty="0"/>
-          </a:p>
-        </p:txBody>
-      </p:sp>
-      <p:sp>
-        <p:nvSpPr>
-          <p:cNvPr id="34" name="Text 32"/>
+            <a:ext cx="329184" cy="329184"/>
+          </a:xfrm>
+          <a:prstGeom prst="rect">
+            <a:avLst/>
+          </a:prstGeom>
+        </p:spPr>
+      </p:pic>
+      <p:pic>
+        <p:nvPicPr>
+          <p:cNvPr id="32" name="Image 1" descr="preencoded.png">    </p:cNvPr>
+          <p:cNvPicPr>
+            <a:picLocks noChangeAspect="1"/>
+          </p:cNvPicPr>
+          <p:nvPr/>
+        </p:nvPicPr>
+        <p:blipFill>
+          <a:blip r:embed="rId3">
+            <a:extLst>
+              <a:ext uri="{96DAC541-7B7A-43D3-8B79-37D633B846F1}">
+                <asvg:svgBlip xmlns:asvg="http://schemas.microsoft.com/office/drawing/2016/SVG/main" r:embed="rId4"/>
+              </a:ext>
+            </a:extLst>
+          </a:blip>
+          <a:stretch>
+            <a:fillRect/>
+          </a:stretch>
+        </p:blipFill>
+        <p:spPr>
+          <a:xfrm>
+            <a:off x="10564063" y="502920"/>
+            <a:ext cx="329184" cy="329184"/>
+          </a:xfrm>
+          <a:prstGeom prst="rect">
+            <a:avLst/>
+          </a:prstGeom>
+        </p:spPr>
+      </p:pic>
+      <p:pic>
+        <p:nvPicPr>
+          <p:cNvPr id="33" name="Image 2" descr="preencoded.png">    </p:cNvPr>
+          <p:cNvPicPr>
+            <a:picLocks noChangeAspect="1"/>
+          </p:cNvPicPr>
+          <p:nvPr/>
+        </p:nvPicPr>
+        <p:blipFill>
+          <a:blip r:embed="rId5">
+            <a:extLst>
+              <a:ext uri="{96DAC541-7B7A-43D3-8B79-37D633B846F1}">
+                <asvg:svgBlip xmlns:asvg="http://schemas.microsoft.com/office/drawing/2016/SVG/main" r:embed="rId6"/>
+              </a:ext>
+            </a:extLst>
+          </a:blip>
+          <a:stretch>
+            <a:fillRect/>
+          </a:stretch>
+        </p:blipFill>
+        <p:spPr>
+          <a:xfrm>
+            <a:off x="10948111" y="502920"/>
+            <a:ext cx="329184" cy="329184"/>
+          </a:xfrm>
+          <a:prstGeom prst="rect">
+            <a:avLst/>
+          </a:prstGeom>
+        </p:spPr>
+      </p:pic>
+      <p:sp>
+        <p:nvSpPr>
+          <p:cNvPr id="34" name="Text 29"/>
           <p:cNvSpPr/>
           <p:nvPr/>
         </p:nvSpPr>
@@ -19292,7 +19259,7 @@
       </p:sp>
       <p:sp>
         <p:nvSpPr>
-          <p:cNvPr id="35" name="Text 33"/>
+          <p:cNvPr id="35" name="Text 30"/>
           <p:cNvSpPr/>
           <p:nvPr/>
         </p:nvSpPr>
@@ -20323,7 +20290,7 @@
                 <a:ea typeface="Consolas" pitchFamily="34" charset="-122"/>
                 <a:cs typeface="Consolas" pitchFamily="34" charset="-120"/>
               </a:rPr>
-              <a:t>// ✈️  Works in airplane mode</a:t>
+              <a:t>// Works in airplane mode</a:t>
             </a:r>
             <a:pPr indent="0" marL="0">
               <a:buNone/>
@@ -20343,7 +20310,7 @@
                 <a:ea typeface="Consolas" pitchFamily="34" charset="-122"/>
                 <a:cs typeface="Consolas" pitchFamily="34" charset="-120"/>
               </a:rPr>
-              <a:t>// 🆓  No API key, no per-token cost</a:t>
+              <a:t>// No API key, no per-token cost</a:t>
             </a:r>
             <a:pPr indent="0" marL="0">
               <a:buNone/>
@@ -20363,7 +20330,7 @@
                 <a:ea typeface="Consolas" pitchFamily="34" charset="-122"/>
                 <a:cs typeface="Consolas" pitchFamily="34" charset="-120"/>
               </a:rPr>
-              <a:t>// 🔒  Data never leaves the device</a:t>
+              <a:t>// Data never leaves the device</a:t>
             </a:r>
             <a:endParaRPr lang="en-US" sz="1200" dirty="0"/>
           </a:p>
@@ -20408,16 +20375,46 @@
           </a:p>
         </p:txBody>
       </p:sp>
-      <p:sp>
-        <p:nvSpPr>
-          <p:cNvPr id="9" name="Text 7"/>
-          <p:cNvSpPr/>
-          <p:nvPr/>
-        </p:nvSpPr>
-        <p:spPr>
-          <a:xfrm>
-            <a:off x="8046720" y="3611880"/>
-            <a:ext cx="3657600" cy="274320"/>
+      <p:pic>
+        <p:nvPicPr>
+          <p:cNvPr id="9" name="Image 0" descr="preencoded.png">    </p:cNvPr>
+          <p:cNvPicPr>
+            <a:picLocks noChangeAspect="1"/>
+          </p:cNvPicPr>
+          <p:nvPr/>
+        </p:nvPicPr>
+        <p:blipFill>
+          <a:blip r:embed="rId1">
+            <a:extLst>
+              <a:ext uri="{96DAC541-7B7A-43D3-8B79-37D633B846F1}">
+                <asvg:svgBlip xmlns:asvg="http://schemas.microsoft.com/office/drawing/2016/SVG/main" r:embed="rId2"/>
+              </a:ext>
+            </a:extLst>
+          </a:blip>
+          <a:stretch>
+            <a:fillRect/>
+          </a:stretch>
+        </p:blipFill>
+        <p:spPr>
+          <a:xfrm>
+            <a:off x="8046720" y="3648456"/>
+            <a:ext cx="256032" cy="256032"/>
+          </a:xfrm>
+          <a:prstGeom prst="rect">
+            <a:avLst/>
+          </a:prstGeom>
+        </p:spPr>
+      </p:pic>
+      <p:sp>
+        <p:nvSpPr>
+          <p:cNvPr id="10" name="Text 7"/>
+          <p:cNvSpPr/>
+          <p:nvPr/>
+        </p:nvSpPr>
+        <p:spPr>
+          <a:xfrm>
+            <a:off x="8394192" y="3611880"/>
+            <a:ext cx="3291840" cy="274320"/>
           </a:xfrm>
           <a:prstGeom prst="rect">
             <a:avLst/>
@@ -20441,7 +20438,7 @@
                 <a:ea typeface="Calibri" pitchFamily="34" charset="-122"/>
                 <a:cs typeface="Calibri" pitchFamily="34" charset="-120"/>
               </a:rPr>
-              <a:t>⚡ Instant first token</a:t>
+              <a:t>Instant first token</a:t>
             </a:r>
             <a:endParaRPr lang="en-US" sz="1400" dirty="0"/>
           </a:p>
@@ -20449,14 +20446,14 @@
       </p:sp>
       <p:sp>
         <p:nvSpPr>
-          <p:cNvPr id="10" name="Text 8"/>
-          <p:cNvSpPr/>
-          <p:nvPr/>
-        </p:nvSpPr>
-        <p:spPr>
-          <a:xfrm>
-            <a:off x="8046720" y="3886200"/>
-            <a:ext cx="3657600" cy="274320"/>
+          <p:cNvPr id="11" name="Text 8"/>
+          <p:cNvSpPr/>
+          <p:nvPr/>
+        </p:nvSpPr>
+        <p:spPr>
+          <a:xfrm>
+            <a:off x="8394192" y="3886200"/>
+            <a:ext cx="3291840" cy="274320"/>
           </a:xfrm>
           <a:prstGeom prst="rect">
             <a:avLst/>
@@ -20486,16 +20483,46 @@
           </a:p>
         </p:txBody>
       </p:sp>
-      <p:sp>
-        <p:nvSpPr>
-          <p:cNvPr id="11" name="Text 9"/>
-          <p:cNvSpPr/>
-          <p:nvPr/>
-        </p:nvSpPr>
-        <p:spPr>
-          <a:xfrm>
-            <a:off x="8046720" y="4251960"/>
-            <a:ext cx="3657600" cy="274320"/>
+      <p:pic>
+        <p:nvPicPr>
+          <p:cNvPr id="12" name="Image 1" descr="preencoded.png">    </p:cNvPr>
+          <p:cNvPicPr>
+            <a:picLocks noChangeAspect="1"/>
+          </p:cNvPicPr>
+          <p:nvPr/>
+        </p:nvPicPr>
+        <p:blipFill>
+          <a:blip r:embed="rId3">
+            <a:extLst>
+              <a:ext uri="{96DAC541-7B7A-43D3-8B79-37D633B846F1}">
+                <asvg:svgBlip xmlns:asvg="http://schemas.microsoft.com/office/drawing/2016/SVG/main" r:embed="rId4"/>
+              </a:ext>
+            </a:extLst>
+          </a:blip>
+          <a:stretch>
+            <a:fillRect/>
+          </a:stretch>
+        </p:blipFill>
+        <p:spPr>
+          <a:xfrm>
+            <a:off x="8046720" y="4288536"/>
+            <a:ext cx="256032" cy="256032"/>
+          </a:xfrm>
+          <a:prstGeom prst="rect">
+            <a:avLst/>
+          </a:prstGeom>
+        </p:spPr>
+      </p:pic>
+      <p:sp>
+        <p:nvSpPr>
+          <p:cNvPr id="13" name="Text 9"/>
+          <p:cNvSpPr/>
+          <p:nvPr/>
+        </p:nvSpPr>
+        <p:spPr>
+          <a:xfrm>
+            <a:off x="8394192" y="4251960"/>
+            <a:ext cx="3291840" cy="274320"/>
           </a:xfrm>
           <a:prstGeom prst="rect">
             <a:avLst/>
@@ -20519,7 +20546,7 @@
                 <a:ea typeface="Calibri" pitchFamily="34" charset="-122"/>
                 <a:cs typeface="Calibri" pitchFamily="34" charset="-120"/>
               </a:rPr>
-              <a:t>🔒 Airplane mode</a:t>
+              <a:t>Airplane mode</a:t>
             </a:r>
             <a:endParaRPr lang="en-US" sz="1400" dirty="0"/>
           </a:p>
@@ -20527,14 +20554,14 @@
       </p:sp>
       <p:sp>
         <p:nvSpPr>
-          <p:cNvPr id="12" name="Text 10"/>
-          <p:cNvSpPr/>
-          <p:nvPr/>
-        </p:nvSpPr>
-        <p:spPr>
-          <a:xfrm>
-            <a:off x="8046720" y="4526280"/>
-            <a:ext cx="3657600" cy="274320"/>
+          <p:cNvPr id="14" name="Text 10"/>
+          <p:cNvSpPr/>
+          <p:nvPr/>
+        </p:nvSpPr>
+        <p:spPr>
+          <a:xfrm>
+            <a:off x="8394192" y="4526280"/>
+            <a:ext cx="3291840" cy="274320"/>
           </a:xfrm>
           <a:prstGeom prst="rect">
             <a:avLst/>
@@ -20564,16 +20591,46 @@
           </a:p>
         </p:txBody>
       </p:sp>
-      <p:sp>
-        <p:nvSpPr>
-          <p:cNvPr id="13" name="Text 11"/>
-          <p:cNvSpPr/>
-          <p:nvPr/>
-        </p:nvSpPr>
-        <p:spPr>
-          <a:xfrm>
-            <a:off x="8046720" y="4892040"/>
-            <a:ext cx="3657600" cy="274320"/>
+      <p:pic>
+        <p:nvPicPr>
+          <p:cNvPr id="15" name="Image 2" descr="preencoded.png">    </p:cNvPr>
+          <p:cNvPicPr>
+            <a:picLocks noChangeAspect="1"/>
+          </p:cNvPicPr>
+          <p:nvPr/>
+        </p:nvPicPr>
+        <p:blipFill>
+          <a:blip r:embed="rId5">
+            <a:extLst>
+              <a:ext uri="{96DAC541-7B7A-43D3-8B79-37D633B846F1}">
+                <asvg:svgBlip xmlns:asvg="http://schemas.microsoft.com/office/drawing/2016/SVG/main" r:embed="rId6"/>
+              </a:ext>
+            </a:extLst>
+          </a:blip>
+          <a:stretch>
+            <a:fillRect/>
+          </a:stretch>
+        </p:blipFill>
+        <p:spPr>
+          <a:xfrm>
+            <a:off x="8046720" y="4928616"/>
+            <a:ext cx="256032" cy="256032"/>
+          </a:xfrm>
+          <a:prstGeom prst="rect">
+            <a:avLst/>
+          </a:prstGeom>
+        </p:spPr>
+      </p:pic>
+      <p:sp>
+        <p:nvSpPr>
+          <p:cNvPr id="16" name="Text 11"/>
+          <p:cNvSpPr/>
+          <p:nvPr/>
+        </p:nvSpPr>
+        <p:spPr>
+          <a:xfrm>
+            <a:off x="8394192" y="4892040"/>
+            <a:ext cx="3291840" cy="274320"/>
           </a:xfrm>
           <a:prstGeom prst="rect">
             <a:avLst/>
@@ -20597,7 +20654,7 @@
                 <a:ea typeface="Calibri" pitchFamily="34" charset="-122"/>
                 <a:cs typeface="Calibri" pitchFamily="34" charset="-120"/>
               </a:rPr>
-              <a:t>📏 Tiny but capable</a:t>
+              <a:t>Tiny but capable</a:t>
             </a:r>
             <a:endParaRPr lang="en-US" sz="1400" dirty="0"/>
           </a:p>
@@ -20605,14 +20662,14 @@
       </p:sp>
       <p:sp>
         <p:nvSpPr>
-          <p:cNvPr id="14" name="Text 12"/>
-          <p:cNvSpPr/>
-          <p:nvPr/>
-        </p:nvSpPr>
-        <p:spPr>
-          <a:xfrm>
-            <a:off x="8046720" y="5166360"/>
-            <a:ext cx="3657600" cy="274320"/>
+          <p:cNvPr id="17" name="Text 12"/>
+          <p:cNvSpPr/>
+          <p:nvPr/>
+        </p:nvSpPr>
+        <p:spPr>
+          <a:xfrm>
+            <a:off x="8394192" y="5166360"/>
+            <a:ext cx="3291840" cy="274320"/>
           </a:xfrm>
           <a:prstGeom prst="rect">
             <a:avLst/>
@@ -20642,16 +20699,46 @@
           </a:p>
         </p:txBody>
       </p:sp>
-      <p:sp>
-        <p:nvSpPr>
-          <p:cNvPr id="15" name="Text 13"/>
-          <p:cNvSpPr/>
-          <p:nvPr/>
-        </p:nvSpPr>
-        <p:spPr>
-          <a:xfrm>
-            <a:off x="8046720" y="5532120"/>
-            <a:ext cx="3657600" cy="274320"/>
+      <p:pic>
+        <p:nvPicPr>
+          <p:cNvPr id="18" name="Image 3" descr="preencoded.png">    </p:cNvPr>
+          <p:cNvPicPr>
+            <a:picLocks noChangeAspect="1"/>
+          </p:cNvPicPr>
+          <p:nvPr/>
+        </p:nvPicPr>
+        <p:blipFill>
+          <a:blip r:embed="rId7">
+            <a:extLst>
+              <a:ext uri="{96DAC541-7B7A-43D3-8B79-37D633B846F1}">
+                <asvg:svgBlip xmlns:asvg="http://schemas.microsoft.com/office/drawing/2016/SVG/main" r:embed="rId8"/>
+              </a:ext>
+            </a:extLst>
+          </a:blip>
+          <a:stretch>
+            <a:fillRect/>
+          </a:stretch>
+        </p:blipFill>
+        <p:spPr>
+          <a:xfrm>
+            <a:off x="8046720" y="5568696"/>
+            <a:ext cx="256032" cy="256032"/>
+          </a:xfrm>
+          <a:prstGeom prst="rect">
+            <a:avLst/>
+          </a:prstGeom>
+        </p:spPr>
+      </p:pic>
+      <p:sp>
+        <p:nvSpPr>
+          <p:cNvPr id="19" name="Text 13"/>
+          <p:cNvSpPr/>
+          <p:nvPr/>
+        </p:nvSpPr>
+        <p:spPr>
+          <a:xfrm>
+            <a:off x="8394192" y="5532120"/>
+            <a:ext cx="3291840" cy="274320"/>
           </a:xfrm>
           <a:prstGeom prst="rect">
             <a:avLst/>
@@ -20675,7 +20762,7 @@
                 <a:ea typeface="Calibri" pitchFamily="34" charset="-122"/>
                 <a:cs typeface="Calibri" pitchFamily="34" charset="-120"/>
               </a:rPr>
-              <a:t>⚠ The limit</a:t>
+              <a:t>The limit</a:t>
             </a:r>
             <a:endParaRPr lang="en-US" sz="1400" dirty="0"/>
           </a:p>
@@ -20683,14 +20770,14 @@
       </p:sp>
       <p:sp>
         <p:nvSpPr>
-          <p:cNvPr id="16" name="Text 14"/>
-          <p:cNvSpPr/>
-          <p:nvPr/>
-        </p:nvSpPr>
-        <p:spPr>
-          <a:xfrm>
-            <a:off x="8046720" y="5806440"/>
-            <a:ext cx="3657600" cy="274320"/>
+          <p:cNvPr id="20" name="Text 14"/>
+          <p:cNvSpPr/>
+          <p:nvPr/>
+        </p:nvSpPr>
+        <p:spPr>
+          <a:xfrm>
+            <a:off x="8394192" y="5806440"/>
+            <a:ext cx="3291840" cy="274320"/>
           </a:xfrm>
           <a:prstGeom prst="rect">
             <a:avLst/>
@@ -20720,108 +20807,96 @@
           </a:p>
         </p:txBody>
       </p:sp>
-      <p:sp>
-        <p:nvSpPr>
-          <p:cNvPr id="17" name="Shape 15"/>
-          <p:cNvSpPr/>
-          <p:nvPr/>
-        </p:nvSpPr>
+      <p:pic>
+        <p:nvPicPr>
+          <p:cNvPr id="21" name="Image 4" descr="preencoded.png">    </p:cNvPr>
+          <p:cNvPicPr>
+            <a:picLocks noChangeAspect="1"/>
+          </p:cNvPicPr>
+          <p:nvPr/>
+        </p:nvPicPr>
+        <p:blipFill>
+          <a:blip r:embed="rId9">
+            <a:extLst>
+              <a:ext uri="{96DAC541-7B7A-43D3-8B79-37D633B846F1}">
+                <asvg:svgBlip xmlns:asvg="http://schemas.microsoft.com/office/drawing/2016/SVG/main" r:embed="rId10"/>
+              </a:ext>
+            </a:extLst>
+          </a:blip>
+          <a:stretch>
+            <a:fillRect/>
+          </a:stretch>
+        </p:blipFill>
         <p:spPr>
           <a:xfrm>
             <a:off x="10180015" y="502920"/>
-            <a:ext cx="292608" cy="292608"/>
-          </a:xfrm>
-          <a:prstGeom prst="roundRect">
-            <a:avLst>
-              <a:gd name="adj" fmla="val 15625"/>
-            </a:avLst>
-          </a:prstGeom>
-          <a:ln w="19050">
-            <a:solidFill>
-              <a:srgbClr val="FB7185"/>
-            </a:solidFill>
-            <a:prstDash val="solid"/>
-          </a:ln>
-        </p:spPr>
-      </p:sp>
-      <p:sp>
-        <p:nvSpPr>
-          <p:cNvPr id="18" name="Text 16"/>
-          <p:cNvSpPr/>
-          <p:nvPr/>
-        </p:nvSpPr>
-        <p:spPr>
-          <a:xfrm>
-            <a:off x="10472623" y="457200"/>
-            <a:ext cx="411480" cy="384048"/>
-          </a:xfrm>
-          <a:prstGeom prst="rect">
-            <a:avLst/>
-          </a:prstGeom>
-          <a:noFill/>
-          <a:ln/>
-        </p:spPr>
-        <p:txBody>
-          <a:bodyPr wrap="square" rtlCol="0" anchor="ctr"/>
-          <a:lstStyle/>
-          <a:p>
-            <a:pPr algn="ctr" indent="0" marL="0">
-              <a:buNone/>
-            </a:pPr>
-            <a:r>
-              <a:rPr lang="en-US" sz="1800" b="1" dirty="0">
-                <a:solidFill>
-                  <a:srgbClr val="FB7185"/>
-                </a:solidFill>
-                <a:latin typeface="Calibri" pitchFamily="34" charset="0"/>
-                <a:ea typeface="Calibri" pitchFamily="34" charset="-122"/>
-                <a:cs typeface="Calibri" pitchFamily="34" charset="-120"/>
-              </a:rPr>
-              <a:t>↔</a:t>
-            </a:r>
-            <a:endParaRPr lang="en-US" sz="1800" dirty="0"/>
-          </a:p>
-        </p:txBody>
-      </p:sp>
-      <p:sp>
-        <p:nvSpPr>
-          <p:cNvPr id="19" name="Text 17"/>
-          <p:cNvSpPr/>
-          <p:nvPr/>
-        </p:nvSpPr>
-        <p:spPr>
-          <a:xfrm>
-            <a:off x="10893247" y="429768"/>
-            <a:ext cx="411480" cy="457200"/>
-          </a:xfrm>
-          <a:prstGeom prst="rect">
-            <a:avLst/>
-          </a:prstGeom>
-          <a:noFill/>
-          <a:ln/>
-        </p:spPr>
-        <p:txBody>
-          <a:bodyPr wrap="square" rtlCol="0" anchor="ctr"/>
-          <a:lstStyle/>
-          <a:p>
-            <a:pPr algn="ctr" indent="0" marL="0">
-              <a:buNone/>
-            </a:pPr>
-            <a:r>
-              <a:rPr lang="en-US" sz="2200" dirty="0">
-                <a:solidFill>
-                  <a:srgbClr val="FB7185"/>
-                </a:solidFill>
-                <a:latin typeface="Calibri" pitchFamily="34" charset="0"/>
-                <a:ea typeface="Calibri" pitchFamily="34" charset="-122"/>
-                <a:cs typeface="Calibri" pitchFamily="34" charset="-120"/>
-              </a:rPr>
-              <a:t>☁</a:t>
-            </a:r>
-            <a:endParaRPr lang="en-US" sz="2200" dirty="0"/>
-          </a:p>
-        </p:txBody>
-      </p:sp>
+            <a:ext cx="329184" cy="329184"/>
+          </a:xfrm>
+          <a:prstGeom prst="rect">
+            <a:avLst/>
+          </a:prstGeom>
+        </p:spPr>
+      </p:pic>
+      <p:pic>
+        <p:nvPicPr>
+          <p:cNvPr id="22" name="Image 5" descr="preencoded.png">    </p:cNvPr>
+          <p:cNvPicPr>
+            <a:picLocks noChangeAspect="1"/>
+          </p:cNvPicPr>
+          <p:nvPr/>
+        </p:nvPicPr>
+        <p:blipFill>
+          <a:blip r:embed="rId11">
+            <a:extLst>
+              <a:ext uri="{96DAC541-7B7A-43D3-8B79-37D633B846F1}">
+                <asvg:svgBlip xmlns:asvg="http://schemas.microsoft.com/office/drawing/2016/SVG/main" r:embed="rId12"/>
+              </a:ext>
+            </a:extLst>
+          </a:blip>
+          <a:stretch>
+            <a:fillRect/>
+          </a:stretch>
+        </p:blipFill>
+        <p:spPr>
+          <a:xfrm>
+            <a:off x="10564063" y="502920"/>
+            <a:ext cx="329184" cy="329184"/>
+          </a:xfrm>
+          <a:prstGeom prst="rect">
+            <a:avLst/>
+          </a:prstGeom>
+        </p:spPr>
+      </p:pic>
+      <p:pic>
+        <p:nvPicPr>
+          <p:cNvPr id="23" name="Image 6" descr="preencoded.png">    </p:cNvPr>
+          <p:cNvPicPr>
+            <a:picLocks noChangeAspect="1"/>
+          </p:cNvPicPr>
+          <p:nvPr/>
+        </p:nvPicPr>
+        <p:blipFill>
+          <a:blip r:embed="rId13">
+            <a:extLst>
+              <a:ext uri="{96DAC541-7B7A-43D3-8B79-37D633B846F1}">
+                <asvg:svgBlip xmlns:asvg="http://schemas.microsoft.com/office/drawing/2016/SVG/main" r:embed="rId14"/>
+              </a:ext>
+            </a:extLst>
+          </a:blip>
+          <a:stretch>
+            <a:fillRect/>
+          </a:stretch>
+        </p:blipFill>
+        <p:spPr>
+          <a:xfrm>
+            <a:off x="10948111" y="502920"/>
+            <a:ext cx="329184" cy="329184"/>
+          </a:xfrm>
+          <a:prstGeom prst="rect">
+            <a:avLst/>
+          </a:prstGeom>
+        </p:spPr>
+      </p:pic>
     </p:spTree>
   </p:cSld>
   <p:clrMapOvr>
@@ -21601,111 +21676,99 @@
           </a:p>
         </p:txBody>
       </p:sp>
-      <p:sp>
-        <p:nvSpPr>
-          <p:cNvPr id="23" name="Shape 21"/>
-          <p:cNvSpPr/>
-          <p:nvPr/>
-        </p:nvSpPr>
+      <p:pic>
+        <p:nvPicPr>
+          <p:cNvPr id="23" name="Image 0" descr="preencoded.png">    </p:cNvPr>
+          <p:cNvPicPr>
+            <a:picLocks noChangeAspect="1"/>
+          </p:cNvPicPr>
+          <p:nvPr/>
+        </p:nvPicPr>
+        <p:blipFill>
+          <a:blip r:embed="rId1">
+            <a:extLst>
+              <a:ext uri="{96DAC541-7B7A-43D3-8B79-37D633B846F1}">
+                <asvg:svgBlip xmlns:asvg="http://schemas.microsoft.com/office/drawing/2016/SVG/main" r:embed="rId2"/>
+              </a:ext>
+            </a:extLst>
+          </a:blip>
+          <a:stretch>
+            <a:fillRect/>
+          </a:stretch>
+        </p:blipFill>
         <p:spPr>
           <a:xfrm>
             <a:off x="10180015" y="502920"/>
-            <a:ext cx="292608" cy="292608"/>
-          </a:xfrm>
-          <a:prstGeom prst="roundRect">
-            <a:avLst>
-              <a:gd name="adj" fmla="val 15625"/>
-            </a:avLst>
-          </a:prstGeom>
-          <a:ln w="19050">
-            <a:solidFill>
-              <a:srgbClr val="6366F1"/>
-            </a:solidFill>
-            <a:prstDash val="solid"/>
-          </a:ln>
-        </p:spPr>
-      </p:sp>
-      <p:sp>
-        <p:nvSpPr>
-          <p:cNvPr id="24" name="Text 22"/>
-          <p:cNvSpPr/>
-          <p:nvPr/>
-        </p:nvSpPr>
-        <p:spPr>
-          <a:xfrm>
-            <a:off x="10472623" y="457200"/>
-            <a:ext cx="411480" cy="384048"/>
-          </a:xfrm>
-          <a:prstGeom prst="rect">
-            <a:avLst/>
-          </a:prstGeom>
-          <a:noFill/>
-          <a:ln/>
-        </p:spPr>
-        <p:txBody>
-          <a:bodyPr wrap="square" rtlCol="0" anchor="ctr"/>
-          <a:lstStyle/>
-          <a:p>
-            <a:pPr algn="ctr" indent="0" marL="0">
-              <a:buNone/>
-            </a:pPr>
-            <a:r>
-              <a:rPr lang="en-US" sz="1800" b="1" dirty="0">
-                <a:solidFill>
-                  <a:srgbClr val="6366F1"/>
-                </a:solidFill>
-                <a:latin typeface="Calibri" pitchFamily="34" charset="0"/>
-                <a:ea typeface="Calibri" pitchFamily="34" charset="-122"/>
-                <a:cs typeface="Calibri" pitchFamily="34" charset="-120"/>
-              </a:rPr>
-              <a:t>↔</a:t>
-            </a:r>
-            <a:endParaRPr lang="en-US" sz="1800" dirty="0"/>
-          </a:p>
-        </p:txBody>
-      </p:sp>
-      <p:sp>
-        <p:nvSpPr>
-          <p:cNvPr id="25" name="Text 23"/>
-          <p:cNvSpPr/>
-          <p:nvPr/>
-        </p:nvSpPr>
-        <p:spPr>
-          <a:xfrm>
-            <a:off x="10893247" y="429768"/>
-            <a:ext cx="411480" cy="457200"/>
-          </a:xfrm>
-          <a:prstGeom prst="rect">
-            <a:avLst/>
-          </a:prstGeom>
-          <a:noFill/>
-          <a:ln/>
-        </p:spPr>
-        <p:txBody>
-          <a:bodyPr wrap="square" rtlCol="0" anchor="ctr"/>
-          <a:lstStyle/>
-          <a:p>
-            <a:pPr algn="ctr" indent="0" marL="0">
-              <a:buNone/>
-            </a:pPr>
-            <a:r>
-              <a:rPr lang="en-US" sz="2200" dirty="0">
-                <a:solidFill>
-                  <a:srgbClr val="6366F1"/>
-                </a:solidFill>
-                <a:latin typeface="Calibri" pitchFamily="34" charset="0"/>
-                <a:ea typeface="Calibri" pitchFamily="34" charset="-122"/>
-                <a:cs typeface="Calibri" pitchFamily="34" charset="-120"/>
-              </a:rPr>
-              <a:t>☁</a:t>
-            </a:r>
-            <a:endParaRPr lang="en-US" sz="2200" dirty="0"/>
-          </a:p>
-        </p:txBody>
-      </p:sp>
-      <p:sp>
-        <p:nvSpPr>
-          <p:cNvPr id="26" name="Text 24"/>
+            <a:ext cx="329184" cy="329184"/>
+          </a:xfrm>
+          <a:prstGeom prst="rect">
+            <a:avLst/>
+          </a:prstGeom>
+        </p:spPr>
+      </p:pic>
+      <p:pic>
+        <p:nvPicPr>
+          <p:cNvPr id="24" name="Image 1" descr="preencoded.png">    </p:cNvPr>
+          <p:cNvPicPr>
+            <a:picLocks noChangeAspect="1"/>
+          </p:cNvPicPr>
+          <p:nvPr/>
+        </p:nvPicPr>
+        <p:blipFill>
+          <a:blip r:embed="rId3">
+            <a:extLst>
+              <a:ext uri="{96DAC541-7B7A-43D3-8B79-37D633B846F1}">
+                <asvg:svgBlip xmlns:asvg="http://schemas.microsoft.com/office/drawing/2016/SVG/main" r:embed="rId4"/>
+              </a:ext>
+            </a:extLst>
+          </a:blip>
+          <a:stretch>
+            <a:fillRect/>
+          </a:stretch>
+        </p:blipFill>
+        <p:spPr>
+          <a:xfrm>
+            <a:off x="10564063" y="502920"/>
+            <a:ext cx="329184" cy="329184"/>
+          </a:xfrm>
+          <a:prstGeom prst="rect">
+            <a:avLst/>
+          </a:prstGeom>
+        </p:spPr>
+      </p:pic>
+      <p:pic>
+        <p:nvPicPr>
+          <p:cNvPr id="25" name="Image 2" descr="preencoded.png">    </p:cNvPr>
+          <p:cNvPicPr>
+            <a:picLocks noChangeAspect="1"/>
+          </p:cNvPicPr>
+          <p:nvPr/>
+        </p:nvPicPr>
+        <p:blipFill>
+          <a:blip r:embed="rId5">
+            <a:extLst>
+              <a:ext uri="{96DAC541-7B7A-43D3-8B79-37D633B846F1}">
+                <asvg:svgBlip xmlns:asvg="http://schemas.microsoft.com/office/drawing/2016/SVG/main" r:embed="rId6"/>
+              </a:ext>
+            </a:extLst>
+          </a:blip>
+          <a:stretch>
+            <a:fillRect/>
+          </a:stretch>
+        </p:blipFill>
+        <p:spPr>
+          <a:xfrm>
+            <a:off x="10948111" y="502920"/>
+            <a:ext cx="329184" cy="329184"/>
+          </a:xfrm>
+          <a:prstGeom prst="rect">
+            <a:avLst/>
+          </a:prstGeom>
+        </p:spPr>
+      </p:pic>
+      <p:sp>
+        <p:nvSpPr>
+          <p:cNvPr id="26" name="Text 21"/>
           <p:cNvSpPr/>
           <p:nvPr/>
         </p:nvSpPr>
@@ -21786,7 +21849,7 @@
       </p:sp>
       <p:sp>
         <p:nvSpPr>
-          <p:cNvPr id="27" name="Text 25"/>
+          <p:cNvPr id="27" name="Text 22"/>
           <p:cNvSpPr/>
           <p:nvPr/>
         </p:nvSpPr>
@@ -22980,16 +23043,46 @@
           </a:p>
         </p:txBody>
       </p:sp>
-      <p:sp>
-        <p:nvSpPr>
-          <p:cNvPr id="9" name="Text 7"/>
-          <p:cNvSpPr/>
-          <p:nvPr/>
-        </p:nvSpPr>
-        <p:spPr>
-          <a:xfrm>
-            <a:off x="8046720" y="3611880"/>
-            <a:ext cx="3657600" cy="274320"/>
+      <p:pic>
+        <p:nvPicPr>
+          <p:cNvPr id="9" name="Image 0" descr="preencoded.png">    </p:cNvPr>
+          <p:cNvPicPr>
+            <a:picLocks noChangeAspect="1"/>
+          </p:cNvPicPr>
+          <p:nvPr/>
+        </p:nvPicPr>
+        <p:blipFill>
+          <a:blip r:embed="rId1">
+            <a:extLst>
+              <a:ext uri="{96DAC541-7B7A-43D3-8B79-37D633B846F1}">
+                <asvg:svgBlip xmlns:asvg="http://schemas.microsoft.com/office/drawing/2016/SVG/main" r:embed="rId2"/>
+              </a:ext>
+            </a:extLst>
+          </a:blip>
+          <a:stretch>
+            <a:fillRect/>
+          </a:stretch>
+        </p:blipFill>
+        <p:spPr>
+          <a:xfrm>
+            <a:off x="8046720" y="3648456"/>
+            <a:ext cx="256032" cy="256032"/>
+          </a:xfrm>
+          <a:prstGeom prst="rect">
+            <a:avLst/>
+          </a:prstGeom>
+        </p:spPr>
+      </p:pic>
+      <p:sp>
+        <p:nvSpPr>
+          <p:cNvPr id="10" name="Text 7"/>
+          <p:cNvSpPr/>
+          <p:nvPr/>
+        </p:nvSpPr>
+        <p:spPr>
+          <a:xfrm>
+            <a:off x="8394192" y="3611880"/>
+            <a:ext cx="3291840" cy="274320"/>
           </a:xfrm>
           <a:prstGeom prst="rect">
             <a:avLst/>
@@ -23013,7 +23106,7 @@
                 <a:ea typeface="Calibri" pitchFamily="34" charset="-122"/>
                 <a:cs typeface="Calibri" pitchFamily="34" charset="-120"/>
               </a:rPr>
-              <a:t>🧠 Real reasoning</a:t>
+              <a:t>Real reasoning</a:t>
             </a:r>
             <a:endParaRPr lang="en-US" sz="1400" dirty="0"/>
           </a:p>
@@ -23021,14 +23114,14 @@
       </p:sp>
       <p:sp>
         <p:nvSpPr>
-          <p:cNvPr id="10" name="Text 8"/>
-          <p:cNvSpPr/>
-          <p:nvPr/>
-        </p:nvSpPr>
-        <p:spPr>
-          <a:xfrm>
-            <a:off x="8046720" y="3886200"/>
-            <a:ext cx="3657600" cy="274320"/>
+          <p:cNvPr id="11" name="Text 8"/>
+          <p:cNvSpPr/>
+          <p:nvPr/>
+        </p:nvSpPr>
+        <p:spPr>
+          <a:xfrm>
+            <a:off x="8394192" y="3886200"/>
+            <a:ext cx="3291840" cy="274320"/>
           </a:xfrm>
           <a:prstGeom prst="rect">
             <a:avLst/>
@@ -23058,16 +23151,46 @@
           </a:p>
         </p:txBody>
       </p:sp>
-      <p:sp>
-        <p:nvSpPr>
-          <p:cNvPr id="11" name="Text 9"/>
-          <p:cNvSpPr/>
-          <p:nvPr/>
-        </p:nvSpPr>
-        <p:spPr>
-          <a:xfrm>
-            <a:off x="8046720" y="4251960"/>
-            <a:ext cx="3657600" cy="274320"/>
+      <p:pic>
+        <p:nvPicPr>
+          <p:cNvPr id="12" name="Image 1" descr="preencoded.png">    </p:cNvPr>
+          <p:cNvPicPr>
+            <a:picLocks noChangeAspect="1"/>
+          </p:cNvPicPr>
+          <p:nvPr/>
+        </p:nvPicPr>
+        <p:blipFill>
+          <a:blip r:embed="rId3">
+            <a:extLst>
+              <a:ext uri="{96DAC541-7B7A-43D3-8B79-37D633B846F1}">
+                <asvg:svgBlip xmlns:asvg="http://schemas.microsoft.com/office/drawing/2016/SVG/main" r:embed="rId4"/>
+              </a:ext>
+            </a:extLst>
+          </a:blip>
+          <a:stretch>
+            <a:fillRect/>
+          </a:stretch>
+        </p:blipFill>
+        <p:spPr>
+          <a:xfrm>
+            <a:off x="8046720" y="4288536"/>
+            <a:ext cx="256032" cy="256032"/>
+          </a:xfrm>
+          <a:prstGeom prst="rect">
+            <a:avLst/>
+          </a:prstGeom>
+        </p:spPr>
+      </p:pic>
+      <p:sp>
+        <p:nvSpPr>
+          <p:cNvPr id="13" name="Text 9"/>
+          <p:cNvSpPr/>
+          <p:nvPr/>
+        </p:nvSpPr>
+        <p:spPr>
+          <a:xfrm>
+            <a:off x="8394192" y="4251960"/>
+            <a:ext cx="3291840" cy="274320"/>
           </a:xfrm>
           <a:prstGeom prst="rect">
             <a:avLst/>
@@ -23091,7 +23214,7 @@
                 <a:ea typeface="Calibri" pitchFamily="34" charset="-122"/>
                 <a:cs typeface="Calibri" pitchFamily="34" charset="-120"/>
               </a:rPr>
-              <a:t>🔒 Stays on device</a:t>
+              <a:t>Stays on device</a:t>
             </a:r>
             <a:endParaRPr lang="en-US" sz="1400" dirty="0"/>
           </a:p>
@@ -23099,14 +23222,14 @@
       </p:sp>
       <p:sp>
         <p:nvSpPr>
-          <p:cNvPr id="12" name="Text 10"/>
-          <p:cNvSpPr/>
-          <p:nvPr/>
-        </p:nvSpPr>
-        <p:spPr>
-          <a:xfrm>
-            <a:off x="8046720" y="4526280"/>
-            <a:ext cx="3657600" cy="274320"/>
+          <p:cNvPr id="14" name="Text 10"/>
+          <p:cNvSpPr/>
+          <p:nvPr/>
+        </p:nvSpPr>
+        <p:spPr>
+          <a:xfrm>
+            <a:off x="8394192" y="4526280"/>
+            <a:ext cx="3291840" cy="274320"/>
           </a:xfrm>
           <a:prstGeom prst="rect">
             <a:avLst/>
@@ -23136,16 +23259,46 @@
           </a:p>
         </p:txBody>
       </p:sp>
-      <p:sp>
-        <p:nvSpPr>
-          <p:cNvPr id="13" name="Text 11"/>
-          <p:cNvSpPr/>
-          <p:nvPr/>
-        </p:nvSpPr>
-        <p:spPr>
-          <a:xfrm>
-            <a:off x="8046720" y="4892040"/>
-            <a:ext cx="3657600" cy="274320"/>
+      <p:pic>
+        <p:nvPicPr>
+          <p:cNvPr id="15" name="Image 2" descr="preencoded.png">    </p:cNvPr>
+          <p:cNvPicPr>
+            <a:picLocks noChangeAspect="1"/>
+          </p:cNvPicPr>
+          <p:nvPr/>
+        </p:nvPicPr>
+        <p:blipFill>
+          <a:blip r:embed="rId5">
+            <a:extLst>
+              <a:ext uri="{96DAC541-7B7A-43D3-8B79-37D633B846F1}">
+                <asvg:svgBlip xmlns:asvg="http://schemas.microsoft.com/office/drawing/2016/SVG/main" r:embed="rId6"/>
+              </a:ext>
+            </a:extLst>
+          </a:blip>
+          <a:stretch>
+            <a:fillRect/>
+          </a:stretch>
+        </p:blipFill>
+        <p:spPr>
+          <a:xfrm>
+            <a:off x="8046720" y="4928616"/>
+            <a:ext cx="256032" cy="256032"/>
+          </a:xfrm>
+          <a:prstGeom prst="rect">
+            <a:avLst/>
+          </a:prstGeom>
+        </p:spPr>
+      </p:pic>
+      <p:sp>
+        <p:nvSpPr>
+          <p:cNvPr id="16" name="Text 11"/>
+          <p:cNvSpPr/>
+          <p:nvPr/>
+        </p:nvSpPr>
+        <p:spPr>
+          <a:xfrm>
+            <a:off x="8394192" y="4892040"/>
+            <a:ext cx="3291840" cy="274320"/>
           </a:xfrm>
           <a:prstGeom prst="rect">
             <a:avLst/>
@@ -23169,7 +23322,7 @@
                 <a:ea typeface="Calibri" pitchFamily="34" charset="-122"/>
                 <a:cs typeface="Calibri" pitchFamily="34" charset="-120"/>
               </a:rPr>
-              <a:t>🔌 OpenAI-compatible</a:t>
+              <a:t>OpenAI-compatible</a:t>
             </a:r>
             <a:endParaRPr lang="en-US" sz="1400" dirty="0"/>
           </a:p>
@@ -23177,14 +23330,14 @@
       </p:sp>
       <p:sp>
         <p:nvSpPr>
-          <p:cNvPr id="14" name="Text 12"/>
-          <p:cNvSpPr/>
-          <p:nvPr/>
-        </p:nvSpPr>
-        <p:spPr>
-          <a:xfrm>
-            <a:off x="8046720" y="5166360"/>
-            <a:ext cx="3657600" cy="274320"/>
+          <p:cNvPr id="17" name="Text 12"/>
+          <p:cNvSpPr/>
+          <p:nvPr/>
+        </p:nvSpPr>
+        <p:spPr>
+          <a:xfrm>
+            <a:off x="8394192" y="5166360"/>
+            <a:ext cx="3291840" cy="274320"/>
           </a:xfrm>
           <a:prstGeom prst="rect">
             <a:avLst/>
@@ -23214,16 +23367,46 @@
           </a:p>
         </p:txBody>
       </p:sp>
-      <p:sp>
-        <p:nvSpPr>
-          <p:cNvPr id="15" name="Text 13"/>
-          <p:cNvSpPr/>
-          <p:nvPr/>
-        </p:nvSpPr>
-        <p:spPr>
-          <a:xfrm>
-            <a:off x="8046720" y="5532120"/>
-            <a:ext cx="3657600" cy="274320"/>
+      <p:pic>
+        <p:nvPicPr>
+          <p:cNvPr id="18" name="Image 3" descr="preencoded.png">    </p:cNvPr>
+          <p:cNvPicPr>
+            <a:picLocks noChangeAspect="1"/>
+          </p:cNvPicPr>
+          <p:nvPr/>
+        </p:nvPicPr>
+        <p:blipFill>
+          <a:blip r:embed="rId7">
+            <a:extLst>
+              <a:ext uri="{96DAC541-7B7A-43D3-8B79-37D633B846F1}">
+                <asvg:svgBlip xmlns:asvg="http://schemas.microsoft.com/office/drawing/2016/SVG/main" r:embed="rId8"/>
+              </a:ext>
+            </a:extLst>
+          </a:blip>
+          <a:stretch>
+            <a:fillRect/>
+          </a:stretch>
+        </p:blipFill>
+        <p:spPr>
+          <a:xfrm>
+            <a:off x="8046720" y="5568696"/>
+            <a:ext cx="256032" cy="256032"/>
+          </a:xfrm>
+          <a:prstGeom prst="rect">
+            <a:avLst/>
+          </a:prstGeom>
+        </p:spPr>
+      </p:pic>
+      <p:sp>
+        <p:nvSpPr>
+          <p:cNvPr id="19" name="Text 13"/>
+          <p:cNvSpPr/>
+          <p:nvPr/>
+        </p:nvSpPr>
+        <p:spPr>
+          <a:xfrm>
+            <a:off x="8394192" y="5532120"/>
+            <a:ext cx="3291840" cy="274320"/>
           </a:xfrm>
           <a:prstGeom prst="rect">
             <a:avLst/>
@@ -23247,7 +23430,7 @@
                 <a:ea typeface="Calibri" pitchFamily="34" charset="-122"/>
                 <a:cs typeface="Calibri" pitchFamily="34" charset="-120"/>
               </a:rPr>
-              <a:t>💾 The tradeoff</a:t>
+              <a:t>The tradeoff</a:t>
             </a:r>
             <a:endParaRPr lang="en-US" sz="1400" dirty="0"/>
           </a:p>
@@ -23255,14 +23438,14 @@
       </p:sp>
       <p:sp>
         <p:nvSpPr>
-          <p:cNvPr id="16" name="Text 14"/>
-          <p:cNvSpPr/>
-          <p:nvPr/>
-        </p:nvSpPr>
-        <p:spPr>
-          <a:xfrm>
-            <a:off x="8046720" y="5806440"/>
-            <a:ext cx="3657600" cy="274320"/>
+          <p:cNvPr id="20" name="Text 14"/>
+          <p:cNvSpPr/>
+          <p:nvPr/>
+        </p:nvSpPr>
+        <p:spPr>
+          <a:xfrm>
+            <a:off x="8394192" y="5806440"/>
+            <a:ext cx="3291840" cy="274320"/>
           </a:xfrm>
           <a:prstGeom prst="rect">
             <a:avLst/>
@@ -23292,108 +23475,96 @@
           </a:p>
         </p:txBody>
       </p:sp>
-      <p:sp>
-        <p:nvSpPr>
-          <p:cNvPr id="17" name="Shape 15"/>
-          <p:cNvSpPr/>
-          <p:nvPr/>
-        </p:nvSpPr>
+      <p:pic>
+        <p:nvPicPr>
+          <p:cNvPr id="21" name="Image 4" descr="preencoded.png">    </p:cNvPr>
+          <p:cNvPicPr>
+            <a:picLocks noChangeAspect="1"/>
+          </p:cNvPicPr>
+          <p:nvPr/>
+        </p:nvPicPr>
+        <p:blipFill>
+          <a:blip r:embed="rId9">
+            <a:extLst>
+              <a:ext uri="{96DAC541-7B7A-43D3-8B79-37D633B846F1}">
+                <asvg:svgBlip xmlns:asvg="http://schemas.microsoft.com/office/drawing/2016/SVG/main" r:embed="rId10"/>
+              </a:ext>
+            </a:extLst>
+          </a:blip>
+          <a:stretch>
+            <a:fillRect/>
+          </a:stretch>
+        </p:blipFill>
         <p:spPr>
           <a:xfrm>
             <a:off x="10180015" y="502920"/>
-            <a:ext cx="292608" cy="292608"/>
-          </a:xfrm>
-          <a:prstGeom prst="roundRect">
-            <a:avLst>
-              <a:gd name="adj" fmla="val 15625"/>
-            </a:avLst>
-          </a:prstGeom>
-          <a:ln w="19050">
-            <a:solidFill>
-              <a:srgbClr val="FBBF24"/>
-            </a:solidFill>
-            <a:prstDash val="solid"/>
-          </a:ln>
-        </p:spPr>
-      </p:sp>
-      <p:sp>
-        <p:nvSpPr>
-          <p:cNvPr id="18" name="Text 16"/>
-          <p:cNvSpPr/>
-          <p:nvPr/>
-        </p:nvSpPr>
-        <p:spPr>
-          <a:xfrm>
-            <a:off x="10472623" y="457200"/>
-            <a:ext cx="411480" cy="384048"/>
-          </a:xfrm>
-          <a:prstGeom prst="rect">
-            <a:avLst/>
-          </a:prstGeom>
-          <a:noFill/>
-          <a:ln/>
-        </p:spPr>
-        <p:txBody>
-          <a:bodyPr wrap="square" rtlCol="0" anchor="ctr"/>
-          <a:lstStyle/>
-          <a:p>
-            <a:pPr algn="ctr" indent="0" marL="0">
-              <a:buNone/>
-            </a:pPr>
-            <a:r>
-              <a:rPr lang="en-US" sz="1800" b="1" dirty="0">
-                <a:solidFill>
-                  <a:srgbClr val="FBBF24"/>
-                </a:solidFill>
-                <a:latin typeface="Calibri" pitchFamily="34" charset="0"/>
-                <a:ea typeface="Calibri" pitchFamily="34" charset="-122"/>
-                <a:cs typeface="Calibri" pitchFamily="34" charset="-120"/>
-              </a:rPr>
-              <a:t>↔</a:t>
-            </a:r>
-            <a:endParaRPr lang="en-US" sz="1800" dirty="0"/>
-          </a:p>
-        </p:txBody>
-      </p:sp>
-      <p:sp>
-        <p:nvSpPr>
-          <p:cNvPr id="19" name="Text 17"/>
-          <p:cNvSpPr/>
-          <p:nvPr/>
-        </p:nvSpPr>
-        <p:spPr>
-          <a:xfrm>
-            <a:off x="10893247" y="429768"/>
-            <a:ext cx="411480" cy="457200"/>
-          </a:xfrm>
-          <a:prstGeom prst="rect">
-            <a:avLst/>
-          </a:prstGeom>
-          <a:noFill/>
-          <a:ln/>
-        </p:spPr>
-        <p:txBody>
-          <a:bodyPr wrap="square" rtlCol="0" anchor="ctr"/>
-          <a:lstStyle/>
-          <a:p>
-            <a:pPr algn="ctr" indent="0" marL="0">
-              <a:buNone/>
-            </a:pPr>
-            <a:r>
-              <a:rPr lang="en-US" sz="2200" dirty="0">
-                <a:solidFill>
-                  <a:srgbClr val="FBBF24"/>
-                </a:solidFill>
-                <a:latin typeface="Calibri" pitchFamily="34" charset="0"/>
-                <a:ea typeface="Calibri" pitchFamily="34" charset="-122"/>
-                <a:cs typeface="Calibri" pitchFamily="34" charset="-120"/>
-              </a:rPr>
-              <a:t>☁</a:t>
-            </a:r>
-            <a:endParaRPr lang="en-US" sz="2200" dirty="0"/>
-          </a:p>
-        </p:txBody>
-      </p:sp>
+            <a:ext cx="329184" cy="329184"/>
+          </a:xfrm>
+          <a:prstGeom prst="rect">
+            <a:avLst/>
+          </a:prstGeom>
+        </p:spPr>
+      </p:pic>
+      <p:pic>
+        <p:nvPicPr>
+          <p:cNvPr id="22" name="Image 5" descr="preencoded.png">    </p:cNvPr>
+          <p:cNvPicPr>
+            <a:picLocks noChangeAspect="1"/>
+          </p:cNvPicPr>
+          <p:nvPr/>
+        </p:nvPicPr>
+        <p:blipFill>
+          <a:blip r:embed="rId11">
+            <a:extLst>
+              <a:ext uri="{96DAC541-7B7A-43D3-8B79-37D633B846F1}">
+                <asvg:svgBlip xmlns:asvg="http://schemas.microsoft.com/office/drawing/2016/SVG/main" r:embed="rId12"/>
+              </a:ext>
+            </a:extLst>
+          </a:blip>
+          <a:stretch>
+            <a:fillRect/>
+          </a:stretch>
+        </p:blipFill>
+        <p:spPr>
+          <a:xfrm>
+            <a:off x="10564063" y="502920"/>
+            <a:ext cx="329184" cy="329184"/>
+          </a:xfrm>
+          <a:prstGeom prst="rect">
+            <a:avLst/>
+          </a:prstGeom>
+        </p:spPr>
+      </p:pic>
+      <p:pic>
+        <p:nvPicPr>
+          <p:cNvPr id="23" name="Image 6" descr="preencoded.png">    </p:cNvPr>
+          <p:cNvPicPr>
+            <a:picLocks noChangeAspect="1"/>
+          </p:cNvPicPr>
+          <p:nvPr/>
+        </p:nvPicPr>
+        <p:blipFill>
+          <a:blip r:embed="rId13">
+            <a:extLst>
+              <a:ext uri="{96DAC541-7B7A-43D3-8B79-37D633B846F1}">
+                <asvg:svgBlip xmlns:asvg="http://schemas.microsoft.com/office/drawing/2016/SVG/main" r:embed="rId14"/>
+              </a:ext>
+            </a:extLst>
+          </a:blip>
+          <a:stretch>
+            <a:fillRect/>
+          </a:stretch>
+        </p:blipFill>
+        <p:spPr>
+          <a:xfrm>
+            <a:off x="10948111" y="502920"/>
+            <a:ext cx="329184" cy="329184"/>
+          </a:xfrm>
+          <a:prstGeom prst="rect">
+            <a:avLst/>
+          </a:prstGeom>
+        </p:spPr>
+      </p:pic>
     </p:spTree>
   </p:cSld>
   <p:clrMapOvr>

</xml_diff>

<commit_message>
Slide 6: status pills now track IChatClient wrapper status, not OS
Old pills 'shipped / PR #178 / exploring' were ambiguous — they read as
'Apple Intelligence ships, the others don't' which is wrong: all three
OS-level models ship today. What's actually variable is the
Microsoft.Maui.Essentials.AI IChatClient wrapper.

New pills are unambiguous and use Lucide icons (matching the rest of
the deck — last emoji holdouts on this slide are now gone):

  Apple     →  ⊙  IChatClient ready          (CircleCheck)
  Microsoft →  ⇄  IChatClient in PR #178     (GitPullRequest)
  Google    →  ⚗  IChatClient exploring       (FlaskConical)

Bottom banner reworded to match:
  'one IChatClient. Apple ready, Phi Silica in PR, Gemini exploring.'

Co-authored-by: Copilot <223556219+Copilot@users.noreply.github.com>
</commit_message>
<xml_diff>
--- a/slides/Unifying-Local-Cloud-AI.pptx
+++ b/slides/Unifying-Local-Cloud-AI.pptx
@@ -22349,768 +22349,9 @@
           </a:p>
         </p:txBody>
       </p:sp>
-      <p:sp>
-        <p:nvSpPr>
-          <p:cNvPr id="12" name="Text 10"/>
-          <p:cNvSpPr/>
-          <p:nvPr/>
-        </p:nvSpPr>
-        <p:spPr>
-          <a:xfrm>
-            <a:off x="822960" y="5440680"/>
-            <a:ext cx="3154680" cy="320040"/>
-          </a:xfrm>
-          <a:prstGeom prst="rect">
-            <a:avLst/>
-          </a:prstGeom>
-          <a:noFill/>
-          <a:ln/>
-        </p:spPr>
-        <p:txBody>
-          <a:bodyPr wrap="square" rtlCol="0" anchor="ctr"/>
-          <a:lstStyle/>
-          <a:p>
-            <a:pPr indent="0" marL="0">
-              <a:buNone/>
-            </a:pPr>
-            <a:r>
-              <a:rPr lang="en-US" sz="1200" b="1" dirty="0">
-                <a:solidFill>
-                  <a:srgbClr val="FB7185"/>
-                </a:solidFill>
-                <a:latin typeface="Calibri" pitchFamily="34" charset="0"/>
-                <a:ea typeface="Calibri" pitchFamily="34" charset="-122"/>
-                <a:cs typeface="Calibri" pitchFamily="34" charset="-120"/>
-              </a:rPr>
-              <a:t>✅  shipped</a:t>
-            </a:r>
-            <a:endParaRPr lang="en-US" sz="1200" dirty="0"/>
-          </a:p>
-        </p:txBody>
-      </p:sp>
-      <p:sp>
-        <p:nvSpPr>
-          <p:cNvPr id="13" name="Shape 11"/>
-          <p:cNvSpPr/>
-          <p:nvPr/>
-        </p:nvSpPr>
-        <p:spPr>
-          <a:xfrm>
-            <a:off x="4389120" y="2286000"/>
-            <a:ext cx="3703320" cy="3566160"/>
-          </a:xfrm>
-          <a:prstGeom prst="roundRect">
-            <a:avLst>
-              <a:gd name="adj" fmla="val 3077"/>
-            </a:avLst>
-          </a:prstGeom>
-          <a:solidFill>
-            <a:srgbClr val="FFFFFF"/>
-          </a:solidFill>
-          <a:ln w="12700">
-            <a:solidFill>
-              <a:srgbClr val="E5E1F5"/>
-            </a:solidFill>
-            <a:prstDash val="solid"/>
-          </a:ln>
-        </p:spPr>
-      </p:sp>
-      <p:sp>
-        <p:nvSpPr>
-          <p:cNvPr id="14" name="Shape 12"/>
-          <p:cNvSpPr/>
-          <p:nvPr/>
-        </p:nvSpPr>
-        <p:spPr>
-          <a:xfrm>
-            <a:off x="4389120" y="2286000"/>
-            <a:ext cx="3703320" cy="164592"/>
-          </a:xfrm>
-          <a:prstGeom prst="rect">
-            <a:avLst/>
-          </a:prstGeom>
-          <a:solidFill>
-            <a:srgbClr val="6366F1"/>
-          </a:solidFill>
-          <a:ln w="12700">
-            <a:solidFill>
-              <a:srgbClr val="6366F1"/>
-            </a:solidFill>
-            <a:prstDash val="solid"/>
-          </a:ln>
-        </p:spPr>
-      </p:sp>
-      <p:sp>
-        <p:nvSpPr>
-          <p:cNvPr id="15" name="Text 13"/>
-          <p:cNvSpPr/>
-          <p:nvPr/>
-        </p:nvSpPr>
-        <p:spPr>
-          <a:xfrm>
-            <a:off x="4663440" y="2606040"/>
-            <a:ext cx="3154680" cy="320040"/>
-          </a:xfrm>
-          <a:prstGeom prst="rect">
-            <a:avLst/>
-          </a:prstGeom>
-          <a:noFill/>
-          <a:ln/>
-        </p:spPr>
-        <p:txBody>
-          <a:bodyPr wrap="square" rtlCol="0" anchor="ctr"/>
-          <a:lstStyle/>
-          <a:p>
-            <a:pPr indent="0" marL="0">
-              <a:buNone/>
-            </a:pPr>
-            <a:r>
-              <a:rPr lang="en-US" sz="1100" b="1" spc="300" kern="0" dirty="0">
-                <a:solidFill>
-                  <a:srgbClr val="6366F1"/>
-                </a:solidFill>
-                <a:latin typeface="Calibri" pitchFamily="34" charset="0"/>
-                <a:ea typeface="Calibri" pitchFamily="34" charset="-122"/>
-                <a:cs typeface="Calibri" pitchFamily="34" charset="-120"/>
-              </a:rPr>
-              <a:t>MICROSOFT</a:t>
-            </a:r>
-            <a:endParaRPr lang="en-US" sz="1100" dirty="0"/>
-          </a:p>
-        </p:txBody>
-      </p:sp>
-      <p:sp>
-        <p:nvSpPr>
-          <p:cNvPr id="16" name="Text 14"/>
-          <p:cNvSpPr/>
-          <p:nvPr/>
-        </p:nvSpPr>
-        <p:spPr>
-          <a:xfrm>
-            <a:off x="4663440" y="2926080"/>
-            <a:ext cx="3154680" cy="548640"/>
-          </a:xfrm>
-          <a:prstGeom prst="rect">
-            <a:avLst/>
-          </a:prstGeom>
-          <a:noFill/>
-          <a:ln/>
-        </p:spPr>
-        <p:txBody>
-          <a:bodyPr wrap="square" rtlCol="0" anchor="ctr"/>
-          <a:lstStyle/>
-          <a:p>
-            <a:pPr indent="0" marL="0">
-              <a:buNone/>
-            </a:pPr>
-            <a:r>
-              <a:rPr lang="en-US" sz="2200" b="1" dirty="0">
-                <a:solidFill>
-                  <a:srgbClr val="0F0A2E"/>
-                </a:solidFill>
-                <a:latin typeface="Georgia" pitchFamily="34" charset="0"/>
-                <a:ea typeface="Georgia" pitchFamily="34" charset="-122"/>
-                <a:cs typeface="Georgia" pitchFamily="34" charset="-120"/>
-              </a:rPr>
-              <a:t>Phi Silica</a:t>
-            </a:r>
-            <a:endParaRPr lang="en-US" sz="2200" dirty="0"/>
-          </a:p>
-        </p:txBody>
-      </p:sp>
-      <p:sp>
-        <p:nvSpPr>
-          <p:cNvPr id="17" name="Text 15"/>
-          <p:cNvSpPr/>
-          <p:nvPr/>
-        </p:nvSpPr>
-        <p:spPr>
-          <a:xfrm>
-            <a:off x="4663440" y="3474720"/>
-            <a:ext cx="3154680" cy="365760"/>
-          </a:xfrm>
-          <a:prstGeom prst="rect">
-            <a:avLst/>
-          </a:prstGeom>
-          <a:noFill/>
-          <a:ln/>
-        </p:spPr>
-        <p:txBody>
-          <a:bodyPr wrap="square" rtlCol="0" anchor="ctr"/>
-          <a:lstStyle/>
-          <a:p>
-            <a:pPr indent="0" marL="0">
-              <a:buNone/>
-            </a:pPr>
-            <a:r>
-              <a:rPr lang="en-US" sz="1300" i="1" dirty="0">
-                <a:solidFill>
-                  <a:srgbClr val="6B6B8F"/>
-                </a:solidFill>
-                <a:latin typeface="Consolas" pitchFamily="34" charset="0"/>
-                <a:ea typeface="Consolas" pitchFamily="34" charset="-122"/>
-                <a:cs typeface="Consolas" pitchFamily="34" charset="-120"/>
-              </a:rPr>
-              <a:t>Windows AI APIs (.NET)</a:t>
-            </a:r>
-            <a:endParaRPr lang="en-US" sz="1300" dirty="0"/>
-          </a:p>
-        </p:txBody>
-      </p:sp>
-      <p:sp>
-        <p:nvSpPr>
-          <p:cNvPr id="18" name="Shape 16"/>
-          <p:cNvSpPr/>
-          <p:nvPr/>
-        </p:nvSpPr>
-        <p:spPr>
-          <a:xfrm>
-            <a:off x="4663440" y="3931920"/>
-            <a:ext cx="3154680" cy="0"/>
-          </a:xfrm>
-          <a:prstGeom prst="line">
-            <a:avLst/>
-          </a:prstGeom>
-          <a:noFill/>
-          <a:ln w="12700">
-            <a:solidFill>
-              <a:srgbClr val="E5E1F5"/>
-            </a:solidFill>
-            <a:prstDash val="solid"/>
-          </a:ln>
-        </p:spPr>
-      </p:sp>
-      <p:sp>
-        <p:nvSpPr>
-          <p:cNvPr id="19" name="Text 17"/>
-          <p:cNvSpPr/>
-          <p:nvPr/>
-        </p:nvSpPr>
-        <p:spPr>
-          <a:xfrm>
-            <a:off x="4663440" y="4069080"/>
-            <a:ext cx="3154680" cy="1325880"/>
-          </a:xfrm>
-          <a:prstGeom prst="rect">
-            <a:avLst/>
-          </a:prstGeom>
-          <a:noFill/>
-          <a:ln/>
-        </p:spPr>
-        <p:txBody>
-          <a:bodyPr wrap="square" rtlCol="0" anchor="ctr"/>
-          <a:lstStyle/>
-          <a:p>
-            <a:pPr indent="0" marL="0">
-              <a:spcAft>
-                <a:spcPts val="400"/>
-              </a:spcAft>
-              <a:buNone/>
-            </a:pPr>
-            <a:r>
-              <a:rPr lang="en-US" sz="1300" dirty="0">
-                <a:solidFill>
-                  <a:srgbClr val="0F0A2E"/>
-                </a:solidFill>
-                <a:latin typeface="Calibri" pitchFamily="34" charset="0"/>
-                <a:ea typeface="Calibri" pitchFamily="34" charset="-122"/>
-                <a:cs typeface="Calibri" pitchFamily="34" charset="-120"/>
-              </a:rPr>
-              <a:t>Copilot+ PCs · NPU-accelerated</a:t>
-            </a:r>
-            <a:endParaRPr lang="en-US" sz="1300" dirty="0"/>
-          </a:p>
-          <a:p>
-            <a:pPr indent="0" marL="0">
-              <a:spcAft>
-                <a:spcPts val="400"/>
-              </a:spcAft>
-              <a:buNone/>
-            </a:pPr>
-            <a:r>
-              <a:rPr lang="en-US" sz="1300" dirty="0">
-                <a:solidFill>
-                  <a:srgbClr val="0F0A2E"/>
-                </a:solidFill>
-                <a:latin typeface="Calibri" pitchFamily="34" charset="0"/>
-                <a:ea typeface="Calibri" pitchFamily="34" charset="-122"/>
-                <a:cs typeface="Calibri" pitchFamily="34" charset="-120"/>
-              </a:rPr>
-              <a:t>Small language model</a:t>
-            </a:r>
-            <a:endParaRPr lang="en-US" sz="1300" dirty="0"/>
-          </a:p>
-          <a:p>
-            <a:pPr indent="0" marL="0">
-              <a:spcAft>
-                <a:spcPts val="400"/>
-              </a:spcAft>
-              <a:buNone/>
-            </a:pPr>
-            <a:r>
-              <a:rPr lang="en-US" sz="1300" dirty="0">
-                <a:solidFill>
-                  <a:srgbClr val="0F0A2E"/>
-                </a:solidFill>
-                <a:latin typeface="Calibri" pitchFamily="34" charset="0"/>
-                <a:ea typeface="Calibri" pitchFamily="34" charset="-122"/>
-                <a:cs typeface="Calibri" pitchFamily="34" charset="-120"/>
-              </a:rPr>
-              <a:t>Summarize · rewrite · generate</a:t>
-            </a:r>
-            <a:endParaRPr lang="en-US" sz="1300" dirty="0"/>
-          </a:p>
-        </p:txBody>
-      </p:sp>
-      <p:sp>
-        <p:nvSpPr>
-          <p:cNvPr id="20" name="Text 18"/>
-          <p:cNvSpPr/>
-          <p:nvPr/>
-        </p:nvSpPr>
-        <p:spPr>
-          <a:xfrm>
-            <a:off x="4663440" y="5440680"/>
-            <a:ext cx="3154680" cy="320040"/>
-          </a:xfrm>
-          <a:prstGeom prst="rect">
-            <a:avLst/>
-          </a:prstGeom>
-          <a:noFill/>
-          <a:ln/>
-        </p:spPr>
-        <p:txBody>
-          <a:bodyPr wrap="square" rtlCol="0" anchor="ctr"/>
-          <a:lstStyle/>
-          <a:p>
-            <a:pPr indent="0" marL="0">
-              <a:buNone/>
-            </a:pPr>
-            <a:r>
-              <a:rPr lang="en-US" sz="1200" b="1" dirty="0">
-                <a:solidFill>
-                  <a:srgbClr val="6366F1"/>
-                </a:solidFill>
-                <a:latin typeface="Calibri" pitchFamily="34" charset="0"/>
-                <a:ea typeface="Calibri" pitchFamily="34" charset="-122"/>
-                <a:cs typeface="Calibri" pitchFamily="34" charset="-120"/>
-              </a:rPr>
-              <a:t>🔜  maui-labs PR #178</a:t>
-            </a:r>
-            <a:endParaRPr lang="en-US" sz="1200" dirty="0"/>
-          </a:p>
-        </p:txBody>
-      </p:sp>
-      <p:sp>
-        <p:nvSpPr>
-          <p:cNvPr id="21" name="Shape 19"/>
-          <p:cNvSpPr/>
-          <p:nvPr/>
-        </p:nvSpPr>
-        <p:spPr>
-          <a:xfrm>
-            <a:off x="8229600" y="2286000"/>
-            <a:ext cx="3703320" cy="3566160"/>
-          </a:xfrm>
-          <a:prstGeom prst="roundRect">
-            <a:avLst>
-              <a:gd name="adj" fmla="val 3077"/>
-            </a:avLst>
-          </a:prstGeom>
-          <a:solidFill>
-            <a:srgbClr val="FFFFFF"/>
-          </a:solidFill>
-          <a:ln w="12700">
-            <a:solidFill>
-              <a:srgbClr val="E5E1F5"/>
-            </a:solidFill>
-            <a:prstDash val="solid"/>
-          </a:ln>
-        </p:spPr>
-      </p:sp>
-      <p:sp>
-        <p:nvSpPr>
-          <p:cNvPr id="22" name="Shape 20"/>
-          <p:cNvSpPr/>
-          <p:nvPr/>
-        </p:nvSpPr>
-        <p:spPr>
-          <a:xfrm>
-            <a:off x="8229600" y="2286000"/>
-            <a:ext cx="3703320" cy="164592"/>
-          </a:xfrm>
-          <a:prstGeom prst="rect">
-            <a:avLst/>
-          </a:prstGeom>
-          <a:solidFill>
-            <a:srgbClr val="FBBF24"/>
-          </a:solidFill>
-          <a:ln w="12700">
-            <a:solidFill>
-              <a:srgbClr val="FBBF24"/>
-            </a:solidFill>
-            <a:prstDash val="solid"/>
-          </a:ln>
-        </p:spPr>
-      </p:sp>
-      <p:sp>
-        <p:nvSpPr>
-          <p:cNvPr id="23" name="Text 21"/>
-          <p:cNvSpPr/>
-          <p:nvPr/>
-        </p:nvSpPr>
-        <p:spPr>
-          <a:xfrm>
-            <a:off x="8503920" y="2606040"/>
-            <a:ext cx="3154680" cy="320040"/>
-          </a:xfrm>
-          <a:prstGeom prst="rect">
-            <a:avLst/>
-          </a:prstGeom>
-          <a:noFill/>
-          <a:ln/>
-        </p:spPr>
-        <p:txBody>
-          <a:bodyPr wrap="square" rtlCol="0" anchor="ctr"/>
-          <a:lstStyle/>
-          <a:p>
-            <a:pPr indent="0" marL="0">
-              <a:buNone/>
-            </a:pPr>
-            <a:r>
-              <a:rPr lang="en-US" sz="1100" b="1" spc="300" kern="0" dirty="0">
-                <a:solidFill>
-                  <a:srgbClr val="FBBF24"/>
-                </a:solidFill>
-                <a:latin typeface="Calibri" pitchFamily="34" charset="0"/>
-                <a:ea typeface="Calibri" pitchFamily="34" charset="-122"/>
-                <a:cs typeface="Calibri" pitchFamily="34" charset="-120"/>
-              </a:rPr>
-              <a:t>GOOGLE</a:t>
-            </a:r>
-            <a:endParaRPr lang="en-US" sz="1100" dirty="0"/>
-          </a:p>
-        </p:txBody>
-      </p:sp>
-      <p:sp>
-        <p:nvSpPr>
-          <p:cNvPr id="24" name="Text 22"/>
-          <p:cNvSpPr/>
-          <p:nvPr/>
-        </p:nvSpPr>
-        <p:spPr>
-          <a:xfrm>
-            <a:off x="8503920" y="2926080"/>
-            <a:ext cx="3154680" cy="548640"/>
-          </a:xfrm>
-          <a:prstGeom prst="rect">
-            <a:avLst/>
-          </a:prstGeom>
-          <a:noFill/>
-          <a:ln/>
-        </p:spPr>
-        <p:txBody>
-          <a:bodyPr wrap="square" rtlCol="0" anchor="ctr"/>
-          <a:lstStyle/>
-          <a:p>
-            <a:pPr indent="0" marL="0">
-              <a:buNone/>
-            </a:pPr>
-            <a:r>
-              <a:rPr lang="en-US" sz="2200" b="1" dirty="0">
-                <a:solidFill>
-                  <a:srgbClr val="0F0A2E"/>
-                </a:solidFill>
-                <a:latin typeface="Georgia" pitchFamily="34" charset="0"/>
-                <a:ea typeface="Georgia" pitchFamily="34" charset="-122"/>
-                <a:cs typeface="Georgia" pitchFamily="34" charset="-120"/>
-              </a:rPr>
-              <a:t>ML Kit + Gemini Nano</a:t>
-            </a:r>
-            <a:endParaRPr lang="en-US" sz="2200" dirty="0"/>
-          </a:p>
-        </p:txBody>
-      </p:sp>
-      <p:sp>
-        <p:nvSpPr>
-          <p:cNvPr id="25" name="Text 23"/>
-          <p:cNvSpPr/>
-          <p:nvPr/>
-        </p:nvSpPr>
-        <p:spPr>
-          <a:xfrm>
-            <a:off x="8503920" y="3474720"/>
-            <a:ext cx="3154680" cy="365760"/>
-          </a:xfrm>
-          <a:prstGeom prst="rect">
-            <a:avLst/>
-          </a:prstGeom>
-          <a:noFill/>
-          <a:ln/>
-        </p:spPr>
-        <p:txBody>
-          <a:bodyPr wrap="square" rtlCol="0" anchor="ctr"/>
-          <a:lstStyle/>
-          <a:p>
-            <a:pPr indent="0" marL="0">
-              <a:buNone/>
-            </a:pPr>
-            <a:r>
-              <a:rPr lang="en-US" sz="1300" i="1" dirty="0">
-                <a:solidFill>
-                  <a:srgbClr val="6B6B8F"/>
-                </a:solidFill>
-                <a:latin typeface="Consolas" pitchFamily="34" charset="0"/>
-                <a:ea typeface="Consolas" pitchFamily="34" charset="-122"/>
-                <a:cs typeface="Consolas" pitchFamily="34" charset="-120"/>
-              </a:rPr>
-              <a:t>ML Kit (Kotlin/Java)</a:t>
-            </a:r>
-            <a:endParaRPr lang="en-US" sz="1300" dirty="0"/>
-          </a:p>
-        </p:txBody>
-      </p:sp>
-      <p:sp>
-        <p:nvSpPr>
-          <p:cNvPr id="26" name="Shape 24"/>
-          <p:cNvSpPr/>
-          <p:nvPr/>
-        </p:nvSpPr>
-        <p:spPr>
-          <a:xfrm>
-            <a:off x="8503920" y="3931920"/>
-            <a:ext cx="3154680" cy="0"/>
-          </a:xfrm>
-          <a:prstGeom prst="line">
-            <a:avLst/>
-          </a:prstGeom>
-          <a:noFill/>
-          <a:ln w="12700">
-            <a:solidFill>
-              <a:srgbClr val="E5E1F5"/>
-            </a:solidFill>
-            <a:prstDash val="solid"/>
-          </a:ln>
-        </p:spPr>
-      </p:sp>
-      <p:sp>
-        <p:nvSpPr>
-          <p:cNvPr id="27" name="Text 25"/>
-          <p:cNvSpPr/>
-          <p:nvPr/>
-        </p:nvSpPr>
-        <p:spPr>
-          <a:xfrm>
-            <a:off x="8503920" y="4069080"/>
-            <a:ext cx="3154680" cy="1325880"/>
-          </a:xfrm>
-          <a:prstGeom prst="rect">
-            <a:avLst/>
-          </a:prstGeom>
-          <a:noFill/>
-          <a:ln/>
-        </p:spPr>
-        <p:txBody>
-          <a:bodyPr wrap="square" rtlCol="0" anchor="ctr"/>
-          <a:lstStyle/>
-          <a:p>
-            <a:pPr indent="0" marL="0">
-              <a:spcAft>
-                <a:spcPts val="400"/>
-              </a:spcAft>
-              <a:buNone/>
-            </a:pPr>
-            <a:r>
-              <a:rPr lang="en-US" sz="1300" dirty="0">
-                <a:solidFill>
-                  <a:srgbClr val="0F0A2E"/>
-                </a:solidFill>
-                <a:latin typeface="Calibri" pitchFamily="34" charset="0"/>
-                <a:ea typeface="Calibri" pitchFamily="34" charset="-122"/>
-                <a:cs typeface="Calibri" pitchFamily="34" charset="-120"/>
-              </a:rPr>
-              <a:t>Android · AICore service</a:t>
-            </a:r>
-            <a:endParaRPr lang="en-US" sz="1300" dirty="0"/>
-          </a:p>
-          <a:p>
-            <a:pPr indent="0" marL="0">
-              <a:spcAft>
-                <a:spcPts val="400"/>
-              </a:spcAft>
-              <a:buNone/>
-            </a:pPr>
-            <a:r>
-              <a:rPr lang="en-US" sz="1300" dirty="0">
-                <a:solidFill>
-                  <a:srgbClr val="0F0A2E"/>
-                </a:solidFill>
-                <a:latin typeface="Calibri" pitchFamily="34" charset="0"/>
-                <a:ea typeface="Calibri" pitchFamily="34" charset="-122"/>
-                <a:cs typeface="Calibri" pitchFamily="34" charset="-120"/>
-              </a:rPr>
-              <a:t>Compact Gemini Nano</a:t>
-            </a:r>
-            <a:endParaRPr lang="en-US" sz="1300" dirty="0"/>
-          </a:p>
-          <a:p>
-            <a:pPr indent="0" marL="0">
-              <a:spcAft>
-                <a:spcPts val="400"/>
-              </a:spcAft>
-              <a:buNone/>
-            </a:pPr>
-            <a:r>
-              <a:rPr lang="en-US" sz="1300" dirty="0">
-                <a:solidFill>
-                  <a:srgbClr val="0F0A2E"/>
-                </a:solidFill>
-                <a:latin typeface="Calibri" pitchFamily="34" charset="0"/>
-                <a:ea typeface="Calibri" pitchFamily="34" charset="-122"/>
-                <a:cs typeface="Calibri" pitchFamily="34" charset="-120"/>
-              </a:rPr>
-              <a:t>Summarize · proofread · rewrite</a:t>
-            </a:r>
-            <a:endParaRPr lang="en-US" sz="1300" dirty="0"/>
-          </a:p>
-        </p:txBody>
-      </p:sp>
-      <p:sp>
-        <p:nvSpPr>
-          <p:cNvPr id="28" name="Text 26"/>
-          <p:cNvSpPr/>
-          <p:nvPr/>
-        </p:nvSpPr>
-        <p:spPr>
-          <a:xfrm>
-            <a:off x="8503920" y="5440680"/>
-            <a:ext cx="3154680" cy="320040"/>
-          </a:xfrm>
-          <a:prstGeom prst="rect">
-            <a:avLst/>
-          </a:prstGeom>
-          <a:noFill/>
-          <a:ln/>
-        </p:spPr>
-        <p:txBody>
-          <a:bodyPr wrap="square" rtlCol="0" anchor="ctr"/>
-          <a:lstStyle/>
-          <a:p>
-            <a:pPr indent="0" marL="0">
-              <a:buNone/>
-            </a:pPr>
-            <a:r>
-              <a:rPr lang="en-US" sz="1200" b="1" dirty="0">
-                <a:solidFill>
-                  <a:srgbClr val="FBBF24"/>
-                </a:solidFill>
-                <a:latin typeface="Calibri" pitchFamily="34" charset="0"/>
-                <a:ea typeface="Calibri" pitchFamily="34" charset="-122"/>
-                <a:cs typeface="Calibri" pitchFamily="34" charset="-120"/>
-              </a:rPr>
-              <a:t>🔬  .NET wrapper under investigation</a:t>
-            </a:r>
-            <a:endParaRPr lang="en-US" sz="1200" dirty="0"/>
-          </a:p>
-        </p:txBody>
-      </p:sp>
-      <p:sp>
-        <p:nvSpPr>
-          <p:cNvPr id="29" name="Shape 27"/>
-          <p:cNvSpPr/>
-          <p:nvPr/>
-        </p:nvSpPr>
-        <p:spPr>
-          <a:xfrm>
-            <a:off x="548640" y="5989320"/>
-            <a:ext cx="11094415" cy="502920"/>
-          </a:xfrm>
-          <a:prstGeom prst="roundRect">
-            <a:avLst>
-              <a:gd name="adj" fmla="val 14545"/>
-            </a:avLst>
-          </a:prstGeom>
-          <a:solidFill>
-            <a:srgbClr val="0F0A2E"/>
-          </a:solidFill>
-          <a:ln w="12700">
-            <a:solidFill>
-              <a:srgbClr val="0F0A2E"/>
-            </a:solidFill>
-            <a:prstDash val="solid"/>
-          </a:ln>
-        </p:spPr>
-      </p:sp>
-      <p:sp>
-        <p:nvSpPr>
-          <p:cNvPr id="30" name="Text 28"/>
-          <p:cNvSpPr/>
-          <p:nvPr/>
-        </p:nvSpPr>
-        <p:spPr>
-          <a:xfrm>
-            <a:off x="548640" y="5989320"/>
-            <a:ext cx="11094415" cy="502920"/>
-          </a:xfrm>
-          <a:prstGeom prst="rect">
-            <a:avLst/>
-          </a:prstGeom>
-          <a:noFill/>
-          <a:ln/>
-        </p:spPr>
-        <p:txBody>
-          <a:bodyPr wrap="square" rtlCol="0" anchor="ctr"/>
-          <a:lstStyle/>
-          <a:p>
-            <a:pPr algn="ctr" indent="0" marL="0">
-              <a:buNone/>
-            </a:pPr>
-            <a:r>
-              <a:rPr lang="en-US" sz="1300" dirty="0">
-                <a:solidFill>
-                  <a:srgbClr val="CFCBED"/>
-                </a:solidFill>
-                <a:latin typeface="Calibri" pitchFamily="34" charset="0"/>
-                <a:ea typeface="Calibri" pitchFamily="34" charset="-122"/>
-                <a:cs typeface="Calibri" pitchFamily="34" charset="-120"/>
-              </a:rPr>
-              <a:t>Unified for .NET MAUI:  </a:t>
-            </a:r>
-            <a:pPr algn="ctr" indent="0" marL="0">
-              <a:buNone/>
-            </a:pPr>
-            <a:r>
-              <a:rPr lang="en-US" sz="1300" b="1" dirty="0">
-                <a:solidFill>
-                  <a:srgbClr val="FB7185"/>
-                </a:solidFill>
-                <a:latin typeface="Consolas" pitchFamily="34" charset="0"/>
-                <a:ea typeface="Consolas" pitchFamily="34" charset="-122"/>
-                <a:cs typeface="Consolas" pitchFamily="34" charset="-120"/>
-              </a:rPr>
-              <a:t>Microsoft.Maui.Essentials.AI</a:t>
-            </a:r>
-            <a:pPr algn="ctr" indent="0" marL="0">
-              <a:buNone/>
-            </a:pPr>
-            <a:r>
-              <a:rPr lang="en-US" sz="1300" i="1" dirty="0">
-                <a:solidFill>
-                  <a:srgbClr val="CFCBED"/>
-                </a:solidFill>
-                <a:latin typeface="Calibri" pitchFamily="34" charset="0"/>
-                <a:ea typeface="Calibri" pitchFamily="34" charset="-122"/>
-                <a:cs typeface="Calibri" pitchFamily="34" charset="-120"/>
-              </a:rPr>
-              <a:t>  →  one IChatClient shape, Apple today · Phi Silica in progress · Gemini under investigation</a:t>
-            </a:r>
-            <a:endParaRPr lang="en-US" sz="1300" dirty="0"/>
-          </a:p>
-        </p:txBody>
-      </p:sp>
       <p:pic>
         <p:nvPicPr>
-          <p:cNvPr id="31" name="Image 0" descr="preencoded.png">    </p:cNvPr>
+          <p:cNvPr id="12" name="Image 0" descr="preencoded.png">    </p:cNvPr>
           <p:cNvPicPr>
             <a:picLocks noChangeAspect="1"/>
           </p:cNvPicPr>
@@ -23130,17 +22371,330 @@
         </p:blipFill>
         <p:spPr>
           <a:xfrm>
-            <a:off x="10180015" y="502920"/>
-            <a:ext cx="329184" cy="329184"/>
+            <a:off x="822960" y="5458968"/>
+            <a:ext cx="237744" cy="237744"/>
           </a:xfrm>
           <a:prstGeom prst="rect">
             <a:avLst/>
           </a:prstGeom>
         </p:spPr>
       </p:pic>
+      <p:sp>
+        <p:nvSpPr>
+          <p:cNvPr id="13" name="Text 10"/>
+          <p:cNvSpPr/>
+          <p:nvPr/>
+        </p:nvSpPr>
+        <p:spPr>
+          <a:xfrm>
+            <a:off x="1115568" y="5440680"/>
+            <a:ext cx="2862072" cy="320040"/>
+          </a:xfrm>
+          <a:prstGeom prst="rect">
+            <a:avLst/>
+          </a:prstGeom>
+          <a:noFill/>
+          <a:ln/>
+        </p:spPr>
+        <p:txBody>
+          <a:bodyPr wrap="square" rtlCol="0" anchor="ctr"/>
+          <a:lstStyle/>
+          <a:p>
+            <a:pPr indent="0" marL="0">
+              <a:buNone/>
+            </a:pPr>
+            <a:r>
+              <a:rPr lang="en-US" sz="1200" b="1" dirty="0">
+                <a:solidFill>
+                  <a:srgbClr val="FB7185"/>
+                </a:solidFill>
+                <a:latin typeface="Calibri" pitchFamily="34" charset="0"/>
+                <a:ea typeface="Calibri" pitchFamily="34" charset="-122"/>
+                <a:cs typeface="Calibri" pitchFamily="34" charset="-120"/>
+              </a:rPr>
+              <a:t>IChatClient ready</a:t>
+            </a:r>
+            <a:endParaRPr lang="en-US" sz="1200" dirty="0"/>
+          </a:p>
+        </p:txBody>
+      </p:sp>
+      <p:sp>
+        <p:nvSpPr>
+          <p:cNvPr id="14" name="Shape 11"/>
+          <p:cNvSpPr/>
+          <p:nvPr/>
+        </p:nvSpPr>
+        <p:spPr>
+          <a:xfrm>
+            <a:off x="4389120" y="2286000"/>
+            <a:ext cx="3703320" cy="3566160"/>
+          </a:xfrm>
+          <a:prstGeom prst="roundRect">
+            <a:avLst>
+              <a:gd name="adj" fmla="val 3077"/>
+            </a:avLst>
+          </a:prstGeom>
+          <a:solidFill>
+            <a:srgbClr val="FFFFFF"/>
+          </a:solidFill>
+          <a:ln w="12700">
+            <a:solidFill>
+              <a:srgbClr val="E5E1F5"/>
+            </a:solidFill>
+            <a:prstDash val="solid"/>
+          </a:ln>
+        </p:spPr>
+      </p:sp>
+      <p:sp>
+        <p:nvSpPr>
+          <p:cNvPr id="15" name="Shape 12"/>
+          <p:cNvSpPr/>
+          <p:nvPr/>
+        </p:nvSpPr>
+        <p:spPr>
+          <a:xfrm>
+            <a:off x="4389120" y="2286000"/>
+            <a:ext cx="3703320" cy="164592"/>
+          </a:xfrm>
+          <a:prstGeom prst="rect">
+            <a:avLst/>
+          </a:prstGeom>
+          <a:solidFill>
+            <a:srgbClr val="6366F1"/>
+          </a:solidFill>
+          <a:ln w="12700">
+            <a:solidFill>
+              <a:srgbClr val="6366F1"/>
+            </a:solidFill>
+            <a:prstDash val="solid"/>
+          </a:ln>
+        </p:spPr>
+      </p:sp>
+      <p:sp>
+        <p:nvSpPr>
+          <p:cNvPr id="16" name="Text 13"/>
+          <p:cNvSpPr/>
+          <p:nvPr/>
+        </p:nvSpPr>
+        <p:spPr>
+          <a:xfrm>
+            <a:off x="4663440" y="2606040"/>
+            <a:ext cx="3154680" cy="320040"/>
+          </a:xfrm>
+          <a:prstGeom prst="rect">
+            <a:avLst/>
+          </a:prstGeom>
+          <a:noFill/>
+          <a:ln/>
+        </p:spPr>
+        <p:txBody>
+          <a:bodyPr wrap="square" rtlCol="0" anchor="ctr"/>
+          <a:lstStyle/>
+          <a:p>
+            <a:pPr indent="0" marL="0">
+              <a:buNone/>
+            </a:pPr>
+            <a:r>
+              <a:rPr lang="en-US" sz="1100" b="1" spc="300" kern="0" dirty="0">
+                <a:solidFill>
+                  <a:srgbClr val="6366F1"/>
+                </a:solidFill>
+                <a:latin typeface="Calibri" pitchFamily="34" charset="0"/>
+                <a:ea typeface="Calibri" pitchFamily="34" charset="-122"/>
+                <a:cs typeface="Calibri" pitchFamily="34" charset="-120"/>
+              </a:rPr>
+              <a:t>MICROSOFT</a:t>
+            </a:r>
+            <a:endParaRPr lang="en-US" sz="1100" dirty="0"/>
+          </a:p>
+        </p:txBody>
+      </p:sp>
+      <p:sp>
+        <p:nvSpPr>
+          <p:cNvPr id="17" name="Text 14"/>
+          <p:cNvSpPr/>
+          <p:nvPr/>
+        </p:nvSpPr>
+        <p:spPr>
+          <a:xfrm>
+            <a:off x="4663440" y="2926080"/>
+            <a:ext cx="3154680" cy="548640"/>
+          </a:xfrm>
+          <a:prstGeom prst="rect">
+            <a:avLst/>
+          </a:prstGeom>
+          <a:noFill/>
+          <a:ln/>
+        </p:spPr>
+        <p:txBody>
+          <a:bodyPr wrap="square" rtlCol="0" anchor="ctr"/>
+          <a:lstStyle/>
+          <a:p>
+            <a:pPr indent="0" marL="0">
+              <a:buNone/>
+            </a:pPr>
+            <a:r>
+              <a:rPr lang="en-US" sz="2200" b="1" dirty="0">
+                <a:solidFill>
+                  <a:srgbClr val="0F0A2E"/>
+                </a:solidFill>
+                <a:latin typeface="Georgia" pitchFamily="34" charset="0"/>
+                <a:ea typeface="Georgia" pitchFamily="34" charset="-122"/>
+                <a:cs typeface="Georgia" pitchFamily="34" charset="-120"/>
+              </a:rPr>
+              <a:t>Phi Silica</a:t>
+            </a:r>
+            <a:endParaRPr lang="en-US" sz="2200" dirty="0"/>
+          </a:p>
+        </p:txBody>
+      </p:sp>
+      <p:sp>
+        <p:nvSpPr>
+          <p:cNvPr id="18" name="Text 15"/>
+          <p:cNvSpPr/>
+          <p:nvPr/>
+        </p:nvSpPr>
+        <p:spPr>
+          <a:xfrm>
+            <a:off x="4663440" y="3474720"/>
+            <a:ext cx="3154680" cy="365760"/>
+          </a:xfrm>
+          <a:prstGeom prst="rect">
+            <a:avLst/>
+          </a:prstGeom>
+          <a:noFill/>
+          <a:ln/>
+        </p:spPr>
+        <p:txBody>
+          <a:bodyPr wrap="square" rtlCol="0" anchor="ctr"/>
+          <a:lstStyle/>
+          <a:p>
+            <a:pPr indent="0" marL="0">
+              <a:buNone/>
+            </a:pPr>
+            <a:r>
+              <a:rPr lang="en-US" sz="1300" i="1" dirty="0">
+                <a:solidFill>
+                  <a:srgbClr val="6B6B8F"/>
+                </a:solidFill>
+                <a:latin typeface="Consolas" pitchFamily="34" charset="0"/>
+                <a:ea typeface="Consolas" pitchFamily="34" charset="-122"/>
+                <a:cs typeface="Consolas" pitchFamily="34" charset="-120"/>
+              </a:rPr>
+              <a:t>Windows AI APIs (.NET)</a:t>
+            </a:r>
+            <a:endParaRPr lang="en-US" sz="1300" dirty="0"/>
+          </a:p>
+        </p:txBody>
+      </p:sp>
+      <p:sp>
+        <p:nvSpPr>
+          <p:cNvPr id="19" name="Shape 16"/>
+          <p:cNvSpPr/>
+          <p:nvPr/>
+        </p:nvSpPr>
+        <p:spPr>
+          <a:xfrm>
+            <a:off x="4663440" y="3931920"/>
+            <a:ext cx="3154680" cy="0"/>
+          </a:xfrm>
+          <a:prstGeom prst="line">
+            <a:avLst/>
+          </a:prstGeom>
+          <a:noFill/>
+          <a:ln w="12700">
+            <a:solidFill>
+              <a:srgbClr val="E5E1F5"/>
+            </a:solidFill>
+            <a:prstDash val="solid"/>
+          </a:ln>
+        </p:spPr>
+      </p:sp>
+      <p:sp>
+        <p:nvSpPr>
+          <p:cNvPr id="20" name="Text 17"/>
+          <p:cNvSpPr/>
+          <p:nvPr/>
+        </p:nvSpPr>
+        <p:spPr>
+          <a:xfrm>
+            <a:off x="4663440" y="4069080"/>
+            <a:ext cx="3154680" cy="1325880"/>
+          </a:xfrm>
+          <a:prstGeom prst="rect">
+            <a:avLst/>
+          </a:prstGeom>
+          <a:noFill/>
+          <a:ln/>
+        </p:spPr>
+        <p:txBody>
+          <a:bodyPr wrap="square" rtlCol="0" anchor="ctr"/>
+          <a:lstStyle/>
+          <a:p>
+            <a:pPr indent="0" marL="0">
+              <a:spcAft>
+                <a:spcPts val="400"/>
+              </a:spcAft>
+              <a:buNone/>
+            </a:pPr>
+            <a:r>
+              <a:rPr lang="en-US" sz="1300" dirty="0">
+                <a:solidFill>
+                  <a:srgbClr val="0F0A2E"/>
+                </a:solidFill>
+                <a:latin typeface="Calibri" pitchFamily="34" charset="0"/>
+                <a:ea typeface="Calibri" pitchFamily="34" charset="-122"/>
+                <a:cs typeface="Calibri" pitchFamily="34" charset="-120"/>
+              </a:rPr>
+              <a:t>Copilot+ PCs · NPU-accelerated</a:t>
+            </a:r>
+            <a:endParaRPr lang="en-US" sz="1300" dirty="0"/>
+          </a:p>
+          <a:p>
+            <a:pPr indent="0" marL="0">
+              <a:spcAft>
+                <a:spcPts val="400"/>
+              </a:spcAft>
+              <a:buNone/>
+            </a:pPr>
+            <a:r>
+              <a:rPr lang="en-US" sz="1300" dirty="0">
+                <a:solidFill>
+                  <a:srgbClr val="0F0A2E"/>
+                </a:solidFill>
+                <a:latin typeface="Calibri" pitchFamily="34" charset="0"/>
+                <a:ea typeface="Calibri" pitchFamily="34" charset="-122"/>
+                <a:cs typeface="Calibri" pitchFamily="34" charset="-120"/>
+              </a:rPr>
+              <a:t>Small language model</a:t>
+            </a:r>
+            <a:endParaRPr lang="en-US" sz="1300" dirty="0"/>
+          </a:p>
+          <a:p>
+            <a:pPr indent="0" marL="0">
+              <a:spcAft>
+                <a:spcPts val="400"/>
+              </a:spcAft>
+              <a:buNone/>
+            </a:pPr>
+            <a:r>
+              <a:rPr lang="en-US" sz="1300" dirty="0">
+                <a:solidFill>
+                  <a:srgbClr val="0F0A2E"/>
+                </a:solidFill>
+                <a:latin typeface="Calibri" pitchFamily="34" charset="0"/>
+                <a:ea typeface="Calibri" pitchFamily="34" charset="-122"/>
+                <a:cs typeface="Calibri" pitchFamily="34" charset="-120"/>
+              </a:rPr>
+              <a:t>Summarize · rewrite · generate</a:t>
+            </a:r>
+            <a:endParaRPr lang="en-US" sz="1300" dirty="0"/>
+          </a:p>
+        </p:txBody>
+      </p:sp>
       <p:pic>
         <p:nvPicPr>
-          <p:cNvPr id="32" name="Image 1" descr="preencoded.png">    </p:cNvPr>
+          <p:cNvPr id="21" name="Image 1" descr="preencoded.png">    </p:cNvPr>
           <p:cNvPicPr>
             <a:picLocks noChangeAspect="1"/>
           </p:cNvPicPr>
@@ -23160,17 +22714,330 @@
         </p:blipFill>
         <p:spPr>
           <a:xfrm>
-            <a:off x="10564063" y="502920"/>
-            <a:ext cx="329184" cy="329184"/>
+            <a:off x="4663440" y="5458968"/>
+            <a:ext cx="237744" cy="237744"/>
           </a:xfrm>
           <a:prstGeom prst="rect">
             <a:avLst/>
           </a:prstGeom>
         </p:spPr>
       </p:pic>
+      <p:sp>
+        <p:nvSpPr>
+          <p:cNvPr id="22" name="Text 18"/>
+          <p:cNvSpPr/>
+          <p:nvPr/>
+        </p:nvSpPr>
+        <p:spPr>
+          <a:xfrm>
+            <a:off x="4956048" y="5440680"/>
+            <a:ext cx="2862072" cy="320040"/>
+          </a:xfrm>
+          <a:prstGeom prst="rect">
+            <a:avLst/>
+          </a:prstGeom>
+          <a:noFill/>
+          <a:ln/>
+        </p:spPr>
+        <p:txBody>
+          <a:bodyPr wrap="square" rtlCol="0" anchor="ctr"/>
+          <a:lstStyle/>
+          <a:p>
+            <a:pPr indent="0" marL="0">
+              <a:buNone/>
+            </a:pPr>
+            <a:r>
+              <a:rPr lang="en-US" sz="1200" b="1" dirty="0">
+                <a:solidFill>
+                  <a:srgbClr val="6366F1"/>
+                </a:solidFill>
+                <a:latin typeface="Calibri" pitchFamily="34" charset="0"/>
+                <a:ea typeface="Calibri" pitchFamily="34" charset="-122"/>
+                <a:cs typeface="Calibri" pitchFamily="34" charset="-120"/>
+              </a:rPr>
+              <a:t>IChatClient in PR #178</a:t>
+            </a:r>
+            <a:endParaRPr lang="en-US" sz="1200" dirty="0"/>
+          </a:p>
+        </p:txBody>
+      </p:sp>
+      <p:sp>
+        <p:nvSpPr>
+          <p:cNvPr id="23" name="Shape 19"/>
+          <p:cNvSpPr/>
+          <p:nvPr/>
+        </p:nvSpPr>
+        <p:spPr>
+          <a:xfrm>
+            <a:off x="8229600" y="2286000"/>
+            <a:ext cx="3703320" cy="3566160"/>
+          </a:xfrm>
+          <a:prstGeom prst="roundRect">
+            <a:avLst>
+              <a:gd name="adj" fmla="val 3077"/>
+            </a:avLst>
+          </a:prstGeom>
+          <a:solidFill>
+            <a:srgbClr val="FFFFFF"/>
+          </a:solidFill>
+          <a:ln w="12700">
+            <a:solidFill>
+              <a:srgbClr val="E5E1F5"/>
+            </a:solidFill>
+            <a:prstDash val="solid"/>
+          </a:ln>
+        </p:spPr>
+      </p:sp>
+      <p:sp>
+        <p:nvSpPr>
+          <p:cNvPr id="24" name="Shape 20"/>
+          <p:cNvSpPr/>
+          <p:nvPr/>
+        </p:nvSpPr>
+        <p:spPr>
+          <a:xfrm>
+            <a:off x="8229600" y="2286000"/>
+            <a:ext cx="3703320" cy="164592"/>
+          </a:xfrm>
+          <a:prstGeom prst="rect">
+            <a:avLst/>
+          </a:prstGeom>
+          <a:solidFill>
+            <a:srgbClr val="FBBF24"/>
+          </a:solidFill>
+          <a:ln w="12700">
+            <a:solidFill>
+              <a:srgbClr val="FBBF24"/>
+            </a:solidFill>
+            <a:prstDash val="solid"/>
+          </a:ln>
+        </p:spPr>
+      </p:sp>
+      <p:sp>
+        <p:nvSpPr>
+          <p:cNvPr id="25" name="Text 21"/>
+          <p:cNvSpPr/>
+          <p:nvPr/>
+        </p:nvSpPr>
+        <p:spPr>
+          <a:xfrm>
+            <a:off x="8503920" y="2606040"/>
+            <a:ext cx="3154680" cy="320040"/>
+          </a:xfrm>
+          <a:prstGeom prst="rect">
+            <a:avLst/>
+          </a:prstGeom>
+          <a:noFill/>
+          <a:ln/>
+        </p:spPr>
+        <p:txBody>
+          <a:bodyPr wrap="square" rtlCol="0" anchor="ctr"/>
+          <a:lstStyle/>
+          <a:p>
+            <a:pPr indent="0" marL="0">
+              <a:buNone/>
+            </a:pPr>
+            <a:r>
+              <a:rPr lang="en-US" sz="1100" b="1" spc="300" kern="0" dirty="0">
+                <a:solidFill>
+                  <a:srgbClr val="FBBF24"/>
+                </a:solidFill>
+                <a:latin typeface="Calibri" pitchFamily="34" charset="0"/>
+                <a:ea typeface="Calibri" pitchFamily="34" charset="-122"/>
+                <a:cs typeface="Calibri" pitchFamily="34" charset="-120"/>
+              </a:rPr>
+              <a:t>GOOGLE</a:t>
+            </a:r>
+            <a:endParaRPr lang="en-US" sz="1100" dirty="0"/>
+          </a:p>
+        </p:txBody>
+      </p:sp>
+      <p:sp>
+        <p:nvSpPr>
+          <p:cNvPr id="26" name="Text 22"/>
+          <p:cNvSpPr/>
+          <p:nvPr/>
+        </p:nvSpPr>
+        <p:spPr>
+          <a:xfrm>
+            <a:off x="8503920" y="2926080"/>
+            <a:ext cx="3154680" cy="548640"/>
+          </a:xfrm>
+          <a:prstGeom prst="rect">
+            <a:avLst/>
+          </a:prstGeom>
+          <a:noFill/>
+          <a:ln/>
+        </p:spPr>
+        <p:txBody>
+          <a:bodyPr wrap="square" rtlCol="0" anchor="ctr"/>
+          <a:lstStyle/>
+          <a:p>
+            <a:pPr indent="0" marL="0">
+              <a:buNone/>
+            </a:pPr>
+            <a:r>
+              <a:rPr lang="en-US" sz="2200" b="1" dirty="0">
+                <a:solidFill>
+                  <a:srgbClr val="0F0A2E"/>
+                </a:solidFill>
+                <a:latin typeface="Georgia" pitchFamily="34" charset="0"/>
+                <a:ea typeface="Georgia" pitchFamily="34" charset="-122"/>
+                <a:cs typeface="Georgia" pitchFamily="34" charset="-120"/>
+              </a:rPr>
+              <a:t>ML Kit + Gemini Nano</a:t>
+            </a:r>
+            <a:endParaRPr lang="en-US" sz="2200" dirty="0"/>
+          </a:p>
+        </p:txBody>
+      </p:sp>
+      <p:sp>
+        <p:nvSpPr>
+          <p:cNvPr id="27" name="Text 23"/>
+          <p:cNvSpPr/>
+          <p:nvPr/>
+        </p:nvSpPr>
+        <p:spPr>
+          <a:xfrm>
+            <a:off x="8503920" y="3474720"/>
+            <a:ext cx="3154680" cy="365760"/>
+          </a:xfrm>
+          <a:prstGeom prst="rect">
+            <a:avLst/>
+          </a:prstGeom>
+          <a:noFill/>
+          <a:ln/>
+        </p:spPr>
+        <p:txBody>
+          <a:bodyPr wrap="square" rtlCol="0" anchor="ctr"/>
+          <a:lstStyle/>
+          <a:p>
+            <a:pPr indent="0" marL="0">
+              <a:buNone/>
+            </a:pPr>
+            <a:r>
+              <a:rPr lang="en-US" sz="1300" i="1" dirty="0">
+                <a:solidFill>
+                  <a:srgbClr val="6B6B8F"/>
+                </a:solidFill>
+                <a:latin typeface="Consolas" pitchFamily="34" charset="0"/>
+                <a:ea typeface="Consolas" pitchFamily="34" charset="-122"/>
+                <a:cs typeface="Consolas" pitchFamily="34" charset="-120"/>
+              </a:rPr>
+              <a:t>ML Kit (Kotlin/Java)</a:t>
+            </a:r>
+            <a:endParaRPr lang="en-US" sz="1300" dirty="0"/>
+          </a:p>
+        </p:txBody>
+      </p:sp>
+      <p:sp>
+        <p:nvSpPr>
+          <p:cNvPr id="28" name="Shape 24"/>
+          <p:cNvSpPr/>
+          <p:nvPr/>
+        </p:nvSpPr>
+        <p:spPr>
+          <a:xfrm>
+            <a:off x="8503920" y="3931920"/>
+            <a:ext cx="3154680" cy="0"/>
+          </a:xfrm>
+          <a:prstGeom prst="line">
+            <a:avLst/>
+          </a:prstGeom>
+          <a:noFill/>
+          <a:ln w="12700">
+            <a:solidFill>
+              <a:srgbClr val="E5E1F5"/>
+            </a:solidFill>
+            <a:prstDash val="solid"/>
+          </a:ln>
+        </p:spPr>
+      </p:sp>
+      <p:sp>
+        <p:nvSpPr>
+          <p:cNvPr id="29" name="Text 25"/>
+          <p:cNvSpPr/>
+          <p:nvPr/>
+        </p:nvSpPr>
+        <p:spPr>
+          <a:xfrm>
+            <a:off x="8503920" y="4069080"/>
+            <a:ext cx="3154680" cy="1325880"/>
+          </a:xfrm>
+          <a:prstGeom prst="rect">
+            <a:avLst/>
+          </a:prstGeom>
+          <a:noFill/>
+          <a:ln/>
+        </p:spPr>
+        <p:txBody>
+          <a:bodyPr wrap="square" rtlCol="0" anchor="ctr"/>
+          <a:lstStyle/>
+          <a:p>
+            <a:pPr indent="0" marL="0">
+              <a:spcAft>
+                <a:spcPts val="400"/>
+              </a:spcAft>
+              <a:buNone/>
+            </a:pPr>
+            <a:r>
+              <a:rPr lang="en-US" sz="1300" dirty="0">
+                <a:solidFill>
+                  <a:srgbClr val="0F0A2E"/>
+                </a:solidFill>
+                <a:latin typeface="Calibri" pitchFamily="34" charset="0"/>
+                <a:ea typeface="Calibri" pitchFamily="34" charset="-122"/>
+                <a:cs typeface="Calibri" pitchFamily="34" charset="-120"/>
+              </a:rPr>
+              <a:t>Android · AICore service</a:t>
+            </a:r>
+            <a:endParaRPr lang="en-US" sz="1300" dirty="0"/>
+          </a:p>
+          <a:p>
+            <a:pPr indent="0" marL="0">
+              <a:spcAft>
+                <a:spcPts val="400"/>
+              </a:spcAft>
+              <a:buNone/>
+            </a:pPr>
+            <a:r>
+              <a:rPr lang="en-US" sz="1300" dirty="0">
+                <a:solidFill>
+                  <a:srgbClr val="0F0A2E"/>
+                </a:solidFill>
+                <a:latin typeface="Calibri" pitchFamily="34" charset="0"/>
+                <a:ea typeface="Calibri" pitchFamily="34" charset="-122"/>
+                <a:cs typeface="Calibri" pitchFamily="34" charset="-120"/>
+              </a:rPr>
+              <a:t>Compact Gemini Nano</a:t>
+            </a:r>
+            <a:endParaRPr lang="en-US" sz="1300" dirty="0"/>
+          </a:p>
+          <a:p>
+            <a:pPr indent="0" marL="0">
+              <a:spcAft>
+                <a:spcPts val="400"/>
+              </a:spcAft>
+              <a:buNone/>
+            </a:pPr>
+            <a:r>
+              <a:rPr lang="en-US" sz="1300" dirty="0">
+                <a:solidFill>
+                  <a:srgbClr val="0F0A2E"/>
+                </a:solidFill>
+                <a:latin typeface="Calibri" pitchFamily="34" charset="0"/>
+                <a:ea typeface="Calibri" pitchFamily="34" charset="-122"/>
+                <a:cs typeface="Calibri" pitchFamily="34" charset="-120"/>
+              </a:rPr>
+              <a:t>Summarize · proofread · rewrite</a:t>
+            </a:r>
+            <a:endParaRPr lang="en-US" sz="1300" dirty="0"/>
+          </a:p>
+        </p:txBody>
+      </p:sp>
       <p:pic>
         <p:nvPicPr>
-          <p:cNvPr id="33" name="Image 2" descr="preencoded.png">    </p:cNvPr>
+          <p:cNvPr id="30" name="Image 2" descr="preencoded.png">    </p:cNvPr>
           <p:cNvPicPr>
             <a:picLocks noChangeAspect="1"/>
           </p:cNvPicPr>
@@ -23190,8 +23057,8 @@
         </p:blipFill>
         <p:spPr>
           <a:xfrm>
-            <a:off x="10948111" y="502920"/>
-            <a:ext cx="329184" cy="329184"/>
+            <a:off x="8503920" y="5458968"/>
+            <a:ext cx="237744" cy="237744"/>
           </a:xfrm>
           <a:prstGeom prst="rect">
             <a:avLst/>
@@ -23200,14 +23067,14 @@
       </p:pic>
       <p:sp>
         <p:nvSpPr>
-          <p:cNvPr id="34" name="Text 29"/>
-          <p:cNvSpPr/>
-          <p:nvPr/>
-        </p:nvSpPr>
-        <p:spPr>
-          <a:xfrm>
-            <a:off x="457200" y="6446520"/>
-            <a:ext cx="7315200" cy="274320"/>
+          <p:cNvPr id="31" name="Text 26"/>
+          <p:cNvSpPr/>
+          <p:nvPr/>
+        </p:nvSpPr>
+        <p:spPr>
+          <a:xfrm>
+            <a:off x="8796528" y="5440680"/>
+            <a:ext cx="2862072" cy="320040"/>
           </a:xfrm>
           <a:prstGeom prst="rect">
             <a:avLst/>
@@ -23219,48 +23086,229 @@
           <a:bodyPr wrap="square" rtlCol="0" anchor="ctr"/>
           <a:lstStyle/>
           <a:p>
-            <a:pPr algn="l" indent="0" marL="0">
-              <a:buNone/>
-            </a:pPr>
-            <a:r>
-              <a:rPr lang="en-US" sz="1000" dirty="0">
-                <a:solidFill>
-                  <a:srgbClr val="6B6B8F"/>
+            <a:pPr indent="0" marL="0">
+              <a:buNone/>
+            </a:pPr>
+            <a:r>
+              <a:rPr lang="en-US" sz="1200" b="1" dirty="0">
+                <a:solidFill>
+                  <a:srgbClr val="FBBF24"/>
                 </a:solidFill>
                 <a:latin typeface="Calibri" pitchFamily="34" charset="0"/>
                 <a:ea typeface="Calibri" pitchFamily="34" charset="-122"/>
                 <a:cs typeface="Calibri" pitchFamily="34" charset="-120"/>
               </a:rPr>
-              <a:t>Unifying Local and Cloud AI</a:t>
-            </a:r>
-            <a:pPr algn="l" indent="0" marL="0">
-              <a:buNone/>
-            </a:pPr>
-            <a:r>
-              <a:rPr lang="en-US" sz="1000" dirty="0">
-                <a:solidFill>
-                  <a:srgbClr val="6B6B8F"/>
+              <a:t>IChatClient exploring</a:t>
+            </a:r>
+            <a:endParaRPr lang="en-US" sz="1200" dirty="0"/>
+          </a:p>
+        </p:txBody>
+      </p:sp>
+      <p:sp>
+        <p:nvSpPr>
+          <p:cNvPr id="32" name="Shape 27"/>
+          <p:cNvSpPr/>
+          <p:nvPr/>
+        </p:nvSpPr>
+        <p:spPr>
+          <a:xfrm>
+            <a:off x="548640" y="5989320"/>
+            <a:ext cx="11094415" cy="502920"/>
+          </a:xfrm>
+          <a:prstGeom prst="roundRect">
+            <a:avLst>
+              <a:gd name="adj" fmla="val 14545"/>
+            </a:avLst>
+          </a:prstGeom>
+          <a:solidFill>
+            <a:srgbClr val="0F0A2E"/>
+          </a:solidFill>
+          <a:ln w="12700">
+            <a:solidFill>
+              <a:srgbClr val="0F0A2E"/>
+            </a:solidFill>
+            <a:prstDash val="solid"/>
+          </a:ln>
+        </p:spPr>
+      </p:sp>
+      <p:sp>
+        <p:nvSpPr>
+          <p:cNvPr id="33" name="Text 28"/>
+          <p:cNvSpPr/>
+          <p:nvPr/>
+        </p:nvSpPr>
+        <p:spPr>
+          <a:xfrm>
+            <a:off x="548640" y="5989320"/>
+            <a:ext cx="11094415" cy="502920"/>
+          </a:xfrm>
+          <a:prstGeom prst="rect">
+            <a:avLst/>
+          </a:prstGeom>
+          <a:noFill/>
+          <a:ln/>
+        </p:spPr>
+        <p:txBody>
+          <a:bodyPr wrap="square" rtlCol="0" anchor="ctr"/>
+          <a:lstStyle/>
+          <a:p>
+            <a:pPr algn="ctr" indent="0" marL="0">
+              <a:buNone/>
+            </a:pPr>
+            <a:r>
+              <a:rPr lang="en-US" sz="1300" dirty="0">
+                <a:solidFill>
+                  <a:srgbClr val="CFCBED"/>
                 </a:solidFill>
                 <a:latin typeface="Calibri" pitchFamily="34" charset="0"/>
                 <a:ea typeface="Calibri" pitchFamily="34" charset="-122"/>
                 <a:cs typeface="Calibri" pitchFamily="34" charset="-120"/>
               </a:rPr>
-              <a:t>  ·  </a:t>
-            </a:r>
-            <a:pPr algn="l" indent="0" marL="0">
-              <a:buNone/>
-            </a:pPr>
-            <a:r>
-              <a:rPr lang="en-US" sz="1000" b="1" dirty="0">
+              <a:t>Unified for .NET MAUI:  </a:t>
+            </a:r>
+            <a:pPr algn="ctr" indent="0" marL="0">
+              <a:buNone/>
+            </a:pPr>
+            <a:r>
+              <a:rPr lang="en-US" sz="1300" b="1" dirty="0">
                 <a:solidFill>
                   <a:srgbClr val="FB7185"/>
+                </a:solidFill>
+                <a:latin typeface="Consolas" pitchFamily="34" charset="0"/>
+                <a:ea typeface="Consolas" pitchFamily="34" charset="-122"/>
+                <a:cs typeface="Consolas" pitchFamily="34" charset="-120"/>
+              </a:rPr>
+              <a:t>Microsoft.Maui.Essentials.AI</a:t>
+            </a:r>
+            <a:pPr algn="ctr" indent="0" marL="0">
+              <a:buNone/>
+            </a:pPr>
+            <a:r>
+              <a:rPr lang="en-US" sz="1300" i="1" dirty="0">
+                <a:solidFill>
+                  <a:srgbClr val="CFCBED"/>
                 </a:solidFill>
                 <a:latin typeface="Calibri" pitchFamily="34" charset="0"/>
                 <a:ea typeface="Calibri" pitchFamily="34" charset="-122"/>
                 <a:cs typeface="Calibri" pitchFamily="34" charset="-120"/>
               </a:rPr>
-              <a:t>@mattleibow</a:t>
-            </a:r>
+              <a:t>  →  one IChatClient. Apple ready, Phi Silica in PR, Gemini exploring.</a:t>
+            </a:r>
+            <a:endParaRPr lang="en-US" sz="1300" dirty="0"/>
+          </a:p>
+        </p:txBody>
+      </p:sp>
+      <p:pic>
+        <p:nvPicPr>
+          <p:cNvPr id="34" name="Image 3" descr="preencoded.png">    </p:cNvPr>
+          <p:cNvPicPr>
+            <a:picLocks noChangeAspect="1"/>
+          </p:cNvPicPr>
+          <p:nvPr/>
+        </p:nvPicPr>
+        <p:blipFill>
+          <a:blip r:embed="rId7">
+            <a:extLst>
+              <a:ext uri="{96DAC541-7B7A-43D3-8B79-37D633B846F1}">
+                <asvg:svgBlip xmlns:asvg="http://schemas.microsoft.com/office/drawing/2016/SVG/main" r:embed="rId8"/>
+              </a:ext>
+            </a:extLst>
+          </a:blip>
+          <a:stretch>
+            <a:fillRect/>
+          </a:stretch>
+        </p:blipFill>
+        <p:spPr>
+          <a:xfrm>
+            <a:off x="10180015" y="502920"/>
+            <a:ext cx="329184" cy="329184"/>
+          </a:xfrm>
+          <a:prstGeom prst="rect">
+            <a:avLst/>
+          </a:prstGeom>
+        </p:spPr>
+      </p:pic>
+      <p:pic>
+        <p:nvPicPr>
+          <p:cNvPr id="35" name="Image 4" descr="preencoded.png">    </p:cNvPr>
+          <p:cNvPicPr>
+            <a:picLocks noChangeAspect="1"/>
+          </p:cNvPicPr>
+          <p:nvPr/>
+        </p:nvPicPr>
+        <p:blipFill>
+          <a:blip r:embed="rId9">
+            <a:extLst>
+              <a:ext uri="{96DAC541-7B7A-43D3-8B79-37D633B846F1}">
+                <asvg:svgBlip xmlns:asvg="http://schemas.microsoft.com/office/drawing/2016/SVG/main" r:embed="rId10"/>
+              </a:ext>
+            </a:extLst>
+          </a:blip>
+          <a:stretch>
+            <a:fillRect/>
+          </a:stretch>
+        </p:blipFill>
+        <p:spPr>
+          <a:xfrm>
+            <a:off x="10564063" y="502920"/>
+            <a:ext cx="329184" cy="329184"/>
+          </a:xfrm>
+          <a:prstGeom prst="rect">
+            <a:avLst/>
+          </a:prstGeom>
+        </p:spPr>
+      </p:pic>
+      <p:pic>
+        <p:nvPicPr>
+          <p:cNvPr id="36" name="Image 5" descr="preencoded.png">    </p:cNvPr>
+          <p:cNvPicPr>
+            <a:picLocks noChangeAspect="1"/>
+          </p:cNvPicPr>
+          <p:nvPr/>
+        </p:nvPicPr>
+        <p:blipFill>
+          <a:blip r:embed="rId11">
+            <a:extLst>
+              <a:ext uri="{96DAC541-7B7A-43D3-8B79-37D633B846F1}">
+                <asvg:svgBlip xmlns:asvg="http://schemas.microsoft.com/office/drawing/2016/SVG/main" r:embed="rId12"/>
+              </a:ext>
+            </a:extLst>
+          </a:blip>
+          <a:stretch>
+            <a:fillRect/>
+          </a:stretch>
+        </p:blipFill>
+        <p:spPr>
+          <a:xfrm>
+            <a:off x="10948111" y="502920"/>
+            <a:ext cx="329184" cy="329184"/>
+          </a:xfrm>
+          <a:prstGeom prst="rect">
+            <a:avLst/>
+          </a:prstGeom>
+        </p:spPr>
+      </p:pic>
+      <p:sp>
+        <p:nvSpPr>
+          <p:cNvPr id="37" name="Text 29"/>
+          <p:cNvSpPr/>
+          <p:nvPr/>
+        </p:nvSpPr>
+        <p:spPr>
+          <a:xfrm>
+            <a:off x="457200" y="6446520"/>
+            <a:ext cx="7315200" cy="274320"/>
+          </a:xfrm>
+          <a:prstGeom prst="rect">
+            <a:avLst/>
+          </a:prstGeom>
+          <a:noFill/>
+          <a:ln/>
+        </p:spPr>
+        <p:txBody>
+          <a:bodyPr wrap="square" rtlCol="0" anchor="ctr"/>
+          <a:lstStyle/>
+          <a:p>
             <a:pPr algn="l" indent="0" marL="0">
               <a:buNone/>
             </a:pPr>
@@ -23273,6 +23321,48 @@
                 <a:ea typeface="Calibri" pitchFamily="34" charset="-122"/>
                 <a:cs typeface="Calibri" pitchFamily="34" charset="-120"/>
               </a:rPr>
+              <a:t>Unifying Local and Cloud AI</a:t>
+            </a:r>
+            <a:pPr algn="l" indent="0" marL="0">
+              <a:buNone/>
+            </a:pPr>
+            <a:r>
+              <a:rPr lang="en-US" sz="1000" dirty="0">
+                <a:solidFill>
+                  <a:srgbClr val="6B6B8F"/>
+                </a:solidFill>
+                <a:latin typeface="Calibri" pitchFamily="34" charset="0"/>
+                <a:ea typeface="Calibri" pitchFamily="34" charset="-122"/>
+                <a:cs typeface="Calibri" pitchFamily="34" charset="-120"/>
+              </a:rPr>
+              <a:t>  ·  </a:t>
+            </a:r>
+            <a:pPr algn="l" indent="0" marL="0">
+              <a:buNone/>
+            </a:pPr>
+            <a:r>
+              <a:rPr lang="en-US" sz="1000" b="1" dirty="0">
+                <a:solidFill>
+                  <a:srgbClr val="FB7185"/>
+                </a:solidFill>
+                <a:latin typeface="Calibri" pitchFamily="34" charset="0"/>
+                <a:ea typeface="Calibri" pitchFamily="34" charset="-122"/>
+                <a:cs typeface="Calibri" pitchFamily="34" charset="-120"/>
+              </a:rPr>
+              <a:t>@mattleibow</a:t>
+            </a:r>
+            <a:pPr algn="l" indent="0" marL="0">
+              <a:buNone/>
+            </a:pPr>
+            <a:r>
+              <a:rPr lang="en-US" sz="1000" dirty="0">
+                <a:solidFill>
+                  <a:srgbClr val="6B6B8F"/>
+                </a:solidFill>
+                <a:latin typeface="Calibri" pitchFamily="34" charset="0"/>
+                <a:ea typeface="Calibri" pitchFamily="34" charset="-122"/>
+                <a:cs typeface="Calibri" pitchFamily="34" charset="-120"/>
+              </a:rPr>
               <a:t>  ·  @CPTMSDUG</a:t>
             </a:r>
             <a:endParaRPr lang="en-US" sz="1000" dirty="0"/>
@@ -23281,7 +23371,7 @@
       </p:sp>
       <p:sp>
         <p:nvSpPr>
-          <p:cNvPr id="35" name="Text 30"/>
+          <p:cNvPr id="38" name="Text 30"/>
           <p:cNvSpPr/>
           <p:nvPr/>
         </p:nvSpPr>

</xml_diff>

<commit_message>
Reorder: 'downgrade the path' — BYO Local before OS On-Device
Cloud → BYO Local → OS On-Device → Live Demo gives a clean
'step down' narrative: each tier shrinks the model and tightens
the locality story before we see the smallest one actually run.

New order:
  4  Cloud AI               (frontier — big and remote)
  5  BYO Local              (cloud-grade LLM, on your box)
  6  OS On-Device           (the surprise — tiny but free + offline)
  7  DEMO 01 Apple          (see the smallest one run)

Renumber: BYO 7→5, OS 5→6, Demo 6→7. Everything else unchanged.

Co-authored-by: Copilot <223556219+Copilot@users.noreply.github.com>
</commit_message>
<xml_diff>
--- a/slides/Unifying-Local-Cloud-AI.pptx
+++ b/slides/Unifying-Local-Cloud-AI.pptx
@@ -15455,13 +15455,13 @@
             <a:r>
               <a:rPr lang="en-US" sz="1200" b="1" spc="400" kern="0" dirty="0">
                 <a:solidFill>
-                  <a:srgbClr val="FB7185"/>
+                  <a:srgbClr val="FBBF24"/>
                 </a:solidFill>
                 <a:latin typeface="Calibri" pitchFamily="34" charset="0"/>
                 <a:ea typeface="Calibri" pitchFamily="34" charset="-122"/>
                 <a:cs typeface="Calibri" pitchFamily="34" charset="-120"/>
               </a:rPr>
-              <a:t>TIER 1  ·  THE SURPRISE</a:t>
+              <a:t>TIER 2  ·  THE PRACTICAL MIDDLE</a:t>
             </a:r>
             <a:endParaRPr lang="en-US" sz="1200" dirty="0"/>
           </a:p>
@@ -15500,7 +15500,7 @@
                 <a:ea typeface="Georgia" pitchFamily="34" charset="-122"/>
                 <a:cs typeface="Georgia" pitchFamily="34" charset="-120"/>
               </a:rPr>
-              <a:t>Your OS already ships an LLM</a:t>
+              <a:t>Bring your own local model</a:t>
             </a:r>
             <a:endParaRPr lang="en-US" sz="3800" dirty="0"/>
           </a:p>
@@ -15539,7 +15539,7 @@
                 <a:ea typeface="Calibri" pitchFamily="34" charset="-122"/>
                 <a:cs typeface="Calibri" pitchFamily="34" charset="-120"/>
               </a:rPr>
-              <a:t>Vendor-managed, shared across apps, zero cost, fully offline. ~3B-class models.</a:t>
+              <a:t>The forgotten tier — cloud-class capability with local-class privacy</a:t>
             </a:r>
             <a:endParaRPr lang="en-US" sz="1700" dirty="0"/>
           </a:p>
@@ -15554,19 +15554,19 @@
         <p:spPr>
           <a:xfrm>
             <a:off x="548640" y="2286000"/>
-            <a:ext cx="3703320" cy="3566160"/>
+            <a:ext cx="3703320" cy="3931920"/>
           </a:xfrm>
           <a:prstGeom prst="roundRect">
             <a:avLst>
-              <a:gd name="adj" fmla="val 3077"/>
+              <a:gd name="adj" fmla="val 2963"/>
             </a:avLst>
           </a:prstGeom>
           <a:solidFill>
             <a:srgbClr val="FFFFFF"/>
           </a:solidFill>
-          <a:ln w="12700">
+          <a:ln w="25400">
             <a:solidFill>
-              <a:srgbClr val="E5E1F5"/>
+              <a:srgbClr val="FB7185"/>
             </a:solidFill>
             <a:prstDash val="solid"/>
           </a:ln>
@@ -15580,11 +15580,13 @@
         </p:nvSpPr>
         <p:spPr>
           <a:xfrm>
-            <a:off x="548640" y="2286000"/>
-            <a:ext cx="3703320" cy="164592"/>
-          </a:xfrm>
-          <a:prstGeom prst="rect">
-            <a:avLst/>
+            <a:off x="822960" y="2514600"/>
+            <a:ext cx="1554480" cy="292608"/>
+          </a:xfrm>
+          <a:prstGeom prst="roundRect">
+            <a:avLst>
+              <a:gd name="adj" fmla="val 50000"/>
+            </a:avLst>
           </a:prstGeom>
           <a:solidFill>
             <a:srgbClr val="FB7185"/>
@@ -15605,8 +15607,8 @@
         </p:nvSpPr>
         <p:spPr>
           <a:xfrm>
-            <a:off x="822960" y="2606040"/>
-            <a:ext cx="3154680" cy="320040"/>
+            <a:off x="822960" y="2514600"/>
+            <a:ext cx="1554480" cy="292608"/>
           </a:xfrm>
           <a:prstGeom prst="rect">
             <a:avLst/>
@@ -15618,21 +15620,21 @@
           <a:bodyPr wrap="square" rtlCol="0" anchor="ctr"/>
           <a:lstStyle/>
           <a:p>
-            <a:pPr indent="0" marL="0">
-              <a:buNone/>
-            </a:pPr>
-            <a:r>
-              <a:rPr lang="en-US" sz="1100" b="1" spc="300" kern="0" dirty="0">
-                <a:solidFill>
-                  <a:srgbClr val="FB7185"/>
+            <a:pPr algn="ctr" indent="0" marL="0">
+              <a:buNone/>
+            </a:pPr>
+            <a:r>
+              <a:rPr lang="en-US" sz="900" b="1" spc="200" kern="0" dirty="0">
+                <a:solidFill>
+                  <a:srgbClr val="FAF8FF"/>
                 </a:solidFill>
                 <a:latin typeface="Calibri" pitchFamily="34" charset="0"/>
                 <a:ea typeface="Calibri" pitchFamily="34" charset="-122"/>
                 <a:cs typeface="Calibri" pitchFamily="34" charset="-120"/>
               </a:rPr>
-              <a:t>APPLE</a:t>
-            </a:r>
-            <a:endParaRPr lang="en-US" sz="1100" dirty="0"/>
+              <a:t>RECOMMENDED</a:t>
+            </a:r>
+            <a:endParaRPr lang="en-US" sz="900" dirty="0"/>
           </a:p>
         </p:txBody>
       </p:sp>
@@ -15644,7 +15646,7 @@
         </p:nvSpPr>
         <p:spPr>
           <a:xfrm>
-            <a:off x="822960" y="2926080"/>
+            <a:off x="822960" y="2971800"/>
             <a:ext cx="3154680" cy="548640"/>
           </a:xfrm>
           <a:prstGeom prst="rect">
@@ -15669,7 +15671,7 @@
                 <a:ea typeface="Georgia" pitchFamily="34" charset="-122"/>
                 <a:cs typeface="Georgia" pitchFamily="34" charset="-120"/>
               </a:rPr>
-              <a:t>Apple Intelligence</a:t>
+              <a:t>Foundry Local</a:t>
             </a:r>
             <a:endParaRPr lang="en-US" sz="2200" dirty="0"/>
           </a:p>
@@ -15683,7 +15685,7 @@
         </p:nvSpPr>
         <p:spPr>
           <a:xfrm>
-            <a:off x="822960" y="3474720"/>
+            <a:off x="822960" y="3520440"/>
             <a:ext cx="3154680" cy="365760"/>
           </a:xfrm>
           <a:prstGeom prst="rect">
@@ -15702,13 +15704,13 @@
             <a:r>
               <a:rPr lang="en-US" sz="1300" i="1" dirty="0">
                 <a:solidFill>
-                  <a:srgbClr val="6B6B8F"/>
-                </a:solidFill>
-                <a:latin typeface="Consolas" pitchFamily="34" charset="0"/>
-                <a:ea typeface="Consolas" pitchFamily="34" charset="-122"/>
-                <a:cs typeface="Consolas" pitchFamily="34" charset="-120"/>
-              </a:rPr>
-              <a:t>FoundationModels (Swift)</a:t>
+                  <a:srgbClr val="FB7185"/>
+                </a:solidFill>
+                <a:latin typeface="Calibri" pitchFamily="34" charset="0"/>
+                <a:ea typeface="Calibri" pitchFamily="34" charset="-122"/>
+                <a:cs typeface="Calibri" pitchFamily="34" charset="-120"/>
+              </a:rPr>
+              <a:t>Cloud-grade LLMs, local host</a:t>
             </a:r>
             <a:endParaRPr lang="en-US" sz="1300" dirty="0"/>
           </a:p>
@@ -15716,22 +15718,65 @@
       </p:sp>
       <p:sp>
         <p:nvSpPr>
-          <p:cNvPr id="10" name="Shape 8"/>
-          <p:cNvSpPr/>
-          <p:nvPr/>
-        </p:nvSpPr>
-        <p:spPr>
-          <a:xfrm>
-            <a:off x="822960" y="3931920"/>
-            <a:ext cx="3154680" cy="0"/>
-          </a:xfrm>
-          <a:prstGeom prst="line">
-            <a:avLst/>
-          </a:prstGeom>
-          <a:noFill/>
-          <a:ln w="12700">
+          <p:cNvPr id="10" name="Text 8"/>
+          <p:cNvSpPr/>
+          <p:nvPr/>
+        </p:nvSpPr>
+        <p:spPr>
+          <a:xfrm>
+            <a:off x="822960" y="4023360"/>
+            <a:ext cx="3154680" cy="2011680"/>
+          </a:xfrm>
+          <a:prstGeom prst="rect">
+            <a:avLst/>
+          </a:prstGeom>
+          <a:noFill/>
+          <a:ln/>
+        </p:spPr>
+        <p:txBody>
+          <a:bodyPr wrap="square" rtlCol="0" anchor="ctr"/>
+          <a:lstStyle/>
+          <a:p>
+            <a:pPr indent="0" marL="0">
+              <a:buNone/>
+            </a:pPr>
+            <a:r>
+              <a:rPr lang="en-US" sz="1300" dirty="0">
+                <a:solidFill>
+                  <a:srgbClr val="0F0A2E"/>
+                </a:solidFill>
+                <a:latin typeface="Calibri" pitchFamily="34" charset="0"/>
+                <a:ea typeface="Calibri" pitchFamily="34" charset="-122"/>
+                <a:cs typeface="Calibri" pitchFamily="34" charset="-120"/>
+              </a:rPr>
+              <a:t>Microsoft's runtime for running Phi, Llama, Qwen and friends on the user's box. .NET-friendly, ONNX-backed, GPU/NPU accelerated.</a:t>
+            </a:r>
+            <a:endParaRPr lang="en-US" sz="1300" dirty="0"/>
+          </a:p>
+        </p:txBody>
+      </p:sp>
+      <p:sp>
+        <p:nvSpPr>
+          <p:cNvPr id="11" name="Shape 9"/>
+          <p:cNvSpPr/>
+          <p:nvPr/>
+        </p:nvSpPr>
+        <p:spPr>
+          <a:xfrm>
+            <a:off x="4389120" y="2286000"/>
+            <a:ext cx="3703320" cy="3931920"/>
+          </a:xfrm>
+          <a:prstGeom prst="roundRect">
+            <a:avLst>
+              <a:gd name="adj" fmla="val 2963"/>
+            </a:avLst>
+          </a:prstGeom>
+          <a:solidFill>
+            <a:srgbClr val="FFFFFF"/>
+          </a:solidFill>
+          <a:ln w="25400">
             <a:solidFill>
-              <a:srgbClr val="E5E1F5"/>
+              <a:srgbClr val="6366F1"/>
             </a:solidFill>
             <a:prstDash val="solid"/>
           </a:ln>
@@ -15739,14 +15784,41 @@
       </p:sp>
       <p:sp>
         <p:nvSpPr>
-          <p:cNvPr id="11" name="Text 9"/>
-          <p:cNvSpPr/>
-          <p:nvPr/>
-        </p:nvSpPr>
-        <p:spPr>
-          <a:xfrm>
-            <a:off x="822960" y="4069080"/>
-            <a:ext cx="3154680" cy="1325880"/>
+          <p:cNvPr id="12" name="Shape 10"/>
+          <p:cNvSpPr/>
+          <p:nvPr/>
+        </p:nvSpPr>
+        <p:spPr>
+          <a:xfrm>
+            <a:off x="4663440" y="2514600"/>
+            <a:ext cx="1554480" cy="292608"/>
+          </a:xfrm>
+          <a:prstGeom prst="roundRect">
+            <a:avLst>
+              <a:gd name="adj" fmla="val 50000"/>
+            </a:avLst>
+          </a:prstGeom>
+          <a:solidFill>
+            <a:srgbClr val="6366F1"/>
+          </a:solidFill>
+          <a:ln w="12700">
+            <a:solidFill>
+              <a:srgbClr val="6366F1"/>
+            </a:solidFill>
+            <a:prstDash val="solid"/>
+          </a:ln>
+        </p:spPr>
+      </p:sp>
+      <p:sp>
+        <p:nvSpPr>
+          <p:cNvPr id="13" name="Text 11"/>
+          <p:cNvSpPr/>
+          <p:nvPr/>
+        </p:nvSpPr>
+        <p:spPr>
+          <a:xfrm>
+            <a:off x="4663440" y="2514600"/>
+            <a:ext cx="1554480" cy="292608"/>
           </a:xfrm>
           <a:prstGeom prst="rect">
             <a:avLst/>
@@ -15758,50 +15830,124 @@
           <a:bodyPr wrap="square" rtlCol="0" anchor="ctr"/>
           <a:lstStyle/>
           <a:p>
-            <a:pPr indent="0" marL="0">
-              <a:spcAft>
-                <a:spcPts val="400"/>
-              </a:spcAft>
-              <a:buNone/>
-            </a:pPr>
-            <a:r>
-              <a:rPr lang="en-US" sz="1300" dirty="0">
-                <a:solidFill>
-                  <a:srgbClr val="0F0A2E"/>
+            <a:pPr algn="ctr" indent="0" marL="0">
+              <a:buNone/>
+            </a:pPr>
+            <a:r>
+              <a:rPr lang="en-US" sz="900" b="1" spc="200" kern="0" dirty="0">
+                <a:solidFill>
+                  <a:srgbClr val="FAF8FF"/>
                 </a:solidFill>
                 <a:latin typeface="Calibri" pitchFamily="34" charset="0"/>
                 <a:ea typeface="Calibri" pitchFamily="34" charset="-122"/>
                 <a:cs typeface="Calibri" pitchFamily="34" charset="-120"/>
               </a:rPr>
-              <a:t>iOS 26 · macOS 26 Tahoe</a:t>
-            </a:r>
-            <a:endParaRPr lang="en-US" sz="1300" dirty="0"/>
-          </a:p>
-          <a:p>
-            <a:pPr indent="0" marL="0">
-              <a:spcAft>
-                <a:spcPts val="400"/>
-              </a:spcAft>
-              <a:buNone/>
-            </a:pPr>
-            <a:r>
-              <a:rPr lang="en-US" sz="1300" dirty="0">
+              <a:t>FLEXIBLE</a:t>
+            </a:r>
+            <a:endParaRPr lang="en-US" sz="900" dirty="0"/>
+          </a:p>
+        </p:txBody>
+      </p:sp>
+      <p:sp>
+        <p:nvSpPr>
+          <p:cNvPr id="14" name="Text 12"/>
+          <p:cNvSpPr/>
+          <p:nvPr/>
+        </p:nvSpPr>
+        <p:spPr>
+          <a:xfrm>
+            <a:off x="4663440" y="2971800"/>
+            <a:ext cx="3154680" cy="548640"/>
+          </a:xfrm>
+          <a:prstGeom prst="rect">
+            <a:avLst/>
+          </a:prstGeom>
+          <a:noFill/>
+          <a:ln/>
+        </p:spPr>
+        <p:txBody>
+          <a:bodyPr wrap="square" rtlCol="0" anchor="ctr"/>
+          <a:lstStyle/>
+          <a:p>
+            <a:pPr indent="0" marL="0">
+              <a:buNone/>
+            </a:pPr>
+            <a:r>
+              <a:rPr lang="en-US" sz="2200" b="1" dirty="0">
                 <a:solidFill>
                   <a:srgbClr val="0F0A2E"/>
+                </a:solidFill>
+                <a:latin typeface="Georgia" pitchFamily="34" charset="0"/>
+                <a:ea typeface="Georgia" pitchFamily="34" charset="-122"/>
+                <a:cs typeface="Georgia" pitchFamily="34" charset="-120"/>
+              </a:rPr>
+              <a:t>ONNX Runtime GenAI</a:t>
+            </a:r>
+            <a:endParaRPr lang="en-US" sz="2200" dirty="0"/>
+          </a:p>
+        </p:txBody>
+      </p:sp>
+      <p:sp>
+        <p:nvSpPr>
+          <p:cNvPr id="15" name="Text 13"/>
+          <p:cNvSpPr/>
+          <p:nvPr/>
+        </p:nvSpPr>
+        <p:spPr>
+          <a:xfrm>
+            <a:off x="4663440" y="3520440"/>
+            <a:ext cx="3154680" cy="365760"/>
+          </a:xfrm>
+          <a:prstGeom prst="rect">
+            <a:avLst/>
+          </a:prstGeom>
+          <a:noFill/>
+          <a:ln/>
+        </p:spPr>
+        <p:txBody>
+          <a:bodyPr wrap="square" rtlCol="0" anchor="ctr"/>
+          <a:lstStyle/>
+          <a:p>
+            <a:pPr indent="0" marL="0">
+              <a:buNone/>
+            </a:pPr>
+            <a:r>
+              <a:rPr lang="en-US" sz="1300" i="1" dirty="0">
+                <a:solidFill>
+                  <a:srgbClr val="6366F1"/>
                 </a:solidFill>
                 <a:latin typeface="Calibri" pitchFamily="34" charset="0"/>
                 <a:ea typeface="Calibri" pitchFamily="34" charset="-122"/>
                 <a:cs typeface="Calibri" pitchFamily="34" charset="-120"/>
               </a:rPr>
-              <a:t>Multilingual</a:t>
+              <a:t>Ship your own model</a:t>
             </a:r>
             <a:endParaRPr lang="en-US" sz="1300" dirty="0"/>
           </a:p>
-          <a:p>
-            <a:pPr indent="0" marL="0">
-              <a:spcAft>
-                <a:spcPts val="400"/>
-              </a:spcAft>
+        </p:txBody>
+      </p:sp>
+      <p:sp>
+        <p:nvSpPr>
+          <p:cNvPr id="16" name="Text 14"/>
+          <p:cNvSpPr/>
+          <p:nvPr/>
+        </p:nvSpPr>
+        <p:spPr>
+          <a:xfrm>
+            <a:off x="4663440" y="4023360"/>
+            <a:ext cx="3154680" cy="2011680"/>
+          </a:xfrm>
+          <a:prstGeom prst="rect">
+            <a:avLst/>
+          </a:prstGeom>
+          <a:noFill/>
+          <a:ln/>
+        </p:spPr>
+        <p:txBody>
+          <a:bodyPr wrap="square" rtlCol="0" anchor="ctr"/>
+          <a:lstStyle/>
+          <a:p>
+            <a:pPr indent="0" marL="0">
               <a:buNone/>
             </a:pPr>
             <a:r>
@@ -15813,7 +15959,217 @@
                 <a:ea typeface="Calibri" pitchFamily="34" charset="-122"/>
                 <a:cs typeface="Calibri" pitchFamily="34" charset="-120"/>
               </a:rPr>
-              <a:t>Tool calling</a:t>
+              <a:t>Cross-platform C# / native inference. Bring any ONNX-converted model — tiny custom classifiers to multi-billion-param LLMs.</a:t>
+            </a:r>
+            <a:endParaRPr lang="en-US" sz="1300" dirty="0"/>
+          </a:p>
+        </p:txBody>
+      </p:sp>
+      <p:sp>
+        <p:nvSpPr>
+          <p:cNvPr id="17" name="Shape 15"/>
+          <p:cNvSpPr/>
+          <p:nvPr/>
+        </p:nvSpPr>
+        <p:spPr>
+          <a:xfrm>
+            <a:off x="8229600" y="2286000"/>
+            <a:ext cx="3703320" cy="3931920"/>
+          </a:xfrm>
+          <a:prstGeom prst="roundRect">
+            <a:avLst>
+              <a:gd name="adj" fmla="val 2963"/>
+            </a:avLst>
+          </a:prstGeom>
+          <a:solidFill>
+            <a:srgbClr val="FFFFFF"/>
+          </a:solidFill>
+          <a:ln w="25400">
+            <a:solidFill>
+              <a:srgbClr val="FBBF24"/>
+            </a:solidFill>
+            <a:prstDash val="solid"/>
+          </a:ln>
+        </p:spPr>
+      </p:sp>
+      <p:sp>
+        <p:nvSpPr>
+          <p:cNvPr id="18" name="Shape 16"/>
+          <p:cNvSpPr/>
+          <p:nvPr/>
+        </p:nvSpPr>
+        <p:spPr>
+          <a:xfrm>
+            <a:off x="8503920" y="2514600"/>
+            <a:ext cx="1554480" cy="292608"/>
+          </a:xfrm>
+          <a:prstGeom prst="roundRect">
+            <a:avLst>
+              <a:gd name="adj" fmla="val 50000"/>
+            </a:avLst>
+          </a:prstGeom>
+          <a:solidFill>
+            <a:srgbClr val="FBBF24"/>
+          </a:solidFill>
+          <a:ln w="12700">
+            <a:solidFill>
+              <a:srgbClr val="FBBF24"/>
+            </a:solidFill>
+            <a:prstDash val="solid"/>
+          </a:ln>
+        </p:spPr>
+      </p:sp>
+      <p:sp>
+        <p:nvSpPr>
+          <p:cNvPr id="19" name="Text 17"/>
+          <p:cNvSpPr/>
+          <p:nvPr/>
+        </p:nvSpPr>
+        <p:spPr>
+          <a:xfrm>
+            <a:off x="8503920" y="2514600"/>
+            <a:ext cx="1554480" cy="292608"/>
+          </a:xfrm>
+          <a:prstGeom prst="rect">
+            <a:avLst/>
+          </a:prstGeom>
+          <a:noFill/>
+          <a:ln/>
+        </p:spPr>
+        <p:txBody>
+          <a:bodyPr wrap="square" rtlCol="0" anchor="ctr"/>
+          <a:lstStyle/>
+          <a:p>
+            <a:pPr algn="ctr" indent="0" marL="0">
+              <a:buNone/>
+            </a:pPr>
+            <a:r>
+              <a:rPr lang="en-US" sz="900" b="1" spc="200" kern="0" dirty="0">
+                <a:solidFill>
+                  <a:srgbClr val="FAF8FF"/>
+                </a:solidFill>
+                <a:latin typeface="Calibri" pitchFamily="34" charset="0"/>
+                <a:ea typeface="Calibri" pitchFamily="34" charset="-122"/>
+                <a:cs typeface="Calibri" pitchFamily="34" charset="-120"/>
+              </a:rPr>
+              <a:t>UNDERRATED</a:t>
+            </a:r>
+            <a:endParaRPr lang="en-US" sz="900" dirty="0"/>
+          </a:p>
+        </p:txBody>
+      </p:sp>
+      <p:sp>
+        <p:nvSpPr>
+          <p:cNvPr id="20" name="Text 18"/>
+          <p:cNvSpPr/>
+          <p:nvPr/>
+        </p:nvSpPr>
+        <p:spPr>
+          <a:xfrm>
+            <a:off x="8503920" y="2971800"/>
+            <a:ext cx="3154680" cy="548640"/>
+          </a:xfrm>
+          <a:prstGeom prst="rect">
+            <a:avLst/>
+          </a:prstGeom>
+          <a:noFill/>
+          <a:ln/>
+        </p:spPr>
+        <p:txBody>
+          <a:bodyPr wrap="square" rtlCol="0" anchor="ctr"/>
+          <a:lstStyle/>
+          <a:p>
+            <a:pPr indent="0" marL="0">
+              <a:buNone/>
+            </a:pPr>
+            <a:r>
+              <a:rPr lang="en-US" sz="2200" b="1" dirty="0">
+                <a:solidFill>
+                  <a:srgbClr val="0F0A2E"/>
+                </a:solidFill>
+                <a:latin typeface="Georgia" pitchFamily="34" charset="0"/>
+                <a:ea typeface="Georgia" pitchFamily="34" charset="-122"/>
+                <a:cs typeface="Georgia" pitchFamily="34" charset="-120"/>
+              </a:rPr>
+              <a:t>Tiny Bespoke Models</a:t>
+            </a:r>
+            <a:endParaRPr lang="en-US" sz="2200" dirty="0"/>
+          </a:p>
+        </p:txBody>
+      </p:sp>
+      <p:sp>
+        <p:nvSpPr>
+          <p:cNvPr id="21" name="Text 19"/>
+          <p:cNvSpPr/>
+          <p:nvPr/>
+        </p:nvSpPr>
+        <p:spPr>
+          <a:xfrm>
+            <a:off x="8503920" y="3520440"/>
+            <a:ext cx="3154680" cy="365760"/>
+          </a:xfrm>
+          <a:prstGeom prst="rect">
+            <a:avLst/>
+          </a:prstGeom>
+          <a:noFill/>
+          <a:ln/>
+        </p:spPr>
+        <p:txBody>
+          <a:bodyPr wrap="square" rtlCol="0" anchor="ctr"/>
+          <a:lstStyle/>
+          <a:p>
+            <a:pPr indent="0" marL="0">
+              <a:buNone/>
+            </a:pPr>
+            <a:r>
+              <a:rPr lang="en-US" sz="1300" i="1" dirty="0">
+                <a:solidFill>
+                  <a:srgbClr val="FBBF24"/>
+                </a:solidFill>
+                <a:latin typeface="Calibri" pitchFamily="34" charset="0"/>
+                <a:ea typeface="Calibri" pitchFamily="34" charset="-122"/>
+                <a:cs typeface="Calibri" pitchFamily="34" charset="-120"/>
+              </a:rPr>
+              <a:t>Right-sized for the task</a:t>
+            </a:r>
+            <a:endParaRPr lang="en-US" sz="1300" dirty="0"/>
+          </a:p>
+        </p:txBody>
+      </p:sp>
+      <p:sp>
+        <p:nvSpPr>
+          <p:cNvPr id="22" name="Text 20"/>
+          <p:cNvSpPr/>
+          <p:nvPr/>
+        </p:nvSpPr>
+        <p:spPr>
+          <a:xfrm>
+            <a:off x="8503920" y="4023360"/>
+            <a:ext cx="3154680" cy="2011680"/>
+          </a:xfrm>
+          <a:prstGeom prst="rect">
+            <a:avLst/>
+          </a:prstGeom>
+          <a:noFill/>
+          <a:ln/>
+        </p:spPr>
+        <p:txBody>
+          <a:bodyPr wrap="square" rtlCol="0" anchor="ctr"/>
+          <a:lstStyle/>
+          <a:p>
+            <a:pPr indent="0" marL="0">
+              <a:buNone/>
+            </a:pPr>
+            <a:r>
+              <a:rPr lang="en-US" sz="1300" dirty="0">
+                <a:solidFill>
+                  <a:srgbClr val="0F0A2E"/>
+                </a:solidFill>
+                <a:latin typeface="Calibri" pitchFamily="34" charset="0"/>
+                <a:ea typeface="Calibri" pitchFamily="34" charset="-122"/>
+                <a:cs typeface="Calibri" pitchFamily="34" charset="-120"/>
+              </a:rPr>
+              <a:t>Sometimes a 50MB classifier beats a 3B LLM. Embeddings, intent detection, structured extraction — fast, cheap, embarrassingly good.</a:t>
             </a:r>
             <a:endParaRPr lang="en-US" sz="1300" dirty="0"/>
           </a:p>
@@ -15821,7 +16177,7 @@
       </p:sp>
       <p:pic>
         <p:nvPicPr>
-          <p:cNvPr id="12" name="Image 0" descr="preencoded.png">    </p:cNvPr>
+          <p:cNvPr id="23" name="Image 0" descr="preencoded.png">    </p:cNvPr>
           <p:cNvPicPr>
             <a:picLocks noChangeAspect="1"/>
           </p:cNvPicPr>
@@ -15841,330 +16197,17 @@
         </p:blipFill>
         <p:spPr>
           <a:xfrm>
-            <a:off x="822960" y="5458968"/>
-            <a:ext cx="237744" cy="237744"/>
+            <a:off x="10180015" y="502920"/>
+            <a:ext cx="329184" cy="329184"/>
           </a:xfrm>
           <a:prstGeom prst="rect">
             <a:avLst/>
           </a:prstGeom>
         </p:spPr>
       </p:pic>
-      <p:sp>
-        <p:nvSpPr>
-          <p:cNvPr id="13" name="Text 10"/>
-          <p:cNvSpPr/>
-          <p:nvPr/>
-        </p:nvSpPr>
-        <p:spPr>
-          <a:xfrm>
-            <a:off x="1115568" y="5440680"/>
-            <a:ext cx="2862072" cy="320040"/>
-          </a:xfrm>
-          <a:prstGeom prst="rect">
-            <a:avLst/>
-          </a:prstGeom>
-          <a:noFill/>
-          <a:ln/>
-        </p:spPr>
-        <p:txBody>
-          <a:bodyPr wrap="square" rtlCol="0" anchor="ctr"/>
-          <a:lstStyle/>
-          <a:p>
-            <a:pPr indent="0" marL="0">
-              <a:buNone/>
-            </a:pPr>
-            <a:r>
-              <a:rPr lang="en-US" sz="1200" b="1" dirty="0">
-                <a:solidFill>
-                  <a:srgbClr val="FB7185"/>
-                </a:solidFill>
-                <a:latin typeface="Calibri" pitchFamily="34" charset="0"/>
-                <a:ea typeface="Calibri" pitchFamily="34" charset="-122"/>
-                <a:cs typeface="Calibri" pitchFamily="34" charset="-120"/>
-              </a:rPr>
-              <a:t>IChatClient ready</a:t>
-            </a:r>
-            <a:endParaRPr lang="en-US" sz="1200" dirty="0"/>
-          </a:p>
-        </p:txBody>
-      </p:sp>
-      <p:sp>
-        <p:nvSpPr>
-          <p:cNvPr id="14" name="Shape 11"/>
-          <p:cNvSpPr/>
-          <p:nvPr/>
-        </p:nvSpPr>
-        <p:spPr>
-          <a:xfrm>
-            <a:off x="4389120" y="2286000"/>
-            <a:ext cx="3703320" cy="3566160"/>
-          </a:xfrm>
-          <a:prstGeom prst="roundRect">
-            <a:avLst>
-              <a:gd name="adj" fmla="val 3077"/>
-            </a:avLst>
-          </a:prstGeom>
-          <a:solidFill>
-            <a:srgbClr val="FFFFFF"/>
-          </a:solidFill>
-          <a:ln w="12700">
-            <a:solidFill>
-              <a:srgbClr val="E5E1F5"/>
-            </a:solidFill>
-            <a:prstDash val="solid"/>
-          </a:ln>
-        </p:spPr>
-      </p:sp>
-      <p:sp>
-        <p:nvSpPr>
-          <p:cNvPr id="15" name="Shape 12"/>
-          <p:cNvSpPr/>
-          <p:nvPr/>
-        </p:nvSpPr>
-        <p:spPr>
-          <a:xfrm>
-            <a:off x="4389120" y="2286000"/>
-            <a:ext cx="3703320" cy="164592"/>
-          </a:xfrm>
-          <a:prstGeom prst="rect">
-            <a:avLst/>
-          </a:prstGeom>
-          <a:solidFill>
-            <a:srgbClr val="6366F1"/>
-          </a:solidFill>
-          <a:ln w="12700">
-            <a:solidFill>
-              <a:srgbClr val="6366F1"/>
-            </a:solidFill>
-            <a:prstDash val="solid"/>
-          </a:ln>
-        </p:spPr>
-      </p:sp>
-      <p:sp>
-        <p:nvSpPr>
-          <p:cNvPr id="16" name="Text 13"/>
-          <p:cNvSpPr/>
-          <p:nvPr/>
-        </p:nvSpPr>
-        <p:spPr>
-          <a:xfrm>
-            <a:off x="4663440" y="2606040"/>
-            <a:ext cx="3154680" cy="320040"/>
-          </a:xfrm>
-          <a:prstGeom prst="rect">
-            <a:avLst/>
-          </a:prstGeom>
-          <a:noFill/>
-          <a:ln/>
-        </p:spPr>
-        <p:txBody>
-          <a:bodyPr wrap="square" rtlCol="0" anchor="ctr"/>
-          <a:lstStyle/>
-          <a:p>
-            <a:pPr indent="0" marL="0">
-              <a:buNone/>
-            </a:pPr>
-            <a:r>
-              <a:rPr lang="en-US" sz="1100" b="1" spc="300" kern="0" dirty="0">
-                <a:solidFill>
-                  <a:srgbClr val="6366F1"/>
-                </a:solidFill>
-                <a:latin typeface="Calibri" pitchFamily="34" charset="0"/>
-                <a:ea typeface="Calibri" pitchFamily="34" charset="-122"/>
-                <a:cs typeface="Calibri" pitchFamily="34" charset="-120"/>
-              </a:rPr>
-              <a:t>MICROSOFT</a:t>
-            </a:r>
-            <a:endParaRPr lang="en-US" sz="1100" dirty="0"/>
-          </a:p>
-        </p:txBody>
-      </p:sp>
-      <p:sp>
-        <p:nvSpPr>
-          <p:cNvPr id="17" name="Text 14"/>
-          <p:cNvSpPr/>
-          <p:nvPr/>
-        </p:nvSpPr>
-        <p:spPr>
-          <a:xfrm>
-            <a:off x="4663440" y="2926080"/>
-            <a:ext cx="3154680" cy="548640"/>
-          </a:xfrm>
-          <a:prstGeom prst="rect">
-            <a:avLst/>
-          </a:prstGeom>
-          <a:noFill/>
-          <a:ln/>
-        </p:spPr>
-        <p:txBody>
-          <a:bodyPr wrap="square" rtlCol="0" anchor="ctr"/>
-          <a:lstStyle/>
-          <a:p>
-            <a:pPr indent="0" marL="0">
-              <a:buNone/>
-            </a:pPr>
-            <a:r>
-              <a:rPr lang="en-US" sz="2200" b="1" dirty="0">
-                <a:solidFill>
-                  <a:srgbClr val="0F0A2E"/>
-                </a:solidFill>
-                <a:latin typeface="Georgia" pitchFamily="34" charset="0"/>
-                <a:ea typeface="Georgia" pitchFamily="34" charset="-122"/>
-                <a:cs typeface="Georgia" pitchFamily="34" charset="-120"/>
-              </a:rPr>
-              <a:t>Phi Silica</a:t>
-            </a:r>
-            <a:endParaRPr lang="en-US" sz="2200" dirty="0"/>
-          </a:p>
-        </p:txBody>
-      </p:sp>
-      <p:sp>
-        <p:nvSpPr>
-          <p:cNvPr id="18" name="Text 15"/>
-          <p:cNvSpPr/>
-          <p:nvPr/>
-        </p:nvSpPr>
-        <p:spPr>
-          <a:xfrm>
-            <a:off x="4663440" y="3474720"/>
-            <a:ext cx="3154680" cy="365760"/>
-          </a:xfrm>
-          <a:prstGeom prst="rect">
-            <a:avLst/>
-          </a:prstGeom>
-          <a:noFill/>
-          <a:ln/>
-        </p:spPr>
-        <p:txBody>
-          <a:bodyPr wrap="square" rtlCol="0" anchor="ctr"/>
-          <a:lstStyle/>
-          <a:p>
-            <a:pPr indent="0" marL="0">
-              <a:buNone/>
-            </a:pPr>
-            <a:r>
-              <a:rPr lang="en-US" sz="1300" i="1" dirty="0">
-                <a:solidFill>
-                  <a:srgbClr val="6B6B8F"/>
-                </a:solidFill>
-                <a:latin typeface="Consolas" pitchFamily="34" charset="0"/>
-                <a:ea typeface="Consolas" pitchFamily="34" charset="-122"/>
-                <a:cs typeface="Consolas" pitchFamily="34" charset="-120"/>
-              </a:rPr>
-              <a:t>Windows AI APIs (.NET)</a:t>
-            </a:r>
-            <a:endParaRPr lang="en-US" sz="1300" dirty="0"/>
-          </a:p>
-        </p:txBody>
-      </p:sp>
-      <p:sp>
-        <p:nvSpPr>
-          <p:cNvPr id="19" name="Shape 16"/>
-          <p:cNvSpPr/>
-          <p:nvPr/>
-        </p:nvSpPr>
-        <p:spPr>
-          <a:xfrm>
-            <a:off x="4663440" y="3931920"/>
-            <a:ext cx="3154680" cy="0"/>
-          </a:xfrm>
-          <a:prstGeom prst="line">
-            <a:avLst/>
-          </a:prstGeom>
-          <a:noFill/>
-          <a:ln w="12700">
-            <a:solidFill>
-              <a:srgbClr val="E5E1F5"/>
-            </a:solidFill>
-            <a:prstDash val="solid"/>
-          </a:ln>
-        </p:spPr>
-      </p:sp>
-      <p:sp>
-        <p:nvSpPr>
-          <p:cNvPr id="20" name="Text 17"/>
-          <p:cNvSpPr/>
-          <p:nvPr/>
-        </p:nvSpPr>
-        <p:spPr>
-          <a:xfrm>
-            <a:off x="4663440" y="4069080"/>
-            <a:ext cx="3154680" cy="1325880"/>
-          </a:xfrm>
-          <a:prstGeom prst="rect">
-            <a:avLst/>
-          </a:prstGeom>
-          <a:noFill/>
-          <a:ln/>
-        </p:spPr>
-        <p:txBody>
-          <a:bodyPr wrap="square" rtlCol="0" anchor="ctr"/>
-          <a:lstStyle/>
-          <a:p>
-            <a:pPr indent="0" marL="0">
-              <a:spcAft>
-                <a:spcPts val="400"/>
-              </a:spcAft>
-              <a:buNone/>
-            </a:pPr>
-            <a:r>
-              <a:rPr lang="en-US" sz="1300" dirty="0">
-                <a:solidFill>
-                  <a:srgbClr val="0F0A2E"/>
-                </a:solidFill>
-                <a:latin typeface="Calibri" pitchFamily="34" charset="0"/>
-                <a:ea typeface="Calibri" pitchFamily="34" charset="-122"/>
-                <a:cs typeface="Calibri" pitchFamily="34" charset="-120"/>
-              </a:rPr>
-              <a:t>Copilot+ PCs · NPU-accelerated</a:t>
-            </a:r>
-            <a:endParaRPr lang="en-US" sz="1300" dirty="0"/>
-          </a:p>
-          <a:p>
-            <a:pPr indent="0" marL="0">
-              <a:spcAft>
-                <a:spcPts val="400"/>
-              </a:spcAft>
-              <a:buNone/>
-            </a:pPr>
-            <a:r>
-              <a:rPr lang="en-US" sz="1300" dirty="0">
-                <a:solidFill>
-                  <a:srgbClr val="0F0A2E"/>
-                </a:solidFill>
-                <a:latin typeface="Calibri" pitchFamily="34" charset="0"/>
-                <a:ea typeface="Calibri" pitchFamily="34" charset="-122"/>
-                <a:cs typeface="Calibri" pitchFamily="34" charset="-120"/>
-              </a:rPr>
-              <a:t>Small language model</a:t>
-            </a:r>
-            <a:endParaRPr lang="en-US" sz="1300" dirty="0"/>
-          </a:p>
-          <a:p>
-            <a:pPr indent="0" marL="0">
-              <a:spcAft>
-                <a:spcPts val="400"/>
-              </a:spcAft>
-              <a:buNone/>
-            </a:pPr>
-            <a:r>
-              <a:rPr lang="en-US" sz="1300" dirty="0">
-                <a:solidFill>
-                  <a:srgbClr val="0F0A2E"/>
-                </a:solidFill>
-                <a:latin typeface="Calibri" pitchFamily="34" charset="0"/>
-                <a:ea typeface="Calibri" pitchFamily="34" charset="-122"/>
-                <a:cs typeface="Calibri" pitchFamily="34" charset="-120"/>
-              </a:rPr>
-              <a:t>Summarize · rewrite · generate</a:t>
-            </a:r>
-            <a:endParaRPr lang="en-US" sz="1300" dirty="0"/>
-          </a:p>
-        </p:txBody>
-      </p:sp>
       <p:pic>
         <p:nvPicPr>
-          <p:cNvPr id="21" name="Image 1" descr="preencoded.png">    </p:cNvPr>
+          <p:cNvPr id="24" name="Image 1" descr="preencoded.png">    </p:cNvPr>
           <p:cNvPicPr>
             <a:picLocks noChangeAspect="1"/>
           </p:cNvPicPr>
@@ -16184,330 +16227,17 @@
         </p:blipFill>
         <p:spPr>
           <a:xfrm>
-            <a:off x="4663440" y="5458968"/>
-            <a:ext cx="237744" cy="237744"/>
+            <a:off x="10564063" y="502920"/>
+            <a:ext cx="329184" cy="329184"/>
           </a:xfrm>
           <a:prstGeom prst="rect">
             <a:avLst/>
           </a:prstGeom>
         </p:spPr>
       </p:pic>
-      <p:sp>
-        <p:nvSpPr>
-          <p:cNvPr id="22" name="Text 18"/>
-          <p:cNvSpPr/>
-          <p:nvPr/>
-        </p:nvSpPr>
-        <p:spPr>
-          <a:xfrm>
-            <a:off x="4956048" y="5440680"/>
-            <a:ext cx="2862072" cy="320040"/>
-          </a:xfrm>
-          <a:prstGeom prst="rect">
-            <a:avLst/>
-          </a:prstGeom>
-          <a:noFill/>
-          <a:ln/>
-        </p:spPr>
-        <p:txBody>
-          <a:bodyPr wrap="square" rtlCol="0" anchor="ctr"/>
-          <a:lstStyle/>
-          <a:p>
-            <a:pPr indent="0" marL="0">
-              <a:buNone/>
-            </a:pPr>
-            <a:r>
-              <a:rPr lang="en-US" sz="1200" b="1" dirty="0">
-                <a:solidFill>
-                  <a:srgbClr val="6366F1"/>
-                </a:solidFill>
-                <a:latin typeface="Calibri" pitchFamily="34" charset="0"/>
-                <a:ea typeface="Calibri" pitchFamily="34" charset="-122"/>
-                <a:cs typeface="Calibri" pitchFamily="34" charset="-120"/>
-              </a:rPr>
-              <a:t>IChatClient in PR #178</a:t>
-            </a:r>
-            <a:endParaRPr lang="en-US" sz="1200" dirty="0"/>
-          </a:p>
-        </p:txBody>
-      </p:sp>
-      <p:sp>
-        <p:nvSpPr>
-          <p:cNvPr id="23" name="Shape 19"/>
-          <p:cNvSpPr/>
-          <p:nvPr/>
-        </p:nvSpPr>
-        <p:spPr>
-          <a:xfrm>
-            <a:off x="8229600" y="2286000"/>
-            <a:ext cx="3703320" cy="3566160"/>
-          </a:xfrm>
-          <a:prstGeom prst="roundRect">
-            <a:avLst>
-              <a:gd name="adj" fmla="val 3077"/>
-            </a:avLst>
-          </a:prstGeom>
-          <a:solidFill>
-            <a:srgbClr val="FFFFFF"/>
-          </a:solidFill>
-          <a:ln w="12700">
-            <a:solidFill>
-              <a:srgbClr val="E5E1F5"/>
-            </a:solidFill>
-            <a:prstDash val="solid"/>
-          </a:ln>
-        </p:spPr>
-      </p:sp>
-      <p:sp>
-        <p:nvSpPr>
-          <p:cNvPr id="24" name="Shape 20"/>
-          <p:cNvSpPr/>
-          <p:nvPr/>
-        </p:nvSpPr>
-        <p:spPr>
-          <a:xfrm>
-            <a:off x="8229600" y="2286000"/>
-            <a:ext cx="3703320" cy="164592"/>
-          </a:xfrm>
-          <a:prstGeom prst="rect">
-            <a:avLst/>
-          </a:prstGeom>
-          <a:solidFill>
-            <a:srgbClr val="FBBF24"/>
-          </a:solidFill>
-          <a:ln w="12700">
-            <a:solidFill>
-              <a:srgbClr val="FBBF24"/>
-            </a:solidFill>
-            <a:prstDash val="solid"/>
-          </a:ln>
-        </p:spPr>
-      </p:sp>
-      <p:sp>
-        <p:nvSpPr>
-          <p:cNvPr id="25" name="Text 21"/>
-          <p:cNvSpPr/>
-          <p:nvPr/>
-        </p:nvSpPr>
-        <p:spPr>
-          <a:xfrm>
-            <a:off x="8503920" y="2606040"/>
-            <a:ext cx="3154680" cy="320040"/>
-          </a:xfrm>
-          <a:prstGeom prst="rect">
-            <a:avLst/>
-          </a:prstGeom>
-          <a:noFill/>
-          <a:ln/>
-        </p:spPr>
-        <p:txBody>
-          <a:bodyPr wrap="square" rtlCol="0" anchor="ctr"/>
-          <a:lstStyle/>
-          <a:p>
-            <a:pPr indent="0" marL="0">
-              <a:buNone/>
-            </a:pPr>
-            <a:r>
-              <a:rPr lang="en-US" sz="1100" b="1" spc="300" kern="0" dirty="0">
-                <a:solidFill>
-                  <a:srgbClr val="FBBF24"/>
-                </a:solidFill>
-                <a:latin typeface="Calibri" pitchFamily="34" charset="0"/>
-                <a:ea typeface="Calibri" pitchFamily="34" charset="-122"/>
-                <a:cs typeface="Calibri" pitchFamily="34" charset="-120"/>
-              </a:rPr>
-              <a:t>GOOGLE</a:t>
-            </a:r>
-            <a:endParaRPr lang="en-US" sz="1100" dirty="0"/>
-          </a:p>
-        </p:txBody>
-      </p:sp>
-      <p:sp>
-        <p:nvSpPr>
-          <p:cNvPr id="26" name="Text 22"/>
-          <p:cNvSpPr/>
-          <p:nvPr/>
-        </p:nvSpPr>
-        <p:spPr>
-          <a:xfrm>
-            <a:off x="8503920" y="2926080"/>
-            <a:ext cx="3154680" cy="548640"/>
-          </a:xfrm>
-          <a:prstGeom prst="rect">
-            <a:avLst/>
-          </a:prstGeom>
-          <a:noFill/>
-          <a:ln/>
-        </p:spPr>
-        <p:txBody>
-          <a:bodyPr wrap="square" rtlCol="0" anchor="ctr"/>
-          <a:lstStyle/>
-          <a:p>
-            <a:pPr indent="0" marL="0">
-              <a:buNone/>
-            </a:pPr>
-            <a:r>
-              <a:rPr lang="en-US" sz="2200" b="1" dirty="0">
-                <a:solidFill>
-                  <a:srgbClr val="0F0A2E"/>
-                </a:solidFill>
-                <a:latin typeface="Georgia" pitchFamily="34" charset="0"/>
-                <a:ea typeface="Georgia" pitchFamily="34" charset="-122"/>
-                <a:cs typeface="Georgia" pitchFamily="34" charset="-120"/>
-              </a:rPr>
-              <a:t>ML Kit + Gemini Nano</a:t>
-            </a:r>
-            <a:endParaRPr lang="en-US" sz="2200" dirty="0"/>
-          </a:p>
-        </p:txBody>
-      </p:sp>
-      <p:sp>
-        <p:nvSpPr>
-          <p:cNvPr id="27" name="Text 23"/>
-          <p:cNvSpPr/>
-          <p:nvPr/>
-        </p:nvSpPr>
-        <p:spPr>
-          <a:xfrm>
-            <a:off x="8503920" y="3474720"/>
-            <a:ext cx="3154680" cy="365760"/>
-          </a:xfrm>
-          <a:prstGeom prst="rect">
-            <a:avLst/>
-          </a:prstGeom>
-          <a:noFill/>
-          <a:ln/>
-        </p:spPr>
-        <p:txBody>
-          <a:bodyPr wrap="square" rtlCol="0" anchor="ctr"/>
-          <a:lstStyle/>
-          <a:p>
-            <a:pPr indent="0" marL="0">
-              <a:buNone/>
-            </a:pPr>
-            <a:r>
-              <a:rPr lang="en-US" sz="1300" i="1" dirty="0">
-                <a:solidFill>
-                  <a:srgbClr val="6B6B8F"/>
-                </a:solidFill>
-                <a:latin typeface="Consolas" pitchFamily="34" charset="0"/>
-                <a:ea typeface="Consolas" pitchFamily="34" charset="-122"/>
-                <a:cs typeface="Consolas" pitchFamily="34" charset="-120"/>
-              </a:rPr>
-              <a:t>ML Kit (Kotlin/Java)</a:t>
-            </a:r>
-            <a:endParaRPr lang="en-US" sz="1300" dirty="0"/>
-          </a:p>
-        </p:txBody>
-      </p:sp>
-      <p:sp>
-        <p:nvSpPr>
-          <p:cNvPr id="28" name="Shape 24"/>
-          <p:cNvSpPr/>
-          <p:nvPr/>
-        </p:nvSpPr>
-        <p:spPr>
-          <a:xfrm>
-            <a:off x="8503920" y="3931920"/>
-            <a:ext cx="3154680" cy="0"/>
-          </a:xfrm>
-          <a:prstGeom prst="line">
-            <a:avLst/>
-          </a:prstGeom>
-          <a:noFill/>
-          <a:ln w="12700">
-            <a:solidFill>
-              <a:srgbClr val="E5E1F5"/>
-            </a:solidFill>
-            <a:prstDash val="solid"/>
-          </a:ln>
-        </p:spPr>
-      </p:sp>
-      <p:sp>
-        <p:nvSpPr>
-          <p:cNvPr id="29" name="Text 25"/>
-          <p:cNvSpPr/>
-          <p:nvPr/>
-        </p:nvSpPr>
-        <p:spPr>
-          <a:xfrm>
-            <a:off x="8503920" y="4069080"/>
-            <a:ext cx="3154680" cy="1325880"/>
-          </a:xfrm>
-          <a:prstGeom prst="rect">
-            <a:avLst/>
-          </a:prstGeom>
-          <a:noFill/>
-          <a:ln/>
-        </p:spPr>
-        <p:txBody>
-          <a:bodyPr wrap="square" rtlCol="0" anchor="ctr"/>
-          <a:lstStyle/>
-          <a:p>
-            <a:pPr indent="0" marL="0">
-              <a:spcAft>
-                <a:spcPts val="400"/>
-              </a:spcAft>
-              <a:buNone/>
-            </a:pPr>
-            <a:r>
-              <a:rPr lang="en-US" sz="1300" dirty="0">
-                <a:solidFill>
-                  <a:srgbClr val="0F0A2E"/>
-                </a:solidFill>
-                <a:latin typeface="Calibri" pitchFamily="34" charset="0"/>
-                <a:ea typeface="Calibri" pitchFamily="34" charset="-122"/>
-                <a:cs typeface="Calibri" pitchFamily="34" charset="-120"/>
-              </a:rPr>
-              <a:t>Android · AICore service</a:t>
-            </a:r>
-            <a:endParaRPr lang="en-US" sz="1300" dirty="0"/>
-          </a:p>
-          <a:p>
-            <a:pPr indent="0" marL="0">
-              <a:spcAft>
-                <a:spcPts val="400"/>
-              </a:spcAft>
-              <a:buNone/>
-            </a:pPr>
-            <a:r>
-              <a:rPr lang="en-US" sz="1300" dirty="0">
-                <a:solidFill>
-                  <a:srgbClr val="0F0A2E"/>
-                </a:solidFill>
-                <a:latin typeface="Calibri" pitchFamily="34" charset="0"/>
-                <a:ea typeface="Calibri" pitchFamily="34" charset="-122"/>
-                <a:cs typeface="Calibri" pitchFamily="34" charset="-120"/>
-              </a:rPr>
-              <a:t>Compact Gemini Nano</a:t>
-            </a:r>
-            <a:endParaRPr lang="en-US" sz="1300" dirty="0"/>
-          </a:p>
-          <a:p>
-            <a:pPr indent="0" marL="0">
-              <a:spcAft>
-                <a:spcPts val="400"/>
-              </a:spcAft>
-              <a:buNone/>
-            </a:pPr>
-            <a:r>
-              <a:rPr lang="en-US" sz="1300" dirty="0">
-                <a:solidFill>
-                  <a:srgbClr val="0F0A2E"/>
-                </a:solidFill>
-                <a:latin typeface="Calibri" pitchFamily="34" charset="0"/>
-                <a:ea typeface="Calibri" pitchFamily="34" charset="-122"/>
-                <a:cs typeface="Calibri" pitchFamily="34" charset="-120"/>
-              </a:rPr>
-              <a:t>Summarize · proofread · rewrite</a:t>
-            </a:r>
-            <a:endParaRPr lang="en-US" sz="1300" dirty="0"/>
-          </a:p>
-        </p:txBody>
-      </p:sp>
       <p:pic>
         <p:nvPicPr>
-          <p:cNvPr id="30" name="Image 2" descr="preencoded.png">    </p:cNvPr>
+          <p:cNvPr id="25" name="Image 2" descr="preencoded.png">    </p:cNvPr>
           <p:cNvPicPr>
             <a:picLocks noChangeAspect="1"/>
           </p:cNvPicPr>
@@ -16527,6 +16257,1265 @@
         </p:blipFill>
         <p:spPr>
           <a:xfrm>
+            <a:off x="10948111" y="502920"/>
+            <a:ext cx="329184" cy="329184"/>
+          </a:xfrm>
+          <a:prstGeom prst="rect">
+            <a:avLst/>
+          </a:prstGeom>
+        </p:spPr>
+      </p:pic>
+      <p:sp>
+        <p:nvSpPr>
+          <p:cNvPr id="26" name="Text 21"/>
+          <p:cNvSpPr/>
+          <p:nvPr/>
+        </p:nvSpPr>
+        <p:spPr>
+          <a:xfrm>
+            <a:off x="457200" y="6446520"/>
+            <a:ext cx="7315200" cy="274320"/>
+          </a:xfrm>
+          <a:prstGeom prst="rect">
+            <a:avLst/>
+          </a:prstGeom>
+          <a:noFill/>
+          <a:ln/>
+        </p:spPr>
+        <p:txBody>
+          <a:bodyPr wrap="square" rtlCol="0" anchor="ctr"/>
+          <a:lstStyle/>
+          <a:p>
+            <a:pPr algn="l" indent="0" marL="0">
+              <a:buNone/>
+            </a:pPr>
+            <a:r>
+              <a:rPr lang="en-US" sz="1000" dirty="0">
+                <a:solidFill>
+                  <a:srgbClr val="6B6B8F"/>
+                </a:solidFill>
+                <a:latin typeface="Calibri" pitchFamily="34" charset="0"/>
+                <a:ea typeface="Calibri" pitchFamily="34" charset="-122"/>
+                <a:cs typeface="Calibri" pitchFamily="34" charset="-120"/>
+              </a:rPr>
+              <a:t>Unifying Local and Cloud AI</a:t>
+            </a:r>
+            <a:pPr algn="l" indent="0" marL="0">
+              <a:buNone/>
+            </a:pPr>
+            <a:r>
+              <a:rPr lang="en-US" sz="1000" dirty="0">
+                <a:solidFill>
+                  <a:srgbClr val="6B6B8F"/>
+                </a:solidFill>
+                <a:latin typeface="Calibri" pitchFamily="34" charset="0"/>
+                <a:ea typeface="Calibri" pitchFamily="34" charset="-122"/>
+                <a:cs typeface="Calibri" pitchFamily="34" charset="-120"/>
+              </a:rPr>
+              <a:t>  ·  </a:t>
+            </a:r>
+            <a:pPr algn="l" indent="0" marL="0">
+              <a:buNone/>
+            </a:pPr>
+            <a:r>
+              <a:rPr lang="en-US" sz="1000" b="1" dirty="0">
+                <a:solidFill>
+                  <a:srgbClr val="FB7185"/>
+                </a:solidFill>
+                <a:latin typeface="Calibri" pitchFamily="34" charset="0"/>
+                <a:ea typeface="Calibri" pitchFamily="34" charset="-122"/>
+                <a:cs typeface="Calibri" pitchFamily="34" charset="-120"/>
+              </a:rPr>
+              <a:t>@mattleibow</a:t>
+            </a:r>
+            <a:pPr algn="l" indent="0" marL="0">
+              <a:buNone/>
+            </a:pPr>
+            <a:r>
+              <a:rPr lang="en-US" sz="1000" dirty="0">
+                <a:solidFill>
+                  <a:srgbClr val="6B6B8F"/>
+                </a:solidFill>
+                <a:latin typeface="Calibri" pitchFamily="34" charset="0"/>
+                <a:ea typeface="Calibri" pitchFamily="34" charset="-122"/>
+                <a:cs typeface="Calibri" pitchFamily="34" charset="-120"/>
+              </a:rPr>
+              <a:t>  ·  @CPTMSDUG</a:t>
+            </a:r>
+            <a:endParaRPr lang="en-US" sz="1000" dirty="0"/>
+          </a:p>
+        </p:txBody>
+      </p:sp>
+      <p:sp>
+        <p:nvSpPr>
+          <p:cNvPr id="27" name="Text 22"/>
+          <p:cNvSpPr/>
+          <p:nvPr/>
+        </p:nvSpPr>
+        <p:spPr>
+          <a:xfrm>
+            <a:off x="10820095" y="6446520"/>
+            <a:ext cx="914400" cy="274320"/>
+          </a:xfrm>
+          <a:prstGeom prst="rect">
+            <a:avLst/>
+          </a:prstGeom>
+          <a:noFill/>
+          <a:ln/>
+        </p:spPr>
+        <p:txBody>
+          <a:bodyPr wrap="square" rtlCol="0" anchor="ctr"/>
+          <a:lstStyle/>
+          <a:p>
+            <a:pPr algn="r" indent="0" marL="0">
+              <a:buNone/>
+            </a:pPr>
+            <a:r>
+              <a:rPr lang="en-US" sz="1000" dirty="0">
+                <a:solidFill>
+                  <a:srgbClr val="6B6B8F"/>
+                </a:solidFill>
+                <a:latin typeface="Calibri" pitchFamily="34" charset="0"/>
+                <a:ea typeface="Calibri" pitchFamily="34" charset="-122"/>
+                <a:cs typeface="Calibri" pitchFamily="34" charset="-120"/>
+              </a:rPr>
+              <a:t>5 / 15</a:t>
+            </a:r>
+            <a:endParaRPr lang="en-US" sz="1000" dirty="0"/>
+          </a:p>
+        </p:txBody>
+      </p:sp>
+    </p:spTree>
+  </p:cSld>
+  <p:clrMapOvr>
+    <a:masterClrMapping/>
+  </p:clrMapOvr>
+</p:sld>
+</file>
+
+<file path=ppt/slides/slide6.xml><?xml version="1.0" encoding="utf-8"?>
+<p:sld xmlns:a="http://schemas.openxmlformats.org/drawingml/2006/main" xmlns:r="http://schemas.openxmlformats.org/officeDocument/2006/relationships" xmlns:p="http://schemas.openxmlformats.org/presentationml/2006/main">
+  <p:cSld name="Slide 6">
+    <p:bg>
+      <p:bgPr>
+        <a:solidFill>
+          <a:srgbClr val="FAF8FF"/>
+        </a:solidFill>
+      </p:bgPr>
+    </p:bg>
+    <p:spTree>
+      <p:nvGrpSpPr>
+        <p:cNvPr id="1" name=""/>
+        <p:cNvGrpSpPr/>
+        <p:nvPr/>
+      </p:nvGrpSpPr>
+      <p:grpSpPr>
+        <a:xfrm>
+          <a:off x="0" y="0"/>
+          <a:ext cx="0" cy="0"/>
+          <a:chOff x="0" y="0"/>
+          <a:chExt cx="0" cy="0"/>
+        </a:xfrm>
+      </p:grpSpPr>
+      <p:sp>
+        <p:nvSpPr>
+          <p:cNvPr id="2" name="Text 0"/>
+          <p:cNvSpPr/>
+          <p:nvPr/>
+        </p:nvSpPr>
+        <p:spPr>
+          <a:xfrm>
+            <a:off x="548640" y="502920"/>
+            <a:ext cx="7315200" cy="320040"/>
+          </a:xfrm>
+          <a:prstGeom prst="rect">
+            <a:avLst/>
+          </a:prstGeom>
+          <a:noFill/>
+          <a:ln/>
+        </p:spPr>
+        <p:txBody>
+          <a:bodyPr wrap="square" rtlCol="0" anchor="ctr"/>
+          <a:lstStyle/>
+          <a:p>
+            <a:pPr indent="0" marL="0">
+              <a:buNone/>
+            </a:pPr>
+            <a:r>
+              <a:rPr lang="en-US" sz="1200" b="1" spc="400" kern="0" dirty="0">
+                <a:solidFill>
+                  <a:srgbClr val="FB7185"/>
+                </a:solidFill>
+                <a:latin typeface="Calibri" pitchFamily="34" charset="0"/>
+                <a:ea typeface="Calibri" pitchFamily="34" charset="-122"/>
+                <a:cs typeface="Calibri" pitchFamily="34" charset="-120"/>
+              </a:rPr>
+              <a:t>TIER 1  ·  THE SURPRISE</a:t>
+            </a:r>
+            <a:endParaRPr lang="en-US" sz="1200" dirty="0"/>
+          </a:p>
+        </p:txBody>
+      </p:sp>
+      <p:sp>
+        <p:nvSpPr>
+          <p:cNvPr id="3" name="Text 1"/>
+          <p:cNvSpPr/>
+          <p:nvPr/>
+        </p:nvSpPr>
+        <p:spPr>
+          <a:xfrm>
+            <a:off x="548640" y="822960"/>
+            <a:ext cx="10058400" cy="822960"/>
+          </a:xfrm>
+          <a:prstGeom prst="rect">
+            <a:avLst/>
+          </a:prstGeom>
+          <a:noFill/>
+          <a:ln/>
+        </p:spPr>
+        <p:txBody>
+          <a:bodyPr wrap="square" rtlCol="0" anchor="ctr"/>
+          <a:lstStyle/>
+          <a:p>
+            <a:pPr indent="0" marL="0">
+              <a:buNone/>
+            </a:pPr>
+            <a:r>
+              <a:rPr lang="en-US" sz="3800" b="1" dirty="0">
+                <a:solidFill>
+                  <a:srgbClr val="0F0A2E"/>
+                </a:solidFill>
+                <a:latin typeface="Georgia" pitchFamily="34" charset="0"/>
+                <a:ea typeface="Georgia" pitchFamily="34" charset="-122"/>
+                <a:cs typeface="Georgia" pitchFamily="34" charset="-120"/>
+              </a:rPr>
+              <a:t>Your OS already ships an LLM</a:t>
+            </a:r>
+            <a:endParaRPr lang="en-US" sz="3800" dirty="0"/>
+          </a:p>
+        </p:txBody>
+      </p:sp>
+      <p:sp>
+        <p:nvSpPr>
+          <p:cNvPr id="4" name="Text 2"/>
+          <p:cNvSpPr/>
+          <p:nvPr/>
+        </p:nvSpPr>
+        <p:spPr>
+          <a:xfrm>
+            <a:off x="548640" y="1600200"/>
+            <a:ext cx="10972800" cy="457200"/>
+          </a:xfrm>
+          <a:prstGeom prst="rect">
+            <a:avLst/>
+          </a:prstGeom>
+          <a:noFill/>
+          <a:ln/>
+        </p:spPr>
+        <p:txBody>
+          <a:bodyPr wrap="square" rtlCol="0" anchor="ctr"/>
+          <a:lstStyle/>
+          <a:p>
+            <a:pPr indent="0" marL="0">
+              <a:buNone/>
+            </a:pPr>
+            <a:r>
+              <a:rPr lang="en-US" sz="1700" i="1" dirty="0">
+                <a:solidFill>
+                  <a:srgbClr val="6B6B8F"/>
+                </a:solidFill>
+                <a:latin typeface="Calibri" pitchFamily="34" charset="0"/>
+                <a:ea typeface="Calibri" pitchFamily="34" charset="-122"/>
+                <a:cs typeface="Calibri" pitchFamily="34" charset="-120"/>
+              </a:rPr>
+              <a:t>Vendor-managed, shared across apps, zero cost, fully offline. ~3B-class models.</a:t>
+            </a:r>
+            <a:endParaRPr lang="en-US" sz="1700" dirty="0"/>
+          </a:p>
+        </p:txBody>
+      </p:sp>
+      <p:sp>
+        <p:nvSpPr>
+          <p:cNvPr id="5" name="Shape 3"/>
+          <p:cNvSpPr/>
+          <p:nvPr/>
+        </p:nvSpPr>
+        <p:spPr>
+          <a:xfrm>
+            <a:off x="548640" y="2286000"/>
+            <a:ext cx="3703320" cy="3566160"/>
+          </a:xfrm>
+          <a:prstGeom prst="roundRect">
+            <a:avLst>
+              <a:gd name="adj" fmla="val 3077"/>
+            </a:avLst>
+          </a:prstGeom>
+          <a:solidFill>
+            <a:srgbClr val="FFFFFF"/>
+          </a:solidFill>
+          <a:ln w="12700">
+            <a:solidFill>
+              <a:srgbClr val="E5E1F5"/>
+            </a:solidFill>
+            <a:prstDash val="solid"/>
+          </a:ln>
+        </p:spPr>
+      </p:sp>
+      <p:sp>
+        <p:nvSpPr>
+          <p:cNvPr id="6" name="Shape 4"/>
+          <p:cNvSpPr/>
+          <p:nvPr/>
+        </p:nvSpPr>
+        <p:spPr>
+          <a:xfrm>
+            <a:off x="548640" y="2286000"/>
+            <a:ext cx="3703320" cy="164592"/>
+          </a:xfrm>
+          <a:prstGeom prst="rect">
+            <a:avLst/>
+          </a:prstGeom>
+          <a:solidFill>
+            <a:srgbClr val="FB7185"/>
+          </a:solidFill>
+          <a:ln w="12700">
+            <a:solidFill>
+              <a:srgbClr val="FB7185"/>
+            </a:solidFill>
+            <a:prstDash val="solid"/>
+          </a:ln>
+        </p:spPr>
+      </p:sp>
+      <p:sp>
+        <p:nvSpPr>
+          <p:cNvPr id="7" name="Text 5"/>
+          <p:cNvSpPr/>
+          <p:nvPr/>
+        </p:nvSpPr>
+        <p:spPr>
+          <a:xfrm>
+            <a:off x="822960" y="2606040"/>
+            <a:ext cx="3154680" cy="320040"/>
+          </a:xfrm>
+          <a:prstGeom prst="rect">
+            <a:avLst/>
+          </a:prstGeom>
+          <a:noFill/>
+          <a:ln/>
+        </p:spPr>
+        <p:txBody>
+          <a:bodyPr wrap="square" rtlCol="0" anchor="ctr"/>
+          <a:lstStyle/>
+          <a:p>
+            <a:pPr indent="0" marL="0">
+              <a:buNone/>
+            </a:pPr>
+            <a:r>
+              <a:rPr lang="en-US" sz="1100" b="1" spc="300" kern="0" dirty="0">
+                <a:solidFill>
+                  <a:srgbClr val="FB7185"/>
+                </a:solidFill>
+                <a:latin typeface="Calibri" pitchFamily="34" charset="0"/>
+                <a:ea typeface="Calibri" pitchFamily="34" charset="-122"/>
+                <a:cs typeface="Calibri" pitchFamily="34" charset="-120"/>
+              </a:rPr>
+              <a:t>APPLE</a:t>
+            </a:r>
+            <a:endParaRPr lang="en-US" sz="1100" dirty="0"/>
+          </a:p>
+        </p:txBody>
+      </p:sp>
+      <p:sp>
+        <p:nvSpPr>
+          <p:cNvPr id="8" name="Text 6"/>
+          <p:cNvSpPr/>
+          <p:nvPr/>
+        </p:nvSpPr>
+        <p:spPr>
+          <a:xfrm>
+            <a:off x="822960" y="2926080"/>
+            <a:ext cx="3154680" cy="548640"/>
+          </a:xfrm>
+          <a:prstGeom prst="rect">
+            <a:avLst/>
+          </a:prstGeom>
+          <a:noFill/>
+          <a:ln/>
+        </p:spPr>
+        <p:txBody>
+          <a:bodyPr wrap="square" rtlCol="0" anchor="ctr"/>
+          <a:lstStyle/>
+          <a:p>
+            <a:pPr indent="0" marL="0">
+              <a:buNone/>
+            </a:pPr>
+            <a:r>
+              <a:rPr lang="en-US" sz="2200" b="1" dirty="0">
+                <a:solidFill>
+                  <a:srgbClr val="0F0A2E"/>
+                </a:solidFill>
+                <a:latin typeface="Georgia" pitchFamily="34" charset="0"/>
+                <a:ea typeface="Georgia" pitchFamily="34" charset="-122"/>
+                <a:cs typeface="Georgia" pitchFamily="34" charset="-120"/>
+              </a:rPr>
+              <a:t>Apple Intelligence</a:t>
+            </a:r>
+            <a:endParaRPr lang="en-US" sz="2200" dirty="0"/>
+          </a:p>
+        </p:txBody>
+      </p:sp>
+      <p:sp>
+        <p:nvSpPr>
+          <p:cNvPr id="9" name="Text 7"/>
+          <p:cNvSpPr/>
+          <p:nvPr/>
+        </p:nvSpPr>
+        <p:spPr>
+          <a:xfrm>
+            <a:off x="822960" y="3474720"/>
+            <a:ext cx="3154680" cy="365760"/>
+          </a:xfrm>
+          <a:prstGeom prst="rect">
+            <a:avLst/>
+          </a:prstGeom>
+          <a:noFill/>
+          <a:ln/>
+        </p:spPr>
+        <p:txBody>
+          <a:bodyPr wrap="square" rtlCol="0" anchor="ctr"/>
+          <a:lstStyle/>
+          <a:p>
+            <a:pPr indent="0" marL="0">
+              <a:buNone/>
+            </a:pPr>
+            <a:r>
+              <a:rPr lang="en-US" sz="1300" i="1" dirty="0">
+                <a:solidFill>
+                  <a:srgbClr val="6B6B8F"/>
+                </a:solidFill>
+                <a:latin typeface="Consolas" pitchFamily="34" charset="0"/>
+                <a:ea typeface="Consolas" pitchFamily="34" charset="-122"/>
+                <a:cs typeface="Consolas" pitchFamily="34" charset="-120"/>
+              </a:rPr>
+              <a:t>FoundationModels (Swift)</a:t>
+            </a:r>
+            <a:endParaRPr lang="en-US" sz="1300" dirty="0"/>
+          </a:p>
+        </p:txBody>
+      </p:sp>
+      <p:sp>
+        <p:nvSpPr>
+          <p:cNvPr id="10" name="Shape 8"/>
+          <p:cNvSpPr/>
+          <p:nvPr/>
+        </p:nvSpPr>
+        <p:spPr>
+          <a:xfrm>
+            <a:off x="822960" y="3931920"/>
+            <a:ext cx="3154680" cy="0"/>
+          </a:xfrm>
+          <a:prstGeom prst="line">
+            <a:avLst/>
+          </a:prstGeom>
+          <a:noFill/>
+          <a:ln w="12700">
+            <a:solidFill>
+              <a:srgbClr val="E5E1F5"/>
+            </a:solidFill>
+            <a:prstDash val="solid"/>
+          </a:ln>
+        </p:spPr>
+      </p:sp>
+      <p:sp>
+        <p:nvSpPr>
+          <p:cNvPr id="11" name="Text 9"/>
+          <p:cNvSpPr/>
+          <p:nvPr/>
+        </p:nvSpPr>
+        <p:spPr>
+          <a:xfrm>
+            <a:off x="822960" y="4069080"/>
+            <a:ext cx="3154680" cy="1325880"/>
+          </a:xfrm>
+          <a:prstGeom prst="rect">
+            <a:avLst/>
+          </a:prstGeom>
+          <a:noFill/>
+          <a:ln/>
+        </p:spPr>
+        <p:txBody>
+          <a:bodyPr wrap="square" rtlCol="0" anchor="ctr"/>
+          <a:lstStyle/>
+          <a:p>
+            <a:pPr indent="0" marL="0">
+              <a:spcAft>
+                <a:spcPts val="400"/>
+              </a:spcAft>
+              <a:buNone/>
+            </a:pPr>
+            <a:r>
+              <a:rPr lang="en-US" sz="1300" dirty="0">
+                <a:solidFill>
+                  <a:srgbClr val="0F0A2E"/>
+                </a:solidFill>
+                <a:latin typeface="Calibri" pitchFamily="34" charset="0"/>
+                <a:ea typeface="Calibri" pitchFamily="34" charset="-122"/>
+                <a:cs typeface="Calibri" pitchFamily="34" charset="-120"/>
+              </a:rPr>
+              <a:t>iOS 26 · macOS 26 Tahoe</a:t>
+            </a:r>
+            <a:endParaRPr lang="en-US" sz="1300" dirty="0"/>
+          </a:p>
+          <a:p>
+            <a:pPr indent="0" marL="0">
+              <a:spcAft>
+                <a:spcPts val="400"/>
+              </a:spcAft>
+              <a:buNone/>
+            </a:pPr>
+            <a:r>
+              <a:rPr lang="en-US" sz="1300" dirty="0">
+                <a:solidFill>
+                  <a:srgbClr val="0F0A2E"/>
+                </a:solidFill>
+                <a:latin typeface="Calibri" pitchFamily="34" charset="0"/>
+                <a:ea typeface="Calibri" pitchFamily="34" charset="-122"/>
+                <a:cs typeface="Calibri" pitchFamily="34" charset="-120"/>
+              </a:rPr>
+              <a:t>Multilingual</a:t>
+            </a:r>
+            <a:endParaRPr lang="en-US" sz="1300" dirty="0"/>
+          </a:p>
+          <a:p>
+            <a:pPr indent="0" marL="0">
+              <a:spcAft>
+                <a:spcPts val="400"/>
+              </a:spcAft>
+              <a:buNone/>
+            </a:pPr>
+            <a:r>
+              <a:rPr lang="en-US" sz="1300" dirty="0">
+                <a:solidFill>
+                  <a:srgbClr val="0F0A2E"/>
+                </a:solidFill>
+                <a:latin typeface="Calibri" pitchFamily="34" charset="0"/>
+                <a:ea typeface="Calibri" pitchFamily="34" charset="-122"/>
+                <a:cs typeface="Calibri" pitchFamily="34" charset="-120"/>
+              </a:rPr>
+              <a:t>Tool calling</a:t>
+            </a:r>
+            <a:endParaRPr lang="en-US" sz="1300" dirty="0"/>
+          </a:p>
+        </p:txBody>
+      </p:sp>
+      <p:pic>
+        <p:nvPicPr>
+          <p:cNvPr id="12" name="Image 0" descr="preencoded.png">    </p:cNvPr>
+          <p:cNvPicPr>
+            <a:picLocks noChangeAspect="1"/>
+          </p:cNvPicPr>
+          <p:nvPr/>
+        </p:nvPicPr>
+        <p:blipFill>
+          <a:blip r:embed="rId1">
+            <a:extLst>
+              <a:ext uri="{96DAC541-7B7A-43D3-8B79-37D633B846F1}">
+                <asvg:svgBlip xmlns:asvg="http://schemas.microsoft.com/office/drawing/2016/SVG/main" r:embed="rId2"/>
+              </a:ext>
+            </a:extLst>
+          </a:blip>
+          <a:stretch>
+            <a:fillRect/>
+          </a:stretch>
+        </p:blipFill>
+        <p:spPr>
+          <a:xfrm>
+            <a:off x="822960" y="5458968"/>
+            <a:ext cx="237744" cy="237744"/>
+          </a:xfrm>
+          <a:prstGeom prst="rect">
+            <a:avLst/>
+          </a:prstGeom>
+        </p:spPr>
+      </p:pic>
+      <p:sp>
+        <p:nvSpPr>
+          <p:cNvPr id="13" name="Text 10"/>
+          <p:cNvSpPr/>
+          <p:nvPr/>
+        </p:nvSpPr>
+        <p:spPr>
+          <a:xfrm>
+            <a:off x="1115568" y="5440680"/>
+            <a:ext cx="2862072" cy="320040"/>
+          </a:xfrm>
+          <a:prstGeom prst="rect">
+            <a:avLst/>
+          </a:prstGeom>
+          <a:noFill/>
+          <a:ln/>
+        </p:spPr>
+        <p:txBody>
+          <a:bodyPr wrap="square" rtlCol="0" anchor="ctr"/>
+          <a:lstStyle/>
+          <a:p>
+            <a:pPr indent="0" marL="0">
+              <a:buNone/>
+            </a:pPr>
+            <a:r>
+              <a:rPr lang="en-US" sz="1200" b="1" dirty="0">
+                <a:solidFill>
+                  <a:srgbClr val="FB7185"/>
+                </a:solidFill>
+                <a:latin typeface="Calibri" pitchFamily="34" charset="0"/>
+                <a:ea typeface="Calibri" pitchFamily="34" charset="-122"/>
+                <a:cs typeface="Calibri" pitchFamily="34" charset="-120"/>
+              </a:rPr>
+              <a:t>IChatClient ready</a:t>
+            </a:r>
+            <a:endParaRPr lang="en-US" sz="1200" dirty="0"/>
+          </a:p>
+        </p:txBody>
+      </p:sp>
+      <p:sp>
+        <p:nvSpPr>
+          <p:cNvPr id="14" name="Shape 11"/>
+          <p:cNvSpPr/>
+          <p:nvPr/>
+        </p:nvSpPr>
+        <p:spPr>
+          <a:xfrm>
+            <a:off x="4389120" y="2286000"/>
+            <a:ext cx="3703320" cy="3566160"/>
+          </a:xfrm>
+          <a:prstGeom prst="roundRect">
+            <a:avLst>
+              <a:gd name="adj" fmla="val 3077"/>
+            </a:avLst>
+          </a:prstGeom>
+          <a:solidFill>
+            <a:srgbClr val="FFFFFF"/>
+          </a:solidFill>
+          <a:ln w="12700">
+            <a:solidFill>
+              <a:srgbClr val="E5E1F5"/>
+            </a:solidFill>
+            <a:prstDash val="solid"/>
+          </a:ln>
+        </p:spPr>
+      </p:sp>
+      <p:sp>
+        <p:nvSpPr>
+          <p:cNvPr id="15" name="Shape 12"/>
+          <p:cNvSpPr/>
+          <p:nvPr/>
+        </p:nvSpPr>
+        <p:spPr>
+          <a:xfrm>
+            <a:off x="4389120" y="2286000"/>
+            <a:ext cx="3703320" cy="164592"/>
+          </a:xfrm>
+          <a:prstGeom prst="rect">
+            <a:avLst/>
+          </a:prstGeom>
+          <a:solidFill>
+            <a:srgbClr val="6366F1"/>
+          </a:solidFill>
+          <a:ln w="12700">
+            <a:solidFill>
+              <a:srgbClr val="6366F1"/>
+            </a:solidFill>
+            <a:prstDash val="solid"/>
+          </a:ln>
+        </p:spPr>
+      </p:sp>
+      <p:sp>
+        <p:nvSpPr>
+          <p:cNvPr id="16" name="Text 13"/>
+          <p:cNvSpPr/>
+          <p:nvPr/>
+        </p:nvSpPr>
+        <p:spPr>
+          <a:xfrm>
+            <a:off x="4663440" y="2606040"/>
+            <a:ext cx="3154680" cy="320040"/>
+          </a:xfrm>
+          <a:prstGeom prst="rect">
+            <a:avLst/>
+          </a:prstGeom>
+          <a:noFill/>
+          <a:ln/>
+        </p:spPr>
+        <p:txBody>
+          <a:bodyPr wrap="square" rtlCol="0" anchor="ctr"/>
+          <a:lstStyle/>
+          <a:p>
+            <a:pPr indent="0" marL="0">
+              <a:buNone/>
+            </a:pPr>
+            <a:r>
+              <a:rPr lang="en-US" sz="1100" b="1" spc="300" kern="0" dirty="0">
+                <a:solidFill>
+                  <a:srgbClr val="6366F1"/>
+                </a:solidFill>
+                <a:latin typeface="Calibri" pitchFamily="34" charset="0"/>
+                <a:ea typeface="Calibri" pitchFamily="34" charset="-122"/>
+                <a:cs typeface="Calibri" pitchFamily="34" charset="-120"/>
+              </a:rPr>
+              <a:t>MICROSOFT</a:t>
+            </a:r>
+            <a:endParaRPr lang="en-US" sz="1100" dirty="0"/>
+          </a:p>
+        </p:txBody>
+      </p:sp>
+      <p:sp>
+        <p:nvSpPr>
+          <p:cNvPr id="17" name="Text 14"/>
+          <p:cNvSpPr/>
+          <p:nvPr/>
+        </p:nvSpPr>
+        <p:spPr>
+          <a:xfrm>
+            <a:off x="4663440" y="2926080"/>
+            <a:ext cx="3154680" cy="548640"/>
+          </a:xfrm>
+          <a:prstGeom prst="rect">
+            <a:avLst/>
+          </a:prstGeom>
+          <a:noFill/>
+          <a:ln/>
+        </p:spPr>
+        <p:txBody>
+          <a:bodyPr wrap="square" rtlCol="0" anchor="ctr"/>
+          <a:lstStyle/>
+          <a:p>
+            <a:pPr indent="0" marL="0">
+              <a:buNone/>
+            </a:pPr>
+            <a:r>
+              <a:rPr lang="en-US" sz="2200" b="1" dirty="0">
+                <a:solidFill>
+                  <a:srgbClr val="0F0A2E"/>
+                </a:solidFill>
+                <a:latin typeface="Georgia" pitchFamily="34" charset="0"/>
+                <a:ea typeface="Georgia" pitchFamily="34" charset="-122"/>
+                <a:cs typeface="Georgia" pitchFamily="34" charset="-120"/>
+              </a:rPr>
+              <a:t>Phi Silica</a:t>
+            </a:r>
+            <a:endParaRPr lang="en-US" sz="2200" dirty="0"/>
+          </a:p>
+        </p:txBody>
+      </p:sp>
+      <p:sp>
+        <p:nvSpPr>
+          <p:cNvPr id="18" name="Text 15"/>
+          <p:cNvSpPr/>
+          <p:nvPr/>
+        </p:nvSpPr>
+        <p:spPr>
+          <a:xfrm>
+            <a:off x="4663440" y="3474720"/>
+            <a:ext cx="3154680" cy="365760"/>
+          </a:xfrm>
+          <a:prstGeom prst="rect">
+            <a:avLst/>
+          </a:prstGeom>
+          <a:noFill/>
+          <a:ln/>
+        </p:spPr>
+        <p:txBody>
+          <a:bodyPr wrap="square" rtlCol="0" anchor="ctr"/>
+          <a:lstStyle/>
+          <a:p>
+            <a:pPr indent="0" marL="0">
+              <a:buNone/>
+            </a:pPr>
+            <a:r>
+              <a:rPr lang="en-US" sz="1300" i="1" dirty="0">
+                <a:solidFill>
+                  <a:srgbClr val="6B6B8F"/>
+                </a:solidFill>
+                <a:latin typeface="Consolas" pitchFamily="34" charset="0"/>
+                <a:ea typeface="Consolas" pitchFamily="34" charset="-122"/>
+                <a:cs typeface="Consolas" pitchFamily="34" charset="-120"/>
+              </a:rPr>
+              <a:t>Windows AI APIs (.NET)</a:t>
+            </a:r>
+            <a:endParaRPr lang="en-US" sz="1300" dirty="0"/>
+          </a:p>
+        </p:txBody>
+      </p:sp>
+      <p:sp>
+        <p:nvSpPr>
+          <p:cNvPr id="19" name="Shape 16"/>
+          <p:cNvSpPr/>
+          <p:nvPr/>
+        </p:nvSpPr>
+        <p:spPr>
+          <a:xfrm>
+            <a:off x="4663440" y="3931920"/>
+            <a:ext cx="3154680" cy="0"/>
+          </a:xfrm>
+          <a:prstGeom prst="line">
+            <a:avLst/>
+          </a:prstGeom>
+          <a:noFill/>
+          <a:ln w="12700">
+            <a:solidFill>
+              <a:srgbClr val="E5E1F5"/>
+            </a:solidFill>
+            <a:prstDash val="solid"/>
+          </a:ln>
+        </p:spPr>
+      </p:sp>
+      <p:sp>
+        <p:nvSpPr>
+          <p:cNvPr id="20" name="Text 17"/>
+          <p:cNvSpPr/>
+          <p:nvPr/>
+        </p:nvSpPr>
+        <p:spPr>
+          <a:xfrm>
+            <a:off x="4663440" y="4069080"/>
+            <a:ext cx="3154680" cy="1325880"/>
+          </a:xfrm>
+          <a:prstGeom prst="rect">
+            <a:avLst/>
+          </a:prstGeom>
+          <a:noFill/>
+          <a:ln/>
+        </p:spPr>
+        <p:txBody>
+          <a:bodyPr wrap="square" rtlCol="0" anchor="ctr"/>
+          <a:lstStyle/>
+          <a:p>
+            <a:pPr indent="0" marL="0">
+              <a:spcAft>
+                <a:spcPts val="400"/>
+              </a:spcAft>
+              <a:buNone/>
+            </a:pPr>
+            <a:r>
+              <a:rPr lang="en-US" sz="1300" dirty="0">
+                <a:solidFill>
+                  <a:srgbClr val="0F0A2E"/>
+                </a:solidFill>
+                <a:latin typeface="Calibri" pitchFamily="34" charset="0"/>
+                <a:ea typeface="Calibri" pitchFamily="34" charset="-122"/>
+                <a:cs typeface="Calibri" pitchFamily="34" charset="-120"/>
+              </a:rPr>
+              <a:t>Copilot+ PCs · NPU-accelerated</a:t>
+            </a:r>
+            <a:endParaRPr lang="en-US" sz="1300" dirty="0"/>
+          </a:p>
+          <a:p>
+            <a:pPr indent="0" marL="0">
+              <a:spcAft>
+                <a:spcPts val="400"/>
+              </a:spcAft>
+              <a:buNone/>
+            </a:pPr>
+            <a:r>
+              <a:rPr lang="en-US" sz="1300" dirty="0">
+                <a:solidFill>
+                  <a:srgbClr val="0F0A2E"/>
+                </a:solidFill>
+                <a:latin typeface="Calibri" pitchFamily="34" charset="0"/>
+                <a:ea typeface="Calibri" pitchFamily="34" charset="-122"/>
+                <a:cs typeface="Calibri" pitchFamily="34" charset="-120"/>
+              </a:rPr>
+              <a:t>Small language model</a:t>
+            </a:r>
+            <a:endParaRPr lang="en-US" sz="1300" dirty="0"/>
+          </a:p>
+          <a:p>
+            <a:pPr indent="0" marL="0">
+              <a:spcAft>
+                <a:spcPts val="400"/>
+              </a:spcAft>
+              <a:buNone/>
+            </a:pPr>
+            <a:r>
+              <a:rPr lang="en-US" sz="1300" dirty="0">
+                <a:solidFill>
+                  <a:srgbClr val="0F0A2E"/>
+                </a:solidFill>
+                <a:latin typeface="Calibri" pitchFamily="34" charset="0"/>
+                <a:ea typeface="Calibri" pitchFamily="34" charset="-122"/>
+                <a:cs typeface="Calibri" pitchFamily="34" charset="-120"/>
+              </a:rPr>
+              <a:t>Summarize · rewrite · generate</a:t>
+            </a:r>
+            <a:endParaRPr lang="en-US" sz="1300" dirty="0"/>
+          </a:p>
+        </p:txBody>
+      </p:sp>
+      <p:pic>
+        <p:nvPicPr>
+          <p:cNvPr id="21" name="Image 1" descr="preencoded.png">    </p:cNvPr>
+          <p:cNvPicPr>
+            <a:picLocks noChangeAspect="1"/>
+          </p:cNvPicPr>
+          <p:nvPr/>
+        </p:nvPicPr>
+        <p:blipFill>
+          <a:blip r:embed="rId3">
+            <a:extLst>
+              <a:ext uri="{96DAC541-7B7A-43D3-8B79-37D633B846F1}">
+                <asvg:svgBlip xmlns:asvg="http://schemas.microsoft.com/office/drawing/2016/SVG/main" r:embed="rId4"/>
+              </a:ext>
+            </a:extLst>
+          </a:blip>
+          <a:stretch>
+            <a:fillRect/>
+          </a:stretch>
+        </p:blipFill>
+        <p:spPr>
+          <a:xfrm>
+            <a:off x="4663440" y="5458968"/>
+            <a:ext cx="237744" cy="237744"/>
+          </a:xfrm>
+          <a:prstGeom prst="rect">
+            <a:avLst/>
+          </a:prstGeom>
+        </p:spPr>
+      </p:pic>
+      <p:sp>
+        <p:nvSpPr>
+          <p:cNvPr id="22" name="Text 18"/>
+          <p:cNvSpPr/>
+          <p:nvPr/>
+        </p:nvSpPr>
+        <p:spPr>
+          <a:xfrm>
+            <a:off x="4956048" y="5440680"/>
+            <a:ext cx="2862072" cy="320040"/>
+          </a:xfrm>
+          <a:prstGeom prst="rect">
+            <a:avLst/>
+          </a:prstGeom>
+          <a:noFill/>
+          <a:ln/>
+        </p:spPr>
+        <p:txBody>
+          <a:bodyPr wrap="square" rtlCol="0" anchor="ctr"/>
+          <a:lstStyle/>
+          <a:p>
+            <a:pPr indent="0" marL="0">
+              <a:buNone/>
+            </a:pPr>
+            <a:r>
+              <a:rPr lang="en-US" sz="1200" b="1" dirty="0">
+                <a:solidFill>
+                  <a:srgbClr val="6366F1"/>
+                </a:solidFill>
+                <a:latin typeface="Calibri" pitchFamily="34" charset="0"/>
+                <a:ea typeface="Calibri" pitchFamily="34" charset="-122"/>
+                <a:cs typeface="Calibri" pitchFamily="34" charset="-120"/>
+              </a:rPr>
+              <a:t>IChatClient in PR #178</a:t>
+            </a:r>
+            <a:endParaRPr lang="en-US" sz="1200" dirty="0"/>
+          </a:p>
+        </p:txBody>
+      </p:sp>
+      <p:sp>
+        <p:nvSpPr>
+          <p:cNvPr id="23" name="Shape 19"/>
+          <p:cNvSpPr/>
+          <p:nvPr/>
+        </p:nvSpPr>
+        <p:spPr>
+          <a:xfrm>
+            <a:off x="8229600" y="2286000"/>
+            <a:ext cx="3703320" cy="3566160"/>
+          </a:xfrm>
+          <a:prstGeom prst="roundRect">
+            <a:avLst>
+              <a:gd name="adj" fmla="val 3077"/>
+            </a:avLst>
+          </a:prstGeom>
+          <a:solidFill>
+            <a:srgbClr val="FFFFFF"/>
+          </a:solidFill>
+          <a:ln w="12700">
+            <a:solidFill>
+              <a:srgbClr val="E5E1F5"/>
+            </a:solidFill>
+            <a:prstDash val="solid"/>
+          </a:ln>
+        </p:spPr>
+      </p:sp>
+      <p:sp>
+        <p:nvSpPr>
+          <p:cNvPr id="24" name="Shape 20"/>
+          <p:cNvSpPr/>
+          <p:nvPr/>
+        </p:nvSpPr>
+        <p:spPr>
+          <a:xfrm>
+            <a:off x="8229600" y="2286000"/>
+            <a:ext cx="3703320" cy="164592"/>
+          </a:xfrm>
+          <a:prstGeom prst="rect">
+            <a:avLst/>
+          </a:prstGeom>
+          <a:solidFill>
+            <a:srgbClr val="FBBF24"/>
+          </a:solidFill>
+          <a:ln w="12700">
+            <a:solidFill>
+              <a:srgbClr val="FBBF24"/>
+            </a:solidFill>
+            <a:prstDash val="solid"/>
+          </a:ln>
+        </p:spPr>
+      </p:sp>
+      <p:sp>
+        <p:nvSpPr>
+          <p:cNvPr id="25" name="Text 21"/>
+          <p:cNvSpPr/>
+          <p:nvPr/>
+        </p:nvSpPr>
+        <p:spPr>
+          <a:xfrm>
+            <a:off x="8503920" y="2606040"/>
+            <a:ext cx="3154680" cy="320040"/>
+          </a:xfrm>
+          <a:prstGeom prst="rect">
+            <a:avLst/>
+          </a:prstGeom>
+          <a:noFill/>
+          <a:ln/>
+        </p:spPr>
+        <p:txBody>
+          <a:bodyPr wrap="square" rtlCol="0" anchor="ctr"/>
+          <a:lstStyle/>
+          <a:p>
+            <a:pPr indent="0" marL="0">
+              <a:buNone/>
+            </a:pPr>
+            <a:r>
+              <a:rPr lang="en-US" sz="1100" b="1" spc="300" kern="0" dirty="0">
+                <a:solidFill>
+                  <a:srgbClr val="FBBF24"/>
+                </a:solidFill>
+                <a:latin typeface="Calibri" pitchFamily="34" charset="0"/>
+                <a:ea typeface="Calibri" pitchFamily="34" charset="-122"/>
+                <a:cs typeface="Calibri" pitchFamily="34" charset="-120"/>
+              </a:rPr>
+              <a:t>GOOGLE</a:t>
+            </a:r>
+            <a:endParaRPr lang="en-US" sz="1100" dirty="0"/>
+          </a:p>
+        </p:txBody>
+      </p:sp>
+      <p:sp>
+        <p:nvSpPr>
+          <p:cNvPr id="26" name="Text 22"/>
+          <p:cNvSpPr/>
+          <p:nvPr/>
+        </p:nvSpPr>
+        <p:spPr>
+          <a:xfrm>
+            <a:off x="8503920" y="2926080"/>
+            <a:ext cx="3154680" cy="548640"/>
+          </a:xfrm>
+          <a:prstGeom prst="rect">
+            <a:avLst/>
+          </a:prstGeom>
+          <a:noFill/>
+          <a:ln/>
+        </p:spPr>
+        <p:txBody>
+          <a:bodyPr wrap="square" rtlCol="0" anchor="ctr"/>
+          <a:lstStyle/>
+          <a:p>
+            <a:pPr indent="0" marL="0">
+              <a:buNone/>
+            </a:pPr>
+            <a:r>
+              <a:rPr lang="en-US" sz="2200" b="1" dirty="0">
+                <a:solidFill>
+                  <a:srgbClr val="0F0A2E"/>
+                </a:solidFill>
+                <a:latin typeface="Georgia" pitchFamily="34" charset="0"/>
+                <a:ea typeface="Georgia" pitchFamily="34" charset="-122"/>
+                <a:cs typeface="Georgia" pitchFamily="34" charset="-120"/>
+              </a:rPr>
+              <a:t>ML Kit + Gemini Nano</a:t>
+            </a:r>
+            <a:endParaRPr lang="en-US" sz="2200" dirty="0"/>
+          </a:p>
+        </p:txBody>
+      </p:sp>
+      <p:sp>
+        <p:nvSpPr>
+          <p:cNvPr id="27" name="Text 23"/>
+          <p:cNvSpPr/>
+          <p:nvPr/>
+        </p:nvSpPr>
+        <p:spPr>
+          <a:xfrm>
+            <a:off x="8503920" y="3474720"/>
+            <a:ext cx="3154680" cy="365760"/>
+          </a:xfrm>
+          <a:prstGeom prst="rect">
+            <a:avLst/>
+          </a:prstGeom>
+          <a:noFill/>
+          <a:ln/>
+        </p:spPr>
+        <p:txBody>
+          <a:bodyPr wrap="square" rtlCol="0" anchor="ctr"/>
+          <a:lstStyle/>
+          <a:p>
+            <a:pPr indent="0" marL="0">
+              <a:buNone/>
+            </a:pPr>
+            <a:r>
+              <a:rPr lang="en-US" sz="1300" i="1" dirty="0">
+                <a:solidFill>
+                  <a:srgbClr val="6B6B8F"/>
+                </a:solidFill>
+                <a:latin typeface="Consolas" pitchFamily="34" charset="0"/>
+                <a:ea typeface="Consolas" pitchFamily="34" charset="-122"/>
+                <a:cs typeface="Consolas" pitchFamily="34" charset="-120"/>
+              </a:rPr>
+              <a:t>ML Kit (Kotlin/Java)</a:t>
+            </a:r>
+            <a:endParaRPr lang="en-US" sz="1300" dirty="0"/>
+          </a:p>
+        </p:txBody>
+      </p:sp>
+      <p:sp>
+        <p:nvSpPr>
+          <p:cNvPr id="28" name="Shape 24"/>
+          <p:cNvSpPr/>
+          <p:nvPr/>
+        </p:nvSpPr>
+        <p:spPr>
+          <a:xfrm>
+            <a:off x="8503920" y="3931920"/>
+            <a:ext cx="3154680" cy="0"/>
+          </a:xfrm>
+          <a:prstGeom prst="line">
+            <a:avLst/>
+          </a:prstGeom>
+          <a:noFill/>
+          <a:ln w="12700">
+            <a:solidFill>
+              <a:srgbClr val="E5E1F5"/>
+            </a:solidFill>
+            <a:prstDash val="solid"/>
+          </a:ln>
+        </p:spPr>
+      </p:sp>
+      <p:sp>
+        <p:nvSpPr>
+          <p:cNvPr id="29" name="Text 25"/>
+          <p:cNvSpPr/>
+          <p:nvPr/>
+        </p:nvSpPr>
+        <p:spPr>
+          <a:xfrm>
+            <a:off x="8503920" y="4069080"/>
+            <a:ext cx="3154680" cy="1325880"/>
+          </a:xfrm>
+          <a:prstGeom prst="rect">
+            <a:avLst/>
+          </a:prstGeom>
+          <a:noFill/>
+          <a:ln/>
+        </p:spPr>
+        <p:txBody>
+          <a:bodyPr wrap="square" rtlCol="0" anchor="ctr"/>
+          <a:lstStyle/>
+          <a:p>
+            <a:pPr indent="0" marL="0">
+              <a:spcAft>
+                <a:spcPts val="400"/>
+              </a:spcAft>
+              <a:buNone/>
+            </a:pPr>
+            <a:r>
+              <a:rPr lang="en-US" sz="1300" dirty="0">
+                <a:solidFill>
+                  <a:srgbClr val="0F0A2E"/>
+                </a:solidFill>
+                <a:latin typeface="Calibri" pitchFamily="34" charset="0"/>
+                <a:ea typeface="Calibri" pitchFamily="34" charset="-122"/>
+                <a:cs typeface="Calibri" pitchFamily="34" charset="-120"/>
+              </a:rPr>
+              <a:t>Android · AICore service</a:t>
+            </a:r>
+            <a:endParaRPr lang="en-US" sz="1300" dirty="0"/>
+          </a:p>
+          <a:p>
+            <a:pPr indent="0" marL="0">
+              <a:spcAft>
+                <a:spcPts val="400"/>
+              </a:spcAft>
+              <a:buNone/>
+            </a:pPr>
+            <a:r>
+              <a:rPr lang="en-US" sz="1300" dirty="0">
+                <a:solidFill>
+                  <a:srgbClr val="0F0A2E"/>
+                </a:solidFill>
+                <a:latin typeface="Calibri" pitchFamily="34" charset="0"/>
+                <a:ea typeface="Calibri" pitchFamily="34" charset="-122"/>
+                <a:cs typeface="Calibri" pitchFamily="34" charset="-120"/>
+              </a:rPr>
+              <a:t>Compact Gemini Nano</a:t>
+            </a:r>
+            <a:endParaRPr lang="en-US" sz="1300" dirty="0"/>
+          </a:p>
+          <a:p>
+            <a:pPr indent="0" marL="0">
+              <a:spcAft>
+                <a:spcPts val="400"/>
+              </a:spcAft>
+              <a:buNone/>
+            </a:pPr>
+            <a:r>
+              <a:rPr lang="en-US" sz="1300" dirty="0">
+                <a:solidFill>
+                  <a:srgbClr val="0F0A2E"/>
+                </a:solidFill>
+                <a:latin typeface="Calibri" pitchFamily="34" charset="0"/>
+                <a:ea typeface="Calibri" pitchFamily="34" charset="-122"/>
+                <a:cs typeface="Calibri" pitchFamily="34" charset="-120"/>
+              </a:rPr>
+              <a:t>Summarize · proofread · rewrite</a:t>
+            </a:r>
+            <a:endParaRPr lang="en-US" sz="1300" dirty="0"/>
+          </a:p>
+        </p:txBody>
+      </p:sp>
+      <p:pic>
+        <p:nvPicPr>
+          <p:cNvPr id="30" name="Image 2" descr="preencoded.png">    </p:cNvPr>
+          <p:cNvPicPr>
+            <a:picLocks noChangeAspect="1"/>
+          </p:cNvPicPr>
+          <p:nvPr/>
+        </p:nvPicPr>
+        <p:blipFill>
+          <a:blip r:embed="rId5">
+            <a:extLst>
+              <a:ext uri="{96DAC541-7B7A-43D3-8B79-37D633B846F1}">
+                <asvg:svgBlip xmlns:asvg="http://schemas.microsoft.com/office/drawing/2016/SVG/main" r:embed="rId6"/>
+              </a:ext>
+            </a:extLst>
+          </a:blip>
+          <a:stretch>
+            <a:fillRect/>
+          </a:stretch>
+        </p:blipFill>
+        <p:spPr>
+          <a:xfrm>
             <a:off x="8503920" y="5458968"/>
             <a:ext cx="237744" cy="237744"/>
           </a:xfrm>
@@ -16872,7 +17861,7 @@
                 <a:ea typeface="Calibri" pitchFamily="34" charset="-122"/>
                 <a:cs typeface="Calibri" pitchFamily="34" charset="-120"/>
               </a:rPr>
-              <a:t>5 / 15</a:t>
+              <a:t>6 / 15</a:t>
             </a:r>
             <a:endParaRPr lang="en-US" sz="1000" dirty="0"/>
           </a:p>
@@ -16886,9 +17875,9 @@
 </p:sld>
 </file>
 
-<file path=ppt/slides/slide6.xml><?xml version="1.0" encoding="utf-8"?>
+<file path=ppt/slides/slide7.xml><?xml version="1.0" encoding="utf-8"?>
 <p:sld xmlns:a="http://schemas.openxmlformats.org/drawingml/2006/main" xmlns:r="http://schemas.openxmlformats.org/officeDocument/2006/relationships" xmlns:p="http://schemas.openxmlformats.org/presentationml/2006/main">
-  <p:cSld name="Slide 6">
+  <p:cSld name="Slide 7">
     <p:bg>
       <p:bgPr>
         <a:solidFill>
@@ -18479,995 +19468,6 @@
           </a:prstGeom>
         </p:spPr>
       </p:pic>
-    </p:spTree>
-  </p:cSld>
-  <p:clrMapOvr>
-    <a:masterClrMapping/>
-  </p:clrMapOvr>
-</p:sld>
-</file>
-
-<file path=ppt/slides/slide7.xml><?xml version="1.0" encoding="utf-8"?>
-<p:sld xmlns:a="http://schemas.openxmlformats.org/drawingml/2006/main" xmlns:r="http://schemas.openxmlformats.org/officeDocument/2006/relationships" xmlns:p="http://schemas.openxmlformats.org/presentationml/2006/main">
-  <p:cSld name="Slide 7">
-    <p:bg>
-      <p:bgPr>
-        <a:solidFill>
-          <a:srgbClr val="FAF8FF"/>
-        </a:solidFill>
-      </p:bgPr>
-    </p:bg>
-    <p:spTree>
-      <p:nvGrpSpPr>
-        <p:cNvPr id="1" name=""/>
-        <p:cNvGrpSpPr/>
-        <p:nvPr/>
-      </p:nvGrpSpPr>
-      <p:grpSpPr>
-        <a:xfrm>
-          <a:off x="0" y="0"/>
-          <a:ext cx="0" cy="0"/>
-          <a:chOff x="0" y="0"/>
-          <a:chExt cx="0" cy="0"/>
-        </a:xfrm>
-      </p:grpSpPr>
-      <p:sp>
-        <p:nvSpPr>
-          <p:cNvPr id="2" name="Text 0"/>
-          <p:cNvSpPr/>
-          <p:nvPr/>
-        </p:nvSpPr>
-        <p:spPr>
-          <a:xfrm>
-            <a:off x="548640" y="502920"/>
-            <a:ext cx="7315200" cy="320040"/>
-          </a:xfrm>
-          <a:prstGeom prst="rect">
-            <a:avLst/>
-          </a:prstGeom>
-          <a:noFill/>
-          <a:ln/>
-        </p:spPr>
-        <p:txBody>
-          <a:bodyPr wrap="square" rtlCol="0" anchor="ctr"/>
-          <a:lstStyle/>
-          <a:p>
-            <a:pPr indent="0" marL="0">
-              <a:buNone/>
-            </a:pPr>
-            <a:r>
-              <a:rPr lang="en-US" sz="1200" b="1" spc="400" kern="0" dirty="0">
-                <a:solidFill>
-                  <a:srgbClr val="FBBF24"/>
-                </a:solidFill>
-                <a:latin typeface="Calibri" pitchFamily="34" charset="0"/>
-                <a:ea typeface="Calibri" pitchFamily="34" charset="-122"/>
-                <a:cs typeface="Calibri" pitchFamily="34" charset="-120"/>
-              </a:rPr>
-              <a:t>TIER 2  ·  THE PRACTICAL MIDDLE</a:t>
-            </a:r>
-            <a:endParaRPr lang="en-US" sz="1200" dirty="0"/>
-          </a:p>
-        </p:txBody>
-      </p:sp>
-      <p:sp>
-        <p:nvSpPr>
-          <p:cNvPr id="3" name="Text 1"/>
-          <p:cNvSpPr/>
-          <p:nvPr/>
-        </p:nvSpPr>
-        <p:spPr>
-          <a:xfrm>
-            <a:off x="548640" y="822960"/>
-            <a:ext cx="10058400" cy="822960"/>
-          </a:xfrm>
-          <a:prstGeom prst="rect">
-            <a:avLst/>
-          </a:prstGeom>
-          <a:noFill/>
-          <a:ln/>
-        </p:spPr>
-        <p:txBody>
-          <a:bodyPr wrap="square" rtlCol="0" anchor="ctr"/>
-          <a:lstStyle/>
-          <a:p>
-            <a:pPr indent="0" marL="0">
-              <a:buNone/>
-            </a:pPr>
-            <a:r>
-              <a:rPr lang="en-US" sz="3800" b="1" dirty="0">
-                <a:solidFill>
-                  <a:srgbClr val="0F0A2E"/>
-                </a:solidFill>
-                <a:latin typeface="Georgia" pitchFamily="34" charset="0"/>
-                <a:ea typeface="Georgia" pitchFamily="34" charset="-122"/>
-                <a:cs typeface="Georgia" pitchFamily="34" charset="-120"/>
-              </a:rPr>
-              <a:t>Bring your own local model</a:t>
-            </a:r>
-            <a:endParaRPr lang="en-US" sz="3800" dirty="0"/>
-          </a:p>
-        </p:txBody>
-      </p:sp>
-      <p:sp>
-        <p:nvSpPr>
-          <p:cNvPr id="4" name="Text 2"/>
-          <p:cNvSpPr/>
-          <p:nvPr/>
-        </p:nvSpPr>
-        <p:spPr>
-          <a:xfrm>
-            <a:off x="548640" y="1600200"/>
-            <a:ext cx="10972800" cy="457200"/>
-          </a:xfrm>
-          <a:prstGeom prst="rect">
-            <a:avLst/>
-          </a:prstGeom>
-          <a:noFill/>
-          <a:ln/>
-        </p:spPr>
-        <p:txBody>
-          <a:bodyPr wrap="square" rtlCol="0" anchor="ctr"/>
-          <a:lstStyle/>
-          <a:p>
-            <a:pPr indent="0" marL="0">
-              <a:buNone/>
-            </a:pPr>
-            <a:r>
-              <a:rPr lang="en-US" sz="1700" i="1" dirty="0">
-                <a:solidFill>
-                  <a:srgbClr val="6B6B8F"/>
-                </a:solidFill>
-                <a:latin typeface="Calibri" pitchFamily="34" charset="0"/>
-                <a:ea typeface="Calibri" pitchFamily="34" charset="-122"/>
-                <a:cs typeface="Calibri" pitchFamily="34" charset="-120"/>
-              </a:rPr>
-              <a:t>The forgotten tier — cloud-class capability with local-class privacy</a:t>
-            </a:r>
-            <a:endParaRPr lang="en-US" sz="1700" dirty="0"/>
-          </a:p>
-        </p:txBody>
-      </p:sp>
-      <p:sp>
-        <p:nvSpPr>
-          <p:cNvPr id="5" name="Shape 3"/>
-          <p:cNvSpPr/>
-          <p:nvPr/>
-        </p:nvSpPr>
-        <p:spPr>
-          <a:xfrm>
-            <a:off x="548640" y="2286000"/>
-            <a:ext cx="3703320" cy="3931920"/>
-          </a:xfrm>
-          <a:prstGeom prst="roundRect">
-            <a:avLst>
-              <a:gd name="adj" fmla="val 2963"/>
-            </a:avLst>
-          </a:prstGeom>
-          <a:solidFill>
-            <a:srgbClr val="FFFFFF"/>
-          </a:solidFill>
-          <a:ln w="25400">
-            <a:solidFill>
-              <a:srgbClr val="FB7185"/>
-            </a:solidFill>
-            <a:prstDash val="solid"/>
-          </a:ln>
-        </p:spPr>
-      </p:sp>
-      <p:sp>
-        <p:nvSpPr>
-          <p:cNvPr id="6" name="Shape 4"/>
-          <p:cNvSpPr/>
-          <p:nvPr/>
-        </p:nvSpPr>
-        <p:spPr>
-          <a:xfrm>
-            <a:off x="822960" y="2514600"/>
-            <a:ext cx="1554480" cy="292608"/>
-          </a:xfrm>
-          <a:prstGeom prst="roundRect">
-            <a:avLst>
-              <a:gd name="adj" fmla="val 50000"/>
-            </a:avLst>
-          </a:prstGeom>
-          <a:solidFill>
-            <a:srgbClr val="FB7185"/>
-          </a:solidFill>
-          <a:ln w="12700">
-            <a:solidFill>
-              <a:srgbClr val="FB7185"/>
-            </a:solidFill>
-            <a:prstDash val="solid"/>
-          </a:ln>
-        </p:spPr>
-      </p:sp>
-      <p:sp>
-        <p:nvSpPr>
-          <p:cNvPr id="7" name="Text 5"/>
-          <p:cNvSpPr/>
-          <p:nvPr/>
-        </p:nvSpPr>
-        <p:spPr>
-          <a:xfrm>
-            <a:off x="822960" y="2514600"/>
-            <a:ext cx="1554480" cy="292608"/>
-          </a:xfrm>
-          <a:prstGeom prst="rect">
-            <a:avLst/>
-          </a:prstGeom>
-          <a:noFill/>
-          <a:ln/>
-        </p:spPr>
-        <p:txBody>
-          <a:bodyPr wrap="square" rtlCol="0" anchor="ctr"/>
-          <a:lstStyle/>
-          <a:p>
-            <a:pPr algn="ctr" indent="0" marL="0">
-              <a:buNone/>
-            </a:pPr>
-            <a:r>
-              <a:rPr lang="en-US" sz="900" b="1" spc="200" kern="0" dirty="0">
-                <a:solidFill>
-                  <a:srgbClr val="FAF8FF"/>
-                </a:solidFill>
-                <a:latin typeface="Calibri" pitchFamily="34" charset="0"/>
-                <a:ea typeface="Calibri" pitchFamily="34" charset="-122"/>
-                <a:cs typeface="Calibri" pitchFamily="34" charset="-120"/>
-              </a:rPr>
-              <a:t>RECOMMENDED</a:t>
-            </a:r>
-            <a:endParaRPr lang="en-US" sz="900" dirty="0"/>
-          </a:p>
-        </p:txBody>
-      </p:sp>
-      <p:sp>
-        <p:nvSpPr>
-          <p:cNvPr id="8" name="Text 6"/>
-          <p:cNvSpPr/>
-          <p:nvPr/>
-        </p:nvSpPr>
-        <p:spPr>
-          <a:xfrm>
-            <a:off x="822960" y="2971800"/>
-            <a:ext cx="3154680" cy="548640"/>
-          </a:xfrm>
-          <a:prstGeom prst="rect">
-            <a:avLst/>
-          </a:prstGeom>
-          <a:noFill/>
-          <a:ln/>
-        </p:spPr>
-        <p:txBody>
-          <a:bodyPr wrap="square" rtlCol="0" anchor="ctr"/>
-          <a:lstStyle/>
-          <a:p>
-            <a:pPr indent="0" marL="0">
-              <a:buNone/>
-            </a:pPr>
-            <a:r>
-              <a:rPr lang="en-US" sz="2200" b="1" dirty="0">
-                <a:solidFill>
-                  <a:srgbClr val="0F0A2E"/>
-                </a:solidFill>
-                <a:latin typeface="Georgia" pitchFamily="34" charset="0"/>
-                <a:ea typeface="Georgia" pitchFamily="34" charset="-122"/>
-                <a:cs typeface="Georgia" pitchFamily="34" charset="-120"/>
-              </a:rPr>
-              <a:t>Foundry Local</a:t>
-            </a:r>
-            <a:endParaRPr lang="en-US" sz="2200" dirty="0"/>
-          </a:p>
-        </p:txBody>
-      </p:sp>
-      <p:sp>
-        <p:nvSpPr>
-          <p:cNvPr id="9" name="Text 7"/>
-          <p:cNvSpPr/>
-          <p:nvPr/>
-        </p:nvSpPr>
-        <p:spPr>
-          <a:xfrm>
-            <a:off x="822960" y="3520440"/>
-            <a:ext cx="3154680" cy="365760"/>
-          </a:xfrm>
-          <a:prstGeom prst="rect">
-            <a:avLst/>
-          </a:prstGeom>
-          <a:noFill/>
-          <a:ln/>
-        </p:spPr>
-        <p:txBody>
-          <a:bodyPr wrap="square" rtlCol="0" anchor="ctr"/>
-          <a:lstStyle/>
-          <a:p>
-            <a:pPr indent="0" marL="0">
-              <a:buNone/>
-            </a:pPr>
-            <a:r>
-              <a:rPr lang="en-US" sz="1300" i="1" dirty="0">
-                <a:solidFill>
-                  <a:srgbClr val="FB7185"/>
-                </a:solidFill>
-                <a:latin typeface="Calibri" pitchFamily="34" charset="0"/>
-                <a:ea typeface="Calibri" pitchFamily="34" charset="-122"/>
-                <a:cs typeface="Calibri" pitchFamily="34" charset="-120"/>
-              </a:rPr>
-              <a:t>Cloud-grade LLMs, local host</a:t>
-            </a:r>
-            <a:endParaRPr lang="en-US" sz="1300" dirty="0"/>
-          </a:p>
-        </p:txBody>
-      </p:sp>
-      <p:sp>
-        <p:nvSpPr>
-          <p:cNvPr id="10" name="Text 8"/>
-          <p:cNvSpPr/>
-          <p:nvPr/>
-        </p:nvSpPr>
-        <p:spPr>
-          <a:xfrm>
-            <a:off x="822960" y="4023360"/>
-            <a:ext cx="3154680" cy="2011680"/>
-          </a:xfrm>
-          <a:prstGeom prst="rect">
-            <a:avLst/>
-          </a:prstGeom>
-          <a:noFill/>
-          <a:ln/>
-        </p:spPr>
-        <p:txBody>
-          <a:bodyPr wrap="square" rtlCol="0" anchor="ctr"/>
-          <a:lstStyle/>
-          <a:p>
-            <a:pPr indent="0" marL="0">
-              <a:buNone/>
-            </a:pPr>
-            <a:r>
-              <a:rPr lang="en-US" sz="1300" dirty="0">
-                <a:solidFill>
-                  <a:srgbClr val="0F0A2E"/>
-                </a:solidFill>
-                <a:latin typeface="Calibri" pitchFamily="34" charset="0"/>
-                <a:ea typeface="Calibri" pitchFamily="34" charset="-122"/>
-                <a:cs typeface="Calibri" pitchFamily="34" charset="-120"/>
-              </a:rPr>
-              <a:t>Microsoft's runtime for running Phi, Llama, Qwen and friends on the user's box. .NET-friendly, ONNX-backed, GPU/NPU accelerated.</a:t>
-            </a:r>
-            <a:endParaRPr lang="en-US" sz="1300" dirty="0"/>
-          </a:p>
-        </p:txBody>
-      </p:sp>
-      <p:sp>
-        <p:nvSpPr>
-          <p:cNvPr id="11" name="Shape 9"/>
-          <p:cNvSpPr/>
-          <p:nvPr/>
-        </p:nvSpPr>
-        <p:spPr>
-          <a:xfrm>
-            <a:off x="4389120" y="2286000"/>
-            <a:ext cx="3703320" cy="3931920"/>
-          </a:xfrm>
-          <a:prstGeom prst="roundRect">
-            <a:avLst>
-              <a:gd name="adj" fmla="val 2963"/>
-            </a:avLst>
-          </a:prstGeom>
-          <a:solidFill>
-            <a:srgbClr val="FFFFFF"/>
-          </a:solidFill>
-          <a:ln w="25400">
-            <a:solidFill>
-              <a:srgbClr val="6366F1"/>
-            </a:solidFill>
-            <a:prstDash val="solid"/>
-          </a:ln>
-        </p:spPr>
-      </p:sp>
-      <p:sp>
-        <p:nvSpPr>
-          <p:cNvPr id="12" name="Shape 10"/>
-          <p:cNvSpPr/>
-          <p:nvPr/>
-        </p:nvSpPr>
-        <p:spPr>
-          <a:xfrm>
-            <a:off x="4663440" y="2514600"/>
-            <a:ext cx="1554480" cy="292608"/>
-          </a:xfrm>
-          <a:prstGeom prst="roundRect">
-            <a:avLst>
-              <a:gd name="adj" fmla="val 50000"/>
-            </a:avLst>
-          </a:prstGeom>
-          <a:solidFill>
-            <a:srgbClr val="6366F1"/>
-          </a:solidFill>
-          <a:ln w="12700">
-            <a:solidFill>
-              <a:srgbClr val="6366F1"/>
-            </a:solidFill>
-            <a:prstDash val="solid"/>
-          </a:ln>
-        </p:spPr>
-      </p:sp>
-      <p:sp>
-        <p:nvSpPr>
-          <p:cNvPr id="13" name="Text 11"/>
-          <p:cNvSpPr/>
-          <p:nvPr/>
-        </p:nvSpPr>
-        <p:spPr>
-          <a:xfrm>
-            <a:off x="4663440" y="2514600"/>
-            <a:ext cx="1554480" cy="292608"/>
-          </a:xfrm>
-          <a:prstGeom prst="rect">
-            <a:avLst/>
-          </a:prstGeom>
-          <a:noFill/>
-          <a:ln/>
-        </p:spPr>
-        <p:txBody>
-          <a:bodyPr wrap="square" rtlCol="0" anchor="ctr"/>
-          <a:lstStyle/>
-          <a:p>
-            <a:pPr algn="ctr" indent="0" marL="0">
-              <a:buNone/>
-            </a:pPr>
-            <a:r>
-              <a:rPr lang="en-US" sz="900" b="1" spc="200" kern="0" dirty="0">
-                <a:solidFill>
-                  <a:srgbClr val="FAF8FF"/>
-                </a:solidFill>
-                <a:latin typeface="Calibri" pitchFamily="34" charset="0"/>
-                <a:ea typeface="Calibri" pitchFamily="34" charset="-122"/>
-                <a:cs typeface="Calibri" pitchFamily="34" charset="-120"/>
-              </a:rPr>
-              <a:t>FLEXIBLE</a:t>
-            </a:r>
-            <a:endParaRPr lang="en-US" sz="900" dirty="0"/>
-          </a:p>
-        </p:txBody>
-      </p:sp>
-      <p:sp>
-        <p:nvSpPr>
-          <p:cNvPr id="14" name="Text 12"/>
-          <p:cNvSpPr/>
-          <p:nvPr/>
-        </p:nvSpPr>
-        <p:spPr>
-          <a:xfrm>
-            <a:off x="4663440" y="2971800"/>
-            <a:ext cx="3154680" cy="548640"/>
-          </a:xfrm>
-          <a:prstGeom prst="rect">
-            <a:avLst/>
-          </a:prstGeom>
-          <a:noFill/>
-          <a:ln/>
-        </p:spPr>
-        <p:txBody>
-          <a:bodyPr wrap="square" rtlCol="0" anchor="ctr"/>
-          <a:lstStyle/>
-          <a:p>
-            <a:pPr indent="0" marL="0">
-              <a:buNone/>
-            </a:pPr>
-            <a:r>
-              <a:rPr lang="en-US" sz="2200" b="1" dirty="0">
-                <a:solidFill>
-                  <a:srgbClr val="0F0A2E"/>
-                </a:solidFill>
-                <a:latin typeface="Georgia" pitchFamily="34" charset="0"/>
-                <a:ea typeface="Georgia" pitchFamily="34" charset="-122"/>
-                <a:cs typeface="Georgia" pitchFamily="34" charset="-120"/>
-              </a:rPr>
-              <a:t>ONNX Runtime GenAI</a:t>
-            </a:r>
-            <a:endParaRPr lang="en-US" sz="2200" dirty="0"/>
-          </a:p>
-        </p:txBody>
-      </p:sp>
-      <p:sp>
-        <p:nvSpPr>
-          <p:cNvPr id="15" name="Text 13"/>
-          <p:cNvSpPr/>
-          <p:nvPr/>
-        </p:nvSpPr>
-        <p:spPr>
-          <a:xfrm>
-            <a:off x="4663440" y="3520440"/>
-            <a:ext cx="3154680" cy="365760"/>
-          </a:xfrm>
-          <a:prstGeom prst="rect">
-            <a:avLst/>
-          </a:prstGeom>
-          <a:noFill/>
-          <a:ln/>
-        </p:spPr>
-        <p:txBody>
-          <a:bodyPr wrap="square" rtlCol="0" anchor="ctr"/>
-          <a:lstStyle/>
-          <a:p>
-            <a:pPr indent="0" marL="0">
-              <a:buNone/>
-            </a:pPr>
-            <a:r>
-              <a:rPr lang="en-US" sz="1300" i="1" dirty="0">
-                <a:solidFill>
-                  <a:srgbClr val="6366F1"/>
-                </a:solidFill>
-                <a:latin typeface="Calibri" pitchFamily="34" charset="0"/>
-                <a:ea typeface="Calibri" pitchFamily="34" charset="-122"/>
-                <a:cs typeface="Calibri" pitchFamily="34" charset="-120"/>
-              </a:rPr>
-              <a:t>Ship your own model</a:t>
-            </a:r>
-            <a:endParaRPr lang="en-US" sz="1300" dirty="0"/>
-          </a:p>
-        </p:txBody>
-      </p:sp>
-      <p:sp>
-        <p:nvSpPr>
-          <p:cNvPr id="16" name="Text 14"/>
-          <p:cNvSpPr/>
-          <p:nvPr/>
-        </p:nvSpPr>
-        <p:spPr>
-          <a:xfrm>
-            <a:off x="4663440" y="4023360"/>
-            <a:ext cx="3154680" cy="2011680"/>
-          </a:xfrm>
-          <a:prstGeom prst="rect">
-            <a:avLst/>
-          </a:prstGeom>
-          <a:noFill/>
-          <a:ln/>
-        </p:spPr>
-        <p:txBody>
-          <a:bodyPr wrap="square" rtlCol="0" anchor="ctr"/>
-          <a:lstStyle/>
-          <a:p>
-            <a:pPr indent="0" marL="0">
-              <a:buNone/>
-            </a:pPr>
-            <a:r>
-              <a:rPr lang="en-US" sz="1300" dirty="0">
-                <a:solidFill>
-                  <a:srgbClr val="0F0A2E"/>
-                </a:solidFill>
-                <a:latin typeface="Calibri" pitchFamily="34" charset="0"/>
-                <a:ea typeface="Calibri" pitchFamily="34" charset="-122"/>
-                <a:cs typeface="Calibri" pitchFamily="34" charset="-120"/>
-              </a:rPr>
-              <a:t>Cross-platform C# / native inference. Bring any ONNX-converted model — tiny custom classifiers to multi-billion-param LLMs.</a:t>
-            </a:r>
-            <a:endParaRPr lang="en-US" sz="1300" dirty="0"/>
-          </a:p>
-        </p:txBody>
-      </p:sp>
-      <p:sp>
-        <p:nvSpPr>
-          <p:cNvPr id="17" name="Shape 15"/>
-          <p:cNvSpPr/>
-          <p:nvPr/>
-        </p:nvSpPr>
-        <p:spPr>
-          <a:xfrm>
-            <a:off x="8229600" y="2286000"/>
-            <a:ext cx="3703320" cy="3931920"/>
-          </a:xfrm>
-          <a:prstGeom prst="roundRect">
-            <a:avLst>
-              <a:gd name="adj" fmla="val 2963"/>
-            </a:avLst>
-          </a:prstGeom>
-          <a:solidFill>
-            <a:srgbClr val="FFFFFF"/>
-          </a:solidFill>
-          <a:ln w="25400">
-            <a:solidFill>
-              <a:srgbClr val="FBBF24"/>
-            </a:solidFill>
-            <a:prstDash val="solid"/>
-          </a:ln>
-        </p:spPr>
-      </p:sp>
-      <p:sp>
-        <p:nvSpPr>
-          <p:cNvPr id="18" name="Shape 16"/>
-          <p:cNvSpPr/>
-          <p:nvPr/>
-        </p:nvSpPr>
-        <p:spPr>
-          <a:xfrm>
-            <a:off x="8503920" y="2514600"/>
-            <a:ext cx="1554480" cy="292608"/>
-          </a:xfrm>
-          <a:prstGeom prst="roundRect">
-            <a:avLst>
-              <a:gd name="adj" fmla="val 50000"/>
-            </a:avLst>
-          </a:prstGeom>
-          <a:solidFill>
-            <a:srgbClr val="FBBF24"/>
-          </a:solidFill>
-          <a:ln w="12700">
-            <a:solidFill>
-              <a:srgbClr val="FBBF24"/>
-            </a:solidFill>
-            <a:prstDash val="solid"/>
-          </a:ln>
-        </p:spPr>
-      </p:sp>
-      <p:sp>
-        <p:nvSpPr>
-          <p:cNvPr id="19" name="Text 17"/>
-          <p:cNvSpPr/>
-          <p:nvPr/>
-        </p:nvSpPr>
-        <p:spPr>
-          <a:xfrm>
-            <a:off x="8503920" y="2514600"/>
-            <a:ext cx="1554480" cy="292608"/>
-          </a:xfrm>
-          <a:prstGeom prst="rect">
-            <a:avLst/>
-          </a:prstGeom>
-          <a:noFill/>
-          <a:ln/>
-        </p:spPr>
-        <p:txBody>
-          <a:bodyPr wrap="square" rtlCol="0" anchor="ctr"/>
-          <a:lstStyle/>
-          <a:p>
-            <a:pPr algn="ctr" indent="0" marL="0">
-              <a:buNone/>
-            </a:pPr>
-            <a:r>
-              <a:rPr lang="en-US" sz="900" b="1" spc="200" kern="0" dirty="0">
-                <a:solidFill>
-                  <a:srgbClr val="FAF8FF"/>
-                </a:solidFill>
-                <a:latin typeface="Calibri" pitchFamily="34" charset="0"/>
-                <a:ea typeface="Calibri" pitchFamily="34" charset="-122"/>
-                <a:cs typeface="Calibri" pitchFamily="34" charset="-120"/>
-              </a:rPr>
-              <a:t>UNDERRATED</a:t>
-            </a:r>
-            <a:endParaRPr lang="en-US" sz="900" dirty="0"/>
-          </a:p>
-        </p:txBody>
-      </p:sp>
-      <p:sp>
-        <p:nvSpPr>
-          <p:cNvPr id="20" name="Text 18"/>
-          <p:cNvSpPr/>
-          <p:nvPr/>
-        </p:nvSpPr>
-        <p:spPr>
-          <a:xfrm>
-            <a:off x="8503920" y="2971800"/>
-            <a:ext cx="3154680" cy="548640"/>
-          </a:xfrm>
-          <a:prstGeom prst="rect">
-            <a:avLst/>
-          </a:prstGeom>
-          <a:noFill/>
-          <a:ln/>
-        </p:spPr>
-        <p:txBody>
-          <a:bodyPr wrap="square" rtlCol="0" anchor="ctr"/>
-          <a:lstStyle/>
-          <a:p>
-            <a:pPr indent="0" marL="0">
-              <a:buNone/>
-            </a:pPr>
-            <a:r>
-              <a:rPr lang="en-US" sz="2200" b="1" dirty="0">
-                <a:solidFill>
-                  <a:srgbClr val="0F0A2E"/>
-                </a:solidFill>
-                <a:latin typeface="Georgia" pitchFamily="34" charset="0"/>
-                <a:ea typeface="Georgia" pitchFamily="34" charset="-122"/>
-                <a:cs typeface="Georgia" pitchFamily="34" charset="-120"/>
-              </a:rPr>
-              <a:t>Tiny Bespoke Models</a:t>
-            </a:r>
-            <a:endParaRPr lang="en-US" sz="2200" dirty="0"/>
-          </a:p>
-        </p:txBody>
-      </p:sp>
-      <p:sp>
-        <p:nvSpPr>
-          <p:cNvPr id="21" name="Text 19"/>
-          <p:cNvSpPr/>
-          <p:nvPr/>
-        </p:nvSpPr>
-        <p:spPr>
-          <a:xfrm>
-            <a:off x="8503920" y="3520440"/>
-            <a:ext cx="3154680" cy="365760"/>
-          </a:xfrm>
-          <a:prstGeom prst="rect">
-            <a:avLst/>
-          </a:prstGeom>
-          <a:noFill/>
-          <a:ln/>
-        </p:spPr>
-        <p:txBody>
-          <a:bodyPr wrap="square" rtlCol="0" anchor="ctr"/>
-          <a:lstStyle/>
-          <a:p>
-            <a:pPr indent="0" marL="0">
-              <a:buNone/>
-            </a:pPr>
-            <a:r>
-              <a:rPr lang="en-US" sz="1300" i="1" dirty="0">
-                <a:solidFill>
-                  <a:srgbClr val="FBBF24"/>
-                </a:solidFill>
-                <a:latin typeface="Calibri" pitchFamily="34" charset="0"/>
-                <a:ea typeface="Calibri" pitchFamily="34" charset="-122"/>
-                <a:cs typeface="Calibri" pitchFamily="34" charset="-120"/>
-              </a:rPr>
-              <a:t>Right-sized for the task</a:t>
-            </a:r>
-            <a:endParaRPr lang="en-US" sz="1300" dirty="0"/>
-          </a:p>
-        </p:txBody>
-      </p:sp>
-      <p:sp>
-        <p:nvSpPr>
-          <p:cNvPr id="22" name="Text 20"/>
-          <p:cNvSpPr/>
-          <p:nvPr/>
-        </p:nvSpPr>
-        <p:spPr>
-          <a:xfrm>
-            <a:off x="8503920" y="4023360"/>
-            <a:ext cx="3154680" cy="2011680"/>
-          </a:xfrm>
-          <a:prstGeom prst="rect">
-            <a:avLst/>
-          </a:prstGeom>
-          <a:noFill/>
-          <a:ln/>
-        </p:spPr>
-        <p:txBody>
-          <a:bodyPr wrap="square" rtlCol="0" anchor="ctr"/>
-          <a:lstStyle/>
-          <a:p>
-            <a:pPr indent="0" marL="0">
-              <a:buNone/>
-            </a:pPr>
-            <a:r>
-              <a:rPr lang="en-US" sz="1300" dirty="0">
-                <a:solidFill>
-                  <a:srgbClr val="0F0A2E"/>
-                </a:solidFill>
-                <a:latin typeface="Calibri" pitchFamily="34" charset="0"/>
-                <a:ea typeface="Calibri" pitchFamily="34" charset="-122"/>
-                <a:cs typeface="Calibri" pitchFamily="34" charset="-120"/>
-              </a:rPr>
-              <a:t>Sometimes a 50MB classifier beats a 3B LLM. Embeddings, intent detection, structured extraction — fast, cheap, embarrassingly good.</a:t>
-            </a:r>
-            <a:endParaRPr lang="en-US" sz="1300" dirty="0"/>
-          </a:p>
-        </p:txBody>
-      </p:sp>
-      <p:pic>
-        <p:nvPicPr>
-          <p:cNvPr id="23" name="Image 0" descr="preencoded.png">    </p:cNvPr>
-          <p:cNvPicPr>
-            <a:picLocks noChangeAspect="1"/>
-          </p:cNvPicPr>
-          <p:nvPr/>
-        </p:nvPicPr>
-        <p:blipFill>
-          <a:blip r:embed="rId1">
-            <a:extLst>
-              <a:ext uri="{96DAC541-7B7A-43D3-8B79-37D633B846F1}">
-                <asvg:svgBlip xmlns:asvg="http://schemas.microsoft.com/office/drawing/2016/SVG/main" r:embed="rId2"/>
-              </a:ext>
-            </a:extLst>
-          </a:blip>
-          <a:stretch>
-            <a:fillRect/>
-          </a:stretch>
-        </p:blipFill>
-        <p:spPr>
-          <a:xfrm>
-            <a:off x="10180015" y="502920"/>
-            <a:ext cx="329184" cy="329184"/>
-          </a:xfrm>
-          <a:prstGeom prst="rect">
-            <a:avLst/>
-          </a:prstGeom>
-        </p:spPr>
-      </p:pic>
-      <p:pic>
-        <p:nvPicPr>
-          <p:cNvPr id="24" name="Image 1" descr="preencoded.png">    </p:cNvPr>
-          <p:cNvPicPr>
-            <a:picLocks noChangeAspect="1"/>
-          </p:cNvPicPr>
-          <p:nvPr/>
-        </p:nvPicPr>
-        <p:blipFill>
-          <a:blip r:embed="rId3">
-            <a:extLst>
-              <a:ext uri="{96DAC541-7B7A-43D3-8B79-37D633B846F1}">
-                <asvg:svgBlip xmlns:asvg="http://schemas.microsoft.com/office/drawing/2016/SVG/main" r:embed="rId4"/>
-              </a:ext>
-            </a:extLst>
-          </a:blip>
-          <a:stretch>
-            <a:fillRect/>
-          </a:stretch>
-        </p:blipFill>
-        <p:spPr>
-          <a:xfrm>
-            <a:off x="10564063" y="502920"/>
-            <a:ext cx="329184" cy="329184"/>
-          </a:xfrm>
-          <a:prstGeom prst="rect">
-            <a:avLst/>
-          </a:prstGeom>
-        </p:spPr>
-      </p:pic>
-      <p:pic>
-        <p:nvPicPr>
-          <p:cNvPr id="25" name="Image 2" descr="preencoded.png">    </p:cNvPr>
-          <p:cNvPicPr>
-            <a:picLocks noChangeAspect="1"/>
-          </p:cNvPicPr>
-          <p:nvPr/>
-        </p:nvPicPr>
-        <p:blipFill>
-          <a:blip r:embed="rId5">
-            <a:extLst>
-              <a:ext uri="{96DAC541-7B7A-43D3-8B79-37D633B846F1}">
-                <asvg:svgBlip xmlns:asvg="http://schemas.microsoft.com/office/drawing/2016/SVG/main" r:embed="rId6"/>
-              </a:ext>
-            </a:extLst>
-          </a:blip>
-          <a:stretch>
-            <a:fillRect/>
-          </a:stretch>
-        </p:blipFill>
-        <p:spPr>
-          <a:xfrm>
-            <a:off x="10948111" y="502920"/>
-            <a:ext cx="329184" cy="329184"/>
-          </a:xfrm>
-          <a:prstGeom prst="rect">
-            <a:avLst/>
-          </a:prstGeom>
-        </p:spPr>
-      </p:pic>
-      <p:sp>
-        <p:nvSpPr>
-          <p:cNvPr id="26" name="Text 21"/>
-          <p:cNvSpPr/>
-          <p:nvPr/>
-        </p:nvSpPr>
-        <p:spPr>
-          <a:xfrm>
-            <a:off x="457200" y="6446520"/>
-            <a:ext cx="7315200" cy="274320"/>
-          </a:xfrm>
-          <a:prstGeom prst="rect">
-            <a:avLst/>
-          </a:prstGeom>
-          <a:noFill/>
-          <a:ln/>
-        </p:spPr>
-        <p:txBody>
-          <a:bodyPr wrap="square" rtlCol="0" anchor="ctr"/>
-          <a:lstStyle/>
-          <a:p>
-            <a:pPr algn="l" indent="0" marL="0">
-              <a:buNone/>
-            </a:pPr>
-            <a:r>
-              <a:rPr lang="en-US" sz="1000" dirty="0">
-                <a:solidFill>
-                  <a:srgbClr val="6B6B8F"/>
-                </a:solidFill>
-                <a:latin typeface="Calibri" pitchFamily="34" charset="0"/>
-                <a:ea typeface="Calibri" pitchFamily="34" charset="-122"/>
-                <a:cs typeface="Calibri" pitchFamily="34" charset="-120"/>
-              </a:rPr>
-              <a:t>Unifying Local and Cloud AI</a:t>
-            </a:r>
-            <a:pPr algn="l" indent="0" marL="0">
-              <a:buNone/>
-            </a:pPr>
-            <a:r>
-              <a:rPr lang="en-US" sz="1000" dirty="0">
-                <a:solidFill>
-                  <a:srgbClr val="6B6B8F"/>
-                </a:solidFill>
-                <a:latin typeface="Calibri" pitchFamily="34" charset="0"/>
-                <a:ea typeface="Calibri" pitchFamily="34" charset="-122"/>
-                <a:cs typeface="Calibri" pitchFamily="34" charset="-120"/>
-              </a:rPr>
-              <a:t>  ·  </a:t>
-            </a:r>
-            <a:pPr algn="l" indent="0" marL="0">
-              <a:buNone/>
-            </a:pPr>
-            <a:r>
-              <a:rPr lang="en-US" sz="1000" b="1" dirty="0">
-                <a:solidFill>
-                  <a:srgbClr val="FB7185"/>
-                </a:solidFill>
-                <a:latin typeface="Calibri" pitchFamily="34" charset="0"/>
-                <a:ea typeface="Calibri" pitchFamily="34" charset="-122"/>
-                <a:cs typeface="Calibri" pitchFamily="34" charset="-120"/>
-              </a:rPr>
-              <a:t>@mattleibow</a:t>
-            </a:r>
-            <a:pPr algn="l" indent="0" marL="0">
-              <a:buNone/>
-            </a:pPr>
-            <a:r>
-              <a:rPr lang="en-US" sz="1000" dirty="0">
-                <a:solidFill>
-                  <a:srgbClr val="6B6B8F"/>
-                </a:solidFill>
-                <a:latin typeface="Calibri" pitchFamily="34" charset="0"/>
-                <a:ea typeface="Calibri" pitchFamily="34" charset="-122"/>
-                <a:cs typeface="Calibri" pitchFamily="34" charset="-120"/>
-              </a:rPr>
-              <a:t>  ·  @CPTMSDUG</a:t>
-            </a:r>
-            <a:endParaRPr lang="en-US" sz="1000" dirty="0"/>
-          </a:p>
-        </p:txBody>
-      </p:sp>
-      <p:sp>
-        <p:nvSpPr>
-          <p:cNvPr id="27" name="Text 22"/>
-          <p:cNvSpPr/>
-          <p:nvPr/>
-        </p:nvSpPr>
-        <p:spPr>
-          <a:xfrm>
-            <a:off x="10820095" y="6446520"/>
-            <a:ext cx="914400" cy="274320"/>
-          </a:xfrm>
-          <a:prstGeom prst="rect">
-            <a:avLst/>
-          </a:prstGeom>
-          <a:noFill/>
-          <a:ln/>
-        </p:spPr>
-        <p:txBody>
-          <a:bodyPr wrap="square" rtlCol="0" anchor="ctr"/>
-          <a:lstStyle/>
-          <a:p>
-            <a:pPr algn="r" indent="0" marL="0">
-              <a:buNone/>
-            </a:pPr>
-            <a:r>
-              <a:rPr lang="en-US" sz="1000" dirty="0">
-                <a:solidFill>
-                  <a:srgbClr val="6B6B8F"/>
-                </a:solidFill>
-                <a:latin typeface="Calibri" pitchFamily="34" charset="0"/>
-                <a:ea typeface="Calibri" pitchFamily="34" charset="-122"/>
-                <a:cs typeface="Calibri" pitchFamily="34" charset="-120"/>
-              </a:rPr>
-              <a:t>7 / 15</a:t>
-            </a:r>
-            <a:endParaRPr lang="en-US" sz="1000" dirty="0"/>
-          </a:p>
-        </p:txBody>
-      </p:sp>
     </p:spTree>
   </p:cSld>
   <p:clrMapOvr>

</xml_diff>

<commit_message>
About Me slide: real profile photo instead of 'ML' initials
- Added slides/assets/profile.jpg (200x200, ~6KB)
- Replaced the initials placeholder with a PptxGenJS rounded image
  (rounding: true) on top of a coral-ring backdrop

Co-authored-by: Copilot <223556219+Copilot@users.noreply.github.com>
</commit_message>
<xml_diff>
--- a/slides/Unifying-Local-Cloud-AI.pptx
+++ b/slides/Unifying-Local-Cloud-AI.pptx
@@ -12741,16 +12741,16 @@
         </p:nvSpPr>
         <p:spPr>
           <a:xfrm>
-            <a:off x="548640" y="2011680"/>
-            <a:ext cx="3291840" cy="3291840"/>
+            <a:off x="502920" y="1965960"/>
+            <a:ext cx="3383280" cy="3383280"/>
           </a:xfrm>
           <a:prstGeom prst="ellipse">
             <a:avLst/>
           </a:prstGeom>
           <a:solidFill>
-            <a:srgbClr val="1E1B4B"/>
+            <a:srgbClr val="FB7185"/>
           </a:solidFill>
-          <a:ln w="50800">
+          <a:ln w="12700">
             <a:solidFill>
               <a:srgbClr val="FB7185"/>
             </a:solidFill>
@@ -12758,16 +12758,40 @@
           </a:ln>
         </p:spPr>
       </p:sp>
-      <p:sp>
-        <p:nvSpPr>
-          <p:cNvPr id="5" name="Text 3"/>
-          <p:cNvSpPr/>
-          <p:nvPr/>
-        </p:nvSpPr>
-        <p:spPr>
-          <a:xfrm>
-            <a:off x="548640" y="2011680"/>
-            <a:ext cx="3291840" cy="3291840"/>
+      <p:pic>
+        <p:nvPicPr>
+          <p:cNvPr id="5" name="Image 0" descr="assets/profile.jpg">    </p:cNvPr>
+          <p:cNvPicPr>
+            <a:picLocks noChangeAspect="1"/>
+          </p:cNvPicPr>
+          <p:nvPr/>
+        </p:nvPicPr>
+        <p:blipFill>
+          <a:blip r:embed="rId1"/>
+          <a:stretch>
+            <a:fillRect/>
+          </a:stretch>
+        </p:blipFill>
+        <p:spPr>
+          <a:xfrm>
+            <a:off x="594360" y="2057400"/>
+            <a:ext cx="3200400" cy="3200400"/>
+          </a:xfrm>
+          <a:prstGeom prst="ellipse">
+            <a:avLst/>
+          </a:prstGeom>
+        </p:spPr>
+      </p:pic>
+      <p:sp>
+        <p:nvSpPr>
+          <p:cNvPr id="6" name="Text 3"/>
+          <p:cNvSpPr/>
+          <p:nvPr/>
+        </p:nvSpPr>
+        <p:spPr>
+          <a:xfrm>
+            <a:off x="4572000" y="2103120"/>
+            <a:ext cx="6858000" cy="640080"/>
           </a:xfrm>
           <a:prstGeom prst="rect">
             <a:avLst/>
@@ -12779,57 +12803,18 @@
           <a:bodyPr wrap="square" rtlCol="0" anchor="ctr"/>
           <a:lstStyle/>
           <a:p>
-            <a:pPr algn="ctr" indent="0" marL="0">
-              <a:buNone/>
-            </a:pPr>
-            <a:r>
-              <a:rPr lang="en-US" sz="9600" b="1" dirty="0">
-                <a:solidFill>
-                  <a:srgbClr val="FAF8FF"/>
+            <a:pPr indent="0" marL="0">
+              <a:buNone/>
+            </a:pPr>
+            <a:r>
+              <a:rPr lang="en-US" sz="3200" b="1" dirty="0">
+                <a:solidFill>
+                  <a:srgbClr val="0F0A2E"/>
                 </a:solidFill>
                 <a:latin typeface="Georgia" pitchFamily="34" charset="0"/>
                 <a:ea typeface="Georgia" pitchFamily="34" charset="-122"/>
                 <a:cs typeface="Georgia" pitchFamily="34" charset="-120"/>
               </a:rPr>
-              <a:t>ML</a:t>
-            </a:r>
-            <a:endParaRPr lang="en-US" sz="9600" dirty="0"/>
-          </a:p>
-        </p:txBody>
-      </p:sp>
-      <p:sp>
-        <p:nvSpPr>
-          <p:cNvPr id="6" name="Text 4"/>
-          <p:cNvSpPr/>
-          <p:nvPr/>
-        </p:nvSpPr>
-        <p:spPr>
-          <a:xfrm>
-            <a:off x="4572000" y="2103120"/>
-            <a:ext cx="6858000" cy="640080"/>
-          </a:xfrm>
-          <a:prstGeom prst="rect">
-            <a:avLst/>
-          </a:prstGeom>
-          <a:noFill/>
-          <a:ln/>
-        </p:spPr>
-        <p:txBody>
-          <a:bodyPr wrap="square" rtlCol="0" anchor="ctr"/>
-          <a:lstStyle/>
-          <a:p>
-            <a:pPr indent="0" marL="0">
-              <a:buNone/>
-            </a:pPr>
-            <a:r>
-              <a:rPr lang="en-US" sz="3200" b="1" dirty="0">
-                <a:solidFill>
-                  <a:srgbClr val="0F0A2E"/>
-                </a:solidFill>
-                <a:latin typeface="Georgia" pitchFamily="34" charset="0"/>
-                <a:ea typeface="Georgia" pitchFamily="34" charset="-122"/>
-                <a:cs typeface="Georgia" pitchFamily="34" charset="-120"/>
-              </a:rPr>
               <a:t>Matthew Leibowitz</a:t>
             </a:r>
             <a:endParaRPr lang="en-US" sz="3200" dirty="0"/>
@@ -12838,7 +12823,7 @@
       </p:sp>
       <p:sp>
         <p:nvSpPr>
-          <p:cNvPr id="7" name="Text 5"/>
+          <p:cNvPr id="7" name="Text 4"/>
           <p:cNvSpPr/>
           <p:nvPr/>
         </p:nvSpPr>
@@ -12877,7 +12862,7 @@
       </p:sp>
       <p:sp>
         <p:nvSpPr>
-          <p:cNvPr id="8" name="Shape 6"/>
+          <p:cNvPr id="8" name="Shape 5"/>
           <p:cNvSpPr/>
           <p:nvPr/>
         </p:nvSpPr>
@@ -12902,7 +12887,7 @@
       </p:sp>
       <p:sp>
         <p:nvSpPr>
-          <p:cNvPr id="9" name="Text 7"/>
+          <p:cNvPr id="9" name="Text 6"/>
           <p:cNvSpPr/>
           <p:nvPr/>
         </p:nvSpPr>
@@ -12941,7 +12926,7 @@
       </p:sp>
       <p:sp>
         <p:nvSpPr>
-          <p:cNvPr id="10" name="Text 8"/>
+          <p:cNvPr id="10" name="Text 7"/>
           <p:cNvSpPr/>
           <p:nvPr/>
         </p:nvSpPr>
@@ -12994,7 +12979,7 @@
       </p:sp>
       <p:sp>
         <p:nvSpPr>
-          <p:cNvPr id="11" name="Shape 9"/>
+          <p:cNvPr id="11" name="Shape 8"/>
           <p:cNvSpPr/>
           <p:nvPr/>
         </p:nvSpPr>
@@ -13019,7 +13004,7 @@
       </p:sp>
       <p:sp>
         <p:nvSpPr>
-          <p:cNvPr id="12" name="Text 10"/>
+          <p:cNvPr id="12" name="Text 9"/>
           <p:cNvSpPr/>
           <p:nvPr/>
         </p:nvSpPr>
@@ -13058,7 +13043,7 @@
       </p:sp>
       <p:sp>
         <p:nvSpPr>
-          <p:cNvPr id="13" name="Text 11"/>
+          <p:cNvPr id="13" name="Text 10"/>
           <p:cNvSpPr/>
           <p:nvPr/>
         </p:nvSpPr>
@@ -13111,7 +13096,7 @@
       </p:sp>
       <p:sp>
         <p:nvSpPr>
-          <p:cNvPr id="14" name="Shape 12"/>
+          <p:cNvPr id="14" name="Shape 11"/>
           <p:cNvSpPr/>
           <p:nvPr/>
         </p:nvSpPr>
@@ -13136,7 +13121,7 @@
       </p:sp>
       <p:sp>
         <p:nvSpPr>
-          <p:cNvPr id="15" name="Text 13"/>
+          <p:cNvPr id="15" name="Text 12"/>
           <p:cNvSpPr/>
           <p:nvPr/>
         </p:nvSpPr>
@@ -13175,7 +13160,7 @@
       </p:sp>
       <p:sp>
         <p:nvSpPr>
-          <p:cNvPr id="16" name="Text 14"/>
+          <p:cNvPr id="16" name="Text 13"/>
           <p:cNvSpPr/>
           <p:nvPr/>
         </p:nvSpPr>
@@ -13228,17 +13213,17 @@
       </p:sp>
       <p:pic>
         <p:nvPicPr>
-          <p:cNvPr id="17" name="Image 0" descr="preencoded.png">    </p:cNvPr>
+          <p:cNvPr id="17" name="Image 1" descr="preencoded.png">    </p:cNvPr>
           <p:cNvPicPr>
             <a:picLocks noChangeAspect="1"/>
           </p:cNvPicPr>
           <p:nvPr/>
         </p:nvPicPr>
         <p:blipFill>
-          <a:blip r:embed="rId1">
+          <a:blip r:embed="rId2">
             <a:extLst>
               <a:ext uri="{96DAC541-7B7A-43D3-8B79-37D633B846F1}">
-                <asvg:svgBlip xmlns:asvg="http://schemas.microsoft.com/office/drawing/2016/SVG/main" r:embed="rId2"/>
+                <asvg:svgBlip xmlns:asvg="http://schemas.microsoft.com/office/drawing/2016/SVG/main" r:embed="rId3"/>
               </a:ext>
             </a:extLst>
           </a:blip>
@@ -13258,17 +13243,17 @@
       </p:pic>
       <p:pic>
         <p:nvPicPr>
-          <p:cNvPr id="18" name="Image 1" descr="preencoded.png">    </p:cNvPr>
+          <p:cNvPr id="18" name="Image 2" descr="preencoded.png">    </p:cNvPr>
           <p:cNvPicPr>
             <a:picLocks noChangeAspect="1"/>
           </p:cNvPicPr>
           <p:nvPr/>
         </p:nvPicPr>
         <p:blipFill>
-          <a:blip r:embed="rId3">
+          <a:blip r:embed="rId4">
             <a:extLst>
               <a:ext uri="{96DAC541-7B7A-43D3-8B79-37D633B846F1}">
-                <asvg:svgBlip xmlns:asvg="http://schemas.microsoft.com/office/drawing/2016/SVG/main" r:embed="rId4"/>
+                <asvg:svgBlip xmlns:asvg="http://schemas.microsoft.com/office/drawing/2016/SVG/main" r:embed="rId5"/>
               </a:ext>
             </a:extLst>
           </a:blip>
@@ -13288,17 +13273,17 @@
       </p:pic>
       <p:pic>
         <p:nvPicPr>
-          <p:cNvPr id="19" name="Image 2" descr="preencoded.png">    </p:cNvPr>
+          <p:cNvPr id="19" name="Image 3" descr="preencoded.png">    </p:cNvPr>
           <p:cNvPicPr>
             <a:picLocks noChangeAspect="1"/>
           </p:cNvPicPr>
           <p:nvPr/>
         </p:nvPicPr>
         <p:blipFill>
-          <a:blip r:embed="rId5">
+          <a:blip r:embed="rId6">
             <a:extLst>
               <a:ext uri="{96DAC541-7B7A-43D3-8B79-37D633B846F1}">
-                <asvg:svgBlip xmlns:asvg="http://schemas.microsoft.com/office/drawing/2016/SVG/main" r:embed="rId6"/>
+                <asvg:svgBlip xmlns:asvg="http://schemas.microsoft.com/office/drawing/2016/SVG/main" r:embed="rId7"/>
               </a:ext>
             </a:extLst>
           </a:blip>
@@ -13318,7 +13303,7 @@
       </p:pic>
       <p:sp>
         <p:nvSpPr>
-          <p:cNvPr id="20" name="Text 15"/>
+          <p:cNvPr id="20" name="Text 14"/>
           <p:cNvSpPr/>
           <p:nvPr/>
         </p:nvSpPr>
@@ -13399,7 +13384,7 @@
       </p:sp>
       <p:sp>
         <p:nvSpPr>
-          <p:cNvPr id="21" name="Text 16"/>
+          <p:cNvPr id="21" name="Text 15"/>
           <p:cNvSpPr/>
           <p:nvPr/>
         </p:nvSpPr>

</xml_diff>